<commit_message>
Deck: black titles, white title slide, no footer or slide number; every element editable on the slide
Co-Authored-By: Claude Fable 5.1 <noreply@anthropic.com>
</commit_message>
<xml_diff>
--- a/slides/Team1_DM1_slides.pptx
+++ b/slides/Team1_DM1_slides.pptx
@@ -116,7 +116,7 @@
   <p:extLst>
     <p:ext uri="{521415D9-36F7-43E2-AB2F-B90AF26B5E84}">
       <p14:sectionLst xmlns:p14="http://schemas.microsoft.com/office/powerpoint/2010/main">
-        <p14:section name="Talk" id="{6f1389f6-b54a-5582-cc2a-a15a3825f6b0}">
+        <p14:section name="Talk" id="{3c5c73da-cd38-0d23-6e71-e1a7e0b194c9}">
           <p14:sldIdLst>
             <p14:sldId id="256"/>
             <p14:sldId id="257"/>
@@ -126,7 +126,7 @@
             <p14:sldId id="261"/>
           </p14:sldIdLst>
         </p14:section>
-        <p14:section name="Backup" id="{0a483e56-b217-2c60-e482-4e65381ac280}">
+        <p14:section name="Backup" id="{83da949f-0596-6652-3048-24e8fb0aa7ba}">
           <p14:sldIdLst>
             <p14:sldId id="262"/>
             <p14:sldId id="263"/>
@@ -1408,7 +1408,7 @@
     <p:bg>
       <p:bgPr>
         <a:solidFill>
-          <a:srgbClr val="1E3A5F"/>
+          <a:srgbClr val="FFFFFF"/>
         </a:solidFill>
       </p:bgPr>
     </p:bg>
@@ -1452,7 +1452,7 @@
               <a:buNone/>
               <a:defRPr lang="en-US" sz="4000" b="1" dirty="0">
                 <a:solidFill>
-                  <a:srgbClr val="FFFFFF"/>
+                  <a:srgbClr val="000000"/>
                 </a:solidFill>
               </a:defRPr>
             </a:lvl1pPr>
@@ -1491,7 +1491,7 @@
               <a:buNone/>
               <a:defRPr lang="en-US" sz="1800" dirty="0">
                 <a:solidFill>
-                  <a:srgbClr val="BFD3E6"/>
+                  <a:srgbClr val="404040"/>
                 </a:solidFill>
               </a:defRPr>
             </a:lvl1pPr>
@@ -1562,7 +1562,7 @@
               <a:buNone/>
               <a:defRPr lang="en-US" sz="2800" b="1" dirty="0">
                 <a:solidFill>
-                  <a:srgbClr val="1E3A5F"/>
+                  <a:srgbClr val="000000"/>
                 </a:solidFill>
               </a:defRPr>
             </a:lvl1pPr>
@@ -1572,87 +1572,6 @@
               <a:buNone/>
             </a:pPr>
             <a:endParaRPr lang="en-US" sz="2800" dirty="0"/>
-          </a:p>
-        </p:txBody>
-      </p:sp>
-      <p:sp>
-        <p:nvSpPr>
-          <p:cNvPr id="3" name="Text 0"/>
-          <p:cNvSpPr/>
-          <p:nvPr/>
-        </p:nvSpPr>
-        <p:spPr>
-          <a:xfrm>
-            <a:off x="548640" y="6400800"/>
-            <a:ext cx="8229600" cy="274320"/>
-          </a:xfrm>
-          <a:prstGeom prst="rect">
-            <a:avLst/>
-          </a:prstGeom>
-          <a:noFill/>
-          <a:ln/>
-        </p:spPr>
-        <p:txBody>
-          <a:bodyPr wrap="square" lIns="0" tIns="0" rIns="0" bIns="0" rtlCol="0" anchor="ctr"/>
-          <a:lstStyle/>
-          <a:p>
-            <a:pPr indent="0" marL="0">
-              <a:buNone/>
-            </a:pPr>
-            <a:r>
-              <a:rPr lang="en-US" sz="1000" dirty="0">
-                <a:solidFill>
-                  <a:srgbClr val="5B6B7A"/>
-                </a:solidFill>
-              </a:rPr>
-              <a:t>Team 1  ·  ACoP 2026 Hackathon  ·  Myotonic dystrophy type 1</a:t>
-            </a:r>
-            <a:endParaRPr lang="en-US" sz="1000" dirty="0"/>
-          </a:p>
-        </p:txBody>
-      </p:sp>
-      <p:sp>
-        <p:nvSpPr>
-          <p:cNvPr id="25" name="Slide Number Placeholder 0"/>
-          <p:cNvSpPr>
-            <a:spLocks noGrp="1"/>
-          </p:cNvSpPr>
-          <p:nvPr>
-            <p:ph type="sldNum" sz="quarter" idx="4294967295"/>
-          </p:nvPr>
-        </p:nvSpPr>
-        <p:spPr>
-          <a:xfrm>
-            <a:off x="11247120" y="6400800"/>
-            <a:ext cx="457200" cy="274320"/>
-          </a:xfrm>
-          <a:prstGeom prst="rect">
-            <a:avLst/>
-          </a:prstGeom>
-          <a:extLst>
-            <a:ext uri="{C572A759-6A51-4108-AA02-DFA0A04FC94B}">
-              <ma14:wrappingTextBoxFlag xmlns:ma14="http://schemas.microsoft.com/office/mac/drawingml/2011/main" val="0"/>
-            </a:ext>
-          </a:extLst>
-        </p:spPr>
-        <p:txBody>
-          <a:bodyPr/>
-          <a:lstStyle>
-            <a:lvl1pPr>
-              <a:defRPr sz="1000">
-                <a:solidFill>
-                  <a:srgbClr val="5B6B7A"/>
-                </a:solidFill>
-              </a:defRPr>
-            </a:lvl1pPr>
-          </a:lstStyle>
-          <a:p>
-            <a:pPr algn="l"/>
-            <a:fld id="{F7021451-1387-4CA6-816F-3879F97B5CBC}" type="slidenum">
-              <a:rPr b="0" lang="en-US"/>
-              <a:t>1003</a:t>
-            </a:fld>
-            <a:endParaRPr lang="en-US"/>
           </a:p>
         </p:txBody>
       </p:sp>
@@ -1681,51 +1600,6 @@
           <a:chExt cx="0" cy="0"/>
         </a:xfrm>
       </p:grpSpPr>
-      <p:sp>
-        <p:nvSpPr>
-          <p:cNvPr id="25" name="Slide Number Placeholder 0"/>
-          <p:cNvSpPr>
-            <a:spLocks noGrp="1"/>
-          </p:cNvSpPr>
-          <p:nvPr>
-            <p:ph type="sldNum" sz="quarter" idx="4294967295"/>
-          </p:nvPr>
-        </p:nvSpPr>
-        <p:spPr>
-          <a:xfrm>
-            <a:off x="11247120" y="6400800"/>
-            <a:ext cx="457200" cy="274320"/>
-          </a:xfrm>
-          <a:prstGeom prst="rect">
-            <a:avLst/>
-          </a:prstGeom>
-          <a:extLst>
-            <a:ext uri="{C572A759-6A51-4108-AA02-DFA0A04FC94B}">
-              <ma14:wrappingTextBoxFlag xmlns:ma14="http://schemas.microsoft.com/office/mac/drawingml/2011/main" val="0"/>
-            </a:ext>
-          </a:extLst>
-        </p:spPr>
-        <p:txBody>
-          <a:bodyPr/>
-          <a:lstStyle>
-            <a:lvl1pPr>
-              <a:defRPr sz="1000">
-                <a:solidFill>
-                  <a:srgbClr val="5B6B7A"/>
-                </a:solidFill>
-              </a:defRPr>
-            </a:lvl1pPr>
-          </a:lstStyle>
-          <a:p>
-            <a:pPr algn="l"/>
-            <a:fld id="{F7021451-1387-4CA6-816F-3879F97B5CBC}" type="slidenum">
-              <a:rPr b="0" lang="en-US"/>
-              <a:t>null</a:t>
-            </a:fld>
-            <a:endParaRPr lang="en-US"/>
-          </a:p>
-        </p:txBody>
-      </p:sp>
     </p:spTree>
   </p:cSld>
   <p:clrMap bg1="lt1" tx1="dk1" bg2="lt2" tx2="dk2" accent1="accent1" accent2="accent2" accent3="accent3" accent4="accent4" accent5="accent5" accent6="accent6" hlink="hlink" folHlink="folHlink"/>
@@ -1994,7 +1868,7 @@
     <p:bg>
       <p:bgPr>
         <a:solidFill>
-          <a:srgbClr val="1E3A5F"/>
+          <a:srgbClr val="FFFFFF"/>
         </a:solidFill>
       </p:bgPr>
     </p:bg>
@@ -2041,7 +1915,7 @@
             <a:r>
               <a:rPr lang="en-US" sz="4000" b="1" dirty="0">
                 <a:solidFill>
-                  <a:srgbClr val="FFFFFF"/>
+                  <a:srgbClr val="000000"/>
                 </a:solidFill>
               </a:rPr>
               <a:t>Beyond CTG repeats: one predictor per drug</a:t>
@@ -2079,7 +1953,7 @@
             <a:r>
               <a:rPr lang="en-US" sz="1800" dirty="0">
                 <a:solidFill>
-                  <a:srgbClr val="BFD3E6"/>
+                  <a:srgbClr val="404040"/>
                 </a:solidFill>
               </a:rPr>
               <a:t>Covariate models and machine learning for patient stratification in myotonic dystrophy type 1</a:t>
@@ -2093,7 +1967,7 @@
             <a:r>
               <a:rPr lang="en-US" sz="800" dirty="0">
                 <a:solidFill>
-                  <a:srgbClr val="BFD3E6"/>
+                  <a:srgbClr val="404040"/>
                 </a:solidFill>
               </a:rPr>
               <a:t> </a:t>
@@ -2107,7 +1981,7 @@
             <a:r>
               <a:rPr lang="en-US" sz="1500" dirty="0">
                 <a:solidFill>
-                  <a:srgbClr val="BFD3E6"/>
+                  <a:srgbClr val="404040"/>
                 </a:solidFill>
               </a:rPr>
               <a:t>Team 1  ·  Euibeom Shin, Wenzhe Ma, Leo Vuong, Bei Zhao, Ming Gao, Izumi Hamada</a:t>
@@ -2121,7 +1995,7 @@
             <a:r>
               <a:rPr lang="en-US" sz="1500" dirty="0">
                 <a:solidFill>
-                  <a:srgbClr val="BFD3E6"/>
+                  <a:srgbClr val="404040"/>
                 </a:solidFill>
               </a:rPr>
               <a:t>ACoP 2026 Hackathon  ·  14 October 2026</a:t>
@@ -2191,7 +2065,7 @@
             <a:r>
               <a:rPr lang="en-US" sz="2800" b="1" dirty="0">
                 <a:solidFill>
-                  <a:srgbClr val="1E3A5F"/>
+                  <a:srgbClr val="000000"/>
                 </a:solidFill>
               </a:rPr>
               <a:t>Backup: references</a:t>
@@ -2389,51 +2263,6 @@
               <a:t>10. Hutmacher MM, Kowalski KG. Covariate selection in pharmacometric analyses: a review of methods. Br J Clin Pharmacol 2015;79:132-47.</a:t>
             </a:r>
             <a:endParaRPr lang="en-US" sz="1200" dirty="0"/>
-          </a:p>
-        </p:txBody>
-      </p:sp>
-      <p:sp>
-        <p:nvSpPr>
-          <p:cNvPr id="25" name="Slide Number Placeholder 0"/>
-          <p:cNvSpPr>
-            <a:spLocks noGrp="1"/>
-          </p:cNvSpPr>
-          <p:nvPr>
-            <p:ph type="sldNum" sz="quarter" idx="4294967295"/>
-          </p:nvPr>
-        </p:nvSpPr>
-        <p:spPr>
-          <a:xfrm>
-            <a:off x="11247120" y="6400800"/>
-            <a:ext cx="457200" cy="274320"/>
-          </a:xfrm>
-          <a:prstGeom prst="rect">
-            <a:avLst/>
-          </a:prstGeom>
-          <a:extLst>
-            <a:ext uri="{C572A759-6A51-4108-AA02-DFA0A04FC94B}">
-              <ma14:wrappingTextBoxFlag xmlns:ma14="http://schemas.microsoft.com/office/mac/drawingml/2011/main" val="0"/>
-            </a:ext>
-          </a:extLst>
-        </p:spPr>
-        <p:txBody>
-          <a:bodyPr/>
-          <a:lstStyle>
-            <a:lvl1pPr>
-              <a:defRPr sz="1000">
-                <a:solidFill>
-                  <a:srgbClr val="5B6B7A"/>
-                </a:solidFill>
-              </a:defRPr>
-            </a:lvl1pPr>
-          </a:lstStyle>
-          <a:p>
-            <a:pPr algn="l"/>
-            <a:fld id="{F7021451-1387-4CA6-816F-3879F97B5CBC}" type="slidenum">
-              <a:rPr b="0" lang="en-US"/>
-              <a:t>10</a:t>
-            </a:fld>
-            <a:endParaRPr lang="en-US"/>
           </a:p>
         </p:txBody>
       </p:sp>
@@ -2498,7 +2327,7 @@
             <a:r>
               <a:rPr lang="en-US" sz="2800" b="1" dirty="0">
                 <a:solidFill>
-                  <a:srgbClr val="1E3A5F"/>
+                  <a:srgbClr val="000000"/>
                 </a:solidFill>
               </a:rPr>
               <a:t>Each drug has one baseline predictor, and it is the measurement nearest to where the drug acts</a:t>
@@ -2548,7 +2377,7 @@
                       <a:r>
                         <a:rPr lang="en-US" sz="1300" b="1" dirty="0">
                           <a:solidFill>
-                            <a:srgbClr val="1E3A5F"/>
+                            <a:srgbClr val="000000"/>
                           </a:solidFill>
                         </a:rPr>
                         <a:t>Drug</a:t>
@@ -2594,7 +2423,7 @@
                       <a:tailEnd type="none" w="med" len="med"/>
                     </a:lnB>
                     <a:solidFill>
-                      <a:srgbClr val="EEF2F6"/>
+                      <a:srgbClr val="F2F2F2"/>
                     </a:solidFill>
                   </a:tcPr>
                 </a:tc>
@@ -2609,7 +2438,7 @@
                       <a:r>
                         <a:rPr lang="en-US" sz="1300" b="1" dirty="0">
                           <a:solidFill>
-                            <a:srgbClr val="1E3A5F"/>
+                            <a:srgbClr val="000000"/>
                           </a:solidFill>
                         </a:rPr>
                         <a:t>Acts on</a:t>
@@ -2655,7 +2484,7 @@
                       <a:tailEnd type="none" w="med" len="med"/>
                     </a:lnB>
                     <a:solidFill>
-                      <a:srgbClr val="EEF2F6"/>
+                      <a:srgbClr val="F2F2F2"/>
                     </a:solidFill>
                   </a:tcPr>
                 </a:tc>
@@ -2670,7 +2499,7 @@
                       <a:r>
                         <a:rPr lang="en-US" sz="1300" b="1" dirty="0">
                           <a:solidFill>
-                            <a:srgbClr val="1E3A5F"/>
+                            <a:srgbClr val="000000"/>
                           </a:solidFill>
                         </a:rPr>
                         <a:t>Main predictor</a:t>
@@ -2716,7 +2545,7 @@
                       <a:tailEnd type="none" w="med" len="med"/>
                     </a:lnB>
                     <a:solidFill>
-                      <a:srgbClr val="EEF2F6"/>
+                      <a:srgbClr val="F2F2F2"/>
                     </a:solidFill>
                   </a:tcPr>
                 </a:tc>
@@ -2731,7 +2560,7 @@
                       <a:r>
                         <a:rPr lang="en-US" sz="1300" b="1" dirty="0">
                           <a:solidFill>
-                            <a:srgbClr val="1E3A5F"/>
+                            <a:srgbClr val="000000"/>
                           </a:solidFill>
                         </a:rPr>
                         <a:t>Held-out responders, high vs low</a:t>
@@ -2777,7 +2606,7 @@
                       <a:tailEnd type="none" w="med" len="med"/>
                     </a:lnB>
                     <a:solidFill>
-                      <a:srgbClr val="EEF2F6"/>
+                      <a:srgbClr val="F2F2F2"/>
                     </a:solidFill>
                   </a:tcPr>
                 </a:tc>
@@ -2792,7 +2621,7 @@
                       <a:r>
                         <a:rPr lang="en-US" sz="1300" b="1" dirty="0">
                           <a:solidFill>
-                            <a:srgbClr val="1E3A5F"/>
+                            <a:srgbClr val="000000"/>
                           </a:solidFill>
                         </a:rPr>
                         <a:t>Evidence</a:t>
@@ -2838,7 +2667,7 @@
                       <a:tailEnd type="none" w="med" len="med"/>
                     </a:lnB>
                     <a:solidFill>
-                      <a:srgbClr val="EEF2F6"/>
+                      <a:srgbClr val="F2F2F2"/>
                     </a:solidFill>
                   </a:tcPr>
                 </a:tc>
@@ -3740,11 +3569,11 @@
             </a:avLst>
           </a:prstGeom>
           <a:solidFill>
-            <a:srgbClr val="EEF2F6"/>
+            <a:srgbClr val="F2F2F2"/>
           </a:solidFill>
           <a:ln w="12700">
             <a:solidFill>
-              <a:srgbClr val="EEF2F6"/>
+              <a:srgbClr val="F2F2F2"/>
             </a:solidFill>
             <a:prstDash val="solid"/>
           </a:ln>
@@ -3808,51 +3637,6 @@
           </a:p>
         </p:txBody>
       </p:sp>
-      <p:sp>
-        <p:nvSpPr>
-          <p:cNvPr id="25" name="Slide Number Placeholder 0"/>
-          <p:cNvSpPr>
-            <a:spLocks noGrp="1"/>
-          </p:cNvSpPr>
-          <p:nvPr>
-            <p:ph type="sldNum" sz="quarter" idx="4294967295"/>
-          </p:nvPr>
-        </p:nvSpPr>
-        <p:spPr>
-          <a:xfrm>
-            <a:off x="11247120" y="6400800"/>
-            <a:ext cx="457200" cy="274320"/>
-          </a:xfrm>
-          <a:prstGeom prst="rect">
-            <a:avLst/>
-          </a:prstGeom>
-          <a:extLst>
-            <a:ext uri="{C572A759-6A51-4108-AA02-DFA0A04FC94B}">
-              <ma14:wrappingTextBoxFlag xmlns:ma14="http://schemas.microsoft.com/office/mac/drawingml/2011/main" val="0"/>
-            </a:ext>
-          </a:extLst>
-        </p:spPr>
-        <p:txBody>
-          <a:bodyPr/>
-          <a:lstStyle>
-            <a:lvl1pPr>
-              <a:defRPr sz="1000">
-                <a:solidFill>
-                  <a:srgbClr val="5B6B7A"/>
-                </a:solidFill>
-              </a:defRPr>
-            </a:lvl1pPr>
-          </a:lstStyle>
-          <a:p>
-            <a:pPr algn="l"/>
-            <a:fld id="{F7021451-1387-4CA6-816F-3879F97B5CBC}" type="slidenum">
-              <a:rPr b="0" lang="en-US"/>
-              <a:t>2</a:t>
-            </a:fld>
-            <a:endParaRPr lang="en-US"/>
-          </a:p>
-        </p:txBody>
-      </p:sp>
     </p:spTree>
   </p:cSld>
   <p:clrMapOvr>
@@ -3914,7 +3698,7 @@
             <a:r>
               <a:rPr lang="en-US" sz="2800" b="1" dirty="0">
                 <a:solidFill>
-                  <a:srgbClr val="1E3A5F"/>
+                  <a:srgbClr val="000000"/>
                 </a:solidFill>
               </a:rPr>
               <a:t>Three drugs act at three different links of the same chain, so each arm is analysed on its own</a:t>
@@ -3940,11 +3724,11 @@
             </a:avLst>
           </a:prstGeom>
           <a:solidFill>
-            <a:srgbClr val="1E3A5F"/>
+            <a:srgbClr val="3A3F45"/>
           </a:solidFill>
           <a:ln w="12700">
             <a:solidFill>
-              <a:srgbClr val="1E3A5F"/>
+              <a:srgbClr val="3A3F45"/>
             </a:solidFill>
             <a:prstDash val="solid"/>
           </a:ln>
@@ -4001,11 +3785,11 @@
             <a:avLst/>
           </a:prstGeom>
           <a:solidFill>
-            <a:srgbClr val="8DA9C4"/>
+            <a:srgbClr val="9AA3AD"/>
           </a:solidFill>
           <a:ln w="12700">
             <a:solidFill>
-              <a:srgbClr val="8DA9C4"/>
+              <a:srgbClr val="9AA3AD"/>
             </a:solidFill>
             <a:prstDash val="solid"/>
           </a:ln>
@@ -4028,11 +3812,11 @@
             </a:avLst>
           </a:prstGeom>
           <a:solidFill>
-            <a:srgbClr val="1E3A5F"/>
+            <a:srgbClr val="3A3F45"/>
           </a:solidFill>
           <a:ln w="12700">
             <a:solidFill>
-              <a:srgbClr val="1E3A5F"/>
+              <a:srgbClr val="3A3F45"/>
             </a:solidFill>
             <a:prstDash val="solid"/>
           </a:ln>
@@ -4089,11 +3873,11 @@
             <a:avLst/>
           </a:prstGeom>
           <a:solidFill>
-            <a:srgbClr val="8DA9C4"/>
+            <a:srgbClr val="9AA3AD"/>
           </a:solidFill>
           <a:ln w="12700">
             <a:solidFill>
-              <a:srgbClr val="8DA9C4"/>
+              <a:srgbClr val="9AA3AD"/>
             </a:solidFill>
             <a:prstDash val="solid"/>
           </a:ln>
@@ -4152,11 +3936,11 @@
             </a:avLst>
           </a:prstGeom>
           <a:solidFill>
-            <a:srgbClr val="1E3A5F"/>
+            <a:srgbClr val="3A3F45"/>
           </a:solidFill>
           <a:ln w="12700">
             <a:solidFill>
-              <a:srgbClr val="1E3A5F"/>
+              <a:srgbClr val="3A3F45"/>
             </a:solidFill>
             <a:prstDash val="solid"/>
           </a:ln>
@@ -4213,11 +3997,11 @@
             <a:avLst/>
           </a:prstGeom>
           <a:solidFill>
-            <a:srgbClr val="8DA9C4"/>
+            <a:srgbClr val="9AA3AD"/>
           </a:solidFill>
           <a:ln w="12700">
             <a:solidFill>
-              <a:srgbClr val="8DA9C4"/>
+              <a:srgbClr val="9AA3AD"/>
             </a:solidFill>
             <a:prstDash val="solid"/>
           </a:ln>
@@ -4276,11 +4060,11 @@
             </a:avLst>
           </a:prstGeom>
           <a:solidFill>
-            <a:srgbClr val="1E3A5F"/>
+            <a:srgbClr val="3A3F45"/>
           </a:solidFill>
           <a:ln w="12700">
             <a:solidFill>
-              <a:srgbClr val="1E3A5F"/>
+              <a:srgbClr val="3A3F45"/>
             </a:solidFill>
             <a:prstDash val="solid"/>
           </a:ln>
@@ -4337,11 +4121,11 @@
             <a:avLst/>
           </a:prstGeom>
           <a:solidFill>
-            <a:srgbClr val="8DA9C4"/>
+            <a:srgbClr val="9AA3AD"/>
           </a:solidFill>
           <a:ln w="12700">
             <a:solidFill>
-              <a:srgbClr val="8DA9C4"/>
+              <a:srgbClr val="9AA3AD"/>
             </a:solidFill>
             <a:prstDash val="solid"/>
           </a:ln>
@@ -4364,11 +4148,11 @@
             </a:avLst>
           </a:prstGeom>
           <a:solidFill>
-            <a:srgbClr val="1E3A5F"/>
+            <a:srgbClr val="3A3F45"/>
           </a:solidFill>
           <a:ln w="12700">
             <a:solidFill>
-              <a:srgbClr val="1E3A5F"/>
+              <a:srgbClr val="3A3F45"/>
             </a:solidFill>
             <a:prstDash val="solid"/>
           </a:ln>
@@ -4473,7 +4257,7 @@
             <a:r>
               <a:rPr lang="en-US" sz="1600" b="1" dirty="0">
                 <a:solidFill>
-                  <a:srgbClr val="1E3A5F"/>
+                  <a:srgbClr val="000000"/>
                 </a:solidFill>
               </a:rPr>
               <a:t>The data</a:t>
@@ -4585,7 +4369,7 @@
             <a:r>
               <a:rPr lang="en-US" sz="1600" b="1" dirty="0">
                 <a:solidFill>
-                  <a:srgbClr val="1E3A5F"/>
+                  <a:srgbClr val="000000"/>
                 </a:solidFill>
               </a:rPr>
               <a:t>How we analysed each arm</a:t>
@@ -4685,51 +4469,6 @@
               <a:t>Noise control: a random-number column added as a covariate, 200 bootstrap resamples for stability, and a vote across the five methods</a:t>
             </a:r>
             <a:endParaRPr lang="en-US" sz="1400" dirty="0"/>
-          </a:p>
-        </p:txBody>
-      </p:sp>
-      <p:sp>
-        <p:nvSpPr>
-          <p:cNvPr id="25" name="Slide Number Placeholder 0"/>
-          <p:cNvSpPr>
-            <a:spLocks noGrp="1"/>
-          </p:cNvSpPr>
-          <p:nvPr>
-            <p:ph type="sldNum" sz="quarter" idx="4294967295"/>
-          </p:nvPr>
-        </p:nvSpPr>
-        <p:spPr>
-          <a:xfrm>
-            <a:off x="11247120" y="6400800"/>
-            <a:ext cx="457200" cy="274320"/>
-          </a:xfrm>
-          <a:prstGeom prst="rect">
-            <a:avLst/>
-          </a:prstGeom>
-          <a:extLst>
-            <a:ext uri="{C572A759-6A51-4108-AA02-DFA0A04FC94B}">
-              <ma14:wrappingTextBoxFlag xmlns:ma14="http://schemas.microsoft.com/office/mac/drawingml/2011/main" val="0"/>
-            </a:ext>
-          </a:extLst>
-        </p:spPr>
-        <p:txBody>
-          <a:bodyPr/>
-          <a:lstStyle>
-            <a:lvl1pPr>
-              <a:defRPr sz="1000">
-                <a:solidFill>
-                  <a:srgbClr val="5B6B7A"/>
-                </a:solidFill>
-              </a:defRPr>
-            </a:lvl1pPr>
-          </a:lstStyle>
-          <a:p>
-            <a:pPr algn="l"/>
-            <a:fld id="{F7021451-1387-4CA6-816F-3879F97B5CBC}" type="slidenum">
-              <a:rPr b="0" lang="en-US"/>
-              <a:t>3</a:t>
-            </a:fld>
-            <a:endParaRPr lang="en-US"/>
           </a:p>
         </p:txBody>
       </p:sp>
@@ -4794,7 +4533,7 @@
             <a:r>
               <a:rPr lang="en-US" sz="2800" b="1" dirty="0">
                 <a:solidFill>
-                  <a:srgbClr val="1E3A5F"/>
+                  <a:srgbClr val="000000"/>
                 </a:solidFill>
               </a:rPr>
               <a:t>Across the covariate range, response moves from about 15% to about 80%, and onset type adds little</a:t>
@@ -4854,7 +4593,7 @@
             <a:r>
               <a:rPr lang="en-US" sz="1500" b="1" dirty="0">
                 <a:solidFill>
-                  <a:srgbClr val="1E3A5F"/>
+                  <a:srgbClr val="000000"/>
                 </a:solidFill>
               </a:rPr>
               <a:t>Mexiletine: myotonia severity</a:t>
@@ -4926,7 +4665,7 @@
             <a:r>
               <a:rPr lang="en-US" sz="1500" b="1" dirty="0">
                 <a:solidFill>
-                  <a:srgbClr val="1E3A5F"/>
+                  <a:srgbClr val="000000"/>
                 </a:solidFill>
               </a:rPr>
               <a:t>Antisense oligonucleotide: CTG repeat length</a:t>
@@ -4998,7 +4737,7 @@
             <a:r>
               <a:rPr lang="en-US" sz="1500" b="1" dirty="0">
                 <a:solidFill>
-                  <a:srgbClr val="1E3A5F"/>
+                  <a:srgbClr val="000000"/>
                 </a:solidFill>
               </a:rPr>
               <a:t>Tideglusib: cognitive function</a:t>
@@ -5060,11 +4799,11 @@
             </a:avLst>
           </a:prstGeom>
           <a:solidFill>
-            <a:srgbClr val="EEF2F6"/>
+            <a:srgbClr val="F2F2F2"/>
           </a:solidFill>
           <a:ln w="12700">
             <a:solidFill>
-              <a:srgbClr val="EEF2F6"/>
+              <a:srgbClr val="F2F2F2"/>
             </a:solidFill>
             <a:prstDash val="solid"/>
           </a:ln>
@@ -5114,51 +4853,6 @@
               <a:t>Three team members, three codebases (R, R, Python), three different splits, up to 30 methods and 20 repeated splits: the same three covariates every time. CTG repeats also trends the same way in the third arm; cognition matters in one arm only.</a:t>
             </a:r>
             <a:endParaRPr lang="en-US" sz="1250" dirty="0"/>
-          </a:p>
-        </p:txBody>
-      </p:sp>
-      <p:sp>
-        <p:nvSpPr>
-          <p:cNvPr id="25" name="Slide Number Placeholder 0"/>
-          <p:cNvSpPr>
-            <a:spLocks noGrp="1"/>
-          </p:cNvSpPr>
-          <p:nvPr>
-            <p:ph type="sldNum" sz="quarter" idx="4294967295"/>
-          </p:nvPr>
-        </p:nvSpPr>
-        <p:spPr>
-          <a:xfrm>
-            <a:off x="11247120" y="6400800"/>
-            <a:ext cx="457200" cy="274320"/>
-          </a:xfrm>
-          <a:prstGeom prst="rect">
-            <a:avLst/>
-          </a:prstGeom>
-          <a:extLst>
-            <a:ext uri="{C572A759-6A51-4108-AA02-DFA0A04FC94B}">
-              <ma14:wrappingTextBoxFlag xmlns:ma14="http://schemas.microsoft.com/office/mac/drawingml/2011/main" val="0"/>
-            </a:ext>
-          </a:extLst>
-        </p:spPr>
-        <p:txBody>
-          <a:bodyPr/>
-          <a:lstStyle>
-            <a:lvl1pPr>
-              <a:defRPr sz="1000">
-                <a:solidFill>
-                  <a:srgbClr val="5B6B7A"/>
-                </a:solidFill>
-              </a:defRPr>
-            </a:lvl1pPr>
-          </a:lstStyle>
-          <a:p>
-            <a:pPr algn="l"/>
-            <a:fld id="{F7021451-1387-4CA6-816F-3879F97B5CBC}" type="slidenum">
-              <a:rPr b="0" lang="en-US"/>
-              <a:t>4</a:t>
-            </a:fld>
-            <a:endParaRPr lang="en-US"/>
           </a:p>
         </p:txBody>
       </p:sp>
@@ -5223,7 +4917,7 @@
             <a:r>
               <a:rPr lang="en-US" sz="2800" b="1" dirty="0">
                 <a:solidFill>
-                  <a:srgbClr val="1E3A5F"/>
+                  <a:srgbClr val="000000"/>
                 </a:solidFill>
               </a:rPr>
               <a:t>Simple models tie machine learning in two arms; trees win the third only because the effect is a step</a:t>
@@ -5283,7 +4977,7 @@
             <a:r>
               <a:rPr lang="en-US" sz="1400" b="1" dirty="0">
                 <a:solidFill>
-                  <a:srgbClr val="1E3A5F"/>
+                  <a:srgbClr val="000000"/>
                 </a:solidFill>
               </a:rPr>
               <a:t>Mexiletine: a tie</a:t>
@@ -5355,7 +5049,7 @@
             <a:r>
               <a:rPr lang="en-US" sz="1400" b="1" dirty="0">
                 <a:solidFill>
-                  <a:srgbClr val="1E3A5F"/>
+                  <a:srgbClr val="000000"/>
                 </a:solidFill>
               </a:rPr>
               <a:t>Oligonucleotide: nobody</a:t>
@@ -5469,51 +5163,6 @@
               <a:t>Trees 0.55 vs straight lines 0.24 to 0.30, on 19 of 20 splits. Give the linear model one cut-off and it reaches 0.45. Tuned XGBoost chose one-question trees: no interactions.</a:t>
             </a:r>
             <a:endParaRPr lang="en-US" sz="1150" dirty="0"/>
-          </a:p>
-        </p:txBody>
-      </p:sp>
-      <p:sp>
-        <p:nvSpPr>
-          <p:cNvPr id="25" name="Slide Number Placeholder 0"/>
-          <p:cNvSpPr>
-            <a:spLocks noGrp="1"/>
-          </p:cNvSpPr>
-          <p:nvPr>
-            <p:ph type="sldNum" sz="quarter" idx="4294967295"/>
-          </p:nvPr>
-        </p:nvSpPr>
-        <p:spPr>
-          <a:xfrm>
-            <a:off x="11247120" y="6400800"/>
-            <a:ext cx="457200" cy="274320"/>
-          </a:xfrm>
-          <a:prstGeom prst="rect">
-            <a:avLst/>
-          </a:prstGeom>
-          <a:extLst>
-            <a:ext uri="{C572A759-6A51-4108-AA02-DFA0A04FC94B}">
-              <ma14:wrappingTextBoxFlag xmlns:ma14="http://schemas.microsoft.com/office/mac/drawingml/2011/main" val="0"/>
-            </a:ext>
-          </a:extLst>
-        </p:spPr>
-        <p:txBody>
-          <a:bodyPr/>
-          <a:lstStyle>
-            <a:lvl1pPr>
-              <a:defRPr sz="1000">
-                <a:solidFill>
-                  <a:srgbClr val="5B6B7A"/>
-                </a:solidFill>
-              </a:defRPr>
-            </a:lvl1pPr>
-          </a:lstStyle>
-          <a:p>
-            <a:pPr algn="l"/>
-            <a:fld id="{F7021451-1387-4CA6-816F-3879F97B5CBC}" type="slidenum">
-              <a:rPr b="0" lang="en-US"/>
-              <a:t>5</a:t>
-            </a:fld>
-            <a:endParaRPr lang="en-US"/>
           </a:p>
         </p:txBody>
       </p:sp>
@@ -5578,7 +5227,7 @@
             <a:r>
               <a:rPr lang="en-US" sz="2800" b="1" dirty="0">
                 <a:solidFill>
-                  <a:srgbClr val="1E3A5F"/>
+                  <a:srgbClr val="000000"/>
                 </a:solidFill>
               </a:rPr>
               <a:t>Measure the organ the drug acts on: one routine test per drug separates response groups 2- to 7-fold</a:t>
@@ -5628,7 +5277,7 @@
                       <a:r>
                         <a:rPr lang="en-US" sz="1300" b="1" dirty="0">
                           <a:solidFill>
-                            <a:srgbClr val="1E3A5F"/>
+                            <a:srgbClr val="000000"/>
                           </a:solidFill>
                         </a:rPr>
                         <a:t>Before giving</a:t>
@@ -5674,7 +5323,7 @@
                       <a:tailEnd type="none" w="med" len="med"/>
                     </a:lnB>
                     <a:solidFill>
-                      <a:srgbClr val="EEF2F6"/>
+                      <a:srgbClr val="F2F2F2"/>
                     </a:solidFill>
                   </a:tcPr>
                 </a:tc>
@@ -5689,7 +5338,7 @@
                       <a:r>
                         <a:rPr lang="en-US" sz="1300" b="1" dirty="0">
                           <a:solidFill>
-                            <a:srgbClr val="1E3A5F"/>
+                            <a:srgbClr val="000000"/>
                           </a:solidFill>
                         </a:rPr>
                         <a:t>Measure</a:t>
@@ -5735,7 +5384,7 @@
                       <a:tailEnd type="none" w="med" len="med"/>
                     </a:lnB>
                     <a:solidFill>
-                      <a:srgbClr val="EEF2F6"/>
+                      <a:srgbClr val="F2F2F2"/>
                     </a:solidFill>
                   </a:tcPr>
                 </a:tc>
@@ -5750,7 +5399,7 @@
                       <a:r>
                         <a:rPr lang="en-US" sz="1300" b="1" dirty="0">
                           <a:solidFill>
-                            <a:srgbClr val="1E3A5F"/>
+                            <a:srgbClr val="000000"/>
                           </a:solidFill>
                         </a:rPr>
                         <a:t>Rule from a training-set tree</a:t>
@@ -5796,7 +5445,7 @@
                       <a:tailEnd type="none" w="med" len="med"/>
                     </a:lnB>
                     <a:solidFill>
-                      <a:srgbClr val="EEF2F6"/>
+                      <a:srgbClr val="F2F2F2"/>
                     </a:solidFill>
                   </a:tcPr>
                 </a:tc>
@@ -5811,7 +5460,7 @@
                       <a:r>
                         <a:rPr lang="en-US" sz="1300" b="1" dirty="0">
                           <a:solidFill>
-                            <a:srgbClr val="1E3A5F"/>
+                            <a:srgbClr val="000000"/>
                           </a:solidFill>
                         </a:rPr>
                         <a:t>Held-out responders</a:t>
@@ -5857,7 +5506,7 @@
                       <a:tailEnd type="none" w="med" len="med"/>
                     </a:lnB>
                     <a:solidFill>
-                      <a:srgbClr val="EEF2F6"/>
+                      <a:srgbClr val="F2F2F2"/>
                     </a:solidFill>
                   </a:tcPr>
                 </a:tc>
@@ -5872,7 +5521,7 @@
                       <a:r>
                         <a:rPr lang="en-US" sz="1300" b="1" dirty="0">
                           <a:solidFill>
-                            <a:srgbClr val="1E3A5F"/>
+                            <a:srgbClr val="000000"/>
                           </a:solidFill>
                         </a:rPr>
                         <a:t>Trial-design implication</a:t>
@@ -5918,7 +5567,7 @@
                       <a:tailEnd type="none" w="med" len="med"/>
                     </a:lnB>
                     <a:solidFill>
-                      <a:srgbClr val="EEF2F6"/>
+                      <a:srgbClr val="F2F2F2"/>
                     </a:solidFill>
                   </a:tcPr>
                 </a:tc>
@@ -6830,7 +6479,7 @@
             <a:r>
               <a:rPr lang="en-US" sz="1600" b="1" dirty="0">
                 <a:solidFill>
-                  <a:srgbClr val="1E3A5F"/>
+                  <a:srgbClr val="000000"/>
                 </a:solidFill>
               </a:rPr>
               <a:t>Limits we state</a:t>
@@ -6942,7 +6591,7 @@
             <a:r>
               <a:rPr lang="en-US" sz="1600" b="1" dirty="0">
                 <a:solidFill>
-                  <a:srgbClr val="1E3A5F"/>
+                  <a:srgbClr val="000000"/>
                 </a:solidFill>
               </a:rPr>
               <a:t>AI use, disclosed</a:t>
@@ -6968,11 +6617,11 @@
             </a:avLst>
           </a:prstGeom>
           <a:solidFill>
-            <a:srgbClr val="EEF2F6"/>
+            <a:srgbClr val="F2F2F2"/>
           </a:solidFill>
           <a:ln w="12700">
             <a:solidFill>
-              <a:srgbClr val="EEF2F6"/>
+              <a:srgbClr val="F2F2F2"/>
             </a:solidFill>
             <a:prstDash val="solid"/>
           </a:ln>
@@ -7011,51 +6660,6 @@
               <a:t>Claude (Anthropic) through Claude Code, and Codex, drafted code, documentation and this deck; noted in the code headers and in AI_DISCLOSURE.md. Every analysis choice and every interpretation was reviewed by the team, which is accountable for all of it.</a:t>
             </a:r>
             <a:endParaRPr lang="en-US" sz="1250" dirty="0"/>
-          </a:p>
-        </p:txBody>
-      </p:sp>
-      <p:sp>
-        <p:nvSpPr>
-          <p:cNvPr id="25" name="Slide Number Placeholder 0"/>
-          <p:cNvSpPr>
-            <a:spLocks noGrp="1"/>
-          </p:cNvSpPr>
-          <p:nvPr>
-            <p:ph type="sldNum" sz="quarter" idx="4294967295"/>
-          </p:nvPr>
-        </p:nvSpPr>
-        <p:spPr>
-          <a:xfrm>
-            <a:off x="11247120" y="6400800"/>
-            <a:ext cx="457200" cy="274320"/>
-          </a:xfrm>
-          <a:prstGeom prst="rect">
-            <a:avLst/>
-          </a:prstGeom>
-          <a:extLst>
-            <a:ext uri="{C572A759-6A51-4108-AA02-DFA0A04FC94B}">
-              <ma14:wrappingTextBoxFlag xmlns:ma14="http://schemas.microsoft.com/office/mac/drawingml/2011/main" val="0"/>
-            </a:ext>
-          </a:extLst>
-        </p:spPr>
-        <p:txBody>
-          <a:bodyPr/>
-          <a:lstStyle>
-            <a:lvl1pPr>
-              <a:defRPr sz="1000">
-                <a:solidFill>
-                  <a:srgbClr val="5B6B7A"/>
-                </a:solidFill>
-              </a:defRPr>
-            </a:lvl1pPr>
-          </a:lstStyle>
-          <a:p>
-            <a:pPr algn="l"/>
-            <a:fld id="{F7021451-1387-4CA6-816F-3879F97B5CBC}" type="slidenum">
-              <a:rPr b="0" lang="en-US"/>
-              <a:t>6</a:t>
-            </a:fld>
-            <a:endParaRPr lang="en-US"/>
           </a:p>
         </p:txBody>
       </p:sp>
@@ -7120,7 +6724,7 @@
             <a:r>
               <a:rPr lang="en-US" sz="2800" b="1" dirty="0">
                 <a:solidFill>
-                  <a:srgbClr val="1E3A5F"/>
+                  <a:srgbClr val="000000"/>
                 </a:solidFill>
               </a:rPr>
               <a:t>Backup: the pattern holds across 20 different train/test splits</a:t>
@@ -7186,51 +6790,6 @@
               <a:t>Test-set R², continuous outcome, 20 seeds. Mexiletine: all methods tie (median about 0.6). Oligonucleotide: all weak (medians 0.06 to 0.12). Tideglusib: a tree model ranked first on 19 of 20 splits; a linear model never did. Absolute R² moves by up to 0.15 between test sets, which is why we report ranges.</a:t>
             </a:r>
             <a:endParaRPr lang="en-US" sz="1150" dirty="0"/>
-          </a:p>
-        </p:txBody>
-      </p:sp>
-      <p:sp>
-        <p:nvSpPr>
-          <p:cNvPr id="25" name="Slide Number Placeholder 0"/>
-          <p:cNvSpPr>
-            <a:spLocks noGrp="1"/>
-          </p:cNvSpPr>
-          <p:nvPr>
-            <p:ph type="sldNum" sz="quarter" idx="4294967295"/>
-          </p:nvPr>
-        </p:nvSpPr>
-        <p:spPr>
-          <a:xfrm>
-            <a:off x="11247120" y="6400800"/>
-            <a:ext cx="457200" cy="274320"/>
-          </a:xfrm>
-          <a:prstGeom prst="rect">
-            <a:avLst/>
-          </a:prstGeom>
-          <a:extLst>
-            <a:ext uri="{C572A759-6A51-4108-AA02-DFA0A04FC94B}">
-              <ma14:wrappingTextBoxFlag xmlns:ma14="http://schemas.microsoft.com/office/mac/drawingml/2011/main" val="0"/>
-            </a:ext>
-          </a:extLst>
-        </p:spPr>
-        <p:txBody>
-          <a:bodyPr/>
-          <a:lstStyle>
-            <a:lvl1pPr>
-              <a:defRPr sz="1000">
-                <a:solidFill>
-                  <a:srgbClr val="5B6B7A"/>
-                </a:solidFill>
-              </a:defRPr>
-            </a:lvl1pPr>
-          </a:lstStyle>
-          <a:p>
-            <a:pPr algn="l"/>
-            <a:fld id="{F7021451-1387-4CA6-816F-3879F97B5CBC}" type="slidenum">
-              <a:rPr b="0" lang="en-US"/>
-              <a:t>7</a:t>
-            </a:fld>
-            <a:endParaRPr lang="en-US"/>
           </a:p>
         </p:txBody>
       </p:sp>
@@ -7295,7 +6854,7 @@
             <a:r>
               <a:rPr lang="en-US" sz="2800" b="1" dirty="0">
                 <a:solidFill>
-                  <a:srgbClr val="1E3A5F"/>
+                  <a:srgbClr val="000000"/>
                 </a:solidFill>
               </a:rPr>
               <a:t>Backup: which method picked which covariate</a:t>
@@ -7361,51 +6920,6 @@
               <a:t>Filled dot = picked. Read down the first three columns of each panel. The two ML columns are fuller because their bar (above the random-number column) is low; the final call also requires LASSO stability of 60% (signal) or 20% (uncertain).</a:t>
             </a:r>
             <a:endParaRPr lang="en-US" sz="1150" dirty="0"/>
-          </a:p>
-        </p:txBody>
-      </p:sp>
-      <p:sp>
-        <p:nvSpPr>
-          <p:cNvPr id="25" name="Slide Number Placeholder 0"/>
-          <p:cNvSpPr>
-            <a:spLocks noGrp="1"/>
-          </p:cNvSpPr>
-          <p:nvPr>
-            <p:ph type="sldNum" sz="quarter" idx="4294967295"/>
-          </p:nvPr>
-        </p:nvSpPr>
-        <p:spPr>
-          <a:xfrm>
-            <a:off x="11247120" y="6400800"/>
-            <a:ext cx="457200" cy="274320"/>
-          </a:xfrm>
-          <a:prstGeom prst="rect">
-            <a:avLst/>
-          </a:prstGeom>
-          <a:extLst>
-            <a:ext uri="{C572A759-6A51-4108-AA02-DFA0A04FC94B}">
-              <ma14:wrappingTextBoxFlag xmlns:ma14="http://schemas.microsoft.com/office/mac/drawingml/2011/main" val="0"/>
-            </a:ext>
-          </a:extLst>
-        </p:spPr>
-        <p:txBody>
-          <a:bodyPr/>
-          <a:lstStyle>
-            <a:lvl1pPr>
-              <a:defRPr sz="1000">
-                <a:solidFill>
-                  <a:srgbClr val="5B6B7A"/>
-                </a:solidFill>
-              </a:defRPr>
-            </a:lvl1pPr>
-          </a:lstStyle>
-          <a:p>
-            <a:pPr algn="l"/>
-            <a:fld id="{F7021451-1387-4CA6-816F-3879F97B5CBC}" type="slidenum">
-              <a:rPr b="0" lang="en-US"/>
-              <a:t>8</a:t>
-            </a:fld>
-            <a:endParaRPr lang="en-US"/>
           </a:p>
         </p:txBody>
       </p:sp>
@@ -7470,7 +6984,7 @@
             <a:r>
               <a:rPr lang="en-US" sz="2800" b="1" dirty="0">
                 <a:solidFill>
-                  <a:srgbClr val="1E3A5F"/>
+                  <a:srgbClr val="000000"/>
                 </a:solidFill>
               </a:rPr>
               <a:t>Backup: the key covariate holds within every onset type, and a which-drug-for-whom reading</a:t>
@@ -7520,7 +7034,7 @@
                       <a:r>
                         <a:rPr lang="en-US" sz="1300" b="1" dirty="0">
                           <a:solidFill>
-                            <a:srgbClr val="1E3A5F"/>
+                            <a:srgbClr val="000000"/>
                           </a:solidFill>
                         </a:rPr>
                         <a:t>Arm, key covariate</a:t>
@@ -7566,7 +7080,7 @@
                       <a:tailEnd type="none" w="med" len="med"/>
                     </a:lnB>
                     <a:solidFill>
-                      <a:srgbClr val="EEF2F6"/>
+                      <a:srgbClr val="F2F2F2"/>
                     </a:solidFill>
                   </a:tcPr>
                 </a:tc>
@@ -7581,7 +7095,7 @@
                       <a:r>
                         <a:rPr lang="en-US" sz="1300" b="1" dirty="0">
                           <a:solidFill>
-                            <a:srgbClr val="1E3A5F"/>
+                            <a:srgbClr val="000000"/>
                           </a:solidFill>
                         </a:rPr>
                         <a:t>Adult onset</a:t>
@@ -7627,7 +7141,7 @@
                       <a:tailEnd type="none" w="med" len="med"/>
                     </a:lnB>
                     <a:solidFill>
-                      <a:srgbClr val="EEF2F6"/>
+                      <a:srgbClr val="F2F2F2"/>
                     </a:solidFill>
                   </a:tcPr>
                 </a:tc>
@@ -7642,7 +7156,7 @@
                       <a:r>
                         <a:rPr lang="en-US" sz="1300" b="1" dirty="0">
                           <a:solidFill>
-                            <a:srgbClr val="1E3A5F"/>
+                            <a:srgbClr val="000000"/>
                           </a:solidFill>
                         </a:rPr>
                         <a:t>Juvenile onset</a:t>
@@ -7688,7 +7202,7 @@
                       <a:tailEnd type="none" w="med" len="med"/>
                     </a:lnB>
                     <a:solidFill>
-                      <a:srgbClr val="EEF2F6"/>
+                      <a:srgbClr val="F2F2F2"/>
                     </a:solidFill>
                   </a:tcPr>
                 </a:tc>
@@ -7703,7 +7217,7 @@
                       <a:r>
                         <a:rPr lang="en-US" sz="1300" b="1" dirty="0">
                           <a:solidFill>
-                            <a:srgbClr val="1E3A5F"/>
+                            <a:srgbClr val="000000"/>
                           </a:solidFill>
                         </a:rPr>
                         <a:t>Late onset</a:t>
@@ -7749,7 +7263,7 @@
                       <a:tailEnd type="none" w="med" len="med"/>
                     </a:lnB>
                     <a:solidFill>
-                      <a:srgbClr val="EEF2F6"/>
+                      <a:srgbClr val="F2F2F2"/>
                     </a:solidFill>
                   </a:tcPr>
                 </a:tc>
@@ -7764,7 +7278,7 @@
                       <a:r>
                         <a:rPr lang="en-US" sz="1300" b="1" dirty="0">
                           <a:solidFill>
-                            <a:srgbClr val="1E3A5F"/>
+                            <a:srgbClr val="000000"/>
                           </a:solidFill>
                         </a:rPr>
                         <a:t>Interaction p</a:t>
@@ -7810,7 +7324,7 @@
                       <a:tailEnd type="none" w="med" len="med"/>
                     </a:lnB>
                     <a:solidFill>
-                      <a:srgbClr val="EEF2F6"/>
+                      <a:srgbClr val="F2F2F2"/>
                     </a:solidFill>
                   </a:tcPr>
                 </a:tc>
@@ -8758,7 +8272,7 @@
             <a:r>
               <a:rPr lang="en-US" sz="1600" b="1" dirty="0">
                 <a:solidFill>
-                  <a:srgbClr val="1E3A5F"/>
+                  <a:srgbClr val="000000"/>
                 </a:solidFill>
               </a:rPr>
               <a:t>Which drug for whom (exploratory)</a:t>
@@ -8840,51 +8354,6 @@
               <a:t>The data dictionary says arm assignment was weighted by patient fit; actual arm matches predicted best drug for 41% of patients against 33% by chance, so the weighting was mild</a:t>
             </a:r>
             <a:endParaRPr lang="en-US" sz="1400" dirty="0"/>
-          </a:p>
-        </p:txBody>
-      </p:sp>
-      <p:sp>
-        <p:nvSpPr>
-          <p:cNvPr id="25" name="Slide Number Placeholder 0"/>
-          <p:cNvSpPr>
-            <a:spLocks noGrp="1"/>
-          </p:cNvSpPr>
-          <p:nvPr>
-            <p:ph type="sldNum" sz="quarter" idx="4294967295"/>
-          </p:nvPr>
-        </p:nvSpPr>
-        <p:spPr>
-          <a:xfrm>
-            <a:off x="11247120" y="6400800"/>
-            <a:ext cx="457200" cy="274320"/>
-          </a:xfrm>
-          <a:prstGeom prst="rect">
-            <a:avLst/>
-          </a:prstGeom>
-          <a:extLst>
-            <a:ext uri="{C572A759-6A51-4108-AA02-DFA0A04FC94B}">
-              <ma14:wrappingTextBoxFlag xmlns:ma14="http://schemas.microsoft.com/office/mac/drawingml/2011/main" val="0"/>
-            </a:ext>
-          </a:extLst>
-        </p:spPr>
-        <p:txBody>
-          <a:bodyPr/>
-          <a:lstStyle>
-            <a:lvl1pPr>
-              <a:defRPr sz="1000">
-                <a:solidFill>
-                  <a:srgbClr val="5B6B7A"/>
-                </a:solidFill>
-              </a:defRPr>
-            </a:lvl1pPr>
-          </a:lstStyle>
-          <a:p>
-            <a:pPr algn="l"/>
-            <a:fld id="{F7021451-1387-4CA6-816F-3879F97B5CBC}" type="slidenum">
-              <a:rPr b="0" lang="en-US"/>
-              <a:t>9</a:t>
-            </a:fld>
-            <a:endParaRPr lang="en-US"/>
           </a:p>
         </p:txBody>
       </p:sp>

</xml_diff>

<commit_message>
Deck: plain-English header on slide 5 (tree models win because the effect is a step)
Co-Authored-By: Claude Fable 5.1 <noreply@anthropic.com>
</commit_message>
<xml_diff>
--- a/slides/Team1_DM1_slides.pptx
+++ b/slides/Team1_DM1_slides.pptx
@@ -116,7 +116,7 @@
   <p:extLst>
     <p:ext uri="{521415D9-36F7-43E2-AB2F-B90AF26B5E84}">
       <p14:sectionLst xmlns:p14="http://schemas.microsoft.com/office/powerpoint/2010/main">
-        <p14:section name="Talk" id="{3c5c73da-cd38-0d23-6e71-e1a7e0b194c9}">
+        <p14:section name="Talk" id="{726a10da-bdb4-3ff5-9673-b6dbd2433436}">
           <p14:sldIdLst>
             <p14:sldId id="256"/>
             <p14:sldId id="257"/>
@@ -126,7 +126,7 @@
             <p14:sldId id="261"/>
           </p14:sldIdLst>
         </p14:section>
-        <p14:section name="Backup" id="{83da949f-0596-6652-3048-24e8fb0aa7ba}">
+        <p14:section name="Backup" id="{c3cf27c8-4da4-2385-a9c5-ecc6b3d43b3c}">
           <p14:sldIdLst>
             <p14:sldId id="262"/>
             <p14:sldId id="263"/>
@@ -5124,7 +5124,7 @@
                   <a:srgbClr val="D95F0E"/>
                 </a:solidFill>
               </a:rPr>
-              <a:t>Tideglusib: trees, for a reason</a:t>
+              <a:t>Tideglusib: tree models win, because the effect is a step</a:t>
             </a:r>
             <a:endParaRPr lang="en-US" sz="1400" dirty="0"/>
           </a:p>
@@ -5160,7 +5160,7 @@
                   <a:srgbClr val="1F2933"/>
                 </a:solidFill>
               </a:rPr>
-              <a:t>Trees 0.55 vs straight lines 0.24 to 0.30, on 19 of 20 splits. Give the linear model one cut-off and it reaches 0.45. Tuned XGBoost chose one-question trees: no interactions.</a:t>
+              <a:t>Random forest and XGBoost 0.55 vs straight lines 0.24 to 0.30, on 19 of 20 splits. Give the linear model one cut-off and it reaches 0.45. Tuned XGBoost chose one-question trees: no interactions.</a:t>
             </a:r>
             <a:endParaRPr lang="en-US" sz="1150" dirty="0"/>
           </a:p>

</xml_diff>

<commit_message>
Deck: wording revised for a pharmacometrics audience
Co-Authored-By: Claude Fable 5.1 <noreply@anthropic.com>
</commit_message>
<xml_diff>
--- a/slides/Team1_DM1_slides.pptx
+++ b/slides/Team1_DM1_slides.pptx
@@ -116,7 +116,7 @@
   <p:extLst>
     <p:ext uri="{521415D9-36F7-43E2-AB2F-B90AF26B5E84}">
       <p14:sectionLst xmlns:p14="http://schemas.microsoft.com/office/powerpoint/2010/main">
-        <p14:section name="Talk" id="{726a10da-bdb4-3ff5-9673-b6dbd2433436}">
+        <p14:section name="Talk" id="{f4ba123e-a822-f7df-0a71-7f8aac630db1}">
           <p14:sldIdLst>
             <p14:sldId id="256"/>
             <p14:sldId id="257"/>
@@ -126,7 +126,7 @@
             <p14:sldId id="261"/>
           </p14:sldIdLst>
         </p14:section>
-        <p14:section name="Backup" id="{c3cf27c8-4da4-2385-a9c5-ecc6b3d43b3c}">
+        <p14:section name="Backup" id="{46597664-70fb-f201-57ba-708c91709204}">
           <p14:sldIdLst>
             <p14:sldId id="262"/>
             <p14:sldId id="263"/>
@@ -1956,7 +1956,7 @@
                   <a:srgbClr val="404040"/>
                 </a:solidFill>
               </a:rPr>
-              <a:t>Covariate models and machine learning for patient stratification in myotonic dystrophy type 1</a:t>
+              <a:t>Covariate modelling versus machine learning for treatment-response stratification in myotonic dystrophy type 1</a:t>
             </a:r>
             <a:endParaRPr lang="en-US" sz="1800" dirty="0"/>
           </a:p>
@@ -2330,7 +2330,7 @@
                   <a:srgbClr val="000000"/>
                 </a:solidFill>
               </a:rPr>
-              <a:t>Each drug has one baseline predictor, and it is the measurement nearest to where the drug acts</a:t>
+              <a:t>Each arm has a single dominant baseline predictor, and it is the measure closest to the drug's site of action</a:t>
             </a:r>
             <a:endParaRPr lang="en-US" sz="2800" dirty="0"/>
           </a:p>
@@ -2441,7 +2441,7 @@
                             <a:srgbClr val="000000"/>
                           </a:solidFill>
                         </a:rPr>
-                        <a:t>Acts on</a:t>
+                        <a:t>Site of action</a:t>
                       </a:r>
                       <a:endParaRPr lang="en-US" sz="1300" dirty="0"/>
                     </a:p>
@@ -2502,7 +2502,7 @@
                             <a:srgbClr val="000000"/>
                           </a:solidFill>
                         </a:rPr>
-                        <a:t>Main predictor</a:t>
+                        <a:t>Dominant predictor</a:t>
                       </a:r>
                       <a:endParaRPr lang="en-US" sz="1300" dirty="0"/>
                     </a:p>
@@ -2563,7 +2563,7 @@
                             <a:srgbClr val="000000"/>
                           </a:solidFill>
                         </a:rPr>
-                        <a:t>Held-out responders, high vs low</a:t>
+                        <a:t>Responder rate in the held-out test set, above vs below cut-off</a:t>
                       </a:r>
                       <a:endParaRPr lang="en-US" sz="1300" dirty="0"/>
                     </a:p>
@@ -2624,7 +2624,7 @@
                             <a:srgbClr val="000000"/>
                           </a:solidFill>
                         </a:rPr>
-                        <a:t>Evidence</a:t>
+                        <a:t>Selection evidence</a:t>
                       </a:r>
                       <a:endParaRPr lang="en-US" sz="1300" dirty="0"/>
                     </a:p>
@@ -2745,7 +2745,7 @@
                             <a:srgbClr val="1F2933"/>
                           </a:solidFill>
                         </a:rPr>
-                        <a:t>The symptom: muscle over-excitability</a:t>
+                        <a:t>Symptomatic: muscle sodium channel</a:t>
                       </a:r>
                       <a:endParaRPr lang="en-US" sz="1300" dirty="0"/>
                     </a:p>
@@ -2919,7 +2919,7 @@
                             <a:srgbClr val="1F2933"/>
                           </a:solidFill>
                         </a:rPr>
-                        <a:t>5 of 5 methods, stable in 100% of 200 resamples</a:t>
+                        <a:t>Selected by 5 of 5 methods; retained in 100% of 200 bootstrap resamples</a:t>
                       </a:r>
                       <a:endParaRPr lang="en-US" sz="1300" dirty="0"/>
                     </a:p>
@@ -3037,7 +3037,7 @@
                             <a:srgbClr val="1F2933"/>
                           </a:solidFill>
                         </a:rPr>
-                        <a:t>The cause: toxic DMPK RNA</a:t>
+                        <a:t>Disease-modifying: toxic DMPK transcript</a:t>
                       </a:r>
                       <a:endParaRPr lang="en-US" sz="1300" dirty="0"/>
                     </a:p>
@@ -3211,7 +3211,7 @@
                             <a:srgbClr val="1F2933"/>
                           </a:solidFill>
                         </a:rPr>
-                        <a:t>5 of 5 methods, 90% stable</a:t>
+                        <a:t>5 of 5 methods; 90% of resamples</a:t>
                       </a:r>
                       <a:endParaRPr lang="en-US" sz="1300" dirty="0"/>
                     </a:p>
@@ -3329,7 +3329,7 @@
                             <a:srgbClr val="1F2933"/>
                           </a:solidFill>
                         </a:rPr>
-                        <a:t>Several organs, including brain</a:t>
+                        <a:t>Multisystem: GSK3β signalling, including CNS</a:t>
                       </a:r>
                       <a:endParaRPr lang="en-US" sz="1300" dirty="0"/>
                     </a:p>
@@ -3503,7 +3503,7 @@
                             <a:srgbClr val="1F2933"/>
                           </a:solidFill>
                         </a:rPr>
-                        <a:t>5 of 5 methods, 100% stable; a step at about -0.5</a:t>
+                        <a:t>5 of 5 methods; 100% of resamples; threshold effect near z = -0.5</a:t>
                       </a:r>
                       <a:endParaRPr lang="en-US" sz="1300" dirty="0"/>
                     </a:p>
@@ -3609,7 +3609,7 @@
                   <a:srgbClr val="1F2933"/>
                 </a:solidFill>
               </a:rPr>
-              <a:t>Machine learning found no new predictors. </a:t>
+              <a:t>Machine learning identified no additional predictors. </a:t>
             </a:r>
             <a:pPr indent="0" marL="0">
               <a:buNone/>
@@ -3620,7 +3620,7 @@
                   <a:srgbClr val="1F2933"/>
                 </a:solidFill>
               </a:rPr>
-              <a:t>Random forest and XGBoost chose the same leaders; they predicted better in one arm only, because of a threshold that a one-cut-off linear model recovers. </a:t>
+              <a:t>Random forest and XGBoost ranked the same covariates first in every arm and outperformed linear models in one arm only, where the effect is a threshold; a linear model with that single threshold recovers most of the gap. </a:t>
             </a:r>
             <a:pPr indent="0" marL="0">
               <a:buNone/>
@@ -3631,7 +3631,7 @@
                   <a:srgbClr val="1F2933"/>
                 </a:solidFill>
               </a:rPr>
-              <a:t>A planted column of random numbers was never selected.</a:t>
+              <a:t>A simulated pure-noise covariate, included as a negative control, was never selected.</a:t>
             </a:r>
             <a:endParaRPr lang="en-US" sz="1600" dirty="0"/>
           </a:p>
@@ -3701,7 +3701,7 @@
                   <a:srgbClr val="000000"/>
                 </a:solidFill>
               </a:rPr>
-              <a:t>Three drugs act at three different links of the same chain, so each arm is analysed on its own</a:t>
+              <a:t>The three drugs act at different points of the DM1 pathogenic cascade, so each arm was analysed separately</a:t>
             </a:r>
             <a:endParaRPr lang="en-US" sz="2800" dirty="0"/>
           </a:p>
@@ -3852,7 +3852,7 @@
                   <a:srgbClr val="FFFFFF"/>
                 </a:solidFill>
               </a:rPr>
-              <a:t>Toxic CUG RNA</a:t>
+              <a:t>Toxic CUG-repeat RNA</a:t>
             </a:r>
             <a:endParaRPr lang="en-US" sz="1250" dirty="0"/>
           </a:p>
@@ -3913,7 +3913,7 @@
                   <a:srgbClr val="D95F0E"/>
                 </a:solidFill>
               </a:rPr>
-              <a:t>Antisense oligonucleotide degrades the RNA</a:t>
+              <a:t>Antisense oligonucleotide: DMPK transcript knockdown</a:t>
             </a:r>
             <a:endParaRPr lang="en-US" sz="1150" dirty="0"/>
           </a:p>
@@ -3976,7 +3976,7 @@
                   <a:srgbClr val="FFFFFF"/>
                 </a:solidFill>
               </a:rPr>
-              <a:t>MBNL1 trapped, GSK3β up: mis-splicing</a:t>
+              <a:t>MBNL1 sequestration, GSK3β activation: mis-splicing</a:t>
             </a:r>
             <a:endParaRPr lang="en-US" sz="1250" dirty="0"/>
           </a:p>
@@ -4037,7 +4037,7 @@
                   <a:srgbClr val="D95F0E"/>
                 </a:solidFill>
               </a:rPr>
-              <a:t>Tideglusib inhibits GSK3β</a:t>
+              <a:t>Tideglusib: GSK3β inhibition</a:t>
             </a:r>
             <a:endParaRPr lang="en-US" sz="1150" dirty="0"/>
           </a:p>
@@ -4100,7 +4100,7 @@
                   <a:srgbClr val="FFFFFF"/>
                 </a:solidFill>
               </a:rPr>
-              <a:t>Organ damage: muscle, brain, heart, eye</a:t>
+              <a:t>Multisystem involvement: muscle, CNS, heart, eye</a:t>
             </a:r>
             <a:endParaRPr lang="en-US" sz="1250" dirty="0"/>
           </a:p>
@@ -4188,7 +4188,7 @@
                   <a:srgbClr val="FFFFFF"/>
                 </a:solidFill>
               </a:rPr>
-              <a:t>Symptoms: myotonia, weakness</a:t>
+              <a:t>Clinical phenotype: myotonia, weakness</a:t>
             </a:r>
             <a:endParaRPr lang="en-US" sz="1250" dirty="0"/>
           </a:p>
@@ -4224,7 +4224,7 @@
                   <a:srgbClr val="D95F0E"/>
                 </a:solidFill>
               </a:rPr>
-              <a:t>Mexiletine damps muscle excitability</a:t>
+              <a:t>Mexiletine: sodium-channel blockade</a:t>
             </a:r>
             <a:endParaRPr lang="en-US" sz="1150" dirty="0"/>
           </a:p>
@@ -4260,7 +4260,7 @@
                   <a:srgbClr val="000000"/>
                 </a:solidFill>
               </a:rPr>
-              <a:t>The data</a:t>
+              <a:t>Dataset</a:t>
             </a:r>
             <a:endParaRPr lang="en-US" sz="1600" dirty="0"/>
           </a:p>
@@ -4300,7 +4300,7 @@
                   <a:srgbClr val="1F2933"/>
                 </a:solidFill>
               </a:rPr>
-              <a:t>500 simulated patients, one drug each: 161 / 170 / 169 per arm, 29% / 41% / 48% responders</a:t>
+              <a:t>500 simulated patients, one treatment each: n = 161 / 170 / 169; responder rate 29% / 41% / 48%</a:t>
             </a:r>
             <a:endParaRPr lang="en-US" sz="1400" dirty="0"/>
           </a:p>
@@ -4318,7 +4318,7 @@
                   <a:srgbClr val="1F2933"/>
                 </a:solidFill>
               </a:rPr>
-              <a:t>18 baseline covariates across genetics, disease course, muscle, brain, heart, eye, metabolism and background; some are noise by design</a:t>
+              <a:t>18 baseline covariates: genetic burden, disease stage, muscle, CNS, cardiac, ophthalmic, metabolic and demographic; some are noise by design</a:t>
             </a:r>
             <a:endParaRPr lang="en-US" sz="1400" dirty="0"/>
           </a:p>
@@ -4336,7 +4336,7 @@
                   <a:srgbClr val="1F2933"/>
                 </a:solidFill>
               </a:rPr>
-              <a:t>Cleaning: no missing values, but albumin was one filled-in value for every mexiletine patient, so it is dropped in that arm. CK floor at 50 and mosaicism at 0 kept as is. No patient removed</a:t>
+              <a:t>Data review: no missing values; albumin is a single imputed constant in the mexiletine arm and was excluded there. CK floor at 50 U/L and mosaicism index of 0 retained as observed. No patients excluded</a:t>
             </a:r>
             <a:endParaRPr lang="en-US" sz="1400" dirty="0"/>
           </a:p>
@@ -4372,7 +4372,7 @@
                   <a:srgbClr val="000000"/>
                 </a:solidFill>
               </a:rPr>
-              <a:t>How we analysed each arm</a:t>
+              <a:t>Analysis workflow, per arm</a:t>
             </a:r>
             <a:endParaRPr lang="en-US" sz="1600" dirty="0"/>
           </a:p>
@@ -4412,7 +4412,7 @@
                   <a:srgbClr val="1F2933"/>
                 </a:solidFill>
               </a:rPr>
-              <a:t>Split first: 75 / 25, balanced on responder status and onset type, fixed seed; the test set is scored once</a:t>
+              <a:t>75/25 train/test split stratified by responder status and onset phenotype, fixed seed; test set evaluated once</a:t>
             </a:r>
             <a:endParaRPr lang="en-US" sz="1400" dirty="0"/>
           </a:p>
@@ -4430,7 +4430,7 @@
                   <a:srgbClr val="1F2933"/>
                 </a:solidFill>
               </a:rPr>
-              <a:t>Every choice by 5-fold cross-validation inside the training set</a:t>
+              <a:t>All model selection and tuning by 5-fold cross-validation within the training set</a:t>
             </a:r>
             <a:endParaRPr lang="en-US" sz="1400" dirty="0"/>
           </a:p>
@@ -4448,7 +4448,7 @@
                   <a:srgbClr val="1F2933"/>
                 </a:solidFill>
               </a:rPr>
-              <a:t>Covariate models: stepwise (BIC), LASSO, elastic net.  ML: random forest, XGBoost tuned and untuned</a:t>
+              <a:t>Covariate models: stepwise selection (BIC), LASSO, elastic net. Machine learning: random forest, XGBoost (untuned and tuned)</a:t>
             </a:r>
             <a:endParaRPr lang="en-US" sz="1400" dirty="0"/>
           </a:p>
@@ -4466,7 +4466,7 @@
                   <a:srgbClr val="1F2933"/>
                 </a:solidFill>
               </a:rPr>
-              <a:t>Noise control: a random-number column added as a covariate, 200 bootstrap resamples for stability, and a vote across the five methods</a:t>
+              <a:t>Noise control: a pure-noise covariate as negative control, selection stability over 200 bootstrap resamples, and agreement across the five methods</a:t>
             </a:r>
             <a:endParaRPr lang="en-US" sz="1400" dirty="0"/>
           </a:p>
@@ -4536,7 +4536,7 @@
                   <a:srgbClr val="000000"/>
                 </a:solidFill>
               </a:rPr>
-              <a:t>Across the covariate range, response moves from about 15% to about 80%, and onset type adds little</a:t>
+              <a:t>Across the range of the dominant covariate, predicted response spans roughly 15% to 85%; onset phenotype adds little</a:t>
             </a:r>
             <a:endParaRPr lang="en-US" sz="2800" dirty="0"/>
           </a:p>
@@ -4632,7 +4632,7 @@
                   <a:srgbClr val="1F2933"/>
                 </a:solidFill>
               </a:rPr>
-              <a:t>Response 17% → 38% from the 10th to the 90th percentile. A symptomatic drug: the effect scales with the symptom present. Late onset lower, because there is little myotonia to treat.</a:t>
+              <a:t>Predicted response 17% → 38% from the 10th to the 90th percentile. A symptomatic agent: effect size scales with baseline symptom burden. Late-onset patients respond less because baseline myotonia is mild.</a:t>
             </a:r>
             <a:endParaRPr lang="en-US" sz="1300" dirty="0"/>
           </a:p>
@@ -4704,7 +4704,7 @@
                   <a:srgbClr val="1F2933"/>
                 </a:solidFill>
               </a:rPr>
-              <a:t>Response 22% → 75%. The only predictor. A target-engagement drug: the effect scales with the substrate. Individual prediction stays weak (R² under 0.1).</a:t>
+              <a:t>Predicted response 22% → 75%. The sole predictor. A target-engaging agent: effect scales with the amount of target transcript. Individual-level prediction remains poor (test R² &lt; 0.1).</a:t>
             </a:r>
             <a:endParaRPr lang="en-US" sz="1300" dirty="0"/>
           </a:p>
@@ -4776,7 +4776,7 @@
                   <a:srgbClr val="1F2933"/>
                 </a:solidFill>
               </a:rPr>
-              <a:t>Response 87% → 14%, as a step at about -0.5 rather than a slope. A composite endpoint with a cognitive part: normal cognition has no room to improve.</a:t>
+              <a:t>Predicted response 87% → 14%, as a threshold near z = -0.5 rather than a gradient. The composite endpoint includes a cognitive domain, so intact cognition leaves no room for measurable gain: a ceiling effect.</a:t>
             </a:r>
             <a:endParaRPr lang="en-US" sz="1300" dirty="0"/>
           </a:p>
@@ -4839,7 +4839,7 @@
                   <a:srgbClr val="1F2933"/>
                 </a:solidFill>
               </a:rPr>
-              <a:t>Replicated three times. </a:t>
+              <a:t>Independently replicated. </a:t>
             </a:r>
             <a:pPr indent="0" marL="0">
               <a:buNone/>
@@ -4850,7 +4850,7 @@
                   <a:srgbClr val="1F2933"/>
                 </a:solidFill>
               </a:rPr>
-              <a:t>Three team members, three codebases (R, R, Python), three different splits, up to 30 methods and 20 repeated splits: the same three covariates every time. CTG repeats also trends the same way in the third arm; cognition matters in one arm only.</a:t>
+              <a:t>Three team members, three implementations (R, R, Python), different splits, up to 30 methods and 20 repeated splits identified the same three covariates. CTG repeat length behaves as a prognostic marker across arms; cognitive function is specific to the tideglusib arm.</a:t>
             </a:r>
             <a:endParaRPr lang="en-US" sz="1250" dirty="0"/>
           </a:p>
@@ -4920,7 +4920,7 @@
                   <a:srgbClr val="000000"/>
                 </a:solidFill>
               </a:rPr>
-              <a:t>Simple models tie machine learning in two arms; trees win the third only because the effect is a step</a:t>
+              <a:t>Covariate models match machine learning in two arms; tree ensembles lead in the third only because the effect is a threshold</a:t>
             </a:r>
             <a:endParaRPr lang="en-US" sz="2800" dirty="0"/>
           </a:p>
@@ -4980,7 +4980,7 @@
                   <a:srgbClr val="000000"/>
                 </a:solidFill>
               </a:rPr>
-              <a:t>Mexiletine: a tie</a:t>
+              <a:t>Mexiletine: equivalent</a:t>
             </a:r>
             <a:endParaRPr lang="en-US" sz="1400" dirty="0"/>
           </a:p>
@@ -5016,7 +5016,7 @@
                   <a:srgbClr val="1F2933"/>
                 </a:solidFill>
               </a:rPr>
-              <a:t>Every method 0.47 to 0.54 on the test set; across 20 repeated splits, first place changes hands between stepwise and XGBoost.</a:t>
+              <a:t>Test R² 0.47 to 0.54 for every method; across 20 repeated splits the top rank alternates between stepwise selection and tuned XGBoost.</a:t>
             </a:r>
             <a:endParaRPr lang="en-US" sz="1150" dirty="0"/>
           </a:p>
@@ -5052,7 +5052,7 @@
                   <a:srgbClr val="000000"/>
                 </a:solidFill>
               </a:rPr>
-              <a:t>Oligonucleotide: nobody</a:t>
+              <a:t>Oligonucleotide: low predictability</a:t>
             </a:r>
             <a:endParaRPr lang="en-US" sz="1400" dirty="0"/>
           </a:p>
@@ -5088,7 +5088,7 @@
                   <a:srgbClr val="1F2933"/>
                 </a:solidFill>
               </a:rPr>
-              <a:t>R² under 0.1 for every method, on every split. The repeat-length effect is real but patients with the same repeats differ a lot.</a:t>
+              <a:t>Test R² &lt; 0.1 for every method on every split. The repeat-length effect is consistent, but residual between-patient variability dominates.</a:t>
             </a:r>
             <a:endParaRPr lang="en-US" sz="1150" dirty="0"/>
           </a:p>
@@ -5124,7 +5124,7 @@
                   <a:srgbClr val="D95F0E"/>
                 </a:solidFill>
               </a:rPr>
-              <a:t>Tideglusib: tree models win, because the effect is a step</a:t>
+              <a:t>Tideglusib: tree ensembles lead, because of a threshold</a:t>
             </a:r>
             <a:endParaRPr lang="en-US" sz="1400" dirty="0"/>
           </a:p>
@@ -5160,7 +5160,7 @@
                   <a:srgbClr val="1F2933"/>
                 </a:solidFill>
               </a:rPr>
-              <a:t>Random forest and XGBoost 0.55 vs straight lines 0.24 to 0.30, on 19 of 20 splits. Give the linear model one cut-off and it reaches 0.45. Tuned XGBoost chose one-question trees: no interactions.</a:t>
+              <a:t>Random forest and XGBoost R² 0.55 vs linear 0.24 to 0.30, on 19 of 20 splits. A linear model with a single threshold on cognition reaches 0.45. Tuned XGBoost selected depth-1 trees: no interactions.</a:t>
             </a:r>
             <a:endParaRPr lang="en-US" sz="1150" dirty="0"/>
           </a:p>
@@ -5230,7 +5230,7 @@
                   <a:srgbClr val="000000"/>
                 </a:solidFill>
               </a:rPr>
-              <a:t>Measure the organ the drug acts on: one routine test per drug separates response groups 2- to 7-fold</a:t>
+              <a:t>Stratify on the measure closest to the drug's target: one routine baseline assessment per arm separates response rates two- to seven-fold</a:t>
             </a:r>
             <a:endParaRPr lang="en-US" sz="2800" dirty="0"/>
           </a:p>
@@ -5280,7 +5280,7 @@
                             <a:srgbClr val="000000"/>
                           </a:solidFill>
                         </a:rPr>
-                        <a:t>Before giving</a:t>
+                        <a:t>Treatment</a:t>
                       </a:r>
                       <a:endParaRPr lang="en-US" sz="1300" dirty="0"/>
                     </a:p>
@@ -5341,7 +5341,7 @@
                             <a:srgbClr val="000000"/>
                           </a:solidFill>
                         </a:rPr>
-                        <a:t>Measure</a:t>
+                        <a:t>Baseline measure</a:t>
                       </a:r>
                       <a:endParaRPr lang="en-US" sz="1300" dirty="0"/>
                     </a:p>
@@ -5402,7 +5402,7 @@
                             <a:srgbClr val="000000"/>
                           </a:solidFill>
                         </a:rPr>
-                        <a:t>Rule from a training-set tree</a:t>
+                        <a:t>Cut-off (training-set tree)</a:t>
                       </a:r>
                       <a:endParaRPr lang="en-US" sz="1300" dirty="0"/>
                     </a:p>
@@ -5463,7 +5463,7 @@
                             <a:srgbClr val="000000"/>
                           </a:solidFill>
                         </a:rPr>
-                        <a:t>Held-out responders</a:t>
+                        <a:t>Held-out responder rate</a:t>
                       </a:r>
                       <a:endParaRPr lang="en-US" sz="1300" dirty="0"/>
                     </a:p>
@@ -5819,7 +5819,7 @@
                             <a:srgbClr val="1F2933"/>
                           </a:solidFill>
                         </a:rPr>
-                        <a:t>Enrol by baseline myotonia, not by diagnosis; mild patients dilute the effect</a:t>
+                        <a:t>Enrol on baseline myotonia severity rather than diagnosis alone; mild cases dilute the treatment effect</a:t>
                       </a:r>
                       <a:endParaRPr lang="en-US" sz="1300" dirty="0"/>
                     </a:p>
@@ -6111,7 +6111,7 @@
                             <a:srgbClr val="1F2933"/>
                           </a:solidFill>
                         </a:rPr>
-                        <a:t>Stratify randomisation by repeat length; it is prognostic</a:t>
+                        <a:t>Stratify randomisation on CTG repeat length, a prognostic factor</a:t>
                       </a:r>
                       <a:endParaRPr lang="en-US" sz="1300" dirty="0"/>
                     </a:p>
@@ -6403,7 +6403,7 @@
                             <a:srgbClr val="1F2933"/>
                           </a:solidFill>
                         </a:rPr>
-                        <a:t>Enrich for impaired cognition: expected response 48% → 74%, a smaller trial</a:t>
+                        <a:t>Enrich for cognitive impairment: expected responder rate 48% → 74%, reducing required sample size</a:t>
                       </a:r>
                       <a:endParaRPr lang="en-US" sz="1300" dirty="0"/>
                     </a:p>
@@ -6482,7 +6482,7 @@
                   <a:srgbClr val="000000"/>
                 </a:solidFill>
               </a:rPr>
-              <a:t>Limits we state</a:t>
+              <a:t>Limitations</a:t>
             </a:r>
             <a:endParaRPr lang="en-US" sz="1600" dirty="0"/>
           </a:p>
@@ -6522,7 +6522,7 @@
                   <a:srgbClr val="1F2933"/>
                 </a:solidFill>
               </a:rPr>
-              <a:t>No placebo arm: this is who does well on the drug, not who the drug helps</a:t>
+              <a:t>No placebo arm: predictors are prognostic within treated patients, not demonstrated effect modifiers</a:t>
             </a:r>
             <a:endParaRPr lang="en-US" sz="1400" dirty="0"/>
           </a:p>
@@ -6540,7 +6540,7 @@
                   <a:srgbClr val="1F2933"/>
                 </a:solidFill>
               </a:rPr>
-              <a:t>About 41 test patients per arm: cut-offs are "about", and we do not rank methods inside an arm</a:t>
+              <a:t>About 41 test patients per arm: cut-offs are approximate, and methods are not ranked within an arm</a:t>
             </a:r>
             <a:endParaRPr lang="en-US" sz="1400" dirty="0"/>
           </a:p>
@@ -6558,7 +6558,7 @@
                   <a:srgbClr val="1F2933"/>
                 </a:solidFill>
               </a:rPr>
-              <a:t>One time point per patient. Next step: a disease-progression model on repeated measures, with these covariates on progression rate and drug effect</a:t>
+              <a:t>Cross-sectional endpoint. Next step: a longitudinal disease-progression model with these covariates on progression rate and drug effect</a:t>
             </a:r>
             <a:endParaRPr lang="en-US" sz="1400" dirty="0"/>
           </a:p>
@@ -6594,7 +6594,7 @@
                   <a:srgbClr val="000000"/>
                 </a:solidFill>
               </a:rPr>
-              <a:t>AI use, disclosed</a:t>
+              <a:t>AI disclosure</a:t>
             </a:r>
             <a:endParaRPr lang="en-US" sz="1600" dirty="0"/>
           </a:p>
@@ -6657,7 +6657,7 @@
                   <a:srgbClr val="1F2933"/>
                 </a:solidFill>
               </a:rPr>
-              <a:t>Claude (Anthropic) through Claude Code, and Codex, drafted code, documentation and this deck; noted in the code headers and in AI_DISCLOSURE.md. Every analysis choice and every interpretation was reviewed by the team, which is accountable for all of it.</a:t>
+              <a:t>Claude (Anthropic, via Claude Code) and Codex were used to draft code, documentation and this deck, as noted in the code headers and AI_DISCLOSURE.md. All analysis decisions and interpretations were reviewed by the team, which is accountable for the results.</a:t>
             </a:r>
             <a:endParaRPr lang="en-US" sz="1250" dirty="0"/>
           </a:p>
@@ -6727,7 +6727,7 @@
                   <a:srgbClr val="000000"/>
                 </a:solidFill>
               </a:rPr>
-              <a:t>Backup: the pattern holds across 20 different train/test splits</a:t>
+              <a:t>Backup: results are robust to the train/test split (20 seeds)</a:t>
             </a:r>
             <a:endParaRPr lang="en-US" sz="2800" dirty="0"/>
           </a:p>
@@ -6787,7 +6787,7 @@
                   <a:srgbClr val="5B6B7A"/>
                 </a:solidFill>
               </a:rPr>
-              <a:t>Test-set R², continuous outcome, 20 seeds. Mexiletine: all methods tie (median about 0.6). Oligonucleotide: all weak (medians 0.06 to 0.12). Tideglusib: a tree model ranked first on 19 of 20 splits; a linear model never did. Absolute R² moves by up to 0.15 between test sets, which is why we report ranges.</a:t>
+              <a:t>Test-set R², continuous endpoint, 20 random splits. Mexiletine: methods equivalent (median ≈ 0.6). Oligonucleotide: all methods weak (medians 0.06 to 0.12). Tideglusib: a tree ensemble ranked first in 19 of 20 splits; a linear model never did. Absolute R² varies by up to 0.15 between splits, hence ranges rather than point estimates.</a:t>
             </a:r>
             <a:endParaRPr lang="en-US" sz="1150" dirty="0"/>
           </a:p>
@@ -6857,7 +6857,7 @@
                   <a:srgbClr val="000000"/>
                 </a:solidFill>
               </a:rPr>
-              <a:t>Backup: which method picked which covariate</a:t>
+              <a:t>Backup: covariate selection by method and arm</a:t>
             </a:r>
             <a:endParaRPr lang="en-US" sz="2800" dirty="0"/>
           </a:p>
@@ -6917,7 +6917,7 @@
                   <a:srgbClr val="5B6B7A"/>
                 </a:solidFill>
               </a:rPr>
-              <a:t>Filled dot = picked. Read down the first three columns of each panel. The two ML columns are fuller because their bar (above the random-number column) is low; the final call also requires LASSO stability of 60% (signal) or 20% (uncertain).</a:t>
+              <a:t>Filled dot = selected. The three covariate-model columns agree on one covariate per arm. The ML columns are fuller because their criterion (importance above the noise covariate) is permissive; the final call also requires LASSO bootstrap stability of 60% (signal) or 20% (uncertain).</a:t>
             </a:r>
             <a:endParaRPr lang="en-US" sz="1150" dirty="0"/>
           </a:p>
@@ -6987,7 +6987,7 @@
                   <a:srgbClr val="000000"/>
                 </a:solidFill>
               </a:rPr>
-              <a:t>Backup: the key covariate holds within every onset type, and a which-drug-for-whom reading</a:t>
+              <a:t>Backup: the dominant covariate holds within each onset phenotype; an exploratory treatment-allocation view</a:t>
             </a:r>
             <a:endParaRPr lang="en-US" sz="2800" dirty="0"/>
           </a:p>
@@ -8239,7 +8239,7 @@
                   <a:srgbClr val="1F2933"/>
                 </a:solidFill>
               </a:rPr>
-              <a:t>Same direction in every onset type in every arm (training patients). Only mexiletine's slope differs by onset type: flatter in late onset, where baseline myotonia is mild.</a:t>
+              <a:t>Same direction within every onset phenotype in every arm (training set). Only the mexiletine slope differs by phenotype: attenuated in late onset, where baseline myotonia is mild.</a:t>
             </a:r>
             <a:endParaRPr lang="en-US" sz="1250" dirty="0"/>
           </a:p>
@@ -8275,7 +8275,7 @@
                   <a:srgbClr val="000000"/>
                 </a:solidFill>
               </a:rPr>
-              <a:t>Which drug for whom (exploratory)</a:t>
+              <a:t>Treatment allocation by covariate profile (exploratory)</a:t>
             </a:r>
             <a:endParaRPr lang="en-US" sz="1600" dirty="0"/>
           </a:p>
@@ -8315,7 +8315,7 @@
                   <a:srgbClr val="1F2933"/>
                 </a:solidFill>
               </a:rPr>
-              <a:t>Each arm's responder model applied to all training patients, relative to that arm's average patient. Best bet: mexiletine for 12% (very high myotonia, median repeats about 530), tideglusib for 35% (impaired cognition), the oligonucleotide for the rest</a:t>
+              <a:t>Each arm's responder model applied to all training patients, expressed relative to that arm's average patient. Highest relative likelihood: mexiletine for 12% (severe myotonia, median ≈ 530 repeats), tideglusib for 35% (cognitive impairment), the oligonucleotide for the remainder</a:t>
             </a:r>
             <a:endParaRPr lang="en-US" sz="1400" dirty="0"/>
           </a:p>
@@ -8333,7 +8333,7 @@
                   <a:srgbClr val="1F2933"/>
                 </a:solidFill>
               </a:rPr>
-              <a:t>An extrapolation across arms; no outcome is used across arms. A proposal for discussion, not a scoreboard result</a:t>
+              <a:t>Extrapolation across arms; no outcome information crosses arms. Hypothesis-generating only</a:t>
             </a:r>
             <a:endParaRPr lang="en-US" sz="1400" dirty="0"/>
           </a:p>
@@ -8351,7 +8351,7 @@
                   <a:srgbClr val="1F2933"/>
                 </a:solidFill>
               </a:rPr>
-              <a:t>The data dictionary says arm assignment was weighted by patient fit; actual arm matches predicted best drug for 41% of patients against 33% by chance, so the weighting was mild</a:t>
+              <a:t>The data dictionary states that arm assignment was weighted by patient fit; observed arm matches the predicted best arm for 41% of patients versus 33% expected by chance, so the weighting was mild</a:t>
             </a:r>
             <a:endParaRPr lang="en-US" sz="1400" dirty="0"/>
           </a:p>

</xml_diff>

<commit_message>
Deck: concise slides, full narration in speaker notes
Co-Authored-By: Claude Fable 5.1 <noreply@anthropic.com>
</commit_message>
<xml_diff>
--- a/slides/Team1_DM1_slides.pptx
+++ b/slides/Team1_DM1_slides.pptx
@@ -116,7 +116,7 @@
   <p:extLst>
     <p:ext uri="{521415D9-36F7-43E2-AB2F-B90AF26B5E84}">
       <p14:sectionLst xmlns:p14="http://schemas.microsoft.com/office/powerpoint/2010/main">
-        <p14:section name="Talk" id="{f4ba123e-a822-f7df-0a71-7f8aac630db1}">
+        <p14:section name="Talk" id="{817d5f1a-55c1-f410-a9d6-292ae4025189}">
           <p14:sldIdLst>
             <p14:sldId id="256"/>
             <p14:sldId id="257"/>
@@ -126,7 +126,7 @@
             <p14:sldId id="261"/>
           </p14:sldIdLst>
         </p14:section>
-        <p14:section name="Backup" id="{46597664-70fb-f201-57ba-708c91709204}">
+        <p14:section name="Backup" id="{21f6a711-e9da-52e7-f6f1-713eeb364b8c}">
           <p14:sldIdLst>
             <p14:sldId id="262"/>
             <p14:sldId id="263"/>
@@ -538,7 +538,10 @@
           <a:p>
             <a:r>
               <a:rPr lang="en-US" dirty="0"/>
-              <a:t>30 seconds. Say the direction once: for mexiletine a lower change is better; for the other two drugs higher is better.</a:t>
+              <a:t>[30 s]
+Good morning. We are Team 1. Our question was the organizers' question: in a simulated DM1 trial with three treatment arms, which baseline covariates predict response, and does machine learning find anything that covariate modelling misses?
+Our answer in one line: each drug has one dominant predictor, it is the measure closest to the drug's site of action, and machine learning found nothing beyond it.
+Direction reminder, said once: for mexiletine a lower change in myotonia is better; for the other two arms higher is better.</a:t>
             </a:r>
             <a:endParaRPr lang="en-US" dirty="0"/>
           </a:p>
@@ -714,7 +717,13 @@
           <a:p>
             <a:r>
               <a:rPr lang="en-US" dirty="0"/>
-              <a:t>The answer first. One predictor per drug; it matches the mechanism; every method agrees; ML adds nothing. The numbers are responder rates among held-out test patients above and below the cut-off a training-set tree chose.</a:t>
+              <a:t>[45 s]
+This is the whole result. One row per arm.
+Mexiletine blocks muscle sodium channels; it treats the symptom. Its predictor is the symptom: baseline myotonia severity. Among held-out test patients, 67% above the cut-off responded versus 10% below.
+The antisense oligonucleotide degrades the toxic DMPK transcript; it acts on the cause. Its predictor is the amount of cause: CTG repeat length. 59% versus 31%.
+Tideglusib inhibits GSK3β and acts across several systems including the brain; the endpoint is a composite with a cognitive domain. Its predictor is baseline cognitive function. 74% versus 17%.
+Three points of evidence behind every row: stepwise selection, LASSO, elastic net, random forest and XGBoost all picked the same covariate; LASSO kept it in 90 to 100% of 200 bootstrap resamples; and a column of pure random numbers that we added as a negative control was never selected by any method in any arm.
+Machine learning, meaning random forest and XGBoost, ranked the same covariates first. It did not add a predictor.</a:t>
             </a:r>
             <a:endParaRPr lang="en-US" dirty="0"/>
           </a:p>
@@ -802,7 +811,12 @@
           <a:p>
             <a:r>
               <a:rPr lang="en-US" dirty="0"/>
-              <a:t>50 seconds. The chain is the disease; the orange labels are where each drug acts. Right column: the kickoff workflow, and the three noise checks. Cleaning catch: albumin constant in one arm.</a:t>
+              <a:t>[50 s]
+The cascade, left to right: an expanded CTG repeat in DMPK makes a toxic RNA; the RNA sequesters MBNL1 and activates GSK3β, which mis-splices dozens of genes; that damages muscle, brain, heart and eye; and the patient presents with myotonia and weakness.
+The three drugs sit at three different points. The antisense oligonucleotide degrades the RNA, at the cause. Tideglusib inhibits GSK3β, in the middle. Mexiletine blocks sodium channels, at the symptom. Different mechanism, different endpoint, so three separate analyses.
+The dataset: 500 simulated patients, one drug each, about 165 per arm, 18 baseline covariates covering genetic burden, disease stage, muscle, CNS, cardiac, eye, metabolic and demographic domains. Some are noise by design.
+Data review found no missing values, but albumin was a single imputed constant for every mexiletine patient, so it is excluded in that arm. The CK floor at 50 and mosaicism index at zero were retained as observed. No patient was excluded.
+Workflow, per arm: split first, 75/25, stratified by responder status and onset phenotype, fixed seed, test set scored once at the end. Every model choice by 5-fold cross-validation inside training. Three covariate models and two machine-learning models. And three noise controls: a pure-noise covariate, selection stability over 200 bootstrap resamples, and agreement across the five methods.</a:t>
             </a:r>
             <a:endParaRPr lang="en-US" dirty="0"/>
           </a:p>
@@ -890,7 +904,14 @@
           <a:p>
             <a:r>
               <a:rPr lang="en-US" dirty="0"/>
-              <a:t>80 seconds. Forest plot: reference patient = median covariates, adult onset; dashed line = its responder probability; rows = key covariate at its 10th and 90th percentile, then each onset type; lines = 90% bootstrap intervals, training patients. Presented in the standard pharmacometric covariate format. Noise list if asked: sex, BMI, smoking, cataracts, CK, PR interval, albumin were noise in every arm; disease duration borderline everywhere.</a:t>
+              <a:t>[80 s]
+This is the covariate forest plot, in the standard pharmacometric format. For each arm, the reference patient has median covariates and adult onset; the dashed line is that patient's predicted probability of response. The rows show the dominant covariate at its 10th and 90th percentile, then each onset phenotype with everything else at reference. Lines are 90% bootstrap intervals, from training patients only.
+Mexiletine: from mild to severe myotonia, predicted response rises from 17% to 38%. A symptomatic drug: the effect scales with the symptom present. Late-onset patients respond less because their baseline myotonia is mild; there is little to treat.
+The oligonucleotide: from short to long repeats, 22% to 75%. The only predictor in the arm. A target-engaging drug: the effect scales with the amount of target transcript. Note that individual prediction stays poor, test R-squared under 0.1: we know the direction, not the person.
+Tideglusib: from impaired to intact cognition, 87% down to 14%, and it is a threshold near minus 0.5, not a gradient. The composite endpoint has a cognitive domain, so a patient with intact cognition has no room for measurable gain. A ceiling effect.
+Onset phenotype adds little once the dominant covariate is in the model: the phenotype rows straddle the reference line.
+Replication: three team members built three independent implementations, two in R and one in Python, with different splits, up to 30 methods, and 20 repeated splits. All found the same three covariates. CTG repeat length behaves like a prognostic marker across arms; cognitive function is specific to tideglusib.
+If asked what was noise: sex, BMI, smoking, cataracts, CK, PR interval and albumin in every arm; disease duration borderline everywhere.</a:t>
             </a:r>
             <a:endParaRPr lang="en-US" dirty="0"/>
           </a:p>
@@ -978,7 +999,12 @@
           <a:p>
             <a:r>
               <a:rPr lang="en-US" dirty="0"/>
-              <a:t>60 seconds. Blue = covariate models, orange = ML, test-set R² for the continuous outcome. Intervals overlap within every arm (about 41 test patients), so we do not rank methods inside an arm; the one solid contrast is linear vs tree in tideglusib, and we know why. ML was the check that nothing was missed; it found the same leaders by permutation importance and SHAP.</a:t>
+              <a:t>[60 s]
+The scoreboard. Blue bars are covariate models, orange bars are machine learning, test-set R-squared for the continuous endpoint, about 41 held-out patients per arm.
+Mexiletine: every method lands between 0.47 and 0.54. Equivalent. Across 20 repeated splits the top rank alternates between stepwise selection and tuned XGBoost.
+Oligonucleotide: every method is under 0.1, on every split. The repeat-length effect is consistent but between-patient variability dominates. We report that as it is.
+Tideglusib: random forest and tuned XGBoost reach 0.55; the straight-line models 0.24 to 0.30, on 19 of 20 splits. We know why: the effect is a threshold, and a straight line cannot draw a step. A linear model given that single threshold on cognition reaches 0.45. Tuned XGBoost chose depth-one trees in every arm, so there are no interactions to find.
+Intervals overlap within each arm, so we do not rank methods inside an arm. Machine learning was the check that nothing was missed: by permutation importance and SHAP it found the same leaders.</a:t>
             </a:r>
             <a:endParaRPr lang="en-US" dirty="0"/>
           </a:p>
@@ -1066,7 +1092,12 @@
           <a:p>
             <a:r>
               <a:rPr lang="en-US" dirty="0"/>
-              <a:t>40 seconds. The stratification sentence, then the limits before a judge asks, then the disclosure. Robustness line if time: we repeated the split 20 times and the pattern held in every arm.</a:t>
+              <a:t>[40 s]
+What a clinician or a trialist does with this: measure the organ the drug acts on. Myotonia severity before mexiletine, repeat length before the antisense drug, cognitive function before tideglusib. One routine baseline assessment per drug, and response rates differ two- to seven-fold between the groups it defines. Cut-offs are approximate: about 5, about 350, about minus 0.5.
+Trial design: for mexiletine, enrol on baseline myotonia severity rather than diagnosis alone, because mild cases dilute the effect, which is what the 2021 placebo-controlled trial found on walking distance. For the oligonucleotide, stratify randomisation on repeat length, a prognostic factor. For tideglusib, enrich for cognitive impairment: expected responder rate goes from 48% to 74%, which reduces the sample size needed to show an effect.
+Limitations we state ourselves: no placebo arm, so these are prognostic predictors within treated patients, not demonstrated effect modifiers. About 41 test patients per arm, so we give ranges and do not rank methods within an arm. One time point per patient; the natural next step is a longitudinal disease-progression model with these covariates on progression rate and drug effect.
+AI disclosure: Claude through Claude Code, and Codex, drafted code, documentation and these slides, as noted in the code headers. Every analysis decision and interpretation was reviewed by the team, and the team is accountable for the results.
+Robustness, if time: we repeated the split 20 times and the pattern held in every arm. Thank you.</a:t>
             </a:r>
             <a:endParaRPr lang="en-US" dirty="0"/>
           </a:p>
@@ -1154,7 +1185,7 @@
           <a:p>
             <a:r>
               <a:rPr lang="en-US" dirty="0"/>
-              <a:t/>
+              <a:t>Mexiletine: methods equivalent, median about 0.6. Oligonucleotide: all weak, medians 0.06 to 0.12. Absolute R² varies by up to 0.15 between splits, hence ranges rather than point estimates.</a:t>
             </a:r>
             <a:endParaRPr lang="en-US" dirty="0"/>
           </a:p>
@@ -1242,7 +1273,7 @@
           <a:p>
             <a:r>
               <a:rPr lang="en-US" dirty="0"/>
-              <a:t/>
+              <a:t>The three covariate-model columns agree on one covariate per arm. The ML columns are fuller because their criterion, importance above the noise covariate, is permissive; that is why the final call also requires bootstrap stability.</a:t>
             </a:r>
             <a:endParaRPr lang="en-US" dirty="0"/>
           </a:p>
@@ -1330,7 +1361,7 @@
           <a:p>
             <a:r>
               <a:rPr lang="en-US" dirty="0"/>
-              <a:t/>
+              <a:t>Same direction within every onset phenotype in every arm, training set. Only the mexiletine slope differs by phenotype: attenuated in late onset, where baseline myotonia is mild. The data dictionary states arm assignment was weighted by patient fit; observed arm matches the predicted best arm for 41% of patients versus 33% by chance, so the weighting was mild.</a:t>
             </a:r>
             <a:endParaRPr lang="en-US" dirty="0"/>
           </a:p>
@@ -2097,172 +2128,172 @@
           <a:p>
             <a:pPr indent="0" marL="0">
               <a:spcAft>
-                <a:spcPts val="500"/>
+                <a:spcPts val="600"/>
               </a:spcAft>
               <a:buNone/>
             </a:pPr>
             <a:r>
-              <a:rPr lang="en-US" sz="1200" dirty="0">
+              <a:rPr lang="en-US" sz="1300" dirty="0">
                 <a:solidFill>
                   <a:srgbClr val="1F2933"/>
                 </a:solidFill>
               </a:rPr>
-              <a:t>1. Morales F et al. Somatic instability of the expanded CTG repeat in DM1 is a heritable quantitative trait and modifier of disease severity. Hum Mol Genet 2012;21:3558-67.</a:t>
+              <a:t>1. Morales F et al. Hum Mol Genet 2012;21:3558-67. Somatic instability of the CTG repeat as a modifier of DM1 severity.</a:t>
             </a:r>
-            <a:endParaRPr lang="en-US" sz="1200" dirty="0"/>
+            <a:endParaRPr lang="en-US" sz="1300" dirty="0"/>
           </a:p>
           <a:p>
             <a:pPr indent="0" marL="0">
               <a:spcAft>
-                <a:spcPts val="500"/>
+                <a:spcPts val="600"/>
               </a:spcAft>
               <a:buNone/>
             </a:pPr>
             <a:r>
-              <a:rPr lang="en-US" sz="1200" dirty="0">
+              <a:rPr lang="en-US" sz="1300" dirty="0">
                 <a:solidFill>
                   <a:srgbClr val="1F2933"/>
                 </a:solidFill>
               </a:rPr>
-              <a:t>2. Cumming SA et al. Genetic determinants of disease severity in the DM1 OPTIMISTIC cohort. Neurology 2019;93:e995-e1009.</a:t>
+              <a:t>2. Cumming SA et al. Neurology 2019;93:e995-e1009. Genetic determinants of severity, OPTIMISTIC cohort.</a:t>
             </a:r>
-            <a:endParaRPr lang="en-US" sz="1200" dirty="0"/>
+            <a:endParaRPr lang="en-US" sz="1300" dirty="0"/>
           </a:p>
           <a:p>
             <a:pPr indent="0" marL="0">
               <a:spcAft>
-                <a:spcPts val="500"/>
+                <a:spcPts val="600"/>
               </a:spcAft>
               <a:buNone/>
             </a:pPr>
             <a:r>
-              <a:rPr lang="en-US" sz="1200" dirty="0">
+              <a:rPr lang="en-US" sz="1300" dirty="0">
                 <a:solidFill>
                   <a:srgbClr val="1F2933"/>
                 </a:solidFill>
               </a:rPr>
-              <a:t>3. De Antonio M et al. Unravelling the DM1 clinical spectrum: a systematic registry-based study. Rev Neurol (Paris) 2016;172:572-80.</a:t>
+              <a:t>3. De Antonio M et al. Rev Neurol (Paris) 2016;172:572-80. DM1 clinical spectrum and onset-based classification.</a:t>
             </a:r>
-            <a:endParaRPr lang="en-US" sz="1200" dirty="0"/>
+            <a:endParaRPr lang="en-US" sz="1300" dirty="0"/>
           </a:p>
           <a:p>
             <a:pPr indent="0" marL="0">
               <a:spcAft>
-                <a:spcPts val="500"/>
+                <a:spcPts val="600"/>
               </a:spcAft>
               <a:buNone/>
             </a:pPr>
             <a:r>
-              <a:rPr lang="en-US" sz="1200" dirty="0">
+              <a:rPr lang="en-US" sz="1300" dirty="0">
                 <a:solidFill>
                   <a:srgbClr val="1F2933"/>
                 </a:solidFill>
               </a:rPr>
-              <a:t>4. Okkersen K et al. Brain imaging in myotonic dystrophy type 1: a systematic review. Neurology 2017;89:960-9.</a:t>
+              <a:t>4. Okkersen K et al. Neurology 2017;89:960-9. Brain imaging in DM1: systematic review.</a:t>
             </a:r>
-            <a:endParaRPr lang="en-US" sz="1200" dirty="0"/>
+            <a:endParaRPr lang="en-US" sz="1300" dirty="0"/>
           </a:p>
           <a:p>
             <a:pPr indent="0" marL="0">
               <a:spcAft>
-                <a:spcPts val="500"/>
+                <a:spcPts val="600"/>
               </a:spcAft>
               <a:buNone/>
             </a:pPr>
             <a:r>
-              <a:rPr lang="en-US" sz="1200" dirty="0">
+              <a:rPr lang="en-US" sz="1300" dirty="0">
                 <a:solidFill>
                   <a:srgbClr val="1F2933"/>
                 </a:solidFill>
               </a:rPr>
-              <a:t>5. Logigian EL et al. Mexiletine is an effective antimyotonia treatment in DM1. Neurology 2010;74:1441-8.</a:t>
+              <a:t>5. Logigian EL et al. Neurology 2010;74:1441-8. Mexiletine as antimyotonia treatment in DM1.</a:t>
             </a:r>
-            <a:endParaRPr lang="en-US" sz="1200" dirty="0"/>
+            <a:endParaRPr lang="en-US" sz="1300" dirty="0"/>
           </a:p>
           <a:p>
             <a:pPr indent="0" marL="0">
               <a:spcAft>
-                <a:spcPts val="500"/>
+                <a:spcPts val="600"/>
               </a:spcAft>
               <a:buNone/>
             </a:pPr>
             <a:r>
-              <a:rPr lang="en-US" sz="1200" dirty="0">
+              <a:rPr lang="en-US" sz="1300" dirty="0">
                 <a:solidFill>
                   <a:srgbClr val="1F2933"/>
                 </a:solidFill>
               </a:rPr>
-              <a:t>6. Heatwole C et al. Mexiletine in myotonic dystrophy type 1: a randomized, double-blind, placebo-controlled trial. Neurology 2021;96:e228-e240.</a:t>
+              <a:t>6. Heatwole C et al. Neurology 2021;96:e228-e240. Mexiletine in DM1: randomized placebo-controlled trial.</a:t>
             </a:r>
-            <a:endParaRPr lang="en-US" sz="1200" dirty="0"/>
+            <a:endParaRPr lang="en-US" sz="1300" dirty="0"/>
           </a:p>
           <a:p>
             <a:pPr indent="0" marL="0">
               <a:spcAft>
-                <a:spcPts val="500"/>
+                <a:spcPts val="600"/>
               </a:spcAft>
               <a:buNone/>
             </a:pPr>
             <a:r>
-              <a:rPr lang="en-US" sz="1200" dirty="0">
+              <a:rPr lang="en-US" sz="1300" dirty="0">
                 <a:solidFill>
                   <a:srgbClr val="1F2933"/>
                 </a:solidFill>
               </a:rPr>
-              <a:t>7. Thornton CA et al. Antisense oligonucleotide targeting DMPK in patients with DM1: phase 1/2a trial. Lancet Neurol 2023;22:218-28.</a:t>
+              <a:t>7. Thornton CA et al. Lancet Neurol 2023;22:218-28. Antisense oligonucleotide targeting DMPK: phase 1/2a trial.</a:t>
             </a:r>
-            <a:endParaRPr lang="en-US" sz="1200" dirty="0"/>
+            <a:endParaRPr lang="en-US" sz="1300" dirty="0"/>
           </a:p>
           <a:p>
             <a:pPr indent="0" marL="0">
               <a:spcAft>
-                <a:spcPts val="500"/>
+                <a:spcPts val="600"/>
               </a:spcAft>
               <a:buNone/>
             </a:pPr>
             <a:r>
-              <a:rPr lang="en-US" sz="1200" dirty="0">
+              <a:rPr lang="en-US" sz="1300" dirty="0">
                 <a:solidFill>
                   <a:srgbClr val="1F2933"/>
                 </a:solidFill>
               </a:rPr>
-              <a:t>8. Jones K et al. GSK3β mediates muscle pathology in myotonic dystrophy. J Clin Invest 2012;122:4461-72.</a:t>
+              <a:t>8. Jones K et al. J Clin Invest 2012;122:4461-72. GSK3β mediates muscle pathology in DM1.</a:t>
             </a:r>
-            <a:endParaRPr lang="en-US" sz="1200" dirty="0"/>
+            <a:endParaRPr lang="en-US" sz="1300" dirty="0"/>
           </a:p>
           <a:p>
             <a:pPr indent="0" marL="0">
               <a:spcAft>
-                <a:spcPts val="500"/>
+                <a:spcPts val="600"/>
               </a:spcAft>
               <a:buNone/>
             </a:pPr>
             <a:r>
-              <a:rPr lang="en-US" sz="1200" dirty="0">
+              <a:rPr lang="en-US" sz="1300" dirty="0">
                 <a:solidFill>
                   <a:srgbClr val="1F2933"/>
                 </a:solidFill>
               </a:rPr>
-              <a:t>9. Horrigan J et al. A phase 2 study of AMO-02 (tideglusib) in congenital and childhood-onset DM1. Pediatr Neurol 2020;112:84-93.</a:t>
+              <a:t>9. Horrigan J et al. Pediatr Neurol 2020;112:84-93. Phase 2 study of tideglusib in congenital and childhood-onset DM1.</a:t>
             </a:r>
-            <a:endParaRPr lang="en-US" sz="1200" dirty="0"/>
+            <a:endParaRPr lang="en-US" sz="1300" dirty="0"/>
           </a:p>
           <a:p>
             <a:pPr indent="0" marL="0">
               <a:spcAft>
-                <a:spcPts val="500"/>
+                <a:spcPts val="600"/>
               </a:spcAft>
               <a:buNone/>
             </a:pPr>
             <a:r>
-              <a:rPr lang="en-US" sz="1200" dirty="0">
+              <a:rPr lang="en-US" sz="1300" dirty="0">
                 <a:solidFill>
                   <a:srgbClr val="1F2933"/>
                 </a:solidFill>
               </a:rPr>
-              <a:t>10. Hutmacher MM, Kowalski KG. Covariate selection in pharmacometric analyses: a review of methods. Br J Clin Pharmacol 2015;79:132-47.</a:t>
+              <a:t>10. Hutmacher MM, Kowalski KG. Br J Clin Pharmacol 2015;79:132-47. Covariate selection in pharmacometric analyses.</a:t>
             </a:r>
-            <a:endParaRPr lang="en-US" sz="1200" dirty="0"/>
+            <a:endParaRPr lang="en-US" sz="1300" dirty="0"/>
           </a:p>
         </p:txBody>
       </p:sp>
@@ -2330,7 +2361,7 @@
                   <a:srgbClr val="000000"/>
                 </a:solidFill>
               </a:rPr>
-              <a:t>Each arm has a single dominant baseline predictor, and it is the measure closest to the drug's site of action</a:t>
+              <a:t>Each arm has one dominant baseline predictor: the measure closest to the drug's site of action</a:t>
             </a:r>
             <a:endParaRPr lang="en-US" sz="2800" dirty="0"/>
           </a:p>
@@ -2351,7 +2382,7 @@
           </p:nvPr>
         </p:nvGraphicFramePr>
         <p:xfrm>
-          <a:off x="548640" y="1463040"/>
+          <a:off x="548640" y="1508760"/>
           <a:ext cx="11064240" cy="914400"/>
         </p:xfrm>
         <a:graphic>
@@ -2359,13 +2390,12 @@
             <a:tbl>
               <a:tblPr/>
               <a:tblGrid>
-                <a:gridCol w="2011680"/>
-                <a:gridCol w="2468880"/>
-                <a:gridCol w="1920240"/>
-                <a:gridCol w="2194560"/>
-                <a:gridCol w="2468880"/>
+                <a:gridCol w="2377440"/>
+                <a:gridCol w="3291840"/>
+                <a:gridCol w="2377440"/>
+                <a:gridCol w="3017520"/>
               </a:tblGrid>
-              <a:tr h="502920">
+              <a:tr h="548640">
                 <a:tc>
                   <a:txBody>
                     <a:bodyPr/>
@@ -2375,17 +2405,17 @@
                         <a:buNone/>
                       </a:pPr>
                       <a:r>
-                        <a:rPr lang="en-US" sz="1300" b="1" dirty="0">
+                        <a:rPr lang="en-US" sz="1400" b="1" dirty="0">
                           <a:solidFill>
                             <a:srgbClr val="000000"/>
                           </a:solidFill>
                         </a:rPr>
-                        <a:t>Drug</a:t>
+                        <a:t>Treatment</a:t>
                       </a:r>
-                      <a:endParaRPr lang="en-US" sz="1300" dirty="0"/>
+                      <a:endParaRPr lang="en-US" sz="1400" dirty="0"/>
                     </a:p>
                   </a:txBody>
-                  <a:tcPr marL="76200" marR="76200" marT="50800" marB="50800" anchor="ctr">
+                  <a:tcPr marL="88900" marR="88900" marT="63500" marB="63500" anchor="ctr">
                     <a:lnL w="9525" cap="flat" cmpd="sng" algn="ctr">
                       <a:solidFill>
                         <a:srgbClr val="D5DAE0"/>
@@ -2436,17 +2466,17 @@
                         <a:buNone/>
                       </a:pPr>
                       <a:r>
-                        <a:rPr lang="en-US" sz="1300" b="1" dirty="0">
+                        <a:rPr lang="en-US" sz="1400" b="1" dirty="0">
                           <a:solidFill>
                             <a:srgbClr val="000000"/>
                           </a:solidFill>
                         </a:rPr>
                         <a:t>Site of action</a:t>
                       </a:r>
-                      <a:endParaRPr lang="en-US" sz="1300" dirty="0"/>
+                      <a:endParaRPr lang="en-US" sz="1400" dirty="0"/>
                     </a:p>
                   </a:txBody>
-                  <a:tcPr marL="76200" marR="76200" marT="50800" marB="50800" anchor="ctr">
+                  <a:tcPr marL="88900" marR="88900" marT="63500" marB="63500" anchor="ctr">
                     <a:lnL w="9525" cap="flat" cmpd="sng" algn="ctr">
                       <a:solidFill>
                         <a:srgbClr val="D5DAE0"/>
@@ -2497,17 +2527,17 @@
                         <a:buNone/>
                       </a:pPr>
                       <a:r>
-                        <a:rPr lang="en-US" sz="1300" b="1" dirty="0">
+                        <a:rPr lang="en-US" sz="1400" b="1" dirty="0">
                           <a:solidFill>
                             <a:srgbClr val="000000"/>
                           </a:solidFill>
                         </a:rPr>
                         <a:t>Dominant predictor</a:t>
                       </a:r>
-                      <a:endParaRPr lang="en-US" sz="1300" dirty="0"/>
+                      <a:endParaRPr lang="en-US" sz="1400" dirty="0"/>
                     </a:p>
                   </a:txBody>
-                  <a:tcPr marL="76200" marR="76200" marT="50800" marB="50800" anchor="ctr">
+                  <a:tcPr marL="88900" marR="88900" marT="63500" marB="63500" anchor="ctr">
                     <a:lnL w="9525" cap="flat" cmpd="sng" algn="ctr">
                       <a:solidFill>
                         <a:srgbClr val="D5DAE0"/>
@@ -2558,78 +2588,17 @@
                         <a:buNone/>
                       </a:pPr>
                       <a:r>
-                        <a:rPr lang="en-US" sz="1300" b="1" dirty="0">
+                        <a:rPr lang="en-US" sz="1400" b="1" dirty="0">
                           <a:solidFill>
                             <a:srgbClr val="000000"/>
                           </a:solidFill>
                         </a:rPr>
-                        <a:t>Responder rate in the held-out test set, above vs below cut-off</a:t>
+                        <a:t>Held-out responder rate, above vs below cut-off</a:t>
                       </a:r>
-                      <a:endParaRPr lang="en-US" sz="1300" dirty="0"/>
+                      <a:endParaRPr lang="en-US" sz="1400" dirty="0"/>
                     </a:p>
                   </a:txBody>
-                  <a:tcPr marL="76200" marR="76200" marT="50800" marB="50800" anchor="ctr">
-                    <a:lnL w="9525" cap="flat" cmpd="sng" algn="ctr">
-                      <a:solidFill>
-                        <a:srgbClr val="D5DAE0"/>
-                      </a:solidFill>
-                      <a:prstDash val="solid"/>
-                      <a:round/>
-                      <a:headEnd type="none" w="med" len="med"/>
-                      <a:tailEnd type="none" w="med" len="med"/>
-                    </a:lnL>
-                    <a:lnR w="9525" cap="flat" cmpd="sng" algn="ctr">
-                      <a:solidFill>
-                        <a:srgbClr val="D5DAE0"/>
-                      </a:solidFill>
-                      <a:prstDash val="solid"/>
-                      <a:round/>
-                      <a:headEnd type="none" w="med" len="med"/>
-                      <a:tailEnd type="none" w="med" len="med"/>
-                    </a:lnR>
-                    <a:lnT w="9525" cap="flat" cmpd="sng" algn="ctr">
-                      <a:solidFill>
-                        <a:srgbClr val="D5DAE0"/>
-                      </a:solidFill>
-                      <a:prstDash val="solid"/>
-                      <a:round/>
-                      <a:headEnd type="none" w="med" len="med"/>
-                      <a:tailEnd type="none" w="med" len="med"/>
-                    </a:lnT>
-                    <a:lnB w="9525" cap="flat" cmpd="sng" algn="ctr">
-                      <a:solidFill>
-                        <a:srgbClr val="D5DAE0"/>
-                      </a:solidFill>
-                      <a:prstDash val="solid"/>
-                      <a:round/>
-                      <a:headEnd type="none" w="med" len="med"/>
-                      <a:tailEnd type="none" w="med" len="med"/>
-                    </a:lnB>
-                    <a:solidFill>
-                      <a:srgbClr val="F2F2F2"/>
-                    </a:solidFill>
-                  </a:tcPr>
-                </a:tc>
-                <a:tc>
-                  <a:txBody>
-                    <a:bodyPr/>
-                    <a:lstStyle/>
-                    <a:p>
-                      <a:pPr indent="0" marL="0">
-                        <a:buNone/>
-                      </a:pPr>
-                      <a:r>
-                        <a:rPr lang="en-US" sz="1300" b="1" dirty="0">
-                          <a:solidFill>
-                            <a:srgbClr val="000000"/>
-                          </a:solidFill>
-                        </a:rPr>
-                        <a:t>Selection evidence</a:t>
-                      </a:r>
-                      <a:endParaRPr lang="en-US" sz="1300" dirty="0"/>
-                    </a:p>
-                  </a:txBody>
-                  <a:tcPr marL="76200" marR="76200" marT="50800" marB="50800" anchor="ctr">
+                  <a:tcPr marL="88900" marR="88900" marT="63500" marB="63500" anchor="ctr">
                     <a:lnL w="9525" cap="flat" cmpd="sng" algn="ctr">
                       <a:solidFill>
                         <a:srgbClr val="D5DAE0"/>
@@ -2682,17 +2651,17 @@
                         <a:buNone/>
                       </a:pPr>
                       <a:r>
-                        <a:rPr lang="en-US" sz="1300" b="1" dirty="0">
+                        <a:rPr lang="en-US" sz="1400" b="1" dirty="0">
                           <a:solidFill>
                             <a:srgbClr val="1F2933"/>
                           </a:solidFill>
                         </a:rPr>
                         <a:t>Mexiletine</a:t>
                       </a:r>
-                      <a:endParaRPr lang="en-US" sz="1300" dirty="0"/>
+                      <a:endParaRPr lang="en-US" sz="1400" dirty="0"/>
                     </a:p>
                   </a:txBody>
-                  <a:tcPr marL="76200" marR="76200" marT="50800" marB="50800" anchor="ctr">
+                  <a:tcPr marL="88900" marR="88900" marT="63500" marB="63500" anchor="ctr">
                     <a:lnL w="9525" cap="flat" cmpd="sng" algn="ctr">
                       <a:solidFill>
                         <a:srgbClr val="D5DAE0"/>
@@ -2740,17 +2709,17 @@
                         <a:buNone/>
                       </a:pPr>
                       <a:r>
-                        <a:rPr lang="en-US" sz="1300" dirty="0">
+                        <a:rPr lang="en-US" sz="1400" dirty="0">
                           <a:solidFill>
                             <a:srgbClr val="1F2933"/>
                           </a:solidFill>
                         </a:rPr>
                         <a:t>Symptomatic: muscle sodium channel</a:t>
                       </a:r>
-                      <a:endParaRPr lang="en-US" sz="1300" dirty="0"/>
+                      <a:endParaRPr lang="en-US" sz="1400" dirty="0"/>
                     </a:p>
                   </a:txBody>
-                  <a:tcPr marL="76200" marR="76200" marT="50800" marB="50800" anchor="ctr">
+                  <a:tcPr marL="88900" marR="88900" marT="63500" marB="63500" anchor="ctr">
                     <a:lnL w="9525" cap="flat" cmpd="sng" algn="ctr">
                       <a:solidFill>
                         <a:srgbClr val="D5DAE0"/>
@@ -2798,17 +2767,17 @@
                         <a:buNone/>
                       </a:pPr>
                       <a:r>
-                        <a:rPr lang="en-US" sz="1300" dirty="0">
+                        <a:rPr lang="en-US" sz="1400" dirty="0">
                           <a:solidFill>
                             <a:srgbClr val="1F2933"/>
                           </a:solidFill>
                         </a:rPr>
                         <a:t>Myotonia severity</a:t>
                       </a:r>
-                      <a:endParaRPr lang="en-US" sz="1300" dirty="0"/>
+                      <a:endParaRPr lang="en-US" sz="1400" dirty="0"/>
                     </a:p>
                   </a:txBody>
-                  <a:tcPr marL="76200" marR="76200" marT="50800" marB="50800" anchor="ctr">
+                  <a:tcPr marL="88900" marR="88900" marT="63500" marB="63500" anchor="ctr">
                     <a:lnL w="9525" cap="flat" cmpd="sng" algn="ctr">
                       <a:solidFill>
                         <a:srgbClr val="D5DAE0"/>
@@ -2856,75 +2825,17 @@
                         <a:buNone/>
                       </a:pPr>
                       <a:r>
-                        <a:rPr lang="en-US" sz="1300" dirty="0">
+                        <a:rPr lang="en-US" sz="1400" b="1" dirty="0">
                           <a:solidFill>
                             <a:srgbClr val="1F2933"/>
                           </a:solidFill>
                         </a:rPr>
                         <a:t>67% vs 10%</a:t>
                       </a:r>
-                      <a:endParaRPr lang="en-US" sz="1300" dirty="0"/>
+                      <a:endParaRPr lang="en-US" sz="1400" dirty="0"/>
                     </a:p>
                   </a:txBody>
-                  <a:tcPr marL="76200" marR="76200" marT="50800" marB="50800" anchor="ctr">
-                    <a:lnL w="9525" cap="flat" cmpd="sng" algn="ctr">
-                      <a:solidFill>
-                        <a:srgbClr val="D5DAE0"/>
-                      </a:solidFill>
-                      <a:prstDash val="solid"/>
-                      <a:round/>
-                      <a:headEnd type="none" w="med" len="med"/>
-                      <a:tailEnd type="none" w="med" len="med"/>
-                    </a:lnL>
-                    <a:lnR w="9525" cap="flat" cmpd="sng" algn="ctr">
-                      <a:solidFill>
-                        <a:srgbClr val="D5DAE0"/>
-                      </a:solidFill>
-                      <a:prstDash val="solid"/>
-                      <a:round/>
-                      <a:headEnd type="none" w="med" len="med"/>
-                      <a:tailEnd type="none" w="med" len="med"/>
-                    </a:lnR>
-                    <a:lnT w="9525" cap="flat" cmpd="sng" algn="ctr">
-                      <a:solidFill>
-                        <a:srgbClr val="D5DAE0"/>
-                      </a:solidFill>
-                      <a:prstDash val="solid"/>
-                      <a:round/>
-                      <a:headEnd type="none" w="med" len="med"/>
-                      <a:tailEnd type="none" w="med" len="med"/>
-                    </a:lnT>
-                    <a:lnB w="9525" cap="flat" cmpd="sng" algn="ctr">
-                      <a:solidFill>
-                        <a:srgbClr val="D5DAE0"/>
-                      </a:solidFill>
-                      <a:prstDash val="solid"/>
-                      <a:round/>
-                      <a:headEnd type="none" w="med" len="med"/>
-                      <a:tailEnd type="none" w="med" len="med"/>
-                    </a:lnB>
-                  </a:tcPr>
-                </a:tc>
-                <a:tc>
-                  <a:txBody>
-                    <a:bodyPr/>
-                    <a:lstStyle/>
-                    <a:p>
-                      <a:pPr indent="0" marL="0">
-                        <a:buNone/>
-                      </a:pPr>
-                      <a:r>
-                        <a:rPr lang="en-US" sz="1300" dirty="0">
-                          <a:solidFill>
-                            <a:srgbClr val="1F2933"/>
-                          </a:solidFill>
-                        </a:rPr>
-                        <a:t>Selected by 5 of 5 methods; retained in 100% of 200 bootstrap resamples</a:t>
-                      </a:r>
-                      <a:endParaRPr lang="en-US" sz="1300" dirty="0"/>
-                    </a:p>
-                  </a:txBody>
-                  <a:tcPr marL="76200" marR="76200" marT="50800" marB="50800" anchor="ctr">
+                  <a:tcPr marL="88900" marR="88900" marT="63500" marB="63500" anchor="ctr">
                     <a:lnL w="9525" cap="flat" cmpd="sng" algn="ctr">
                       <a:solidFill>
                         <a:srgbClr val="D5DAE0"/>
@@ -2974,17 +2885,17 @@
                         <a:buNone/>
                       </a:pPr>
                       <a:r>
-                        <a:rPr lang="en-US" sz="1300" b="1" dirty="0">
+                        <a:rPr lang="en-US" sz="1400" b="1" dirty="0">
                           <a:solidFill>
                             <a:srgbClr val="1F2933"/>
                           </a:solidFill>
                         </a:rPr>
                         <a:t>Antisense oligonucleotide</a:t>
                       </a:r>
-                      <a:endParaRPr lang="en-US" sz="1300" dirty="0"/>
+                      <a:endParaRPr lang="en-US" sz="1400" dirty="0"/>
                     </a:p>
                   </a:txBody>
-                  <a:tcPr marL="76200" marR="76200" marT="50800" marB="50800" anchor="ctr">
+                  <a:tcPr marL="88900" marR="88900" marT="63500" marB="63500" anchor="ctr">
                     <a:lnL w="9525" cap="flat" cmpd="sng" algn="ctr">
                       <a:solidFill>
                         <a:srgbClr val="D5DAE0"/>
@@ -3032,17 +2943,17 @@
                         <a:buNone/>
                       </a:pPr>
                       <a:r>
-                        <a:rPr lang="en-US" sz="1300" dirty="0">
+                        <a:rPr lang="en-US" sz="1400" dirty="0">
                           <a:solidFill>
                             <a:srgbClr val="1F2933"/>
                           </a:solidFill>
                         </a:rPr>
                         <a:t>Disease-modifying: toxic DMPK transcript</a:t>
                       </a:r>
-                      <a:endParaRPr lang="en-US" sz="1300" dirty="0"/>
+                      <a:endParaRPr lang="en-US" sz="1400" dirty="0"/>
                     </a:p>
                   </a:txBody>
-                  <a:tcPr marL="76200" marR="76200" marT="50800" marB="50800" anchor="ctr">
+                  <a:tcPr marL="88900" marR="88900" marT="63500" marB="63500" anchor="ctr">
                     <a:lnL w="9525" cap="flat" cmpd="sng" algn="ctr">
                       <a:solidFill>
                         <a:srgbClr val="D5DAE0"/>
@@ -3090,17 +3001,17 @@
                         <a:buNone/>
                       </a:pPr>
                       <a:r>
-                        <a:rPr lang="en-US" sz="1300" dirty="0">
+                        <a:rPr lang="en-US" sz="1400" dirty="0">
                           <a:solidFill>
                             <a:srgbClr val="1F2933"/>
                           </a:solidFill>
                         </a:rPr>
                         <a:t>CTG repeat length</a:t>
                       </a:r>
-                      <a:endParaRPr lang="en-US" sz="1300" dirty="0"/>
+                      <a:endParaRPr lang="en-US" sz="1400" dirty="0"/>
                     </a:p>
                   </a:txBody>
-                  <a:tcPr marL="76200" marR="76200" marT="50800" marB="50800" anchor="ctr">
+                  <a:tcPr marL="88900" marR="88900" marT="63500" marB="63500" anchor="ctr">
                     <a:lnL w="9525" cap="flat" cmpd="sng" algn="ctr">
                       <a:solidFill>
                         <a:srgbClr val="D5DAE0"/>
@@ -3148,75 +3059,17 @@
                         <a:buNone/>
                       </a:pPr>
                       <a:r>
-                        <a:rPr lang="en-US" sz="1300" dirty="0">
+                        <a:rPr lang="en-US" sz="1400" b="1" dirty="0">
                           <a:solidFill>
                             <a:srgbClr val="1F2933"/>
                           </a:solidFill>
                         </a:rPr>
                         <a:t>59% vs 31%</a:t>
                       </a:r>
-                      <a:endParaRPr lang="en-US" sz="1300" dirty="0"/>
+                      <a:endParaRPr lang="en-US" sz="1400" dirty="0"/>
                     </a:p>
                   </a:txBody>
-                  <a:tcPr marL="76200" marR="76200" marT="50800" marB="50800" anchor="ctr">
-                    <a:lnL w="9525" cap="flat" cmpd="sng" algn="ctr">
-                      <a:solidFill>
-                        <a:srgbClr val="D5DAE0"/>
-                      </a:solidFill>
-                      <a:prstDash val="solid"/>
-                      <a:round/>
-                      <a:headEnd type="none" w="med" len="med"/>
-                      <a:tailEnd type="none" w="med" len="med"/>
-                    </a:lnL>
-                    <a:lnR w="9525" cap="flat" cmpd="sng" algn="ctr">
-                      <a:solidFill>
-                        <a:srgbClr val="D5DAE0"/>
-                      </a:solidFill>
-                      <a:prstDash val="solid"/>
-                      <a:round/>
-                      <a:headEnd type="none" w="med" len="med"/>
-                      <a:tailEnd type="none" w="med" len="med"/>
-                    </a:lnR>
-                    <a:lnT w="9525" cap="flat" cmpd="sng" algn="ctr">
-                      <a:solidFill>
-                        <a:srgbClr val="D5DAE0"/>
-                      </a:solidFill>
-                      <a:prstDash val="solid"/>
-                      <a:round/>
-                      <a:headEnd type="none" w="med" len="med"/>
-                      <a:tailEnd type="none" w="med" len="med"/>
-                    </a:lnT>
-                    <a:lnB w="9525" cap="flat" cmpd="sng" algn="ctr">
-                      <a:solidFill>
-                        <a:srgbClr val="D5DAE0"/>
-                      </a:solidFill>
-                      <a:prstDash val="solid"/>
-                      <a:round/>
-                      <a:headEnd type="none" w="med" len="med"/>
-                      <a:tailEnd type="none" w="med" len="med"/>
-                    </a:lnB>
-                  </a:tcPr>
-                </a:tc>
-                <a:tc>
-                  <a:txBody>
-                    <a:bodyPr/>
-                    <a:lstStyle/>
-                    <a:p>
-                      <a:pPr indent="0" marL="0">
-                        <a:buNone/>
-                      </a:pPr>
-                      <a:r>
-                        <a:rPr lang="en-US" sz="1300" dirty="0">
-                          <a:solidFill>
-                            <a:srgbClr val="1F2933"/>
-                          </a:solidFill>
-                        </a:rPr>
-                        <a:t>5 of 5 methods; 90% of resamples</a:t>
-                      </a:r>
-                      <a:endParaRPr lang="en-US" sz="1300" dirty="0"/>
-                    </a:p>
-                  </a:txBody>
-                  <a:tcPr marL="76200" marR="76200" marT="50800" marB="50800" anchor="ctr">
+                  <a:tcPr marL="88900" marR="88900" marT="63500" marB="63500" anchor="ctr">
                     <a:lnL w="9525" cap="flat" cmpd="sng" algn="ctr">
                       <a:solidFill>
                         <a:srgbClr val="D5DAE0"/>
@@ -3266,17 +3119,17 @@
                         <a:buNone/>
                       </a:pPr>
                       <a:r>
-                        <a:rPr lang="en-US" sz="1300" b="1" dirty="0">
+                        <a:rPr lang="en-US" sz="1400" b="1" dirty="0">
                           <a:solidFill>
                             <a:srgbClr val="1F2933"/>
                           </a:solidFill>
                         </a:rPr>
                         <a:t>Tideglusib</a:t>
                       </a:r>
-                      <a:endParaRPr lang="en-US" sz="1300" dirty="0"/>
+                      <a:endParaRPr lang="en-US" sz="1400" dirty="0"/>
                     </a:p>
                   </a:txBody>
-                  <a:tcPr marL="76200" marR="76200" marT="50800" marB="50800" anchor="ctr">
+                  <a:tcPr marL="88900" marR="88900" marT="63500" marB="63500" anchor="ctr">
                     <a:lnL w="9525" cap="flat" cmpd="sng" algn="ctr">
                       <a:solidFill>
                         <a:srgbClr val="D5DAE0"/>
@@ -3324,17 +3177,17 @@
                         <a:buNone/>
                       </a:pPr>
                       <a:r>
-                        <a:rPr lang="en-US" sz="1300" dirty="0">
+                        <a:rPr lang="en-US" sz="1400" dirty="0">
                           <a:solidFill>
                             <a:srgbClr val="1F2933"/>
                           </a:solidFill>
                         </a:rPr>
-                        <a:t>Multisystem: GSK3β signalling, including CNS</a:t>
+                        <a:t>Multisystem: GSK3β signalling, incl. CNS</a:t>
                       </a:r>
-                      <a:endParaRPr lang="en-US" sz="1300" dirty="0"/>
+                      <a:endParaRPr lang="en-US" sz="1400" dirty="0"/>
                     </a:p>
                   </a:txBody>
-                  <a:tcPr marL="76200" marR="76200" marT="50800" marB="50800" anchor="ctr">
+                  <a:tcPr marL="88900" marR="88900" marT="63500" marB="63500" anchor="ctr">
                     <a:lnL w="9525" cap="flat" cmpd="sng" algn="ctr">
                       <a:solidFill>
                         <a:srgbClr val="D5DAE0"/>
@@ -3382,17 +3235,17 @@
                         <a:buNone/>
                       </a:pPr>
                       <a:r>
-                        <a:rPr lang="en-US" sz="1300" dirty="0">
+                        <a:rPr lang="en-US" sz="1400" dirty="0">
                           <a:solidFill>
                             <a:srgbClr val="1F2933"/>
                           </a:solidFill>
                         </a:rPr>
                         <a:t>Cognitive function</a:t>
                       </a:r>
-                      <a:endParaRPr lang="en-US" sz="1300" dirty="0"/>
+                      <a:endParaRPr lang="en-US" sz="1400" dirty="0"/>
                     </a:p>
                   </a:txBody>
-                  <a:tcPr marL="76200" marR="76200" marT="50800" marB="50800" anchor="ctr">
+                  <a:tcPr marL="88900" marR="88900" marT="63500" marB="63500" anchor="ctr">
                     <a:lnL w="9525" cap="flat" cmpd="sng" algn="ctr">
                       <a:solidFill>
                         <a:srgbClr val="D5DAE0"/>
@@ -3440,75 +3293,17 @@
                         <a:buNone/>
                       </a:pPr>
                       <a:r>
-                        <a:rPr lang="en-US" sz="1300" dirty="0">
+                        <a:rPr lang="en-US" sz="1400" b="1" dirty="0">
                           <a:solidFill>
                             <a:srgbClr val="1F2933"/>
                           </a:solidFill>
                         </a:rPr>
                         <a:t>74% vs 17%</a:t>
                       </a:r>
-                      <a:endParaRPr lang="en-US" sz="1300" dirty="0"/>
+                      <a:endParaRPr lang="en-US" sz="1400" dirty="0"/>
                     </a:p>
                   </a:txBody>
-                  <a:tcPr marL="76200" marR="76200" marT="50800" marB="50800" anchor="ctr">
-                    <a:lnL w="9525" cap="flat" cmpd="sng" algn="ctr">
-                      <a:solidFill>
-                        <a:srgbClr val="D5DAE0"/>
-                      </a:solidFill>
-                      <a:prstDash val="solid"/>
-                      <a:round/>
-                      <a:headEnd type="none" w="med" len="med"/>
-                      <a:tailEnd type="none" w="med" len="med"/>
-                    </a:lnL>
-                    <a:lnR w="9525" cap="flat" cmpd="sng" algn="ctr">
-                      <a:solidFill>
-                        <a:srgbClr val="D5DAE0"/>
-                      </a:solidFill>
-                      <a:prstDash val="solid"/>
-                      <a:round/>
-                      <a:headEnd type="none" w="med" len="med"/>
-                      <a:tailEnd type="none" w="med" len="med"/>
-                    </a:lnR>
-                    <a:lnT w="9525" cap="flat" cmpd="sng" algn="ctr">
-                      <a:solidFill>
-                        <a:srgbClr val="D5DAE0"/>
-                      </a:solidFill>
-                      <a:prstDash val="solid"/>
-                      <a:round/>
-                      <a:headEnd type="none" w="med" len="med"/>
-                      <a:tailEnd type="none" w="med" len="med"/>
-                    </a:lnT>
-                    <a:lnB w="9525" cap="flat" cmpd="sng" algn="ctr">
-                      <a:solidFill>
-                        <a:srgbClr val="D5DAE0"/>
-                      </a:solidFill>
-                      <a:prstDash val="solid"/>
-                      <a:round/>
-                      <a:headEnd type="none" w="med" len="med"/>
-                      <a:tailEnd type="none" w="med" len="med"/>
-                    </a:lnB>
-                  </a:tcPr>
-                </a:tc>
-                <a:tc>
-                  <a:txBody>
-                    <a:bodyPr/>
-                    <a:lstStyle/>
-                    <a:p>
-                      <a:pPr indent="0" marL="0">
-                        <a:buNone/>
-                      </a:pPr>
-                      <a:r>
-                        <a:rPr lang="en-US" sz="1300" dirty="0">
-                          <a:solidFill>
-                            <a:srgbClr val="1F2933"/>
-                          </a:solidFill>
-                        </a:rPr>
-                        <a:t>5 of 5 methods; 100% of resamples; threshold effect near z = -0.5</a:t>
-                      </a:r>
-                      <a:endParaRPr lang="en-US" sz="1300" dirty="0"/>
-                    </a:p>
-                  </a:txBody>
-                  <a:tcPr marL="76200" marR="76200" marT="50800" marB="50800" anchor="ctr">
+                  <a:tcPr marL="88900" marR="88900" marT="63500" marB="63500" anchor="ctr">
                     <a:lnL w="9525" cap="flat" cmpd="sng" algn="ctr">
                       <a:solidFill>
                         <a:srgbClr val="D5DAE0"/>
@@ -3560,12 +3355,12 @@
         </p:nvSpPr>
         <p:spPr>
           <a:xfrm>
-            <a:off x="548640" y="4572000"/>
-            <a:ext cx="11064240" cy="1417320"/>
+            <a:off x="548640" y="4663440"/>
+            <a:ext cx="11064240" cy="1371600"/>
           </a:xfrm>
           <a:prstGeom prst="roundRect">
             <a:avLst>
-              <a:gd name="adj" fmla="val 5161"/>
+              <a:gd name="adj" fmla="val 5333"/>
             </a:avLst>
           </a:prstGeom>
           <a:solidFill>
@@ -3587,8 +3382,8 @@
         </p:nvSpPr>
         <p:spPr>
           <a:xfrm>
-            <a:off x="822960" y="4709160"/>
-            <a:ext cx="10515600" cy="1188720"/>
+            <a:off x="777240" y="4754880"/>
+            <a:ext cx="10607040" cy="1188720"/>
           </a:xfrm>
           <a:prstGeom prst="rect">
             <a:avLst/>
@@ -3604,36 +3399,36 @@
               <a:buNone/>
             </a:pPr>
             <a:r>
-              <a:rPr lang="en-US" sz="1600" b="1" dirty="0">
+              <a:rPr lang="en-US" sz="1700" b="1" dirty="0">
                 <a:solidFill>
                   <a:srgbClr val="1F2933"/>
                 </a:solidFill>
               </a:rPr>
-              <a:t>Machine learning identified no additional predictors. </a:t>
+              <a:t>Selected by all five methods in every arm.  </a:t>
             </a:r>
             <a:pPr indent="0" marL="0">
               <a:buNone/>
             </a:pPr>
             <a:r>
-              <a:rPr lang="en-US" sz="1600" dirty="0">
+              <a:rPr lang="en-US" sz="1700" b="1" dirty="0">
                 <a:solidFill>
                   <a:srgbClr val="1F2933"/>
                 </a:solidFill>
               </a:rPr>
-              <a:t>Random forest and XGBoost ranked the same covariates first in every arm and outperformed linear models in one arm only, where the effect is a threshold; a linear model with that single threshold recovers most of the gap. </a:t>
+              <a:t>Machine learning added no predictor.  </a:t>
             </a:r>
             <a:pPr indent="0" marL="0">
               <a:buNone/>
             </a:pPr>
             <a:r>
-              <a:rPr lang="en-US" sz="1600" b="1" dirty="0">
+              <a:rPr lang="en-US" sz="1700" b="1" dirty="0">
                 <a:solidFill>
                   <a:srgbClr val="1F2933"/>
                 </a:solidFill>
               </a:rPr>
-              <a:t>A simulated pure-noise covariate, included as a negative control, was never selected.</a:t>
+              <a:t>A pure-noise control covariate was never selected.</a:t>
             </a:r>
-            <a:endParaRPr lang="en-US" sz="1600" dirty="0"/>
+            <a:endParaRPr lang="en-US" sz="1700" dirty="0"/>
           </a:p>
         </p:txBody>
       </p:sp>
@@ -3701,7 +3496,7 @@
                   <a:srgbClr val="000000"/>
                 </a:solidFill>
               </a:rPr>
-              <a:t>The three drugs act at different points of the DM1 pathogenic cascade, so each arm was analysed separately</a:t>
+              <a:t>The three drugs act at different points of the DM1 cascade, so each arm was analysed separately</a:t>
             </a:r>
             <a:endParaRPr lang="en-US" sz="2800" dirty="0"/>
           </a:p>
@@ -3715,12 +3510,12 @@
         </p:nvSpPr>
         <p:spPr>
           <a:xfrm>
-            <a:off x="548640" y="1508760"/>
-            <a:ext cx="2011680" cy="868680"/>
+            <a:off x="548640" y="1554480"/>
+            <a:ext cx="2011680" cy="914400"/>
           </a:xfrm>
           <a:prstGeom prst="roundRect">
             <a:avLst>
-              <a:gd name="adj" fmla="val 8421"/>
+              <a:gd name="adj" fmla="val 8000"/>
             </a:avLst>
           </a:prstGeom>
           <a:solidFill>
@@ -3742,8 +3537,8 @@
         </p:nvSpPr>
         <p:spPr>
           <a:xfrm>
-            <a:off x="548640" y="1508760"/>
-            <a:ext cx="2011680" cy="868680"/>
+            <a:off x="548640" y="1554480"/>
+            <a:ext cx="2011680" cy="914400"/>
           </a:xfrm>
           <a:prstGeom prst="rect">
             <a:avLst/>
@@ -3759,14 +3554,14 @@
               <a:buNone/>
             </a:pPr>
             <a:r>
-              <a:rPr lang="en-US" sz="1250" dirty="0">
+              <a:rPr lang="en-US" sz="1300" dirty="0">
                 <a:solidFill>
                   <a:srgbClr val="FFFFFF"/>
                 </a:solidFill>
               </a:rPr>
               <a:t>CTG repeat expansion in DMPK</a:t>
             </a:r>
-            <a:endParaRPr lang="en-US" sz="1250" dirty="0"/>
+            <a:endParaRPr lang="en-US" sz="1300" dirty="0"/>
           </a:p>
         </p:txBody>
       </p:sp>
@@ -3778,7 +3573,7 @@
         </p:nvSpPr>
         <p:spPr>
           <a:xfrm>
-            <a:off x="2596896" y="1810512"/>
+            <a:off x="2596896" y="1874520"/>
             <a:ext cx="182880" cy="274320"/>
           </a:xfrm>
           <a:prstGeom prst="rightArrow">
@@ -3803,12 +3598,12 @@
         </p:nvSpPr>
         <p:spPr>
           <a:xfrm>
-            <a:off x="2811780" y="1508760"/>
-            <a:ext cx="2011680" cy="868680"/>
+            <a:off x="2811780" y="1554480"/>
+            <a:ext cx="2011680" cy="914400"/>
           </a:xfrm>
           <a:prstGeom prst="roundRect">
             <a:avLst>
-              <a:gd name="adj" fmla="val 8421"/>
+              <a:gd name="adj" fmla="val 8000"/>
             </a:avLst>
           </a:prstGeom>
           <a:solidFill>
@@ -3830,8 +3625,8 @@
         </p:nvSpPr>
         <p:spPr>
           <a:xfrm>
-            <a:off x="2811780" y="1508760"/>
-            <a:ext cx="2011680" cy="868680"/>
+            <a:off x="2811780" y="1554480"/>
+            <a:ext cx="2011680" cy="914400"/>
           </a:xfrm>
           <a:prstGeom prst="rect">
             <a:avLst/>
@@ -3847,14 +3642,14 @@
               <a:buNone/>
             </a:pPr>
             <a:r>
-              <a:rPr lang="en-US" sz="1250" dirty="0">
+              <a:rPr lang="en-US" sz="1300" dirty="0">
                 <a:solidFill>
                   <a:srgbClr val="FFFFFF"/>
                 </a:solidFill>
               </a:rPr>
               <a:t>Toxic CUG-repeat RNA</a:t>
             </a:r>
-            <a:endParaRPr lang="en-US" sz="1250" dirty="0"/>
+            <a:endParaRPr lang="en-US" sz="1300" dirty="0"/>
           </a:p>
         </p:txBody>
       </p:sp>
@@ -3866,7 +3661,7 @@
         </p:nvSpPr>
         <p:spPr>
           <a:xfrm>
-            <a:off x="4860036" y="1810512"/>
+            <a:off x="4860036" y="1874520"/>
             <a:ext cx="182880" cy="274320"/>
           </a:xfrm>
           <a:prstGeom prst="rightArrow">
@@ -3891,8 +3686,8 @@
         </p:nvSpPr>
         <p:spPr>
           <a:xfrm>
-            <a:off x="2720340" y="2441448"/>
-            <a:ext cx="2194560" cy="502920"/>
+            <a:off x="2720340" y="2542032"/>
+            <a:ext cx="2194560" cy="365760"/>
           </a:xfrm>
           <a:prstGeom prst="rect">
             <a:avLst/>
@@ -3908,14 +3703,14 @@
               <a:buNone/>
             </a:pPr>
             <a:r>
-              <a:rPr lang="en-US" sz="1150" b="1" dirty="0">
+              <a:rPr lang="en-US" sz="1400" b="1" dirty="0">
                 <a:solidFill>
                   <a:srgbClr val="D95F0E"/>
                 </a:solidFill>
               </a:rPr>
-              <a:t>Antisense oligonucleotide: DMPK transcript knockdown</a:t>
+              <a:t>Antisense oligonucleotide</a:t>
             </a:r>
-            <a:endParaRPr lang="en-US" sz="1150" dirty="0"/>
+            <a:endParaRPr lang="en-US" sz="1400" dirty="0"/>
           </a:p>
         </p:txBody>
       </p:sp>
@@ -3927,12 +3722,12 @@
         </p:nvSpPr>
         <p:spPr>
           <a:xfrm>
-            <a:off x="5074920" y="1508760"/>
-            <a:ext cx="2011680" cy="868680"/>
+            <a:off x="5074920" y="1554480"/>
+            <a:ext cx="2011680" cy="914400"/>
           </a:xfrm>
           <a:prstGeom prst="roundRect">
             <a:avLst>
-              <a:gd name="adj" fmla="val 8421"/>
+              <a:gd name="adj" fmla="val 8000"/>
             </a:avLst>
           </a:prstGeom>
           <a:solidFill>
@@ -3954,8 +3749,8 @@
         </p:nvSpPr>
         <p:spPr>
           <a:xfrm>
-            <a:off x="5074920" y="1508760"/>
-            <a:ext cx="2011680" cy="868680"/>
+            <a:off x="5074920" y="1554480"/>
+            <a:ext cx="2011680" cy="914400"/>
           </a:xfrm>
           <a:prstGeom prst="rect">
             <a:avLst/>
@@ -3971,14 +3766,14 @@
               <a:buNone/>
             </a:pPr>
             <a:r>
-              <a:rPr lang="en-US" sz="1250" dirty="0">
+              <a:rPr lang="en-US" sz="1300" dirty="0">
                 <a:solidFill>
                   <a:srgbClr val="FFFFFF"/>
                 </a:solidFill>
               </a:rPr>
               <a:t>MBNL1 sequestration, GSK3β activation: mis-splicing</a:t>
             </a:r>
-            <a:endParaRPr lang="en-US" sz="1250" dirty="0"/>
+            <a:endParaRPr lang="en-US" sz="1300" dirty="0"/>
           </a:p>
         </p:txBody>
       </p:sp>
@@ -3990,7 +3785,7 @@
         </p:nvSpPr>
         <p:spPr>
           <a:xfrm>
-            <a:off x="7123176" y="1810512"/>
+            <a:off x="7123176" y="1874520"/>
             <a:ext cx="182880" cy="274320"/>
           </a:xfrm>
           <a:prstGeom prst="rightArrow">
@@ -4015,8 +3810,8 @@
         </p:nvSpPr>
         <p:spPr>
           <a:xfrm>
-            <a:off x="4983480" y="2441448"/>
-            <a:ext cx="2194560" cy="502920"/>
+            <a:off x="4983480" y="2542032"/>
+            <a:ext cx="2194560" cy="365760"/>
           </a:xfrm>
           <a:prstGeom prst="rect">
             <a:avLst/>
@@ -4032,14 +3827,14 @@
               <a:buNone/>
             </a:pPr>
             <a:r>
-              <a:rPr lang="en-US" sz="1150" b="1" dirty="0">
+              <a:rPr lang="en-US" sz="1400" b="1" dirty="0">
                 <a:solidFill>
                   <a:srgbClr val="D95F0E"/>
                 </a:solidFill>
               </a:rPr>
-              <a:t>Tideglusib: GSK3β inhibition</a:t>
+              <a:t>Tideglusib</a:t>
             </a:r>
-            <a:endParaRPr lang="en-US" sz="1150" dirty="0"/>
+            <a:endParaRPr lang="en-US" sz="1400" dirty="0"/>
           </a:p>
         </p:txBody>
       </p:sp>
@@ -4051,12 +3846,12 @@
         </p:nvSpPr>
         <p:spPr>
           <a:xfrm>
-            <a:off x="7338060" y="1508760"/>
-            <a:ext cx="2011680" cy="868680"/>
+            <a:off x="7338060" y="1554480"/>
+            <a:ext cx="2011680" cy="914400"/>
           </a:xfrm>
           <a:prstGeom prst="roundRect">
             <a:avLst>
-              <a:gd name="adj" fmla="val 8421"/>
+              <a:gd name="adj" fmla="val 8000"/>
             </a:avLst>
           </a:prstGeom>
           <a:solidFill>
@@ -4078,8 +3873,8 @@
         </p:nvSpPr>
         <p:spPr>
           <a:xfrm>
-            <a:off x="7338060" y="1508760"/>
-            <a:ext cx="2011680" cy="868680"/>
+            <a:off x="7338060" y="1554480"/>
+            <a:ext cx="2011680" cy="914400"/>
           </a:xfrm>
           <a:prstGeom prst="rect">
             <a:avLst/>
@@ -4095,14 +3890,14 @@
               <a:buNone/>
             </a:pPr>
             <a:r>
-              <a:rPr lang="en-US" sz="1250" dirty="0">
+              <a:rPr lang="en-US" sz="1300" dirty="0">
                 <a:solidFill>
                   <a:srgbClr val="FFFFFF"/>
                 </a:solidFill>
               </a:rPr>
               <a:t>Multisystem involvement: muscle, CNS, heart, eye</a:t>
             </a:r>
-            <a:endParaRPr lang="en-US" sz="1250" dirty="0"/>
+            <a:endParaRPr lang="en-US" sz="1300" dirty="0"/>
           </a:p>
         </p:txBody>
       </p:sp>
@@ -4114,7 +3909,7 @@
         </p:nvSpPr>
         <p:spPr>
           <a:xfrm>
-            <a:off x="9386316" y="1810512"/>
+            <a:off x="9386316" y="1874520"/>
             <a:ext cx="182880" cy="274320"/>
           </a:xfrm>
           <a:prstGeom prst="rightArrow">
@@ -4139,12 +3934,12 @@
         </p:nvSpPr>
         <p:spPr>
           <a:xfrm>
-            <a:off x="9601200" y="1508760"/>
-            <a:ext cx="2011680" cy="868680"/>
+            <a:off x="9601200" y="1554480"/>
+            <a:ext cx="2011680" cy="914400"/>
           </a:xfrm>
           <a:prstGeom prst="roundRect">
             <a:avLst>
-              <a:gd name="adj" fmla="val 8421"/>
+              <a:gd name="adj" fmla="val 8000"/>
             </a:avLst>
           </a:prstGeom>
           <a:solidFill>
@@ -4166,8 +3961,8 @@
         </p:nvSpPr>
         <p:spPr>
           <a:xfrm>
-            <a:off x="9601200" y="1508760"/>
-            <a:ext cx="2011680" cy="868680"/>
+            <a:off x="9601200" y="1554480"/>
+            <a:ext cx="2011680" cy="914400"/>
           </a:xfrm>
           <a:prstGeom prst="rect">
             <a:avLst/>
@@ -4183,14 +3978,14 @@
               <a:buNone/>
             </a:pPr>
             <a:r>
-              <a:rPr lang="en-US" sz="1250" dirty="0">
+              <a:rPr lang="en-US" sz="1300" dirty="0">
                 <a:solidFill>
                   <a:srgbClr val="FFFFFF"/>
                 </a:solidFill>
               </a:rPr>
               <a:t>Clinical phenotype: myotonia, weakness</a:t>
             </a:r>
-            <a:endParaRPr lang="en-US" sz="1250" dirty="0"/>
+            <a:endParaRPr lang="en-US" sz="1300" dirty="0"/>
           </a:p>
         </p:txBody>
       </p:sp>
@@ -4202,8 +3997,8 @@
         </p:nvSpPr>
         <p:spPr>
           <a:xfrm>
-            <a:off x="9509760" y="2441448"/>
-            <a:ext cx="2194560" cy="502920"/>
+            <a:off x="9509760" y="2542032"/>
+            <a:ext cx="2194560" cy="365760"/>
           </a:xfrm>
           <a:prstGeom prst="rect">
             <a:avLst/>
@@ -4219,14 +4014,14 @@
               <a:buNone/>
             </a:pPr>
             <a:r>
-              <a:rPr lang="en-US" sz="1150" b="1" dirty="0">
+              <a:rPr lang="en-US" sz="1400" b="1" dirty="0">
                 <a:solidFill>
                   <a:srgbClr val="D95F0E"/>
                 </a:solidFill>
               </a:rPr>
-              <a:t>Mexiletine: sodium-channel blockade</a:t>
+              <a:t>Mexiletine</a:t>
             </a:r>
-            <a:endParaRPr lang="en-US" sz="1150" dirty="0"/>
+            <a:endParaRPr lang="en-US" sz="1400" dirty="0"/>
           </a:p>
         </p:txBody>
       </p:sp>
@@ -4238,7 +4033,7 @@
         </p:nvSpPr>
         <p:spPr>
           <a:xfrm>
-            <a:off x="548640" y="3246120"/>
+            <a:off x="548640" y="3429000"/>
             <a:ext cx="5120640" cy="365760"/>
           </a:xfrm>
           <a:prstGeom prst="rect">
@@ -4255,14 +4050,14 @@
               <a:buNone/>
             </a:pPr>
             <a:r>
-              <a:rPr lang="en-US" sz="1600" b="1" dirty="0">
+              <a:rPr lang="en-US" sz="1700" b="1" dirty="0">
                 <a:solidFill>
                   <a:srgbClr val="000000"/>
                 </a:solidFill>
               </a:rPr>
               <a:t>Dataset</a:t>
             </a:r>
-            <a:endParaRPr lang="en-US" sz="1600" dirty="0"/>
+            <a:endParaRPr lang="en-US" sz="1700" dirty="0"/>
           </a:p>
         </p:txBody>
       </p:sp>
@@ -4274,8 +4069,8 @@
         </p:nvSpPr>
         <p:spPr>
           <a:xfrm>
-            <a:off x="548640" y="3657600"/>
-            <a:ext cx="5212080" cy="2651760"/>
+            <a:off x="548640" y="3840480"/>
+            <a:ext cx="5212080" cy="2377440"/>
           </a:xfrm>
           <a:prstGeom prst="rect">
             <a:avLst/>
@@ -4289,56 +4084,56 @@
           <a:p>
             <a:pPr marL="177800" indent="-177800">
               <a:spcAft>
-                <a:spcPts val="600"/>
+                <a:spcPts val="800"/>
               </a:spcAft>
               <a:buSzPct val="100000"/>
               <a:buChar char="•"/>
             </a:pPr>
             <a:r>
-              <a:rPr lang="en-US" sz="1300" dirty="0">
+              <a:rPr lang="en-US" sz="1500" dirty="0">
                 <a:solidFill>
                   <a:srgbClr val="1F2933"/>
                 </a:solidFill>
               </a:rPr>
-              <a:t>500 simulated patients, one treatment each: n = 161 / 170 / 169; responder rate 29% / 41% / 48%</a:t>
+              <a:t>500 simulated patients, one treatment each; n = 161 / 170 / 169</a:t>
             </a:r>
-            <a:endParaRPr lang="en-US" sz="1400" dirty="0"/>
+            <a:endParaRPr lang="en-US" sz="1500" dirty="0"/>
           </a:p>
           <a:p>
             <a:pPr marL="177800" indent="-177800">
               <a:spcAft>
-                <a:spcPts val="600"/>
+                <a:spcPts val="800"/>
               </a:spcAft>
               <a:buSzPct val="100000"/>
               <a:buChar char="•"/>
             </a:pPr>
             <a:r>
-              <a:rPr lang="en-US" sz="1300" dirty="0">
+              <a:rPr lang="en-US" sz="1500" dirty="0">
                 <a:solidFill>
                   <a:srgbClr val="1F2933"/>
                 </a:solidFill>
               </a:rPr>
-              <a:t>18 baseline covariates: genetic burden, disease stage, muscle, CNS, cardiac, ophthalmic, metabolic and demographic; some are noise by design</a:t>
+              <a:t>18 baseline covariates, some pure noise by design</a:t>
             </a:r>
-            <a:endParaRPr lang="en-US" sz="1400" dirty="0"/>
+            <a:endParaRPr lang="en-US" sz="1500" dirty="0"/>
           </a:p>
           <a:p>
             <a:pPr marL="177800" indent="-177800">
               <a:spcAft>
-                <a:spcPts val="600"/>
+                <a:spcPts val="800"/>
               </a:spcAft>
               <a:buSzPct val="100000"/>
               <a:buChar char="•"/>
             </a:pPr>
             <a:r>
-              <a:rPr lang="en-US" sz="1300" dirty="0">
+              <a:rPr lang="en-US" sz="1500" dirty="0">
                 <a:solidFill>
                   <a:srgbClr val="1F2933"/>
                 </a:solidFill>
               </a:rPr>
-              <a:t>Data review: no missing values; albumin is a single imputed constant in the mexiletine arm and was excluded there. CK floor at 50 U/L and mosaicism index of 0 retained as observed. No patients excluded</a:t>
+              <a:t>Albumin constant in the mexiletine arm: excluded there. No patients excluded</a:t>
             </a:r>
-            <a:endParaRPr lang="en-US" sz="1400" dirty="0"/>
+            <a:endParaRPr lang="en-US" sz="1500" dirty="0"/>
           </a:p>
         </p:txBody>
       </p:sp>
@@ -4350,7 +4145,7 @@
         </p:nvSpPr>
         <p:spPr>
           <a:xfrm>
-            <a:off x="6217920" y="3246120"/>
+            <a:off x="6217920" y="3429000"/>
             <a:ext cx="5394960" cy="365760"/>
           </a:xfrm>
           <a:prstGeom prst="rect">
@@ -4367,14 +4162,14 @@
               <a:buNone/>
             </a:pPr>
             <a:r>
-              <a:rPr lang="en-US" sz="1600" b="1" dirty="0">
+              <a:rPr lang="en-US" sz="1700" b="1" dirty="0">
                 <a:solidFill>
                   <a:srgbClr val="000000"/>
                 </a:solidFill>
               </a:rPr>
-              <a:t>Analysis workflow, per arm</a:t>
+              <a:t>Workflow, per arm</a:t>
             </a:r>
-            <a:endParaRPr lang="en-US" sz="1600" dirty="0"/>
+            <a:endParaRPr lang="en-US" sz="1700" dirty="0"/>
           </a:p>
         </p:txBody>
       </p:sp>
@@ -4386,8 +4181,8 @@
         </p:nvSpPr>
         <p:spPr>
           <a:xfrm>
-            <a:off x="6217920" y="3657600"/>
-            <a:ext cx="5394960" cy="2651760"/>
+            <a:off x="6217920" y="3840480"/>
+            <a:ext cx="5394960" cy="2377440"/>
           </a:xfrm>
           <a:prstGeom prst="rect">
             <a:avLst/>
@@ -4401,74 +4196,74 @@
           <a:p>
             <a:pPr marL="177800" indent="-177800">
               <a:spcAft>
-                <a:spcPts val="600"/>
+                <a:spcPts val="800"/>
               </a:spcAft>
               <a:buSzPct val="100000"/>
               <a:buChar char="•"/>
             </a:pPr>
             <a:r>
-              <a:rPr lang="en-US" sz="1300" dirty="0">
+              <a:rPr lang="en-US" sz="1500" dirty="0">
                 <a:solidFill>
                   <a:srgbClr val="1F2933"/>
                 </a:solidFill>
               </a:rPr>
-              <a:t>75/25 train/test split stratified by responder status and onset phenotype, fixed seed; test set evaluated once</a:t>
+              <a:t>75/25 split, stratified by response and onset; test set scored once</a:t>
             </a:r>
-            <a:endParaRPr lang="en-US" sz="1400" dirty="0"/>
+            <a:endParaRPr lang="en-US" sz="1500" dirty="0"/>
           </a:p>
           <a:p>
             <a:pPr marL="177800" indent="-177800">
               <a:spcAft>
-                <a:spcPts val="600"/>
+                <a:spcPts val="800"/>
               </a:spcAft>
               <a:buSzPct val="100000"/>
               <a:buChar char="•"/>
             </a:pPr>
             <a:r>
-              <a:rPr lang="en-US" sz="1300" dirty="0">
+              <a:rPr lang="en-US" sz="1500" dirty="0">
                 <a:solidFill>
                   <a:srgbClr val="1F2933"/>
                 </a:solidFill>
               </a:rPr>
-              <a:t>All model selection and tuning by 5-fold cross-validation within the training set</a:t>
+              <a:t>5-fold cross-validation within training for every choice</a:t>
             </a:r>
-            <a:endParaRPr lang="en-US" sz="1400" dirty="0"/>
+            <a:endParaRPr lang="en-US" sz="1500" dirty="0"/>
           </a:p>
           <a:p>
             <a:pPr marL="177800" indent="-177800">
               <a:spcAft>
-                <a:spcPts val="600"/>
+                <a:spcPts val="800"/>
               </a:spcAft>
               <a:buSzPct val="100000"/>
               <a:buChar char="•"/>
             </a:pPr>
             <a:r>
-              <a:rPr lang="en-US" sz="1300" dirty="0">
+              <a:rPr lang="en-US" sz="1500" dirty="0">
                 <a:solidFill>
                   <a:srgbClr val="1F2933"/>
                 </a:solidFill>
               </a:rPr>
-              <a:t>Covariate models: stepwise selection (BIC), LASSO, elastic net. Machine learning: random forest, XGBoost (untuned and tuned)</a:t>
+              <a:t>Stepwise (BIC), LASSO, elastic net  vs  random forest, XGBoost</a:t>
             </a:r>
-            <a:endParaRPr lang="en-US" sz="1400" dirty="0"/>
+            <a:endParaRPr lang="en-US" sz="1500" dirty="0"/>
           </a:p>
           <a:p>
             <a:pPr marL="177800" indent="-177800">
               <a:spcAft>
-                <a:spcPts val="600"/>
+                <a:spcPts val="800"/>
               </a:spcAft>
               <a:buSzPct val="100000"/>
               <a:buChar char="•"/>
             </a:pPr>
             <a:r>
-              <a:rPr lang="en-US" sz="1300" dirty="0">
+              <a:rPr lang="en-US" sz="1500" dirty="0">
                 <a:solidFill>
                   <a:srgbClr val="1F2933"/>
                 </a:solidFill>
               </a:rPr>
-              <a:t>Noise control: a pure-noise covariate as negative control, selection stability over 200 bootstrap resamples, and agreement across the five methods</a:t>
+              <a:t>Noise control: pure-noise covariate, 200 bootstrap resamples, 5-method agreement</a:t>
             </a:r>
-            <a:endParaRPr lang="en-US" sz="1400" dirty="0"/>
+            <a:endParaRPr lang="en-US" sz="1500" dirty="0"/>
           </a:p>
         </p:txBody>
       </p:sp>
@@ -4536,7 +4331,7 @@
                   <a:srgbClr val="000000"/>
                 </a:solidFill>
               </a:rPr>
-              <a:t>Across the range of the dominant covariate, predicted response spans roughly 15% to 85%; onset phenotype adds little</a:t>
+              <a:t>Across the dominant covariate's range, predicted response spans 15% to 85%; onset phenotype adds little</a:t>
             </a:r>
             <a:endParaRPr lang="en-US" sz="2800" dirty="0"/>
           </a:p>
@@ -4574,7 +4369,7 @@
         </p:nvSpPr>
         <p:spPr>
           <a:xfrm>
-            <a:off x="6400800" y="1371600"/>
+            <a:off x="6400800" y="1417320"/>
             <a:ext cx="5212080" cy="365760"/>
           </a:xfrm>
           <a:prstGeom prst="rect">
@@ -4591,14 +4386,14 @@
               <a:buNone/>
             </a:pPr>
             <a:r>
-              <a:rPr lang="en-US" sz="1500" b="1" dirty="0">
+              <a:rPr lang="en-US" sz="1600" b="1" dirty="0">
                 <a:solidFill>
                   <a:srgbClr val="000000"/>
                 </a:solidFill>
               </a:rPr>
-              <a:t>Mexiletine: myotonia severity</a:t>
+              <a:t>Mexiletine · myotonia severity</a:t>
             </a:r>
-            <a:endParaRPr lang="en-US" sz="1500" dirty="0"/>
+            <a:endParaRPr lang="en-US" sz="1600" dirty="0"/>
           </a:p>
         </p:txBody>
       </p:sp>
@@ -4610,8 +4405,8 @@
         </p:nvSpPr>
         <p:spPr>
           <a:xfrm>
-            <a:off x="6400800" y="1719072"/>
-            <a:ext cx="5212080" cy="914400"/>
+            <a:off x="6400800" y="1801368"/>
+            <a:ext cx="5212080" cy="640080"/>
           </a:xfrm>
           <a:prstGeom prst="rect">
             <a:avLst/>
@@ -4627,14 +4422,14 @@
               <a:buNone/>
             </a:pPr>
             <a:r>
-              <a:rPr lang="en-US" sz="1300" dirty="0">
+              <a:rPr lang="en-US" sz="1500" dirty="0">
                 <a:solidFill>
                   <a:srgbClr val="1F2933"/>
                 </a:solidFill>
               </a:rPr>
-              <a:t>Predicted response 17% → 38% from the 10th to the 90th percentile. A symptomatic agent: effect size scales with baseline symptom burden. Late-onset patients respond less because baseline myotonia is mild.</a:t>
+              <a:t>17% → 38%.  Symptomatic drug: effect scales with symptom burden.</a:t>
             </a:r>
-            <a:endParaRPr lang="en-US" sz="1300" dirty="0"/>
+            <a:endParaRPr lang="en-US" sz="1500" dirty="0"/>
           </a:p>
         </p:txBody>
       </p:sp>
@@ -4646,7 +4441,7 @@
         </p:nvSpPr>
         <p:spPr>
           <a:xfrm>
-            <a:off x="6400800" y="2606040"/>
+            <a:off x="6400800" y="2560320"/>
             <a:ext cx="5212080" cy="365760"/>
           </a:xfrm>
           <a:prstGeom prst="rect">
@@ -4663,14 +4458,14 @@
               <a:buNone/>
             </a:pPr>
             <a:r>
-              <a:rPr lang="en-US" sz="1500" b="1" dirty="0">
+              <a:rPr lang="en-US" sz="1600" b="1" dirty="0">
                 <a:solidFill>
                   <a:srgbClr val="000000"/>
                 </a:solidFill>
               </a:rPr>
-              <a:t>Antisense oligonucleotide: CTG repeat length</a:t>
+              <a:t>Antisense oligonucleotide · CTG repeats</a:t>
             </a:r>
-            <a:endParaRPr lang="en-US" sz="1500" dirty="0"/>
+            <a:endParaRPr lang="en-US" sz="1600" dirty="0"/>
           </a:p>
         </p:txBody>
       </p:sp>
@@ -4682,8 +4477,8 @@
         </p:nvSpPr>
         <p:spPr>
           <a:xfrm>
-            <a:off x="6400800" y="2953512"/>
-            <a:ext cx="5212080" cy="914400"/>
+            <a:off x="6400800" y="2944368"/>
+            <a:ext cx="5212080" cy="640080"/>
           </a:xfrm>
           <a:prstGeom prst="rect">
             <a:avLst/>
@@ -4699,14 +4494,14 @@
               <a:buNone/>
             </a:pPr>
             <a:r>
-              <a:rPr lang="en-US" sz="1300" dirty="0">
+              <a:rPr lang="en-US" sz="1500" dirty="0">
                 <a:solidFill>
                   <a:srgbClr val="1F2933"/>
                 </a:solidFill>
               </a:rPr>
-              <a:t>Predicted response 22% → 75%. The sole predictor. A target-engaging agent: effect scales with the amount of target transcript. Individual-level prediction remains poor (test R² &lt; 0.1).</a:t>
+              <a:t>22% → 75%.  Target-engaging drug: effect scales with target amount.</a:t>
             </a:r>
-            <a:endParaRPr lang="en-US" sz="1300" dirty="0"/>
+            <a:endParaRPr lang="en-US" sz="1500" dirty="0"/>
           </a:p>
         </p:txBody>
       </p:sp>
@@ -4718,7 +4513,7 @@
         </p:nvSpPr>
         <p:spPr>
           <a:xfrm>
-            <a:off x="6400800" y="3840480"/>
+            <a:off x="6400800" y="3703320"/>
             <a:ext cx="5212080" cy="365760"/>
           </a:xfrm>
           <a:prstGeom prst="rect">
@@ -4735,14 +4530,14 @@
               <a:buNone/>
             </a:pPr>
             <a:r>
-              <a:rPr lang="en-US" sz="1500" b="1" dirty="0">
+              <a:rPr lang="en-US" sz="1600" b="1" dirty="0">
                 <a:solidFill>
                   <a:srgbClr val="000000"/>
                 </a:solidFill>
               </a:rPr>
-              <a:t>Tideglusib: cognitive function</a:t>
+              <a:t>Tideglusib · cognitive function</a:t>
             </a:r>
-            <a:endParaRPr lang="en-US" sz="1500" dirty="0"/>
+            <a:endParaRPr lang="en-US" sz="1600" dirty="0"/>
           </a:p>
         </p:txBody>
       </p:sp>
@@ -4754,8 +4549,8 @@
         </p:nvSpPr>
         <p:spPr>
           <a:xfrm>
-            <a:off x="6400800" y="4187952"/>
-            <a:ext cx="5212080" cy="914400"/>
+            <a:off x="6400800" y="4087368"/>
+            <a:ext cx="5212080" cy="640080"/>
           </a:xfrm>
           <a:prstGeom prst="rect">
             <a:avLst/>
@@ -4771,14 +4566,14 @@
               <a:buNone/>
             </a:pPr>
             <a:r>
-              <a:rPr lang="en-US" sz="1300" dirty="0">
+              <a:rPr lang="en-US" sz="1500" dirty="0">
                 <a:solidFill>
                   <a:srgbClr val="1F2933"/>
                 </a:solidFill>
               </a:rPr>
-              <a:t>Predicted response 87% → 14%, as a threshold near z = -0.5 rather than a gradient. The composite endpoint includes a cognitive domain, so intact cognition leaves no room for measurable gain: a ceiling effect.</a:t>
+              <a:t>87% → 14%, as a threshold near z = -0.5.  Composite endpoint: ceiling effect.</a:t>
             </a:r>
-            <a:endParaRPr lang="en-US" sz="1300" dirty="0"/>
+            <a:endParaRPr lang="en-US" sz="1500" dirty="0"/>
           </a:p>
         </p:txBody>
       </p:sp>
@@ -4790,12 +4585,12 @@
         </p:nvSpPr>
         <p:spPr>
           <a:xfrm>
-            <a:off x="6400800" y="5166360"/>
-            <a:ext cx="5212080" cy="1051560"/>
+            <a:off x="6400800" y="5074920"/>
+            <a:ext cx="5212080" cy="1143000"/>
           </a:xfrm>
           <a:prstGeom prst="roundRect">
             <a:avLst>
-              <a:gd name="adj" fmla="val 6957"/>
+              <a:gd name="adj" fmla="val 6400"/>
             </a:avLst>
           </a:prstGeom>
           <a:solidFill>
@@ -4817,8 +4612,8 @@
         </p:nvSpPr>
         <p:spPr>
           <a:xfrm>
-            <a:off x="6583680" y="5257800"/>
-            <a:ext cx="4846320" cy="868680"/>
+            <a:off x="6629400" y="5166360"/>
+            <a:ext cx="4754880" cy="960120"/>
           </a:xfrm>
           <a:prstGeom prst="rect">
             <a:avLst/>
@@ -4834,25 +4629,25 @@
               <a:buNone/>
             </a:pPr>
             <a:r>
-              <a:rPr lang="en-US" sz="1250" b="1" dirty="0">
+              <a:rPr lang="en-US" sz="1500" b="1" dirty="0">
                 <a:solidFill>
                   <a:srgbClr val="1F2933"/>
                 </a:solidFill>
               </a:rPr>
-              <a:t>Independently replicated. </a:t>
+              <a:t>Independently replicated: </a:t>
             </a:r>
             <a:pPr indent="0" marL="0">
               <a:buNone/>
             </a:pPr>
             <a:r>
-              <a:rPr lang="en-US" sz="1250" dirty="0">
+              <a:rPr lang="en-US" sz="1500" dirty="0">
                 <a:solidFill>
                   <a:srgbClr val="1F2933"/>
                 </a:solidFill>
               </a:rPr>
-              <a:t>Three team members, three implementations (R, R, Python), different splits, up to 30 methods and 20 repeated splits identified the same three covariates. CTG repeat length behaves as a prognostic marker across arms; cognitive function is specific to the tideglusib arm.</a:t>
+              <a:t>three implementations, 20 repeated splits, same three covariates.</a:t>
             </a:r>
-            <a:endParaRPr lang="en-US" sz="1250" dirty="0"/>
+            <a:endParaRPr lang="en-US" sz="1500" dirty="0"/>
           </a:p>
         </p:txBody>
       </p:sp>
@@ -4920,7 +4715,7 @@
                   <a:srgbClr val="000000"/>
                 </a:solidFill>
               </a:rPr>
-              <a:t>Covariate models match machine learning in two arms; tree ensembles lead in the third only because the effect is a threshold</a:t>
+              <a:t>Covariate models match machine learning in two arms; tree ensembles lead in the third because the effect is a threshold</a:t>
             </a:r>
             <a:endParaRPr lang="en-US" sz="2800" dirty="0"/>
           </a:p>
@@ -4942,7 +4737,7 @@
         </p:blipFill>
         <p:spPr>
           <a:xfrm>
-            <a:off x="548640" y="1325880"/>
+            <a:off x="548640" y="1371600"/>
             <a:ext cx="11064240" cy="4023360"/>
           </a:xfrm>
           <a:prstGeom prst="rect">
@@ -4958,7 +4753,7 @@
         </p:nvSpPr>
         <p:spPr>
           <a:xfrm>
-            <a:off x="548640" y="5440680"/>
+            <a:off x="548640" y="5532120"/>
             <a:ext cx="3566160" cy="365760"/>
           </a:xfrm>
           <a:prstGeom prst="rect">
@@ -4975,14 +4770,14 @@
               <a:buNone/>
             </a:pPr>
             <a:r>
-              <a:rPr lang="en-US" sz="1400" b="1" dirty="0">
+              <a:rPr lang="en-US" sz="1600" b="1" dirty="0">
                 <a:solidFill>
                   <a:srgbClr val="000000"/>
                 </a:solidFill>
               </a:rPr>
-              <a:t>Mexiletine: equivalent</a:t>
+              <a:t>Mexiletine</a:t>
             </a:r>
-            <a:endParaRPr lang="en-US" sz="1400" dirty="0"/>
+            <a:endParaRPr lang="en-US" sz="1600" dirty="0"/>
           </a:p>
         </p:txBody>
       </p:sp>
@@ -4994,8 +4789,8 @@
         </p:nvSpPr>
         <p:spPr>
           <a:xfrm>
-            <a:off x="548640" y="5760720"/>
-            <a:ext cx="3566160" cy="640080"/>
+            <a:off x="548640" y="5897880"/>
+            <a:ext cx="3566160" cy="548640"/>
           </a:xfrm>
           <a:prstGeom prst="rect">
             <a:avLst/>
@@ -5011,14 +4806,14 @@
               <a:buNone/>
             </a:pPr>
             <a:r>
-              <a:rPr lang="en-US" sz="1150" dirty="0">
+              <a:rPr lang="en-US" sz="1400" dirty="0">
                 <a:solidFill>
                   <a:srgbClr val="1F2933"/>
                 </a:solidFill>
               </a:rPr>
-              <a:t>Test R² 0.47 to 0.54 for every method; across 20 repeated splits the top rank alternates between stepwise selection and tuned XGBoost.</a:t>
+              <a:t>Equivalent: R² 0.47 to 0.54 for every method</a:t>
             </a:r>
-            <a:endParaRPr lang="en-US" sz="1150" dirty="0"/>
+            <a:endParaRPr lang="en-US" sz="1400" dirty="0"/>
           </a:p>
         </p:txBody>
       </p:sp>
@@ -5030,7 +4825,7 @@
         </p:nvSpPr>
         <p:spPr>
           <a:xfrm>
-            <a:off x="4297680" y="5440680"/>
+            <a:off x="4297680" y="5532120"/>
             <a:ext cx="3566160" cy="365760"/>
           </a:xfrm>
           <a:prstGeom prst="rect">
@@ -5047,14 +4842,14 @@
               <a:buNone/>
             </a:pPr>
             <a:r>
-              <a:rPr lang="en-US" sz="1400" b="1" dirty="0">
+              <a:rPr lang="en-US" sz="1600" b="1" dirty="0">
                 <a:solidFill>
                   <a:srgbClr val="000000"/>
                 </a:solidFill>
               </a:rPr>
-              <a:t>Oligonucleotide: low predictability</a:t>
+              <a:t>Oligonucleotide</a:t>
             </a:r>
-            <a:endParaRPr lang="en-US" sz="1400" dirty="0"/>
+            <a:endParaRPr lang="en-US" sz="1600" dirty="0"/>
           </a:p>
         </p:txBody>
       </p:sp>
@@ -5066,8 +4861,8 @@
         </p:nvSpPr>
         <p:spPr>
           <a:xfrm>
-            <a:off x="4297680" y="5760720"/>
-            <a:ext cx="3566160" cy="640080"/>
+            <a:off x="4297680" y="5897880"/>
+            <a:ext cx="3566160" cy="548640"/>
           </a:xfrm>
           <a:prstGeom prst="rect">
             <a:avLst/>
@@ -5083,14 +4878,14 @@
               <a:buNone/>
             </a:pPr>
             <a:r>
-              <a:rPr lang="en-US" sz="1150" dirty="0">
+              <a:rPr lang="en-US" sz="1400" dirty="0">
                 <a:solidFill>
                   <a:srgbClr val="1F2933"/>
                 </a:solidFill>
               </a:rPr>
-              <a:t>Test R² &lt; 0.1 for every method on every split. The repeat-length effect is consistent, but residual between-patient variability dominates.</a:t>
+              <a:t>Low predictability: R² &lt; 0.1 for every method</a:t>
             </a:r>
-            <a:endParaRPr lang="en-US" sz="1150" dirty="0"/>
+            <a:endParaRPr lang="en-US" sz="1400" dirty="0"/>
           </a:p>
         </p:txBody>
       </p:sp>
@@ -5102,7 +4897,7 @@
         </p:nvSpPr>
         <p:spPr>
           <a:xfrm>
-            <a:off x="8046720" y="5440680"/>
+            <a:off x="8046720" y="5532120"/>
             <a:ext cx="3566160" cy="365760"/>
           </a:xfrm>
           <a:prstGeom prst="rect">
@@ -5119,14 +4914,14 @@
               <a:buNone/>
             </a:pPr>
             <a:r>
-              <a:rPr lang="en-US" sz="1400" b="1" dirty="0">
+              <a:rPr lang="en-US" sz="1600" b="1" dirty="0">
                 <a:solidFill>
                   <a:srgbClr val="D95F0E"/>
                 </a:solidFill>
               </a:rPr>
-              <a:t>Tideglusib: tree ensembles lead, because of a threshold</a:t>
+              <a:t>Tideglusib</a:t>
             </a:r>
-            <a:endParaRPr lang="en-US" sz="1400" dirty="0"/>
+            <a:endParaRPr lang="en-US" sz="1600" dirty="0"/>
           </a:p>
         </p:txBody>
       </p:sp>
@@ -5138,8 +4933,8 @@
         </p:nvSpPr>
         <p:spPr>
           <a:xfrm>
-            <a:off x="8046720" y="5760720"/>
-            <a:ext cx="3566160" cy="640080"/>
+            <a:off x="8046720" y="5897880"/>
+            <a:ext cx="3566160" cy="548640"/>
           </a:xfrm>
           <a:prstGeom prst="rect">
             <a:avLst/>
@@ -5155,14 +4950,14 @@
               <a:buNone/>
             </a:pPr>
             <a:r>
-              <a:rPr lang="en-US" sz="1150" dirty="0">
+              <a:rPr lang="en-US" sz="1400" dirty="0">
                 <a:solidFill>
                   <a:srgbClr val="1F2933"/>
                 </a:solidFill>
               </a:rPr>
-              <a:t>Random forest and XGBoost R² 0.55 vs linear 0.24 to 0.30, on 19 of 20 splits. A linear model with a single threshold on cognition reaches 0.45. Tuned XGBoost selected depth-1 trees: no interactions.</a:t>
+              <a:t>Tree ensembles 0.55 vs linear 0.24 to 0.30; one threshold brings linear to 0.45</a:t>
             </a:r>
-            <a:endParaRPr lang="en-US" sz="1150" dirty="0"/>
+            <a:endParaRPr lang="en-US" sz="1400" dirty="0"/>
           </a:p>
         </p:txBody>
       </p:sp>
@@ -5230,7 +5025,7 @@
                   <a:srgbClr val="000000"/>
                 </a:solidFill>
               </a:rPr>
-              <a:t>Stratify on the measure closest to the drug's target: one routine baseline assessment per arm separates response rates two- to seven-fold</a:t>
+              <a:t>Stratify on the measure closest to the drug's target: one baseline assessment per arm separates response two- to seven-fold</a:t>
             </a:r>
             <a:endParaRPr lang="en-US" sz="2800" dirty="0"/>
           </a:p>
@@ -5251,7 +5046,7 @@
           </p:nvPr>
         </p:nvGraphicFramePr>
         <p:xfrm>
-          <a:off x="548640" y="1371600"/>
+          <a:off x="548640" y="1417320"/>
           <a:ext cx="11064240" cy="914400"/>
         </p:xfrm>
         <a:graphic>
@@ -5259,13 +5054,13 @@
             <a:tbl>
               <a:tblPr/>
               <a:tblGrid>
+                <a:gridCol w="2286000"/>
+                <a:gridCol w="2103120"/>
+                <a:gridCol w="1463040"/>
                 <a:gridCol w="1920240"/>
-                <a:gridCol w="1737360"/>
-                <a:gridCol w="1920240"/>
-                <a:gridCol w="1645920"/>
-                <a:gridCol w="3840480"/>
+                <a:gridCol w="3291840"/>
               </a:tblGrid>
-              <a:tr h="411480">
+              <a:tr h="457200">
                 <a:tc>
                   <a:txBody>
                     <a:bodyPr/>
@@ -5275,17 +5070,17 @@
                         <a:buNone/>
                       </a:pPr>
                       <a:r>
-                        <a:rPr lang="en-US" sz="1300" b="1" dirty="0">
+                        <a:rPr lang="en-US" sz="1400" b="1" dirty="0">
                           <a:solidFill>
                             <a:srgbClr val="000000"/>
                           </a:solidFill>
                         </a:rPr>
                         <a:t>Treatment</a:t>
                       </a:r>
-                      <a:endParaRPr lang="en-US" sz="1300" dirty="0"/>
+                      <a:endParaRPr lang="en-US" sz="1400" dirty="0"/>
                     </a:p>
                   </a:txBody>
-                  <a:tcPr marL="76200" marR="76200" marT="50800" marB="50800" anchor="ctr">
+                  <a:tcPr marL="88900" marR="88900" marT="63500" marB="63500" anchor="ctr">
                     <a:lnL w="9525" cap="flat" cmpd="sng" algn="ctr">
                       <a:solidFill>
                         <a:srgbClr val="D5DAE0"/>
@@ -5336,17 +5131,17 @@
                         <a:buNone/>
                       </a:pPr>
                       <a:r>
-                        <a:rPr lang="en-US" sz="1300" b="1" dirty="0">
+                        <a:rPr lang="en-US" sz="1400" b="1" dirty="0">
                           <a:solidFill>
                             <a:srgbClr val="000000"/>
                           </a:solidFill>
                         </a:rPr>
-                        <a:t>Baseline measure</a:t>
+                        <a:t>Measure at baseline</a:t>
                       </a:r>
-                      <a:endParaRPr lang="en-US" sz="1300" dirty="0"/>
+                      <a:endParaRPr lang="en-US" sz="1400" dirty="0"/>
                     </a:p>
                   </a:txBody>
-                  <a:tcPr marL="76200" marR="76200" marT="50800" marB="50800" anchor="ctr">
+                  <a:tcPr marL="88900" marR="88900" marT="63500" marB="63500" anchor="ctr">
                     <a:lnL w="9525" cap="flat" cmpd="sng" algn="ctr">
                       <a:solidFill>
                         <a:srgbClr val="D5DAE0"/>
@@ -5397,17 +5192,17 @@
                         <a:buNone/>
                       </a:pPr>
                       <a:r>
-                        <a:rPr lang="en-US" sz="1300" b="1" dirty="0">
+                        <a:rPr lang="en-US" sz="1400" b="1" dirty="0">
                           <a:solidFill>
                             <a:srgbClr val="000000"/>
                           </a:solidFill>
                         </a:rPr>
-                        <a:t>Cut-off (training-set tree)</a:t>
+                        <a:t>Cut-off</a:t>
                       </a:r>
-                      <a:endParaRPr lang="en-US" sz="1300" dirty="0"/>
+                      <a:endParaRPr lang="en-US" sz="1400" dirty="0"/>
                     </a:p>
                   </a:txBody>
-                  <a:tcPr marL="76200" marR="76200" marT="50800" marB="50800" anchor="ctr">
+                  <a:tcPr marL="88900" marR="88900" marT="63500" marB="63500" anchor="ctr">
                     <a:lnL w="9525" cap="flat" cmpd="sng" algn="ctr">
                       <a:solidFill>
                         <a:srgbClr val="D5DAE0"/>
@@ -5458,17 +5253,17 @@
                         <a:buNone/>
                       </a:pPr>
                       <a:r>
-                        <a:rPr lang="en-US" sz="1300" b="1" dirty="0">
+                        <a:rPr lang="en-US" sz="1400" b="1" dirty="0">
                           <a:solidFill>
                             <a:srgbClr val="000000"/>
                           </a:solidFill>
                         </a:rPr>
-                        <a:t>Held-out responder rate</a:t>
+                        <a:t>Held-out responders</a:t>
                       </a:r>
-                      <a:endParaRPr lang="en-US" sz="1300" dirty="0"/>
+                      <a:endParaRPr lang="en-US" sz="1400" dirty="0"/>
                     </a:p>
                   </a:txBody>
-                  <a:tcPr marL="76200" marR="76200" marT="50800" marB="50800" anchor="ctr">
+                  <a:tcPr marL="88900" marR="88900" marT="63500" marB="63500" anchor="ctr">
                     <a:lnL w="9525" cap="flat" cmpd="sng" algn="ctr">
                       <a:solidFill>
                         <a:srgbClr val="D5DAE0"/>
@@ -5519,17 +5314,17 @@
                         <a:buNone/>
                       </a:pPr>
                       <a:r>
-                        <a:rPr lang="en-US" sz="1300" b="1" dirty="0">
+                        <a:rPr lang="en-US" sz="1400" b="1" dirty="0">
                           <a:solidFill>
                             <a:srgbClr val="000000"/>
                           </a:solidFill>
                         </a:rPr>
-                        <a:t>Trial-design implication</a:t>
+                        <a:t>Trial design</a:t>
                       </a:r>
-                      <a:endParaRPr lang="en-US" sz="1300" dirty="0"/>
+                      <a:endParaRPr lang="en-US" sz="1400" dirty="0"/>
                     </a:p>
                   </a:txBody>
-                  <a:tcPr marL="76200" marR="76200" marT="50800" marB="50800" anchor="ctr">
+                  <a:tcPr marL="88900" marR="88900" marT="63500" marB="63500" anchor="ctr">
                     <a:lnL w="9525" cap="flat" cmpd="sng" algn="ctr">
                       <a:solidFill>
                         <a:srgbClr val="D5DAE0"/>
@@ -5572,7 +5367,7 @@
                   </a:tcPr>
                 </a:tc>
               </a:tr>
-              <a:tr h="640080">
+              <a:tr h="685800">
                 <a:tc>
                   <a:txBody>
                     <a:bodyPr/>
@@ -5582,17 +5377,17 @@
                         <a:buNone/>
                       </a:pPr>
                       <a:r>
-                        <a:rPr lang="en-US" sz="1300" b="1" dirty="0">
+                        <a:rPr lang="en-US" sz="1400" b="1" dirty="0">
                           <a:solidFill>
                             <a:srgbClr val="1F2933"/>
                           </a:solidFill>
                         </a:rPr>
                         <a:t>Mexiletine</a:t>
                       </a:r>
-                      <a:endParaRPr lang="en-US" sz="1300" dirty="0"/>
+                      <a:endParaRPr lang="en-US" sz="1400" dirty="0"/>
                     </a:p>
                   </a:txBody>
-                  <a:tcPr marL="76200" marR="76200" marT="50800" marB="50800" anchor="ctr">
+                  <a:tcPr marL="88900" marR="88900" marT="63500" marB="63500" anchor="ctr">
                     <a:lnL w="9525" cap="flat" cmpd="sng" algn="ctr">
                       <a:solidFill>
                         <a:srgbClr val="D5DAE0"/>
@@ -5640,17 +5435,17 @@
                         <a:buNone/>
                       </a:pPr>
                       <a:r>
-                        <a:rPr lang="en-US" sz="1300" dirty="0">
+                        <a:rPr lang="en-US" sz="1400" dirty="0">
                           <a:solidFill>
                             <a:srgbClr val="1F2933"/>
                           </a:solidFill>
                         </a:rPr>
                         <a:t>Myotonia severity</a:t>
                       </a:r>
-                      <a:endParaRPr lang="en-US" sz="1300" dirty="0"/>
+                      <a:endParaRPr lang="en-US" sz="1400" dirty="0"/>
                     </a:p>
                   </a:txBody>
-                  <a:tcPr marL="76200" marR="76200" marT="50800" marB="50800" anchor="ctr">
+                  <a:tcPr marL="88900" marR="88900" marT="63500" marB="63500" anchor="ctr">
                     <a:lnL w="9525" cap="flat" cmpd="sng" algn="ctr">
                       <a:solidFill>
                         <a:srgbClr val="D5DAE0"/>
@@ -5698,17 +5493,17 @@
                         <a:buNone/>
                       </a:pPr>
                       <a:r>
-                        <a:rPr lang="en-US" sz="1300" dirty="0">
+                        <a:rPr lang="en-US" sz="1400" dirty="0">
                           <a:solidFill>
                             <a:srgbClr val="1F2933"/>
                           </a:solidFill>
                         </a:rPr>
-                        <a:t>About 5 or more</a:t>
+                        <a:t>≥ about 5</a:t>
                       </a:r>
-                      <a:endParaRPr lang="en-US" sz="1300" dirty="0"/>
+                      <a:endParaRPr lang="en-US" sz="1400" dirty="0"/>
                     </a:p>
                   </a:txBody>
-                  <a:tcPr marL="76200" marR="76200" marT="50800" marB="50800" anchor="ctr">
+                  <a:tcPr marL="88900" marR="88900" marT="63500" marB="63500" anchor="ctr">
                     <a:lnL w="9525" cap="flat" cmpd="sng" algn="ctr">
                       <a:solidFill>
                         <a:srgbClr val="D5DAE0"/>
@@ -5756,17 +5551,17 @@
                         <a:buNone/>
                       </a:pPr>
                       <a:r>
-                        <a:rPr lang="en-US" sz="1300" dirty="0">
+                        <a:rPr lang="en-US" sz="1400" dirty="0">
                           <a:solidFill>
                             <a:srgbClr val="1F2933"/>
                           </a:solidFill>
                         </a:rPr>
                         <a:t>67% vs 10%</a:t>
                       </a:r>
-                      <a:endParaRPr lang="en-US" sz="1300" dirty="0"/>
+                      <a:endParaRPr lang="en-US" sz="1400" dirty="0"/>
                     </a:p>
                   </a:txBody>
-                  <a:tcPr marL="76200" marR="76200" marT="50800" marB="50800" anchor="ctr">
+                  <a:tcPr marL="88900" marR="88900" marT="63500" marB="63500" anchor="ctr">
                     <a:lnL w="9525" cap="flat" cmpd="sng" algn="ctr">
                       <a:solidFill>
                         <a:srgbClr val="D5DAE0"/>
@@ -5814,17 +5609,17 @@
                         <a:buNone/>
                       </a:pPr>
                       <a:r>
-                        <a:rPr lang="en-US" sz="1300" dirty="0">
+                        <a:rPr lang="en-US" sz="1400" dirty="0">
                           <a:solidFill>
                             <a:srgbClr val="1F2933"/>
                           </a:solidFill>
                         </a:rPr>
-                        <a:t>Enrol on baseline myotonia severity rather than diagnosis alone; mild cases dilute the treatment effect</a:t>
+                        <a:t>Enrol on symptom severity, not diagnosis alone</a:t>
                       </a:r>
-                      <a:endParaRPr lang="en-US" sz="1300" dirty="0"/>
+                      <a:endParaRPr lang="en-US" sz="1400" dirty="0"/>
                     </a:p>
                   </a:txBody>
-                  <a:tcPr marL="76200" marR="76200" marT="50800" marB="50800" anchor="ctr">
+                  <a:tcPr marL="88900" marR="88900" marT="63500" marB="63500" anchor="ctr">
                     <a:lnL w="9525" cap="flat" cmpd="sng" algn="ctr">
                       <a:solidFill>
                         <a:srgbClr val="D5DAE0"/>
@@ -5864,7 +5659,7 @@
                   </a:tcPr>
                 </a:tc>
               </a:tr>
-              <a:tr h="640080">
+              <a:tr h="685800">
                 <a:tc>
                   <a:txBody>
                     <a:bodyPr/>
@@ -5874,17 +5669,17 @@
                         <a:buNone/>
                       </a:pPr>
                       <a:r>
-                        <a:rPr lang="en-US" sz="1300" b="1" dirty="0">
+                        <a:rPr lang="en-US" sz="1400" b="1" dirty="0">
                           <a:solidFill>
                             <a:srgbClr val="1F2933"/>
                           </a:solidFill>
                         </a:rPr>
                         <a:t>Antisense oligonucleotide</a:t>
                       </a:r>
-                      <a:endParaRPr lang="en-US" sz="1300" dirty="0"/>
+                      <a:endParaRPr lang="en-US" sz="1400" dirty="0"/>
                     </a:p>
                   </a:txBody>
-                  <a:tcPr marL="76200" marR="76200" marT="50800" marB="50800" anchor="ctr">
+                  <a:tcPr marL="88900" marR="88900" marT="63500" marB="63500" anchor="ctr">
                     <a:lnL w="9525" cap="flat" cmpd="sng" algn="ctr">
                       <a:solidFill>
                         <a:srgbClr val="D5DAE0"/>
@@ -5932,17 +5727,17 @@
                         <a:buNone/>
                       </a:pPr>
                       <a:r>
-                        <a:rPr lang="en-US" sz="1300" dirty="0">
+                        <a:rPr lang="en-US" sz="1400" dirty="0">
                           <a:solidFill>
                             <a:srgbClr val="1F2933"/>
                           </a:solidFill>
                         </a:rPr>
                         <a:t>CTG repeat length</a:t>
                       </a:r>
-                      <a:endParaRPr lang="en-US" sz="1300" dirty="0"/>
+                      <a:endParaRPr lang="en-US" sz="1400" dirty="0"/>
                     </a:p>
                   </a:txBody>
-                  <a:tcPr marL="76200" marR="76200" marT="50800" marB="50800" anchor="ctr">
+                  <a:tcPr marL="88900" marR="88900" marT="63500" marB="63500" anchor="ctr">
                     <a:lnL w="9525" cap="flat" cmpd="sng" algn="ctr">
                       <a:solidFill>
                         <a:srgbClr val="D5DAE0"/>
@@ -5990,17 +5785,17 @@
                         <a:buNone/>
                       </a:pPr>
                       <a:r>
-                        <a:rPr lang="en-US" sz="1300" dirty="0">
+                        <a:rPr lang="en-US" sz="1400" dirty="0">
                           <a:solidFill>
                             <a:srgbClr val="1F2933"/>
                           </a:solidFill>
                         </a:rPr>
-                        <a:t>About 350 or more</a:t>
+                        <a:t>≥ about 350</a:t>
                       </a:r>
-                      <a:endParaRPr lang="en-US" sz="1300" dirty="0"/>
+                      <a:endParaRPr lang="en-US" sz="1400" dirty="0"/>
                     </a:p>
                   </a:txBody>
-                  <a:tcPr marL="76200" marR="76200" marT="50800" marB="50800" anchor="ctr">
+                  <a:tcPr marL="88900" marR="88900" marT="63500" marB="63500" anchor="ctr">
                     <a:lnL w="9525" cap="flat" cmpd="sng" algn="ctr">
                       <a:solidFill>
                         <a:srgbClr val="D5DAE0"/>
@@ -6048,17 +5843,17 @@
                         <a:buNone/>
                       </a:pPr>
                       <a:r>
-                        <a:rPr lang="en-US" sz="1300" dirty="0">
+                        <a:rPr lang="en-US" sz="1400" dirty="0">
                           <a:solidFill>
                             <a:srgbClr val="1F2933"/>
                           </a:solidFill>
                         </a:rPr>
                         <a:t>59% vs 31%</a:t>
                       </a:r>
-                      <a:endParaRPr lang="en-US" sz="1300" dirty="0"/>
+                      <a:endParaRPr lang="en-US" sz="1400" dirty="0"/>
                     </a:p>
                   </a:txBody>
-                  <a:tcPr marL="76200" marR="76200" marT="50800" marB="50800" anchor="ctr">
+                  <a:tcPr marL="88900" marR="88900" marT="63500" marB="63500" anchor="ctr">
                     <a:lnL w="9525" cap="flat" cmpd="sng" algn="ctr">
                       <a:solidFill>
                         <a:srgbClr val="D5DAE0"/>
@@ -6106,17 +5901,17 @@
                         <a:buNone/>
                       </a:pPr>
                       <a:r>
-                        <a:rPr lang="en-US" sz="1300" dirty="0">
+                        <a:rPr lang="en-US" sz="1400" dirty="0">
                           <a:solidFill>
                             <a:srgbClr val="1F2933"/>
                           </a:solidFill>
                         </a:rPr>
-                        <a:t>Stratify randomisation on CTG repeat length, a prognostic factor</a:t>
+                        <a:t>Stratify randomisation on repeat length</a:t>
                       </a:r>
-                      <a:endParaRPr lang="en-US" sz="1300" dirty="0"/>
+                      <a:endParaRPr lang="en-US" sz="1400" dirty="0"/>
                     </a:p>
                   </a:txBody>
-                  <a:tcPr marL="76200" marR="76200" marT="50800" marB="50800" anchor="ctr">
+                  <a:tcPr marL="88900" marR="88900" marT="63500" marB="63500" anchor="ctr">
                     <a:lnL w="9525" cap="flat" cmpd="sng" algn="ctr">
                       <a:solidFill>
                         <a:srgbClr val="D5DAE0"/>
@@ -6156,7 +5951,7 @@
                   </a:tcPr>
                 </a:tc>
               </a:tr>
-              <a:tr h="640080">
+              <a:tr h="685800">
                 <a:tc>
                   <a:txBody>
                     <a:bodyPr/>
@@ -6166,17 +5961,17 @@
                         <a:buNone/>
                       </a:pPr>
                       <a:r>
-                        <a:rPr lang="en-US" sz="1300" b="1" dirty="0">
+                        <a:rPr lang="en-US" sz="1400" b="1" dirty="0">
                           <a:solidFill>
                             <a:srgbClr val="1F2933"/>
                           </a:solidFill>
                         </a:rPr>
                         <a:t>Tideglusib</a:t>
                       </a:r>
-                      <a:endParaRPr lang="en-US" sz="1300" dirty="0"/>
+                      <a:endParaRPr lang="en-US" sz="1400" dirty="0"/>
                     </a:p>
                   </a:txBody>
-                  <a:tcPr marL="76200" marR="76200" marT="50800" marB="50800" anchor="ctr">
+                  <a:tcPr marL="88900" marR="88900" marT="63500" marB="63500" anchor="ctr">
                     <a:lnL w="9525" cap="flat" cmpd="sng" algn="ctr">
                       <a:solidFill>
                         <a:srgbClr val="D5DAE0"/>
@@ -6224,17 +6019,17 @@
                         <a:buNone/>
                       </a:pPr>
                       <a:r>
-                        <a:rPr lang="en-US" sz="1300" dirty="0">
+                        <a:rPr lang="en-US" sz="1400" dirty="0">
                           <a:solidFill>
                             <a:srgbClr val="1F2933"/>
                           </a:solidFill>
                         </a:rPr>
                         <a:t>Cognitive function</a:t>
                       </a:r>
-                      <a:endParaRPr lang="en-US" sz="1300" dirty="0"/>
+                      <a:endParaRPr lang="en-US" sz="1400" dirty="0"/>
                     </a:p>
                   </a:txBody>
-                  <a:tcPr marL="76200" marR="76200" marT="50800" marB="50800" anchor="ctr">
+                  <a:tcPr marL="88900" marR="88900" marT="63500" marB="63500" anchor="ctr">
                     <a:lnL w="9525" cap="flat" cmpd="sng" algn="ctr">
                       <a:solidFill>
                         <a:srgbClr val="D5DAE0"/>
@@ -6282,17 +6077,17 @@
                         <a:buNone/>
                       </a:pPr>
                       <a:r>
-                        <a:rPr lang="en-US" sz="1300" dirty="0">
+                        <a:rPr lang="en-US" sz="1400" dirty="0">
                           <a:solidFill>
                             <a:srgbClr val="1F2933"/>
                           </a:solidFill>
                         </a:rPr>
-                        <a:t>Below about -0.5</a:t>
+                        <a:t>&lt; about -0.5</a:t>
                       </a:r>
-                      <a:endParaRPr lang="en-US" sz="1300" dirty="0"/>
+                      <a:endParaRPr lang="en-US" sz="1400" dirty="0"/>
                     </a:p>
                   </a:txBody>
-                  <a:tcPr marL="76200" marR="76200" marT="50800" marB="50800" anchor="ctr">
+                  <a:tcPr marL="88900" marR="88900" marT="63500" marB="63500" anchor="ctr">
                     <a:lnL w="9525" cap="flat" cmpd="sng" algn="ctr">
                       <a:solidFill>
                         <a:srgbClr val="D5DAE0"/>
@@ -6340,17 +6135,17 @@
                         <a:buNone/>
                       </a:pPr>
                       <a:r>
-                        <a:rPr lang="en-US" sz="1300" dirty="0">
+                        <a:rPr lang="en-US" sz="1400" dirty="0">
                           <a:solidFill>
                             <a:srgbClr val="1F2933"/>
                           </a:solidFill>
                         </a:rPr>
                         <a:t>74% vs 17%</a:t>
                       </a:r>
-                      <a:endParaRPr lang="en-US" sz="1300" dirty="0"/>
+                      <a:endParaRPr lang="en-US" sz="1400" dirty="0"/>
                     </a:p>
                   </a:txBody>
-                  <a:tcPr marL="76200" marR="76200" marT="50800" marB="50800" anchor="ctr">
+                  <a:tcPr marL="88900" marR="88900" marT="63500" marB="63500" anchor="ctr">
                     <a:lnL w="9525" cap="flat" cmpd="sng" algn="ctr">
                       <a:solidFill>
                         <a:srgbClr val="D5DAE0"/>
@@ -6398,17 +6193,17 @@
                         <a:buNone/>
                       </a:pPr>
                       <a:r>
-                        <a:rPr lang="en-US" sz="1300" dirty="0">
+                        <a:rPr lang="en-US" sz="1400" dirty="0">
                           <a:solidFill>
                             <a:srgbClr val="1F2933"/>
                           </a:solidFill>
                         </a:rPr>
-                        <a:t>Enrich for cognitive impairment: expected responder rate 48% → 74%, reducing required sample size</a:t>
+                        <a:t>Enrich for cognitive impairment: 48% → 74% responders</a:t>
                       </a:r>
-                      <a:endParaRPr lang="en-US" sz="1300" dirty="0"/>
+                      <a:endParaRPr lang="en-US" sz="1400" dirty="0"/>
                     </a:p>
                   </a:txBody>
-                  <a:tcPr marL="76200" marR="76200" marT="50800" marB="50800" anchor="ctr">
+                  <a:tcPr marL="88900" marR="88900" marT="63500" marB="63500" anchor="ctr">
                     <a:lnL w="9525" cap="flat" cmpd="sng" algn="ctr">
                       <a:solidFill>
                         <a:srgbClr val="D5DAE0"/>
@@ -6460,7 +6255,7 @@
         </p:nvSpPr>
         <p:spPr>
           <a:xfrm>
-            <a:off x="548640" y="4069080"/>
+            <a:off x="548640" y="4206240"/>
             <a:ext cx="5486400" cy="365760"/>
           </a:xfrm>
           <a:prstGeom prst="rect">
@@ -6477,14 +6272,14 @@
               <a:buNone/>
             </a:pPr>
             <a:r>
-              <a:rPr lang="en-US" sz="1600" b="1" dirty="0">
+              <a:rPr lang="en-US" sz="1700" b="1" dirty="0">
                 <a:solidFill>
                   <a:srgbClr val="000000"/>
                 </a:solidFill>
               </a:rPr>
               <a:t>Limitations</a:t>
             </a:r>
-            <a:endParaRPr lang="en-US" sz="1600" dirty="0"/>
+            <a:endParaRPr lang="en-US" sz="1700" dirty="0"/>
           </a:p>
         </p:txBody>
       </p:sp>
@@ -6496,8 +6291,8 @@
         </p:nvSpPr>
         <p:spPr>
           <a:xfrm>
-            <a:off x="548640" y="4434840"/>
-            <a:ext cx="5486400" cy="1920240"/>
+            <a:off x="548640" y="4617720"/>
+            <a:ext cx="5486400" cy="1737360"/>
           </a:xfrm>
           <a:prstGeom prst="rect">
             <a:avLst/>
@@ -6511,56 +6306,56 @@
           <a:p>
             <a:pPr marL="177800" indent="-177800">
               <a:spcAft>
-                <a:spcPts val="600"/>
+                <a:spcPts val="800"/>
               </a:spcAft>
               <a:buSzPct val="100000"/>
               <a:buChar char="•"/>
             </a:pPr>
             <a:r>
-              <a:rPr lang="en-US" sz="1250" dirty="0">
+              <a:rPr lang="en-US" sz="1400" dirty="0">
                 <a:solidFill>
                   <a:srgbClr val="1F2933"/>
                 </a:solidFill>
               </a:rPr>
-              <a:t>No placebo arm: predictors are prognostic within treated patients, not demonstrated effect modifiers</a:t>
+              <a:t>No placebo arm: prognostic within treated patients, not effect modification</a:t>
             </a:r>
-            <a:endParaRPr lang="en-US" sz="1400" dirty="0"/>
+            <a:endParaRPr lang="en-US" sz="1500" dirty="0"/>
           </a:p>
           <a:p>
             <a:pPr marL="177800" indent="-177800">
               <a:spcAft>
-                <a:spcPts val="600"/>
+                <a:spcPts val="800"/>
               </a:spcAft>
               <a:buSzPct val="100000"/>
               <a:buChar char="•"/>
             </a:pPr>
             <a:r>
-              <a:rPr lang="en-US" sz="1250" dirty="0">
+              <a:rPr lang="en-US" sz="1400" dirty="0">
                 <a:solidFill>
                   <a:srgbClr val="1F2933"/>
                 </a:solidFill>
               </a:rPr>
-              <a:t>About 41 test patients per arm: cut-offs are approximate, and methods are not ranked within an arm</a:t>
+              <a:t>About 41 test patients per arm: cut-offs approximate; no ranking within an arm</a:t>
             </a:r>
-            <a:endParaRPr lang="en-US" sz="1400" dirty="0"/>
+            <a:endParaRPr lang="en-US" sz="1500" dirty="0"/>
           </a:p>
           <a:p>
             <a:pPr marL="177800" indent="-177800">
               <a:spcAft>
-                <a:spcPts val="600"/>
+                <a:spcPts val="800"/>
               </a:spcAft>
               <a:buSzPct val="100000"/>
               <a:buChar char="•"/>
             </a:pPr>
             <a:r>
-              <a:rPr lang="en-US" sz="1250" dirty="0">
+              <a:rPr lang="en-US" sz="1400" dirty="0">
                 <a:solidFill>
                   <a:srgbClr val="1F2933"/>
                 </a:solidFill>
               </a:rPr>
-              <a:t>Cross-sectional endpoint. Next step: a longitudinal disease-progression model with these covariates on progression rate and drug effect</a:t>
+              <a:t>Cross-sectional endpoint; next step is a longitudinal disease-progression model</a:t>
             </a:r>
-            <a:endParaRPr lang="en-US" sz="1400" dirty="0"/>
+            <a:endParaRPr lang="en-US" sz="1500" dirty="0"/>
           </a:p>
         </p:txBody>
       </p:sp>
@@ -6572,7 +6367,7 @@
         </p:nvSpPr>
         <p:spPr>
           <a:xfrm>
-            <a:off x="6492240" y="4069080"/>
+            <a:off x="6492240" y="4206240"/>
             <a:ext cx="5120640" cy="365760"/>
           </a:xfrm>
           <a:prstGeom prst="rect">
@@ -6589,14 +6384,14 @@
               <a:buNone/>
             </a:pPr>
             <a:r>
-              <a:rPr lang="en-US" sz="1600" b="1" dirty="0">
+              <a:rPr lang="en-US" sz="1700" b="1" dirty="0">
                 <a:solidFill>
                   <a:srgbClr val="000000"/>
                 </a:solidFill>
               </a:rPr>
               <a:t>AI disclosure</a:t>
             </a:r>
-            <a:endParaRPr lang="en-US" sz="1600" dirty="0"/>
+            <a:endParaRPr lang="en-US" sz="1700" dirty="0"/>
           </a:p>
         </p:txBody>
       </p:sp>
@@ -6608,12 +6403,12 @@
         </p:nvSpPr>
         <p:spPr>
           <a:xfrm>
-            <a:off x="6492240" y="4434840"/>
-            <a:ext cx="5120640" cy="1783080"/>
+            <a:off x="6492240" y="4617720"/>
+            <a:ext cx="5120640" cy="1463040"/>
           </a:xfrm>
           <a:prstGeom prst="roundRect">
             <a:avLst>
-              <a:gd name="adj" fmla="val 4103"/>
+              <a:gd name="adj" fmla="val 5000"/>
             </a:avLst>
           </a:prstGeom>
           <a:solidFill>
@@ -6635,8 +6430,8 @@
         </p:nvSpPr>
         <p:spPr>
           <a:xfrm>
-            <a:off x="6675120" y="4526280"/>
-            <a:ext cx="4754880" cy="1600200"/>
+            <a:off x="6720840" y="4709160"/>
+            <a:ext cx="4663440" cy="1280160"/>
           </a:xfrm>
           <a:prstGeom prst="rect">
             <a:avLst/>
@@ -6652,14 +6447,14 @@
               <a:buNone/>
             </a:pPr>
             <a:r>
-              <a:rPr lang="en-US" sz="1250" dirty="0">
+              <a:rPr lang="en-US" sz="1400" dirty="0">
                 <a:solidFill>
                   <a:srgbClr val="1F2933"/>
                 </a:solidFill>
               </a:rPr>
-              <a:t>Claude (Anthropic, via Claude Code) and Codex were used to draft code, documentation and this deck, as noted in the code headers and AI_DISCLOSURE.md. All analysis decisions and interpretations were reviewed by the team, which is accountable for the results.</a:t>
+              <a:t>Claude (via Claude Code) and Codex drafted code, documentation and slides. All decisions and interpretations were reviewed by the team, which is accountable for the results.</a:t>
             </a:r>
-            <a:endParaRPr lang="en-US" sz="1250" dirty="0"/>
+            <a:endParaRPr lang="en-US" sz="1400" dirty="0"/>
           </a:p>
         </p:txBody>
       </p:sp>
@@ -6765,8 +6560,8 @@
         </p:nvSpPr>
         <p:spPr>
           <a:xfrm>
-            <a:off x="548640" y="5943600"/>
-            <a:ext cx="11064240" cy="457200"/>
+            <a:off x="548640" y="5989320"/>
+            <a:ext cx="11064240" cy="411480"/>
           </a:xfrm>
           <a:prstGeom prst="rect">
             <a:avLst/>
@@ -6782,14 +6577,14 @@
               <a:buNone/>
             </a:pPr>
             <a:r>
-              <a:rPr lang="en-US" sz="1150" dirty="0">
+              <a:rPr lang="en-US" sz="1300" dirty="0">
                 <a:solidFill>
                   <a:srgbClr val="5B6B7A"/>
                 </a:solidFill>
               </a:rPr>
-              <a:t>Test-set R², continuous endpoint, 20 random splits. Mexiletine: methods equivalent (median ≈ 0.6). Oligonucleotide: all methods weak (medians 0.06 to 0.12). Tideglusib: a tree ensemble ranked first in 19 of 20 splits; a linear model never did. Absolute R² varies by up to 0.15 between splits, hence ranges rather than point estimates.</a:t>
+              <a:t>Test-set R², continuous endpoint, 20 random splits. Tideglusib: a tree ensemble ranked first in 19 of 20; a linear model never did.</a:t>
             </a:r>
-            <a:endParaRPr lang="en-US" sz="1150" dirty="0"/>
+            <a:endParaRPr lang="en-US" sz="1300" dirty="0"/>
           </a:p>
         </p:txBody>
       </p:sp>
@@ -6895,8 +6690,8 @@
         </p:nvSpPr>
         <p:spPr>
           <a:xfrm>
-            <a:off x="548640" y="5943600"/>
-            <a:ext cx="11064240" cy="457200"/>
+            <a:off x="548640" y="5989320"/>
+            <a:ext cx="11064240" cy="411480"/>
           </a:xfrm>
           <a:prstGeom prst="rect">
             <a:avLst/>
@@ -6912,14 +6707,14 @@
               <a:buNone/>
             </a:pPr>
             <a:r>
-              <a:rPr lang="en-US" sz="1150" dirty="0">
+              <a:rPr lang="en-US" sz="1300" dirty="0">
                 <a:solidFill>
                   <a:srgbClr val="5B6B7A"/>
                 </a:solidFill>
               </a:rPr>
-              <a:t>Filled dot = selected. The three covariate-model columns agree on one covariate per arm. The ML columns are fuller because their criterion (importance above the noise covariate) is permissive; the final call also requires LASSO bootstrap stability of 60% (signal) or 20% (uncertain).</a:t>
+              <a:t>Filled dot = selected. Final call requires 4 of 5 methods and LASSO bootstrap stability ≥ 60% (signal); 2 votes and ≥ 20% (uncertain).</a:t>
             </a:r>
-            <a:endParaRPr lang="en-US" sz="1150" dirty="0"/>
+            <a:endParaRPr lang="en-US" sz="1300" dirty="0"/>
           </a:p>
         </p:txBody>
       </p:sp>
@@ -6987,7 +6782,7 @@
                   <a:srgbClr val="000000"/>
                 </a:solidFill>
               </a:rPr>
-              <a:t>Backup: the dominant covariate holds within each onset phenotype; an exploratory treatment-allocation view</a:t>
+              <a:t>Backup: the dominant covariate holds within each onset phenotype</a:t>
             </a:r>
             <a:endParaRPr lang="en-US" sz="2800" dirty="0"/>
           </a:p>
@@ -7008,7 +6803,7 @@
           </p:nvPr>
         </p:nvGraphicFramePr>
         <p:xfrm>
-          <a:off x="548640" y="1371600"/>
+          <a:off x="548640" y="1417320"/>
           <a:ext cx="11064240" cy="914400"/>
         </p:xfrm>
         <a:graphic>
@@ -7022,7 +6817,7 @@
                 <a:gridCol w="1783080"/>
                 <a:gridCol w="1783080"/>
               </a:tblGrid>
-              <a:tr h="411480">
+              <a:tr h="457200">
                 <a:tc>
                   <a:txBody>
                     <a:bodyPr/>
@@ -7032,17 +6827,17 @@
                         <a:buNone/>
                       </a:pPr>
                       <a:r>
-                        <a:rPr lang="en-US" sz="1300" b="1" dirty="0">
+                        <a:rPr lang="en-US" sz="1400" b="1" dirty="0">
                           <a:solidFill>
                             <a:srgbClr val="000000"/>
                           </a:solidFill>
                         </a:rPr>
-                        <a:t>Arm, key covariate</a:t>
+                        <a:t>Arm, covariate (slope per unit)</a:t>
                       </a:r>
-                      <a:endParaRPr lang="en-US" sz="1300" dirty="0"/>
+                      <a:endParaRPr lang="en-US" sz="1400" dirty="0"/>
                     </a:p>
                   </a:txBody>
-                  <a:tcPr marL="76200" marR="76200" marT="50800" marB="50800" anchor="ctr">
+                  <a:tcPr marL="88900" marR="88900" marT="63500" marB="63500" anchor="ctr">
                     <a:lnL w="9525" cap="flat" cmpd="sng" algn="ctr">
                       <a:solidFill>
                         <a:srgbClr val="D5DAE0"/>
@@ -7093,17 +6888,17 @@
                         <a:buNone/>
                       </a:pPr>
                       <a:r>
-                        <a:rPr lang="en-US" sz="1300" b="1" dirty="0">
+                        <a:rPr lang="en-US" sz="1400" b="1" dirty="0">
                           <a:solidFill>
                             <a:srgbClr val="000000"/>
                           </a:solidFill>
                         </a:rPr>
                         <a:t>Adult onset</a:t>
                       </a:r>
-                      <a:endParaRPr lang="en-US" sz="1300" dirty="0"/>
+                      <a:endParaRPr lang="en-US" sz="1400" dirty="0"/>
                     </a:p>
                   </a:txBody>
-                  <a:tcPr marL="76200" marR="76200" marT="50800" marB="50800" anchor="ctr">
+                  <a:tcPr marL="88900" marR="88900" marT="63500" marB="63500" anchor="ctr">
                     <a:lnL w="9525" cap="flat" cmpd="sng" algn="ctr">
                       <a:solidFill>
                         <a:srgbClr val="D5DAE0"/>
@@ -7154,17 +6949,17 @@
                         <a:buNone/>
                       </a:pPr>
                       <a:r>
-                        <a:rPr lang="en-US" sz="1300" b="1" dirty="0">
+                        <a:rPr lang="en-US" sz="1400" b="1" dirty="0">
                           <a:solidFill>
                             <a:srgbClr val="000000"/>
                           </a:solidFill>
                         </a:rPr>
                         <a:t>Juvenile onset</a:t>
                       </a:r>
-                      <a:endParaRPr lang="en-US" sz="1300" dirty="0"/>
+                      <a:endParaRPr lang="en-US" sz="1400" dirty="0"/>
                     </a:p>
                   </a:txBody>
-                  <a:tcPr marL="76200" marR="76200" marT="50800" marB="50800" anchor="ctr">
+                  <a:tcPr marL="88900" marR="88900" marT="63500" marB="63500" anchor="ctr">
                     <a:lnL w="9525" cap="flat" cmpd="sng" algn="ctr">
                       <a:solidFill>
                         <a:srgbClr val="D5DAE0"/>
@@ -7215,17 +7010,17 @@
                         <a:buNone/>
                       </a:pPr>
                       <a:r>
-                        <a:rPr lang="en-US" sz="1300" b="1" dirty="0">
+                        <a:rPr lang="en-US" sz="1400" b="1" dirty="0">
                           <a:solidFill>
                             <a:srgbClr val="000000"/>
                           </a:solidFill>
                         </a:rPr>
                         <a:t>Late onset</a:t>
                       </a:r>
-                      <a:endParaRPr lang="en-US" sz="1300" dirty="0"/>
+                      <a:endParaRPr lang="en-US" sz="1400" dirty="0"/>
                     </a:p>
                   </a:txBody>
-                  <a:tcPr marL="76200" marR="76200" marT="50800" marB="50800" anchor="ctr">
+                  <a:tcPr marL="88900" marR="88900" marT="63500" marB="63500" anchor="ctr">
                     <a:lnL w="9525" cap="flat" cmpd="sng" algn="ctr">
                       <a:solidFill>
                         <a:srgbClr val="D5DAE0"/>
@@ -7276,17 +7071,17 @@
                         <a:buNone/>
                       </a:pPr>
                       <a:r>
-                        <a:rPr lang="en-US" sz="1300" b="1" dirty="0">
+                        <a:rPr lang="en-US" sz="1400" b="1" dirty="0">
                           <a:solidFill>
                             <a:srgbClr val="000000"/>
                           </a:solidFill>
                         </a:rPr>
                         <a:t>Interaction p</a:t>
                       </a:r>
-                      <a:endParaRPr lang="en-US" sz="1300" dirty="0"/>
+                      <a:endParaRPr lang="en-US" sz="1400" dirty="0"/>
                     </a:p>
                   </a:txBody>
-                  <a:tcPr marL="76200" marR="76200" marT="50800" marB="50800" anchor="ctr">
+                  <a:tcPr marL="88900" marR="88900" marT="63500" marB="63500" anchor="ctr">
                     <a:lnL w="9525" cap="flat" cmpd="sng" algn="ctr">
                       <a:solidFill>
                         <a:srgbClr val="D5DAE0"/>
@@ -7329,7 +7124,7 @@
                   </a:tcPr>
                 </a:tc>
               </a:tr>
-              <a:tr h="502920">
+              <a:tr h="548640">
                 <a:tc>
                   <a:txBody>
                     <a:bodyPr/>
@@ -7339,17 +7134,17 @@
                         <a:buNone/>
                       </a:pPr>
                       <a:r>
-                        <a:rPr lang="en-US" sz="1300" dirty="0">
+                        <a:rPr lang="en-US" sz="1400" dirty="0">
                           <a:solidFill>
                             <a:srgbClr val="1F2933"/>
                           </a:solidFill>
                         </a:rPr>
-                        <a:t>Mexiletine, myotonia severity (slope per unit)</a:t>
+                        <a:t>Mexiletine, myotonia severity</a:t>
                       </a:r>
-                      <a:endParaRPr lang="en-US" sz="1300" dirty="0"/>
+                      <a:endParaRPr lang="en-US" sz="1400" dirty="0"/>
                     </a:p>
                   </a:txBody>
-                  <a:tcPr marL="76200" marR="76200" marT="50800" marB="50800" anchor="ctr">
+                  <a:tcPr marL="88900" marR="88900" marT="63500" marB="63500" anchor="ctr">
                     <a:lnL w="9525" cap="flat" cmpd="sng" algn="ctr">
                       <a:solidFill>
                         <a:srgbClr val="D5DAE0"/>
@@ -7397,17 +7192,17 @@
                         <a:buNone/>
                       </a:pPr>
                       <a:r>
-                        <a:rPr lang="en-US" sz="1300" dirty="0">
+                        <a:rPr lang="en-US" sz="1400" dirty="0">
                           <a:solidFill>
                             <a:srgbClr val="1F2933"/>
                           </a:solidFill>
                         </a:rPr>
                         <a:t>-0.51 (n 71)</a:t>
                       </a:r>
-                      <a:endParaRPr lang="en-US" sz="1300" dirty="0"/>
+                      <a:endParaRPr lang="en-US" sz="1400" dirty="0"/>
                     </a:p>
                   </a:txBody>
-                  <a:tcPr marL="76200" marR="76200" marT="50800" marB="50800" anchor="ctr">
+                  <a:tcPr marL="88900" marR="88900" marT="63500" marB="63500" anchor="ctr">
                     <a:lnL w="9525" cap="flat" cmpd="sng" algn="ctr">
                       <a:solidFill>
                         <a:srgbClr val="D5DAE0"/>
@@ -7455,17 +7250,17 @@
                         <a:buNone/>
                       </a:pPr>
                       <a:r>
-                        <a:rPr lang="en-US" sz="1300" dirty="0">
+                        <a:rPr lang="en-US" sz="1400" dirty="0">
                           <a:solidFill>
                             <a:srgbClr val="1F2933"/>
                           </a:solidFill>
                         </a:rPr>
                         <a:t>-0.66 (n 28)</a:t>
                       </a:r>
-                      <a:endParaRPr lang="en-US" sz="1300" dirty="0"/>
+                      <a:endParaRPr lang="en-US" sz="1400" dirty="0"/>
                     </a:p>
                   </a:txBody>
-                  <a:tcPr marL="76200" marR="76200" marT="50800" marB="50800" anchor="ctr">
+                  <a:tcPr marL="88900" marR="88900" marT="63500" marB="63500" anchor="ctr">
                     <a:lnL w="9525" cap="flat" cmpd="sng" algn="ctr">
                       <a:solidFill>
                         <a:srgbClr val="D5DAE0"/>
@@ -7513,17 +7308,17 @@
                         <a:buNone/>
                       </a:pPr>
                       <a:r>
-                        <a:rPr lang="en-US" sz="1300" dirty="0">
+                        <a:rPr lang="en-US" sz="1400" dirty="0">
                           <a:solidFill>
                             <a:srgbClr val="1F2933"/>
                           </a:solidFill>
                         </a:rPr>
                         <a:t>-0.25 (n 21)</a:t>
                       </a:r>
-                      <a:endParaRPr lang="en-US" sz="1300" dirty="0"/>
+                      <a:endParaRPr lang="en-US" sz="1400" dirty="0"/>
                     </a:p>
                   </a:txBody>
-                  <a:tcPr marL="76200" marR="76200" marT="50800" marB="50800" anchor="ctr">
+                  <a:tcPr marL="88900" marR="88900" marT="63500" marB="63500" anchor="ctr">
                     <a:lnL w="9525" cap="flat" cmpd="sng" algn="ctr">
                       <a:solidFill>
                         <a:srgbClr val="D5DAE0"/>
@@ -7571,17 +7366,17 @@
                         <a:buNone/>
                       </a:pPr>
                       <a:r>
-                        <a:rPr lang="en-US" sz="1300" dirty="0">
+                        <a:rPr lang="en-US" sz="1400" dirty="0">
                           <a:solidFill>
                             <a:srgbClr val="1F2933"/>
                           </a:solidFill>
                         </a:rPr>
                         <a:t>0.03</a:t>
                       </a:r>
-                      <a:endParaRPr lang="en-US" sz="1300" dirty="0"/>
+                      <a:endParaRPr lang="en-US" sz="1400" dirty="0"/>
                     </a:p>
                   </a:txBody>
-                  <a:tcPr marL="76200" marR="76200" marT="50800" marB="50800" anchor="ctr">
+                  <a:tcPr marL="88900" marR="88900" marT="63500" marB="63500" anchor="ctr">
                     <a:lnL w="9525" cap="flat" cmpd="sng" algn="ctr">
                       <a:solidFill>
                         <a:srgbClr val="D5DAE0"/>
@@ -7621,7 +7416,7 @@
                   </a:tcPr>
                 </a:tc>
               </a:tr>
-              <a:tr h="502920">
+              <a:tr h="548640">
                 <a:tc>
                   <a:txBody>
                     <a:bodyPr/>
@@ -7631,17 +7426,17 @@
                         <a:buNone/>
                       </a:pPr>
                       <a:r>
-                        <a:rPr lang="en-US" sz="1300" dirty="0">
+                        <a:rPr lang="en-US" sz="1400" dirty="0">
                           <a:solidFill>
                             <a:srgbClr val="1F2933"/>
                           </a:solidFill>
                         </a:rPr>
-                        <a:t>Oligonucleotide, CTG repeats (slope per repeat)</a:t>
+                        <a:t>Oligonucleotide, CTG repeats</a:t>
                       </a:r>
-                      <a:endParaRPr lang="en-US" sz="1300" dirty="0"/>
+                      <a:endParaRPr lang="en-US" sz="1400" dirty="0"/>
                     </a:p>
                   </a:txBody>
-                  <a:tcPr marL="76200" marR="76200" marT="50800" marB="50800" anchor="ctr">
+                  <a:tcPr marL="88900" marR="88900" marT="63500" marB="63500" anchor="ctr">
                     <a:lnL w="9525" cap="flat" cmpd="sng" algn="ctr">
                       <a:solidFill>
                         <a:srgbClr val="D5DAE0"/>
@@ -7689,17 +7484,17 @@
                         <a:buNone/>
                       </a:pPr>
                       <a:r>
-                        <a:rPr lang="en-US" sz="1300" dirty="0">
+                        <a:rPr lang="en-US" sz="1400" dirty="0">
                           <a:solidFill>
                             <a:srgbClr val="1F2933"/>
                           </a:solidFill>
                         </a:rPr>
                         <a:t>0.005 (n 78)</a:t>
                       </a:r>
-                      <a:endParaRPr lang="en-US" sz="1300" dirty="0"/>
+                      <a:endParaRPr lang="en-US" sz="1400" dirty="0"/>
                     </a:p>
                   </a:txBody>
-                  <a:tcPr marL="76200" marR="76200" marT="50800" marB="50800" anchor="ctr">
+                  <a:tcPr marL="88900" marR="88900" marT="63500" marB="63500" anchor="ctr">
                     <a:lnL w="9525" cap="flat" cmpd="sng" algn="ctr">
                       <a:solidFill>
                         <a:srgbClr val="D5DAE0"/>
@@ -7747,17 +7542,17 @@
                         <a:buNone/>
                       </a:pPr>
                       <a:r>
-                        <a:rPr lang="en-US" sz="1300" dirty="0">
+                        <a:rPr lang="en-US" sz="1400" dirty="0">
                           <a:solidFill>
                             <a:srgbClr val="1F2933"/>
                           </a:solidFill>
                         </a:rPr>
                         <a:t>0.006 (n 23)</a:t>
                       </a:r>
-                      <a:endParaRPr lang="en-US" sz="1300" dirty="0"/>
+                      <a:endParaRPr lang="en-US" sz="1400" dirty="0"/>
                     </a:p>
                   </a:txBody>
-                  <a:tcPr marL="76200" marR="76200" marT="50800" marB="50800" anchor="ctr">
+                  <a:tcPr marL="88900" marR="88900" marT="63500" marB="63500" anchor="ctr">
                     <a:lnL w="9525" cap="flat" cmpd="sng" algn="ctr">
                       <a:solidFill>
                         <a:srgbClr val="D5DAE0"/>
@@ -7805,17 +7600,17 @@
                         <a:buNone/>
                       </a:pPr>
                       <a:r>
-                        <a:rPr lang="en-US" sz="1300" dirty="0">
+                        <a:rPr lang="en-US" sz="1400" dirty="0">
                           <a:solidFill>
                             <a:srgbClr val="1F2933"/>
                           </a:solidFill>
                         </a:rPr>
                         <a:t>0.014 (n 26)</a:t>
                       </a:r>
-                      <a:endParaRPr lang="en-US" sz="1300" dirty="0"/>
+                      <a:endParaRPr lang="en-US" sz="1400" dirty="0"/>
                     </a:p>
                   </a:txBody>
-                  <a:tcPr marL="76200" marR="76200" marT="50800" marB="50800" anchor="ctr">
+                  <a:tcPr marL="88900" marR="88900" marT="63500" marB="63500" anchor="ctr">
                     <a:lnL w="9525" cap="flat" cmpd="sng" algn="ctr">
                       <a:solidFill>
                         <a:srgbClr val="D5DAE0"/>
@@ -7863,17 +7658,17 @@
                         <a:buNone/>
                       </a:pPr>
                       <a:r>
-                        <a:rPr lang="en-US" sz="1300" dirty="0">
+                        <a:rPr lang="en-US" sz="1400" dirty="0">
                           <a:solidFill>
                             <a:srgbClr val="1F2933"/>
                           </a:solidFill>
                         </a:rPr>
                         <a:t>0.50</a:t>
                       </a:r>
-                      <a:endParaRPr lang="en-US" sz="1300" dirty="0"/>
+                      <a:endParaRPr lang="en-US" sz="1400" dirty="0"/>
                     </a:p>
                   </a:txBody>
-                  <a:tcPr marL="76200" marR="76200" marT="50800" marB="50800" anchor="ctr">
+                  <a:tcPr marL="88900" marR="88900" marT="63500" marB="63500" anchor="ctr">
                     <a:lnL w="9525" cap="flat" cmpd="sng" algn="ctr">
                       <a:solidFill>
                         <a:srgbClr val="D5DAE0"/>
@@ -7913,7 +7708,7 @@
                   </a:tcPr>
                 </a:tc>
               </a:tr>
-              <a:tr h="502920">
+              <a:tr h="548640">
                 <a:tc>
                   <a:txBody>
                     <a:bodyPr/>
@@ -7923,17 +7718,17 @@
                         <a:buNone/>
                       </a:pPr>
                       <a:r>
-                        <a:rPr lang="en-US" sz="1300" dirty="0">
+                        <a:rPr lang="en-US" sz="1400" dirty="0">
                           <a:solidFill>
                             <a:srgbClr val="1F2933"/>
                           </a:solidFill>
                         </a:rPr>
-                        <a:t>Tideglusib, cognitive function (slope per z)</a:t>
+                        <a:t>Tideglusib, cognitive function</a:t>
                       </a:r>
-                      <a:endParaRPr lang="en-US" sz="1300" dirty="0"/>
+                      <a:endParaRPr lang="en-US" sz="1400" dirty="0"/>
                     </a:p>
                   </a:txBody>
-                  <a:tcPr marL="76200" marR="76200" marT="50800" marB="50800" anchor="ctr">
+                  <a:tcPr marL="88900" marR="88900" marT="63500" marB="63500" anchor="ctr">
                     <a:lnL w="9525" cap="flat" cmpd="sng" algn="ctr">
                       <a:solidFill>
                         <a:srgbClr val="D5DAE0"/>
@@ -7981,17 +7776,17 @@
                         <a:buNone/>
                       </a:pPr>
                       <a:r>
-                        <a:rPr lang="en-US" sz="1300" dirty="0">
+                        <a:rPr lang="en-US" sz="1400" dirty="0">
                           <a:solidFill>
                             <a:srgbClr val="1F2933"/>
                           </a:solidFill>
                         </a:rPr>
                         <a:t>-3.1 (n 83)</a:t>
                       </a:r>
-                      <a:endParaRPr lang="en-US" sz="1300" dirty="0"/>
+                      <a:endParaRPr lang="en-US" sz="1400" dirty="0"/>
                     </a:p>
                   </a:txBody>
-                  <a:tcPr marL="76200" marR="76200" marT="50800" marB="50800" anchor="ctr">
+                  <a:tcPr marL="88900" marR="88900" marT="63500" marB="63500" anchor="ctr">
                     <a:lnL w="9525" cap="flat" cmpd="sng" algn="ctr">
                       <a:solidFill>
                         <a:srgbClr val="D5DAE0"/>
@@ -8039,17 +7834,17 @@
                         <a:buNone/>
                       </a:pPr>
                       <a:r>
-                        <a:rPr lang="en-US" sz="1300" dirty="0">
+                        <a:rPr lang="en-US" sz="1400" dirty="0">
                           <a:solidFill>
                             <a:srgbClr val="1F2933"/>
                           </a:solidFill>
                         </a:rPr>
                         <a:t>-4.4 (n 24)</a:t>
                       </a:r>
-                      <a:endParaRPr lang="en-US" sz="1300" dirty="0"/>
+                      <a:endParaRPr lang="en-US" sz="1400" dirty="0"/>
                     </a:p>
                   </a:txBody>
-                  <a:tcPr marL="76200" marR="76200" marT="50800" marB="50800" anchor="ctr">
+                  <a:tcPr marL="88900" marR="88900" marT="63500" marB="63500" anchor="ctr">
                     <a:lnL w="9525" cap="flat" cmpd="sng" algn="ctr">
                       <a:solidFill>
                         <a:srgbClr val="D5DAE0"/>
@@ -8097,17 +7892,17 @@
                         <a:buNone/>
                       </a:pPr>
                       <a:r>
-                        <a:rPr lang="en-US" sz="1300" dirty="0">
+                        <a:rPr lang="en-US" sz="1400" dirty="0">
                           <a:solidFill>
                             <a:srgbClr val="1F2933"/>
                           </a:solidFill>
                         </a:rPr>
                         <a:t>-1.3 (n 21)</a:t>
                       </a:r>
-                      <a:endParaRPr lang="en-US" sz="1300" dirty="0"/>
+                      <a:endParaRPr lang="en-US" sz="1400" dirty="0"/>
                     </a:p>
                   </a:txBody>
-                  <a:tcPr marL="76200" marR="76200" marT="50800" marB="50800" anchor="ctr">
+                  <a:tcPr marL="88900" marR="88900" marT="63500" marB="63500" anchor="ctr">
                     <a:lnL w="9525" cap="flat" cmpd="sng" algn="ctr">
                       <a:solidFill>
                         <a:srgbClr val="D5DAE0"/>
@@ -8155,17 +7950,17 @@
                         <a:buNone/>
                       </a:pPr>
                       <a:r>
-                        <a:rPr lang="en-US" sz="1300" dirty="0">
+                        <a:rPr lang="en-US" sz="1400" dirty="0">
                           <a:solidFill>
                             <a:srgbClr val="1F2933"/>
                           </a:solidFill>
                         </a:rPr>
                         <a:t>0.16</a:t>
                       </a:r>
-                      <a:endParaRPr lang="en-US" sz="1300" dirty="0"/>
+                      <a:endParaRPr lang="en-US" sz="1400" dirty="0"/>
                     </a:p>
                   </a:txBody>
-                  <a:tcPr marL="76200" marR="76200" marT="50800" marB="50800" anchor="ctr">
+                  <a:tcPr marL="88900" marR="88900" marT="63500" marB="63500" anchor="ctr">
                     <a:lnL w="9525" cap="flat" cmpd="sng" algn="ctr">
                       <a:solidFill>
                         <a:srgbClr val="D5DAE0"/>
@@ -8217,43 +8012,7 @@
         </p:nvSpPr>
         <p:spPr>
           <a:xfrm>
-            <a:off x="548640" y="3429000"/>
-            <a:ext cx="11064240" cy="457200"/>
-          </a:xfrm>
-          <a:prstGeom prst="rect">
-            <a:avLst/>
-          </a:prstGeom>
-          <a:noFill/>
-          <a:ln/>
-        </p:spPr>
-        <p:txBody>
-          <a:bodyPr wrap="square" lIns="0" tIns="0" rIns="0" bIns="0" rtlCol="0" anchor="t"/>
-          <a:lstStyle/>
-          <a:p>
-            <a:pPr indent="0" marL="0">
-              <a:buNone/>
-            </a:pPr>
-            <a:r>
-              <a:rPr lang="en-US" sz="1250" dirty="0">
-                <a:solidFill>
-                  <a:srgbClr val="1F2933"/>
-                </a:solidFill>
-              </a:rPr>
-              <a:t>Same direction within every onset phenotype in every arm (training set). Only the mexiletine slope differs by phenotype: attenuated in late onset, where baseline myotonia is mild.</a:t>
-            </a:r>
-            <a:endParaRPr lang="en-US" sz="1250" dirty="0"/>
-          </a:p>
-        </p:txBody>
-      </p:sp>
-      <p:sp>
-        <p:nvSpPr>
-          <p:cNvPr id="5" name="Text 2"/>
-          <p:cNvSpPr txBox="1"/>
-          <p:nvPr/>
-        </p:nvSpPr>
-        <p:spPr>
-          <a:xfrm>
-            <a:off x="548640" y="4114800"/>
+            <a:off x="548640" y="3840480"/>
             <a:ext cx="11064240" cy="365760"/>
           </a:xfrm>
           <a:prstGeom prst="rect">
@@ -8270,27 +8029,27 @@
               <a:buNone/>
             </a:pPr>
             <a:r>
-              <a:rPr lang="en-US" sz="1600" b="1" dirty="0">
+              <a:rPr lang="en-US" sz="1700" b="1" dirty="0">
                 <a:solidFill>
                   <a:srgbClr val="000000"/>
                 </a:solidFill>
               </a:rPr>
               <a:t>Treatment allocation by covariate profile (exploratory)</a:t>
             </a:r>
-            <a:endParaRPr lang="en-US" sz="1600" dirty="0"/>
+            <a:endParaRPr lang="en-US" sz="1700" dirty="0"/>
           </a:p>
         </p:txBody>
       </p:sp>
       <p:sp>
         <p:nvSpPr>
-          <p:cNvPr id="6" name="Text 3"/>
+          <p:cNvPr id="5" name="Text 2"/>
           <p:cNvSpPr txBox="1"/>
           <p:nvPr/>
         </p:nvSpPr>
         <p:spPr>
           <a:xfrm>
-            <a:off x="548640" y="4480560"/>
-            <a:ext cx="11064240" cy="1828800"/>
+            <a:off x="548640" y="4251960"/>
+            <a:ext cx="11064240" cy="2011680"/>
           </a:xfrm>
           <a:prstGeom prst="rect">
             <a:avLst/>
@@ -8304,56 +8063,56 @@
           <a:p>
             <a:pPr marL="177800" indent="-177800">
               <a:spcAft>
-                <a:spcPts val="600"/>
+                <a:spcPts val="800"/>
               </a:spcAft>
               <a:buSzPct val="100000"/>
               <a:buChar char="•"/>
             </a:pPr>
             <a:r>
-              <a:rPr lang="en-US" sz="1250" dirty="0">
+              <a:rPr lang="en-US" sz="1400" dirty="0">
                 <a:solidFill>
                   <a:srgbClr val="1F2933"/>
                 </a:solidFill>
               </a:rPr>
-              <a:t>Each arm's responder model applied to all training patients, expressed relative to that arm's average patient. Highest relative likelihood: mexiletine for 12% (severe myotonia, median ≈ 530 repeats), tideglusib for 35% (cognitive impairment), the oligonucleotide for the remainder</a:t>
+              <a:t>Each arm's responder model applied to all training patients, relative to that arm's average patient</a:t>
             </a:r>
-            <a:endParaRPr lang="en-US" sz="1400" dirty="0"/>
+            <a:endParaRPr lang="en-US" sz="1500" dirty="0"/>
           </a:p>
           <a:p>
             <a:pPr marL="177800" indent="-177800">
               <a:spcAft>
-                <a:spcPts val="600"/>
+                <a:spcPts val="800"/>
               </a:spcAft>
               <a:buSzPct val="100000"/>
               <a:buChar char="•"/>
             </a:pPr>
             <a:r>
-              <a:rPr lang="en-US" sz="1250" dirty="0">
+              <a:rPr lang="en-US" sz="1400" dirty="0">
                 <a:solidFill>
                   <a:srgbClr val="1F2933"/>
                 </a:solidFill>
               </a:rPr>
-              <a:t>Extrapolation across arms; no outcome information crosses arms. Hypothesis-generating only</a:t>
+              <a:t>Highest relative likelihood: mexiletine 12% (severe myotonia), tideglusib 35% (cognitive impairment), oligonucleotide the remainder</a:t>
             </a:r>
-            <a:endParaRPr lang="en-US" sz="1400" dirty="0"/>
+            <a:endParaRPr lang="en-US" sz="1500" dirty="0"/>
           </a:p>
           <a:p>
             <a:pPr marL="177800" indent="-177800">
               <a:spcAft>
-                <a:spcPts val="600"/>
+                <a:spcPts val="800"/>
               </a:spcAft>
               <a:buSzPct val="100000"/>
               <a:buChar char="•"/>
             </a:pPr>
             <a:r>
-              <a:rPr lang="en-US" sz="1250" dirty="0">
+              <a:rPr lang="en-US" sz="1400" dirty="0">
                 <a:solidFill>
                   <a:srgbClr val="1F2933"/>
                 </a:solidFill>
               </a:rPr>
-              <a:t>The data dictionary states that arm assignment was weighted by patient fit; observed arm matches the predicted best arm for 41% of patients versus 33% expected by chance, so the weighting was mild</a:t>
+              <a:t>Hypothesis-generating only: extrapolation across arms, no outcome information crosses arms</a:t>
             </a:r>
-            <a:endParaRPr lang="en-US" sz="1400" dirty="0"/>
+            <a:endParaRPr lang="en-US" sz="1500" dirty="0"/>
           </a:p>
         </p:txBody>
       </p:sp>
@@ -8376,10 +8135,10 @@
         <a:srgbClr val="FFFFFF"/>
       </a:lt1>
       <a:dk2>
-        <a:srgbClr val="1E3A5F"/>
+        <a:srgbClr val="3A3F45"/>
       </a:dk2>
       <a:lt2>
-        <a:srgbClr val="EEF2F6"/>
+        <a:srgbClr val="F2F2F2"/>
       </a:lt2>
       <a:accent1>
         <a:srgbClr val="2C7FB8"/>
@@ -8394,7 +8153,7 @@
         <a:srgbClr val="2A7A2A"/>
       </a:accent4>
       <a:accent5>
-        <a:srgbClr val="8DA9C4"/>
+        <a:srgbClr val="9AA3AD"/>
       </a:accent5>
       <a:accent6>
         <a:srgbClr val="BFD3E6"/>

</xml_diff>

<commit_message>
Correct the mexiletine single-cut-off responder rate (48% vs 10%) and the fold range (2 to 5) in deck, outline and report
Co-Authored-By: Claude Fable 5.1 <noreply@anthropic.com>
</commit_message>
<xml_diff>
--- a/slides/Team1_DM1_slides.pptx
+++ b/slides/Team1_DM1_slides.pptx
@@ -116,7 +116,7 @@
   <p:extLst>
     <p:ext uri="{521415D9-36F7-43E2-AB2F-B90AF26B5E84}">
       <p14:sectionLst xmlns:p14="http://schemas.microsoft.com/office/powerpoint/2010/main">
-        <p14:section name="Talk" id="{817d5f1a-55c1-f410-a9d6-292ae4025189}">
+        <p14:section name="Talk" id="{8f93376a-ebdb-fa5d-7667-57089bd0d2a4}">
           <p14:sldIdLst>
             <p14:sldId id="256"/>
             <p14:sldId id="257"/>
@@ -126,7 +126,7 @@
             <p14:sldId id="261"/>
           </p14:sldIdLst>
         </p14:section>
-        <p14:section name="Backup" id="{21f6a711-e9da-52e7-f6f1-713eeb364b8c}">
+        <p14:section name="Backup" id="{fbf4a132-d65b-ab51-4c2e-75f48846f403}">
           <p14:sldIdLst>
             <p14:sldId id="262"/>
             <p14:sldId id="263"/>
@@ -719,7 +719,7 @@
               <a:rPr lang="en-US" dirty="0"/>
               <a:t>[45 s]
 This is the whole result. One row per arm.
-Mexiletine blocks muscle sodium channels; it treats the symptom. Its predictor is the symptom: baseline myotonia severity. Among held-out test patients, 67% above the cut-off responded versus 10% below.
+Mexiletine blocks muscle sodium channels; it treats the symptom. Its predictor is the symptom: baseline myotonia severity. Among held-out test patients, 48% above the cut-off responded versus 10% below.
 The antisense oligonucleotide degrades the toxic DMPK transcript; it acts on the cause. Its predictor is the amount of cause: CTG repeat length. 59% versus 31%.
 Tideglusib inhibits GSK3β and acts across several systems including the brain; the endpoint is a composite with a cognitive domain. Its predictor is baseline cognitive function. 74% versus 17%.
 Three points of evidence behind every row: stepwise selection, LASSO, elastic net, random forest and XGBoost all picked the same covariate; LASSO kept it in 90 to 100% of 200 bootstrap resamples; and a column of pure random numbers that we added as a negative control was never selected by any method in any arm.
@@ -1093,7 +1093,7 @@
             <a:r>
               <a:rPr lang="en-US" dirty="0"/>
               <a:t>[40 s]
-What a clinician or a trialist does with this: measure the organ the drug acts on. Myotonia severity before mexiletine, repeat length before the antisense drug, cognitive function before tideglusib. One routine baseline assessment per drug, and response rates differ two- to seven-fold between the groups it defines. Cut-offs are approximate: about 5, about 350, about minus 0.5.
+What a clinician or a trialist does with this: measure the organ the drug acts on. Myotonia severity before mexiletine, repeat length before the antisense drug, cognitive function before tideglusib. One routine baseline assessment per drug, and response rates differ two- to five-fold between the groups it defines. Cut-offs are approximate: about 5, about 350, about minus 0.5.
 Trial design: for mexiletine, enrol on baseline myotonia severity rather than diagnosis alone, because mild cases dilute the effect, which is what the 2021 placebo-controlled trial found on walking distance. For the oligonucleotide, stratify randomisation on repeat length, a prognostic factor. For tideglusib, enrich for cognitive impairment: expected responder rate goes from 48% to 74%, which reduces the sample size needed to show an effect.
 Limitations we state ourselves: no placebo arm, so these are prognostic predictors within treated patients, not demonstrated effect modifiers. About 41 test patients per arm, so we give ranges and do not rank methods within an arm. One time point per patient; the natural next step is a longitudinal disease-progression model with these covariates on progression rate and drug effect.
 AI disclosure: Claude through Claude Code, and Codex, drafted code, documentation and these slides, as noted in the code headers. Every analysis decision and interpretation was reviewed by the team, and the team is accountable for the results.
@@ -2830,7 +2830,7 @@
                             <a:srgbClr val="1F2933"/>
                           </a:solidFill>
                         </a:rPr>
-                        <a:t>67% vs 10%</a:t>
+                        <a:t>48% vs 10%</a:t>
                       </a:r>
                       <a:endParaRPr lang="en-US" sz="1400" dirty="0"/>
                     </a:p>
@@ -5025,7 +5025,7 @@
                   <a:srgbClr val="000000"/>
                 </a:solidFill>
               </a:rPr>
-              <a:t>Stratify on the measure closest to the drug's target: one baseline assessment per arm separates response two- to seven-fold</a:t>
+              <a:t>Stratify on the measure closest to the drug's target: one baseline assessment per arm separates response two- to five-fold</a:t>
             </a:r>
             <a:endParaRPr lang="en-US" sz="2800" dirty="0"/>
           </a:p>
@@ -5556,7 +5556,7 @@
                             <a:srgbClr val="1F2933"/>
                           </a:solidFill>
                         </a:rPr>
-                        <a:t>67% vs 10%</a:t>
+                        <a:t>48% vs 10%</a:t>
                       </a:r>
                       <a:endParaRPr lang="en-US" sz="1400" dirty="0"/>
                     </a:p>

</xml_diff>

<commit_message>
Deck: responder column shows counts and percentages, labelled as test patients
Co-Authored-By: Claude Fable 5.1 <noreply@anthropic.com>
</commit_message>
<xml_diff>
--- a/slides/Team1_DM1_slides.pptx
+++ b/slides/Team1_DM1_slides.pptx
@@ -116,7 +116,7 @@
   <p:extLst>
     <p:ext uri="{521415D9-36F7-43E2-AB2F-B90AF26B5E84}">
       <p14:sectionLst xmlns:p14="http://schemas.microsoft.com/office/powerpoint/2010/main">
-        <p14:section name="Talk" id="{8f93376a-ebdb-fa5d-7667-57089bd0d2a4}">
+        <p14:section name="Talk" id="{895ae816-a7ec-367d-294d-a6dddaddfea6}">
           <p14:sldIdLst>
             <p14:sldId id="256"/>
             <p14:sldId id="257"/>
@@ -126,7 +126,7 @@
             <p14:sldId id="261"/>
           </p14:sldIdLst>
         </p14:section>
-        <p14:section name="Backup" id="{fbf4a132-d65b-ab51-4c2e-75f48846f403}">
+        <p14:section name="Backup" id="{c50a6589-a1da-9ee4-7cf9-be7ed99f92c9}">
           <p14:sldIdLst>
             <p14:sldId id="262"/>
             <p14:sldId id="263"/>
@@ -2390,10 +2390,10 @@
             <a:tbl>
               <a:tblPr/>
               <a:tblGrid>
-                <a:gridCol w="2377440"/>
-                <a:gridCol w="3291840"/>
-                <a:gridCol w="2377440"/>
-                <a:gridCol w="3017520"/>
+                <a:gridCol w="2194560"/>
+                <a:gridCol w="2926080"/>
+                <a:gridCol w="2103120"/>
+                <a:gridCol w="3840480"/>
               </a:tblGrid>
               <a:tr h="548640">
                 <a:tc>
@@ -2593,7 +2593,7 @@
                             <a:srgbClr val="000000"/>
                           </a:solidFill>
                         </a:rPr>
-                        <a:t>Held-out responder rate, above vs below cut-off</a:t>
+                        <a:t>Test patients who responded: above cut-off  vs  below</a:t>
                       </a:r>
                       <a:endParaRPr lang="en-US" sz="1400" dirty="0"/>
                     </a:p>
@@ -2830,7 +2830,7 @@
                             <a:srgbClr val="1F2933"/>
                           </a:solidFill>
                         </a:rPr>
-                        <a:t>48% vs 10%</a:t>
+                        <a:t>10 of 21 (48%)  vs  2 of 20 (10%)</a:t>
                       </a:r>
                       <a:endParaRPr lang="en-US" sz="1400" dirty="0"/>
                     </a:p>
@@ -3064,7 +3064,7 @@
                             <a:srgbClr val="1F2933"/>
                           </a:solidFill>
                         </a:rPr>
-                        <a:t>59% vs 31%</a:t>
+                        <a:t>10 of 17 (59%)  vs  8 of 26 (31%)</a:t>
                       </a:r>
                       <a:endParaRPr lang="en-US" sz="1400" dirty="0"/>
                     </a:p>
@@ -3298,7 +3298,7 @@
                             <a:srgbClr val="1F2933"/>
                           </a:solidFill>
                         </a:rPr>
-                        <a:t>74% vs 17%</a:t>
+                        <a:t>17 of 23 (74%)  vs  3 of 18 (17%)</a:t>
                       </a:r>
                       <a:endParaRPr lang="en-US" sz="1400" dirty="0"/>
                     </a:p>
@@ -5054,13 +5054,13 @@
             <a:tbl>
               <a:tblPr/>
               <a:tblGrid>
-                <a:gridCol w="2286000"/>
                 <a:gridCol w="2103120"/>
-                <a:gridCol w="1463040"/>
-                <a:gridCol w="1920240"/>
-                <a:gridCol w="3291840"/>
+                <a:gridCol w="1828800"/>
+                <a:gridCol w="1371600"/>
+                <a:gridCol w="2834640"/>
+                <a:gridCol w="2926080"/>
               </a:tblGrid>
-              <a:tr h="457200">
+              <a:tr h="548640">
                 <a:tc>
                   <a:txBody>
                     <a:bodyPr/>
@@ -5258,7 +5258,7 @@
                             <a:srgbClr val="000000"/>
                           </a:solidFill>
                         </a:rPr>
-                        <a:t>Held-out responders</a:t>
+                        <a:t>Test patients who responded: above vs below cut-off</a:t>
                       </a:r>
                       <a:endParaRPr lang="en-US" sz="1400" dirty="0"/>
                     </a:p>
@@ -5556,7 +5556,7 @@
                             <a:srgbClr val="1F2933"/>
                           </a:solidFill>
                         </a:rPr>
-                        <a:t>48% vs 10%</a:t>
+                        <a:t>10 of 21 (48%) vs 2 of 20 (10%)</a:t>
                       </a:r>
                       <a:endParaRPr lang="en-US" sz="1400" dirty="0"/>
                     </a:p>
@@ -5848,7 +5848,7 @@
                             <a:srgbClr val="1F2933"/>
                           </a:solidFill>
                         </a:rPr>
-                        <a:t>59% vs 31%</a:t>
+                        <a:t>10 of 17 (59%) vs 8 of 26 (31%)</a:t>
                       </a:r>
                       <a:endParaRPr lang="en-US" sz="1400" dirty="0"/>
                     </a:p>
@@ -6140,7 +6140,7 @@
                             <a:srgbClr val="1F2933"/>
                           </a:solidFill>
                         </a:rPr>
-                        <a:t>74% vs 17%</a:t>
+                        <a:t>17 of 23 (74%) vs 3 of 18 (17%)</a:t>
                       </a:r>
                       <a:endParaRPr lang="en-US" sz="1400" dirty="0"/>
                     </a:p>

</xml_diff>

<commit_message>
Deck: Euibeom's manual edits in PowerPoint
</commit_message>
<xml_diff>
--- a/slides/Team1_DM1_slides.pptx
+++ b/slides/Team1_DM1_slides.pptx
@@ -4,6 +4,9 @@
   <p:sldMasterIdLst>
     <p:sldMasterId id="2147483648" r:id="rId1"/>
   </p:sldMasterIdLst>
+  <p:notesMasterIdLst>
+    <p:notesMasterId r:id="rId12"/>
+  </p:notesMasterIdLst>
   <p:sldIdLst>
     <p:sldId id="256" r:id="rId2"/>
     <p:sldId id="257" r:id="rId3"/>
@@ -16,9 +19,6 @@
     <p:sldId id="264" r:id="rId10"/>
     <p:sldId id="265" r:id="rId11"/>
   </p:sldIdLst>
-  <p:notesMasterIdLst>
-    <p:notesMasterId r:id="rId12"/>
-  </p:notesMasterIdLst>
   <p:sldSz cx="12192000" cy="6858000"/>
   <p:notesSz cx="6858000" cy="12192000"/>
   <p:defaultTextStyle>
@@ -116,7 +116,7 @@
   <p:extLst>
     <p:ext uri="{521415D9-36F7-43E2-AB2F-B90AF26B5E84}">
       <p14:sectionLst xmlns:p14="http://schemas.microsoft.com/office/powerpoint/2010/main">
-        <p14:section name="Talk" id="{895ae816-a7ec-367d-294d-a6dddaddfea6}">
+        <p14:section name="Talk" id="{895AE816-A7EC-367D-294D-A6DDDADDFEA6}">
           <p14:sldIdLst>
             <p14:sldId id="256"/>
             <p14:sldId id="257"/>
@@ -126,7 +126,7 @@
             <p14:sldId id="261"/>
           </p14:sldIdLst>
         </p14:section>
-        <p14:section name="Backup" id="{c50a6589-a1da-9ee4-7cf9-be7ed99f92c9}">
+        <p14:section name="Backup" id="{C50A6589-A1DA-9EE4-7CF9-BE7ED99F92C9}">
           <p14:sldIdLst>
             <p14:sldId id="262"/>
             <p14:sldId id="263"/>
@@ -165,234 +165,10 @@
           <a:chExt cx="0" cy="0"/>
         </a:xfrm>
       </p:grpSpPr>
-      <p:sp>
-        <p:nvSpPr>
-          <p:cNvPr id="2" name="Header Placeholder 1"/>
-          <p:cNvSpPr>
-            <a:spLocks noGrp="1"/>
-          </p:cNvSpPr>
-          <p:nvPr>
-            <p:ph type="hdr" sz="quarter"/>
-          </p:nvPr>
-        </p:nvSpPr>
-        <p:spPr>
-          <a:xfrm>
-            <a:off x="0" y="0"/>
-            <a:ext cx="2971800" cy="458788"/>
-          </a:xfrm>
-          <a:prstGeom prst="rect">
-            <a:avLst/>
-          </a:prstGeom>
-        </p:spPr>
-        <p:txBody>
-          <a:bodyPr vert="horz" lIns="91440" tIns="45720" rIns="91440" bIns="45720" rtlCol="0"/>
-          <a:lstStyle>
-            <a:lvl1pPr algn="l">
-              <a:defRPr sz="1200"/>
-            </a:lvl1pPr>
-          </a:lstStyle>
-          <a:p>
-            <a:endParaRPr lang="en-US"/>
-          </a:p>
-        </p:txBody>
-      </p:sp>
-      <p:sp>
-        <p:nvSpPr>
-          <p:cNvPr id="3" name="Date Placeholder 2"/>
-          <p:cNvSpPr>
-            <a:spLocks noGrp="1"/>
-          </p:cNvSpPr>
-          <p:nvPr>
-            <p:ph type="dt" idx="1"/>
-          </p:nvPr>
-        </p:nvSpPr>
-        <p:spPr>
-          <a:xfrm>
-            <a:off x="3884613" y="0"/>
-            <a:ext cx="2971800" cy="458788"/>
-          </a:xfrm>
-          <a:prstGeom prst="rect">
-            <a:avLst/>
-          </a:prstGeom>
-        </p:spPr>
-        <p:txBody>
-          <a:bodyPr vert="horz" lIns="91440" tIns="45720" rIns="91440" bIns="45720" rtlCol="0"/>
-          <a:lstStyle>
-            <a:lvl1pPr algn="r">
-              <a:defRPr sz="1200"/>
-            </a:lvl1pPr>
-          </a:lstStyle>
-          <a:p>
-            <a:fld id="{5282F153-3F37-0F45-9E97-73ACFA13230C}" type="datetimeFigureOut">
-              <a:rPr lang="en-US"/>
-              <a:t>7/23/19</a:t>
-            </a:fld>
-            <a:endParaRPr lang="en-US"/>
-          </a:p>
-        </p:txBody>
-      </p:sp>
-      <p:sp>
-        <p:nvSpPr>
-          <p:cNvPr id="4" name="Slide Image Placeholder 3"/>
-          <p:cNvSpPr>
-            <a:spLocks noGrp="1" noRot="1" noChangeAspect="1"/>
-          </p:cNvSpPr>
-          <p:nvPr>
-            <p:ph type="sldImg" idx="2"/>
-          </p:nvPr>
-        </p:nvSpPr>
-        <p:spPr>
-          <a:xfrm>
-            <a:off x="685800" y="1143000"/>
-            <a:ext cx="5486400" cy="3086100"/>
-          </a:xfrm>
-          <a:prstGeom prst="rect">
-            <a:avLst/>
-          </a:prstGeom>
-          <a:noFill/>
-          <a:ln w="12700">
-            <a:solidFill>
-              <a:prstClr val="black"/>
-            </a:solidFill>
-          </a:ln>
-        </p:spPr>
-        <p:txBody>
-          <a:bodyPr vert="horz" lIns="91440" tIns="45720" rIns="91440" bIns="45720" rtlCol="0" anchor="ctr"/>
-          <a:lstStyle/>
-          <a:p>
-            <a:endParaRPr lang="en-US"/>
-          </a:p>
-        </p:txBody>
-      </p:sp>
-      <p:sp>
-        <p:nvSpPr>
-          <p:cNvPr id="5" name="Notes Placeholder 4"/>
-          <p:cNvSpPr>
-            <a:spLocks noGrp="1"/>
-          </p:cNvSpPr>
-          <p:nvPr>
-            <p:ph type="body" sz="quarter" idx="3"/>
-          </p:nvPr>
-        </p:nvSpPr>
-        <p:spPr>
-          <a:xfrm>
-            <a:off x="685800" y="4400550"/>
-            <a:ext cx="5486400" cy="3600450"/>
-          </a:xfrm>
-          <a:prstGeom prst="rect">
-            <a:avLst/>
-          </a:prstGeom>
-        </p:spPr>
-        <p:txBody>
-          <a:bodyPr vert="horz" lIns="91440" tIns="45720" rIns="91440" bIns="45720" rtlCol="0"/>
-          <a:lstStyle/>
-          <a:p>
-            <a:pPr lvl="0"/>
-            <a:r>
-              <a:rPr lang="en-US"/>
-              <a:t>Click to edit Master text styles</a:t>
-            </a:r>
-          </a:p>
-          <a:p>
-            <a:pPr lvl="1"/>
-            <a:r>
-              <a:rPr lang="en-US"/>
-              <a:t>Second level</a:t>
-            </a:r>
-          </a:p>
-          <a:p>
-            <a:pPr lvl="2"/>
-            <a:r>
-              <a:rPr lang="en-US"/>
-              <a:t>Third level</a:t>
-            </a:r>
-          </a:p>
-          <a:p>
-            <a:pPr lvl="3"/>
-            <a:r>
-              <a:rPr lang="en-US"/>
-              <a:t>Fourth level</a:t>
-            </a:r>
-          </a:p>
-          <a:p>
-            <a:pPr lvl="4"/>
-            <a:r>
-              <a:rPr lang="en-US"/>
-              <a:t>Fifth level</a:t>
-            </a:r>
-          </a:p>
-        </p:txBody>
-      </p:sp>
-      <p:sp>
-        <p:nvSpPr>
-          <p:cNvPr id="6" name="Footer Placeholder 5"/>
-          <p:cNvSpPr>
-            <a:spLocks noGrp="1"/>
-          </p:cNvSpPr>
-          <p:nvPr>
-            <p:ph type="ftr" sz="quarter" idx="4"/>
-          </p:nvPr>
-        </p:nvSpPr>
-        <p:spPr>
-          <a:xfrm>
-            <a:off x="0" y="8685213"/>
-            <a:ext cx="2971800" cy="458787"/>
-          </a:xfrm>
-          <a:prstGeom prst="rect">
-            <a:avLst/>
-          </a:prstGeom>
-        </p:spPr>
-        <p:txBody>
-          <a:bodyPr vert="horz" lIns="91440" tIns="45720" rIns="91440" bIns="45720" rtlCol="0" anchor="b"/>
-          <a:lstStyle>
-            <a:lvl1pPr algn="l">
-              <a:defRPr sz="1200"/>
-            </a:lvl1pPr>
-          </a:lstStyle>
-          <a:p>
-            <a:endParaRPr lang="en-US"/>
-          </a:p>
-        </p:txBody>
-      </p:sp>
-      <p:sp>
-        <p:nvSpPr>
-          <p:cNvPr id="7" name="Slide Number Placeholder 6"/>
-          <p:cNvSpPr>
-            <a:spLocks noGrp="1"/>
-          </p:cNvSpPr>
-          <p:nvPr>
-            <p:ph type="sldNum" sz="quarter" idx="5"/>
-          </p:nvPr>
-        </p:nvSpPr>
-        <p:spPr>
-          <a:xfrm>
-            <a:off x="3884613" y="8685213"/>
-            <a:ext cx="2971800" cy="458787"/>
-          </a:xfrm>
-          <a:prstGeom prst="rect">
-            <a:avLst/>
-          </a:prstGeom>
-        </p:spPr>
-        <p:txBody>
-          <a:bodyPr vert="horz" lIns="91440" tIns="45720" rIns="91440" bIns="45720" rtlCol="0" anchor="b"/>
-          <a:lstStyle>
-            <a:lvl1pPr algn="r">
-              <a:defRPr sz="1200"/>
-            </a:lvl1pPr>
-          </a:lstStyle>
-          <a:p>
-            <a:fld id="{CE5E9CC1-C706-0F49-92D6-E571CC5EEA8F}" type="slidenum">
-              <a:rPr lang="en-US"/>
-              <a:t>‹#›</a:t>
-            </a:fld>
-            <a:endParaRPr lang="en-US"/>
-          </a:p>
-        </p:txBody>
-      </p:sp>
     </p:spTree>
     <p:extLst>
       <p:ext uri="{BB962C8B-B14F-4D97-AF65-F5344CB8AC3E}">
-        <p14:creationId xmlns:p14="http://schemas.microsoft.com/office/powerpoint/2010/main" val="1024086991"/>
+        <p14:creationId xmlns:p14="http://schemas.microsoft.com/office/powerpoint/2010/main" val="2823969499"/>
       </p:ext>
     </p:extLst>
   </p:cSld>
@@ -543,7 +319,6 @@
 Our answer in one line: each drug has one dominant predictor, it is the measure closest to the drug's site of action, and machine learning found nothing beyond it.
 Direction reminder, said once: for mexiletine a lower change in myotonia is better; for the other two arms higher is better.</a:t>
             </a:r>
-            <a:endParaRPr lang="en-US" dirty="0"/>
           </a:p>
         </p:txBody>
       </p:sp>
@@ -627,10 +402,6 @@
           <a:bodyPr/>
           <a:lstStyle/>
           <a:p>
-            <a:r>
-              <a:rPr lang="en-US" dirty="0"/>
-              <a:t/>
-            </a:r>
             <a:endParaRPr lang="en-US" dirty="0"/>
           </a:p>
         </p:txBody>
@@ -725,7 +496,6 @@
 Three points of evidence behind every row: stepwise selection, LASSO, elastic net, random forest and XGBoost all picked the same covariate; LASSO kept it in 90 to 100% of 200 bootstrap resamples; and a column of pure random numbers that we added as a negative control was never selected by any method in any arm.
 Machine learning, meaning random forest and XGBoost, ranked the same covariates first. It did not add a predictor.</a:t>
             </a:r>
-            <a:endParaRPr lang="en-US" dirty="0"/>
           </a:p>
         </p:txBody>
       </p:sp>
@@ -818,7 +588,6 @@
 Data review found no missing values, but albumin was a single imputed constant for every mexiletine patient, so it is excluded in that arm. The CK floor at 50 and mosaicism index at zero were retained as observed. No patient was excluded.
 Workflow, per arm: split first, 75/25, stratified by responder status and onset phenotype, fixed seed, test set scored once at the end. Every model choice by 5-fold cross-validation inside training. Three covariate models and two machine-learning models. And three noise controls: a pure-noise covariate, selection stability over 200 bootstrap resamples, and agreement across the five methods.</a:t>
             </a:r>
-            <a:endParaRPr lang="en-US" dirty="0"/>
           </a:p>
         </p:txBody>
       </p:sp>
@@ -913,7 +682,6 @@
 Replication: three team members built three independent implementations, two in R and one in Python, with different splits, up to 30 methods, and 20 repeated splits. All found the same three covariates. CTG repeat length behaves like a prognostic marker across arms; cognitive function is specific to tideglusib.
 If asked what was noise: sex, BMI, smoking, cataracts, CK, PR interval and albumin in every arm; disease duration borderline everywhere.</a:t>
             </a:r>
-            <a:endParaRPr lang="en-US" dirty="0"/>
           </a:p>
         </p:txBody>
       </p:sp>
@@ -1006,7 +774,6 @@
 Tideglusib: random forest and tuned XGBoost reach 0.55; the straight-line models 0.24 to 0.30, on 19 of 20 splits. We know why: the effect is a threshold, and a straight line cannot draw a step. A linear model given that single threshold on cognition reaches 0.45. Tuned XGBoost chose depth-one trees in every arm, so there are no interactions to find.
 Intervals overlap within each arm, so we do not rank methods inside an arm. Machine learning was the check that nothing was missed: by permutation importance and SHAP it found the same leaders.</a:t>
             </a:r>
-            <a:endParaRPr lang="en-US" dirty="0"/>
           </a:p>
         </p:txBody>
       </p:sp>
@@ -1099,7 +866,6 @@
 AI disclosure: Claude through Claude Code, and Codex, drafted code, documentation and these slides, as noted in the code headers. Every analysis decision and interpretation was reviewed by the team, and the team is accountable for the results.
 Robustness, if time: we repeated the split 20 times and the pattern held in every arm. Thank you.</a:t>
             </a:r>
-            <a:endParaRPr lang="en-US" dirty="0"/>
           </a:p>
         </p:txBody>
       </p:sp>
@@ -1187,7 +953,6 @@
               <a:rPr lang="en-US" dirty="0"/>
               <a:t>Mexiletine: methods equivalent, median about 0.6. Oligonucleotide: all weak, medians 0.06 to 0.12. Absolute R² varies by up to 0.15 between splits, hence ranges rather than point estimates.</a:t>
             </a:r>
-            <a:endParaRPr lang="en-US" dirty="0"/>
           </a:p>
         </p:txBody>
       </p:sp>
@@ -1275,7 +1040,6 @@
               <a:rPr lang="en-US" dirty="0"/>
               <a:t>The three covariate-model columns agree on one covariate per arm. The ML columns are fuller because their criterion, importance above the noise covariate, is permissive; that is why the final call also requires bootstrap stability.</a:t>
             </a:r>
-            <a:endParaRPr lang="en-US" dirty="0"/>
           </a:p>
         </p:txBody>
       </p:sp>
@@ -1363,7 +1127,6 @@
               <a:rPr lang="en-US" dirty="0"/>
               <a:t>Same direction within every onset phenotype in every arm, training set. Only the mexiletine slope differs by phenotype: attenuated in late onset, where baseline myotonia is mild. The data dictionary states arm assignment was weighted by patient fit; observed arm matches the predicted best arm for 41% of patients versus 33% by chance, so the weighting was mild.</a:t>
             </a:r>
-            <a:endParaRPr lang="en-US" dirty="0"/>
           </a:p>
         </p:txBody>
       </p:sp>
@@ -1441,6 +1204,7 @@
         <a:solidFill>
           <a:srgbClr val="FFFFFF"/>
         </a:solidFill>
+        <a:effectLst/>
       </p:bgPr>
     </p:bg>
     <p:spTree>
@@ -1460,9 +1224,11 @@
       <p:sp>
         <p:nvSpPr>
           <p:cNvPr id="2" name="Text 0"/>
-          <p:cNvSpPr/>
+          <p:cNvSpPr>
+            <a:spLocks noGrp="1"/>
+          </p:cNvSpPr>
           <p:nvPr>
-            <p:ph idx="100" type="title" hasCustomPrompt="1"/>
+            <p:ph type="title" idx="100" hasCustomPrompt="1"/>
           </p:nvPr>
         </p:nvSpPr>
         <p:spPr>
@@ -1479,7 +1245,7 @@
         <p:txBody>
           <a:bodyPr wrap="square" rtlCol="0"/>
           <a:lstStyle>
-            <a:lvl1pPr algn="l" indent="0" marL="0">
+            <a:lvl1pPr marL="0" indent="0" algn="l">
               <a:buNone/>
               <a:defRPr lang="en-US" sz="4000" b="1" dirty="0">
                 <a:solidFill>
@@ -1489,7 +1255,7 @@
             </a:lvl1pPr>
           </a:lstStyle>
           <a:p>
-            <a:pPr algn="l" indent="0" marL="0">
+            <a:pPr marL="0" indent="0" algn="l">
               <a:buNone/>
             </a:pPr>
             <a:endParaRPr lang="en-US" sz="4000" dirty="0"/>
@@ -1499,9 +1265,11 @@
       <p:sp>
         <p:nvSpPr>
           <p:cNvPr id="3" name="Text 0"/>
-          <p:cNvSpPr/>
+          <p:cNvSpPr>
+            <a:spLocks noGrp="1"/>
+          </p:cNvSpPr>
           <p:nvPr>
-            <p:ph idx="101" type="body" hasCustomPrompt="1"/>
+            <p:ph type="body" idx="101" hasCustomPrompt="1"/>
           </p:nvPr>
         </p:nvSpPr>
         <p:spPr>
@@ -1518,7 +1286,7 @@
         <p:txBody>
           <a:bodyPr wrap="square" rtlCol="0"/>
           <a:lstStyle>
-            <a:lvl1pPr algn="l" indent="0" marL="0">
+            <a:lvl1pPr marL="0" indent="0" algn="l">
               <a:buNone/>
               <a:defRPr lang="en-US" sz="1800" dirty="0">
                 <a:solidFill>
@@ -1528,7 +1296,7 @@
             </a:lvl1pPr>
           </a:lstStyle>
           <a:p>
-            <a:pPr algn="l" indent="0" marL="0">
+            <a:pPr marL="0" indent="0" algn="l">
               <a:buNone/>
             </a:pPr>
             <a:endParaRPr lang="en-US" sz="1800" dirty="0"/>
@@ -1551,6 +1319,7 @@
         <a:solidFill>
           <a:srgbClr val="FFFFFF"/>
         </a:solidFill>
+        <a:effectLst/>
       </p:bgPr>
     </p:bg>
     <p:spTree>
@@ -1570,9 +1339,11 @@
       <p:sp>
         <p:nvSpPr>
           <p:cNvPr id="2" name="Text 0"/>
-          <p:cNvSpPr/>
+          <p:cNvSpPr>
+            <a:spLocks noGrp="1"/>
+          </p:cNvSpPr>
           <p:nvPr>
-            <p:ph idx="100" type="title" hasCustomPrompt="1"/>
+            <p:ph type="title" idx="100" hasCustomPrompt="1"/>
           </p:nvPr>
         </p:nvSpPr>
         <p:spPr>
@@ -1589,7 +1360,7 @@
         <p:txBody>
           <a:bodyPr wrap="square" rtlCol="0"/>
           <a:lstStyle>
-            <a:lvl1pPr algn="l" indent="0" marL="0">
+            <a:lvl1pPr marL="0" indent="0" algn="l">
               <a:buNone/>
               <a:defRPr lang="en-US" sz="2800" b="1" dirty="0">
                 <a:solidFill>
@@ -1599,7 +1370,7 @@
             </a:lvl1pPr>
           </a:lstStyle>
           <a:p>
-            <a:pPr algn="l" indent="0" marL="0">
+            <a:pPr marL="0" indent="0" algn="l">
               <a:buNone/>
             </a:pPr>
             <a:endParaRPr lang="en-US" sz="2800" dirty="0"/>
@@ -1617,6 +1388,11 @@
 <file path=ppt/slideMasters/slideMaster1.xml><?xml version="1.0" encoding="utf-8"?>
 <p:sldMaster xmlns:a="http://schemas.openxmlformats.org/drawingml/2006/main" xmlns:r="http://schemas.openxmlformats.org/officeDocument/2006/relationships" xmlns:p="http://schemas.openxmlformats.org/presentationml/2006/main">
   <p:cSld>
+    <p:bg>
+      <p:bgRef idx="1001">
+        <a:schemeClr val="bg1"/>
+      </p:bgRef>
+    </p:bg>
     <p:spTree>
       <p:nvGrpSpPr>
         <p:cNvPr id="1" name=""/>
@@ -1901,6 +1677,7 @@
         <a:solidFill>
           <a:srgbClr val="FFFFFF"/>
         </a:solidFill>
+        <a:effectLst/>
       </p:bgPr>
     </p:bg>
     <p:spTree>
@@ -1920,9 +1697,11 @@
       <p:sp>
         <p:nvSpPr>
           <p:cNvPr id="2" name="Text 0"/>
-          <p:cNvSpPr/>
+          <p:cNvSpPr>
+            <a:spLocks noGrp="1"/>
+          </p:cNvSpPr>
           <p:nvPr>
-            <p:ph idx="100" type="title" hasCustomPrompt="1"/>
+            <p:ph type="title" idx="100" hasCustomPrompt="1"/>
           </p:nvPr>
         </p:nvSpPr>
         <p:spPr>
@@ -1940,7 +1719,7 @@
           <a:bodyPr wrap="square" lIns="0" tIns="0" rIns="0" bIns="0" rtlCol="0"/>
           <a:lstStyle/>
           <a:p>
-            <a:pPr algn="l" indent="0" marL="0">
+            <a:pPr marL="0" indent="0" algn="l">
               <a:buNone/>
             </a:pPr>
             <a:r>
@@ -1958,9 +1737,11 @@
       <p:sp>
         <p:nvSpPr>
           <p:cNvPr id="3" name="Text 0"/>
-          <p:cNvSpPr/>
+          <p:cNvSpPr>
+            <a:spLocks noGrp="1"/>
+          </p:cNvSpPr>
           <p:nvPr>
-            <p:ph idx="101" type="body" hasCustomPrompt="1"/>
+            <p:ph type="body" idx="101" hasCustomPrompt="1"/>
           </p:nvPr>
         </p:nvSpPr>
         <p:spPr>
@@ -1978,60 +1759,76 @@
           <a:bodyPr wrap="square" lIns="0" tIns="0" rIns="0" bIns="0" rtlCol="0"/>
           <a:lstStyle/>
           <a:p>
-            <a:pPr algn="l" indent="0" marL="0">
+            <a:pPr marL="0" indent="0" algn="l">
               <a:buNone/>
             </a:pPr>
             <a:r>
-              <a:rPr lang="en-US" sz="1800" dirty="0">
+              <a:rPr lang="en-US" sz="2000" dirty="0">
                 <a:solidFill>
                   <a:srgbClr val="404040"/>
                 </a:solidFill>
               </a:rPr>
               <a:t>Covariate modelling versus machine learning for treatment-response stratification in myotonic dystrophy type 1</a:t>
             </a:r>
-            <a:endParaRPr lang="en-US" sz="1800" dirty="0"/>
-          </a:p>
-          <a:p>
-            <a:pPr algn="l" indent="0" marL="0">
+            <a:endParaRPr lang="en-US" sz="2000" dirty="0"/>
+          </a:p>
+          <a:p>
+            <a:pPr marL="0" indent="0" algn="l">
               <a:buNone/>
             </a:pPr>
             <a:r>
-              <a:rPr lang="en-US" sz="800" dirty="0">
+              <a:rPr lang="en-US" sz="900" dirty="0">
                 <a:solidFill>
                   <a:srgbClr val="404040"/>
                 </a:solidFill>
               </a:rPr>
               <a:t> </a:t>
             </a:r>
-            <a:endParaRPr lang="en-US" sz="1800" dirty="0"/>
-          </a:p>
-          <a:p>
-            <a:pPr algn="l" indent="0" marL="0">
+            <a:endParaRPr lang="en-US" sz="2000" dirty="0"/>
+          </a:p>
+          <a:p>
+            <a:pPr marL="0" indent="0" algn="l">
               <a:buNone/>
             </a:pPr>
             <a:r>
-              <a:rPr lang="en-US" sz="1500" dirty="0">
+              <a:rPr lang="en-US" sz="1600" b="1" dirty="0">
                 <a:solidFill>
                   <a:srgbClr val="404040"/>
                 </a:solidFill>
               </a:rPr>
-              <a:t>Team 1  ·  Euibeom Shin, Wenzhe Ma, Leo Vuong, Bei Zhao, Ming Gao, Izumi Hamada</a:t>
+              <a:t>Team 1 </a:t>
             </a:r>
-            <a:endParaRPr lang="en-US" sz="1800" dirty="0"/>
-          </a:p>
-          <a:p>
-            <a:pPr algn="l" indent="0" marL="0">
-              <a:buNone/>
-            </a:pPr>
             <a:r>
-              <a:rPr lang="en-US" sz="1500" dirty="0">
+              <a:rPr lang="en-US" sz="1600" dirty="0">
                 <a:solidFill>
                   <a:srgbClr val="404040"/>
                 </a:solidFill>
               </a:rPr>
-              <a:t>ACoP 2026 Hackathon  ·  14 October 2026</a:t>
+              <a:t>: Euibeom Shin, Wenzhe Ma, Leo Vuong, Bei Zhao, Ming Gao, Izumi Hamada</a:t>
             </a:r>
-            <a:endParaRPr lang="en-US" sz="1800" dirty="0"/>
+            <a:endParaRPr lang="en-US" sz="2000" dirty="0"/>
+          </a:p>
+          <a:p>
+            <a:pPr marL="0" indent="0" algn="l">
+              <a:buNone/>
+            </a:pPr>
+            <a:r>
+              <a:rPr lang="en-US" sz="1600" dirty="0">
+                <a:solidFill>
+                  <a:srgbClr val="404040"/>
+                </a:solidFill>
+              </a:rPr>
+              <a:t>ACoP </a:t>
+            </a:r>
+            <a:r>
+              <a:rPr lang="en-US" sz="1600">
+                <a:solidFill>
+                  <a:srgbClr val="404040"/>
+                </a:solidFill>
+              </a:rPr>
+              <a:t>2026 Hackathon</a:t>
+            </a:r>
+            <a:endParaRPr lang="en-US" sz="2000" dirty="0"/>
           </a:p>
         </p:txBody>
       </p:sp>
@@ -2051,6 +1848,7 @@
         <a:solidFill>
           <a:srgbClr val="FFFFFF"/>
         </a:solidFill>
+        <a:effectLst/>
       </p:bgPr>
     </p:bg>
     <p:spTree>
@@ -2070,9 +1868,11 @@
       <p:sp>
         <p:nvSpPr>
           <p:cNvPr id="2" name="Text 0"/>
-          <p:cNvSpPr/>
+          <p:cNvSpPr>
+            <a:spLocks noGrp="1"/>
+          </p:cNvSpPr>
           <p:nvPr>
-            <p:ph idx="100" type="title" hasCustomPrompt="1"/>
+            <p:ph type="title" idx="100" hasCustomPrompt="1"/>
           </p:nvPr>
         </p:nvSpPr>
         <p:spPr>
@@ -2090,7 +1890,7 @@
           <a:bodyPr wrap="square" lIns="0" tIns="0" rIns="0" bIns="0" rtlCol="0" anchor="t"/>
           <a:lstStyle/>
           <a:p>
-            <a:pPr algn="l" indent="0" marL="0">
+            <a:pPr marL="0" indent="0" algn="l">
               <a:buNone/>
             </a:pPr>
             <a:r>
@@ -2126,7 +1926,7 @@
           <a:bodyPr wrap="square" lIns="0" tIns="0" rIns="0" bIns="0" rtlCol="0" anchor="t"/>
           <a:lstStyle/>
           <a:p>
-            <a:pPr indent="0" marL="0">
+            <a:pPr marL="0" indent="0">
               <a:spcAft>
                 <a:spcPts val="600"/>
               </a:spcAft>
@@ -2143,7 +1943,7 @@
             <a:endParaRPr lang="en-US" sz="1300" dirty="0"/>
           </a:p>
           <a:p>
-            <a:pPr indent="0" marL="0">
+            <a:pPr marL="0" indent="0">
               <a:spcAft>
                 <a:spcPts val="600"/>
               </a:spcAft>
@@ -2160,7 +1960,7 @@
             <a:endParaRPr lang="en-US" sz="1300" dirty="0"/>
           </a:p>
           <a:p>
-            <a:pPr indent="0" marL="0">
+            <a:pPr marL="0" indent="0">
               <a:spcAft>
                 <a:spcPts val="600"/>
               </a:spcAft>
@@ -2177,7 +1977,7 @@
             <a:endParaRPr lang="en-US" sz="1300" dirty="0"/>
           </a:p>
           <a:p>
-            <a:pPr indent="0" marL="0">
+            <a:pPr marL="0" indent="0">
               <a:spcAft>
                 <a:spcPts val="600"/>
               </a:spcAft>
@@ -2194,7 +1994,7 @@
             <a:endParaRPr lang="en-US" sz="1300" dirty="0"/>
           </a:p>
           <a:p>
-            <a:pPr indent="0" marL="0">
+            <a:pPr marL="0" indent="0">
               <a:spcAft>
                 <a:spcPts val="600"/>
               </a:spcAft>
@@ -2211,7 +2011,7 @@
             <a:endParaRPr lang="en-US" sz="1300" dirty="0"/>
           </a:p>
           <a:p>
-            <a:pPr indent="0" marL="0">
+            <a:pPr marL="0" indent="0">
               <a:spcAft>
                 <a:spcPts val="600"/>
               </a:spcAft>
@@ -2228,7 +2028,7 @@
             <a:endParaRPr lang="en-US" sz="1300" dirty="0"/>
           </a:p>
           <a:p>
-            <a:pPr indent="0" marL="0">
+            <a:pPr marL="0" indent="0">
               <a:spcAft>
                 <a:spcPts val="600"/>
               </a:spcAft>
@@ -2245,7 +2045,7 @@
             <a:endParaRPr lang="en-US" sz="1300" dirty="0"/>
           </a:p>
           <a:p>
-            <a:pPr indent="0" marL="0">
+            <a:pPr marL="0" indent="0">
               <a:spcAft>
                 <a:spcPts val="600"/>
               </a:spcAft>
@@ -2262,7 +2062,7 @@
             <a:endParaRPr lang="en-US" sz="1300" dirty="0"/>
           </a:p>
           <a:p>
-            <a:pPr indent="0" marL="0">
+            <a:pPr marL="0" indent="0">
               <a:spcAft>
                 <a:spcPts val="600"/>
               </a:spcAft>
@@ -2279,7 +2079,7 @@
             <a:endParaRPr lang="en-US" sz="1300" dirty="0"/>
           </a:p>
           <a:p>
-            <a:pPr indent="0" marL="0">
+            <a:pPr marL="0" indent="0">
               <a:spcAft>
                 <a:spcPts val="600"/>
               </a:spcAft>
@@ -2313,6 +2113,7 @@
         <a:solidFill>
           <a:srgbClr val="FFFFFF"/>
         </a:solidFill>
+        <a:effectLst/>
       </p:bgPr>
     </p:bg>
     <p:spTree>
@@ -2332,9 +2133,11 @@
       <p:sp>
         <p:nvSpPr>
           <p:cNvPr id="2" name="Text 0"/>
-          <p:cNvSpPr/>
+          <p:cNvSpPr>
+            <a:spLocks noGrp="1"/>
+          </p:cNvSpPr>
           <p:nvPr>
-            <p:ph idx="100" type="title" hasCustomPrompt="1"/>
+            <p:ph type="title" idx="100" hasCustomPrompt="1"/>
           </p:nvPr>
         </p:nvSpPr>
         <p:spPr>
@@ -2352,7 +2155,7 @@
           <a:bodyPr wrap="square" lIns="0" tIns="0" rIns="0" bIns="0" rtlCol="0" anchor="t"/>
           <a:lstStyle/>
           <a:p>
-            <a:pPr algn="l" indent="0" marL="0">
+            <a:pPr marL="0" indent="0" algn="l">
               <a:buNone/>
             </a:pPr>
             <a:r>
@@ -2383,17 +2186,41 @@
         </p:nvGraphicFramePr>
         <p:xfrm>
           <a:off x="548640" y="1508760"/>
-          <a:ext cx="11064240" cy="914400"/>
+          <a:ext cx="11064240" cy="2885440"/>
         </p:xfrm>
         <a:graphic>
           <a:graphicData uri="http://schemas.openxmlformats.org/drawingml/2006/table">
             <a:tbl>
               <a:tblPr/>
               <a:tblGrid>
-                <a:gridCol w="2194560"/>
-                <a:gridCol w="2926080"/>
-                <a:gridCol w="2103120"/>
-                <a:gridCol w="3840480"/>
+                <a:gridCol w="2194560">
+                  <a:extLst>
+                    <a:ext uri="{9D8B030D-6E8A-4147-A177-3AD203B41FA5}">
+                      <a16:colId xmlns:a16="http://schemas.microsoft.com/office/drawing/2014/main" val="20000"/>
+                    </a:ext>
+                  </a:extLst>
+                </a:gridCol>
+                <a:gridCol w="2926080">
+                  <a:extLst>
+                    <a:ext uri="{9D8B030D-6E8A-4147-A177-3AD203B41FA5}">
+                      <a16:colId xmlns:a16="http://schemas.microsoft.com/office/drawing/2014/main" val="20001"/>
+                    </a:ext>
+                  </a:extLst>
+                </a:gridCol>
+                <a:gridCol w="2103120">
+                  <a:extLst>
+                    <a:ext uri="{9D8B030D-6E8A-4147-A177-3AD203B41FA5}">
+                      <a16:colId xmlns:a16="http://schemas.microsoft.com/office/drawing/2014/main" val="20002"/>
+                    </a:ext>
+                  </a:extLst>
+                </a:gridCol>
+                <a:gridCol w="3840480">
+                  <a:extLst>
+                    <a:ext uri="{9D8B030D-6E8A-4147-A177-3AD203B41FA5}">
+                      <a16:colId xmlns:a16="http://schemas.microsoft.com/office/drawing/2014/main" val="20003"/>
+                    </a:ext>
+                  </a:extLst>
+                </a:gridCol>
               </a:tblGrid>
               <a:tr h="548640">
                 <a:tc>
@@ -2401,7 +2228,7 @@
                     <a:bodyPr/>
                     <a:lstStyle/>
                     <a:p>
-                      <a:pPr indent="0" marL="0">
+                      <a:pPr marL="0" indent="0">
                         <a:buNone/>
                       </a:pPr>
                       <a:r>
@@ -2462,7 +2289,7 @@
                     <a:bodyPr/>
                     <a:lstStyle/>
                     <a:p>
-                      <a:pPr indent="0" marL="0">
+                      <a:pPr marL="0" indent="0">
                         <a:buNone/>
                       </a:pPr>
                       <a:r>
@@ -2523,7 +2350,7 @@
                     <a:bodyPr/>
                     <a:lstStyle/>
                     <a:p>
-                      <a:pPr indent="0" marL="0">
+                      <a:pPr marL="0" indent="0">
                         <a:buNone/>
                       </a:pPr>
                       <a:r>
@@ -2584,7 +2411,7 @@
                     <a:bodyPr/>
                     <a:lstStyle/>
                     <a:p>
-                      <a:pPr indent="0" marL="0">
+                      <a:pPr marL="0" indent="0">
                         <a:buNone/>
                       </a:pPr>
                       <a:r>
@@ -2640,6 +2467,11 @@
                     </a:solidFill>
                   </a:tcPr>
                 </a:tc>
+                <a:extLst>
+                  <a:ext uri="{0D108BD9-81ED-4DB2-BD59-A6C34878D82A}">
+                    <a16:rowId xmlns:a16="http://schemas.microsoft.com/office/drawing/2014/main" val="10000"/>
+                  </a:ext>
+                </a:extLst>
               </a:tr>
               <a:tr h="777240">
                 <a:tc>
@@ -2647,7 +2479,7 @@
                     <a:bodyPr/>
                     <a:lstStyle/>
                     <a:p>
-                      <a:pPr indent="0" marL="0">
+                      <a:pPr marL="0" indent="0">
                         <a:buNone/>
                       </a:pPr>
                       <a:r>
@@ -2705,7 +2537,7 @@
                     <a:bodyPr/>
                     <a:lstStyle/>
                     <a:p>
-                      <a:pPr indent="0" marL="0">
+                      <a:pPr marL="0" indent="0">
                         <a:buNone/>
                       </a:pPr>
                       <a:r>
@@ -2763,7 +2595,7 @@
                     <a:bodyPr/>
                     <a:lstStyle/>
                     <a:p>
-                      <a:pPr indent="0" marL="0">
+                      <a:pPr marL="0" indent="0">
                         <a:buNone/>
                       </a:pPr>
                       <a:r>
@@ -2821,7 +2653,7 @@
                     <a:bodyPr/>
                     <a:lstStyle/>
                     <a:p>
-                      <a:pPr indent="0" marL="0">
+                      <a:pPr marL="0" indent="0">
                         <a:buNone/>
                       </a:pPr>
                       <a:r>
@@ -2874,6 +2706,11 @@
                     </a:lnB>
                   </a:tcPr>
                 </a:tc>
+                <a:extLst>
+                  <a:ext uri="{0D108BD9-81ED-4DB2-BD59-A6C34878D82A}">
+                    <a16:rowId xmlns:a16="http://schemas.microsoft.com/office/drawing/2014/main" val="10001"/>
+                  </a:ext>
+                </a:extLst>
               </a:tr>
               <a:tr h="777240">
                 <a:tc>
@@ -2881,7 +2718,7 @@
                     <a:bodyPr/>
                     <a:lstStyle/>
                     <a:p>
-                      <a:pPr indent="0" marL="0">
+                      <a:pPr marL="0" indent="0">
                         <a:buNone/>
                       </a:pPr>
                       <a:r>
@@ -2939,7 +2776,7 @@
                     <a:bodyPr/>
                     <a:lstStyle/>
                     <a:p>
-                      <a:pPr indent="0" marL="0">
+                      <a:pPr marL="0" indent="0">
                         <a:buNone/>
                       </a:pPr>
                       <a:r>
@@ -2997,7 +2834,7 @@
                     <a:bodyPr/>
                     <a:lstStyle/>
                     <a:p>
-                      <a:pPr indent="0" marL="0">
+                      <a:pPr marL="0" indent="0">
                         <a:buNone/>
                       </a:pPr>
                       <a:r>
@@ -3055,7 +2892,7 @@
                     <a:bodyPr/>
                     <a:lstStyle/>
                     <a:p>
-                      <a:pPr indent="0" marL="0">
+                      <a:pPr marL="0" indent="0">
                         <a:buNone/>
                       </a:pPr>
                       <a:r>
@@ -3108,6 +2945,11 @@
                     </a:lnB>
                   </a:tcPr>
                 </a:tc>
+                <a:extLst>
+                  <a:ext uri="{0D108BD9-81ED-4DB2-BD59-A6C34878D82A}">
+                    <a16:rowId xmlns:a16="http://schemas.microsoft.com/office/drawing/2014/main" val="10002"/>
+                  </a:ext>
+                </a:extLst>
               </a:tr>
               <a:tr h="777240">
                 <a:tc>
@@ -3115,7 +2957,7 @@
                     <a:bodyPr/>
                     <a:lstStyle/>
                     <a:p>
-                      <a:pPr indent="0" marL="0">
+                      <a:pPr marL="0" indent="0">
                         <a:buNone/>
                       </a:pPr>
                       <a:r>
@@ -3173,7 +3015,7 @@
                     <a:bodyPr/>
                     <a:lstStyle/>
                     <a:p>
-                      <a:pPr indent="0" marL="0">
+                      <a:pPr marL="0" indent="0">
                         <a:buNone/>
                       </a:pPr>
                       <a:r>
@@ -3231,7 +3073,7 @@
                     <a:bodyPr/>
                     <a:lstStyle/>
                     <a:p>
-                      <a:pPr indent="0" marL="0">
+                      <a:pPr marL="0" indent="0">
                         <a:buNone/>
                       </a:pPr>
                       <a:r>
@@ -3289,7 +3131,7 @@
                     <a:bodyPr/>
                     <a:lstStyle/>
                     <a:p>
-                      <a:pPr indent="0" marL="0">
+                      <a:pPr marL="0" indent="0">
                         <a:buNone/>
                       </a:pPr>
                       <a:r>
@@ -3342,6 +3184,11 @@
                     </a:lnB>
                   </a:tcPr>
                 </a:tc>
+                <a:extLst>
+                  <a:ext uri="{0D108BD9-81ED-4DB2-BD59-A6C34878D82A}">
+                    <a16:rowId xmlns:a16="http://schemas.microsoft.com/office/drawing/2014/main" val="10003"/>
+                  </a:ext>
+                </a:extLst>
               </a:tr>
             </a:tbl>
           </a:graphicData>
@@ -3373,6 +3220,13 @@
             <a:prstDash val="solid"/>
           </a:ln>
         </p:spPr>
+        <p:txBody>
+          <a:bodyPr/>
+          <a:lstStyle/>
+          <a:p>
+            <a:endParaRPr lang="en-US"/>
+          </a:p>
+        </p:txBody>
       </p:sp>
       <p:sp>
         <p:nvSpPr>
@@ -3395,7 +3249,7 @@
           <a:bodyPr wrap="square" lIns="0" tIns="0" rIns="0" bIns="0" rtlCol="0" anchor="ctr"/>
           <a:lstStyle/>
           <a:p>
-            <a:pPr indent="0" marL="0">
+            <a:pPr marL="0" indent="0">
               <a:buNone/>
             </a:pPr>
             <a:r>
@@ -3404,29 +3258,7 @@
                   <a:srgbClr val="1F2933"/>
                 </a:solidFill>
               </a:rPr>
-              <a:t>Selected by all five methods in every arm.  </a:t>
-            </a:r>
-            <a:pPr indent="0" marL="0">
-              <a:buNone/>
-            </a:pPr>
-            <a:r>
-              <a:rPr lang="en-US" sz="1700" b="1" dirty="0">
-                <a:solidFill>
-                  <a:srgbClr val="1F2933"/>
-                </a:solidFill>
-              </a:rPr>
-              <a:t>Machine learning added no predictor.  </a:t>
-            </a:r>
-            <a:pPr indent="0" marL="0">
-              <a:buNone/>
-            </a:pPr>
-            <a:r>
-              <a:rPr lang="en-US" sz="1700" b="1" dirty="0">
-                <a:solidFill>
-                  <a:srgbClr val="1F2933"/>
-                </a:solidFill>
-              </a:rPr>
-              <a:t>A pure-noise control covariate was never selected.</a:t>
+              <a:t>Selected by all five methods in every arm.  Machine learning added no predictor.  A pure-noise control covariate was never selected.</a:t>
             </a:r>
             <a:endParaRPr lang="en-US" sz="1700" dirty="0"/>
           </a:p>
@@ -3448,6 +3280,7 @@
         <a:solidFill>
           <a:srgbClr val="FFFFFF"/>
         </a:solidFill>
+        <a:effectLst/>
       </p:bgPr>
     </p:bg>
     <p:spTree>
@@ -3467,9 +3300,11 @@
       <p:sp>
         <p:nvSpPr>
           <p:cNvPr id="2" name="Text 0"/>
-          <p:cNvSpPr/>
+          <p:cNvSpPr>
+            <a:spLocks noGrp="1"/>
+          </p:cNvSpPr>
           <p:nvPr>
-            <p:ph idx="100" type="title" hasCustomPrompt="1"/>
+            <p:ph type="title" idx="100" hasCustomPrompt="1"/>
           </p:nvPr>
         </p:nvSpPr>
         <p:spPr>
@@ -3487,7 +3322,7 @@
           <a:bodyPr wrap="square" lIns="0" tIns="0" rIns="0" bIns="0" rtlCol="0" anchor="t"/>
           <a:lstStyle/>
           <a:p>
-            <a:pPr algn="l" indent="0" marL="0">
+            <a:pPr marL="0" indent="0" algn="l">
               <a:buNone/>
             </a:pPr>
             <a:r>
@@ -3528,6 +3363,13 @@
             <a:prstDash val="solid"/>
           </a:ln>
         </p:spPr>
+        <p:txBody>
+          <a:bodyPr/>
+          <a:lstStyle/>
+          <a:p>
+            <a:endParaRPr lang="en-US"/>
+          </a:p>
+        </p:txBody>
       </p:sp>
       <p:sp>
         <p:nvSpPr>
@@ -3550,7 +3392,7 @@
           <a:bodyPr wrap="square" lIns="50800" tIns="50800" rIns="50800" bIns="50800" rtlCol="0" anchor="ctr"/>
           <a:lstStyle/>
           <a:p>
-            <a:pPr algn="ctr" indent="0" marL="0">
+            <a:pPr marL="0" indent="0" algn="ctr">
               <a:buNone/>
             </a:pPr>
             <a:r>
@@ -3589,6 +3431,13 @@
             <a:prstDash val="solid"/>
           </a:ln>
         </p:spPr>
+        <p:txBody>
+          <a:bodyPr/>
+          <a:lstStyle/>
+          <a:p>
+            <a:endParaRPr lang="en-US"/>
+          </a:p>
+        </p:txBody>
       </p:sp>
       <p:sp>
         <p:nvSpPr>
@@ -3616,6 +3465,13 @@
             <a:prstDash val="solid"/>
           </a:ln>
         </p:spPr>
+        <p:txBody>
+          <a:bodyPr/>
+          <a:lstStyle/>
+          <a:p>
+            <a:endParaRPr lang="en-US"/>
+          </a:p>
+        </p:txBody>
       </p:sp>
       <p:sp>
         <p:nvSpPr>
@@ -3638,7 +3494,7 @@
           <a:bodyPr wrap="square" lIns="50800" tIns="50800" rIns="50800" bIns="50800" rtlCol="0" anchor="ctr"/>
           <a:lstStyle/>
           <a:p>
-            <a:pPr algn="ctr" indent="0" marL="0">
+            <a:pPr marL="0" indent="0" algn="ctr">
               <a:buNone/>
             </a:pPr>
             <a:r>
@@ -3677,6 +3533,13 @@
             <a:prstDash val="solid"/>
           </a:ln>
         </p:spPr>
+        <p:txBody>
+          <a:bodyPr/>
+          <a:lstStyle/>
+          <a:p>
+            <a:endParaRPr lang="en-US"/>
+          </a:p>
+        </p:txBody>
       </p:sp>
       <p:sp>
         <p:nvSpPr>
@@ -3699,7 +3562,7 @@
           <a:bodyPr wrap="square" lIns="0" tIns="0" rIns="0" bIns="0" rtlCol="0" anchor="t"/>
           <a:lstStyle/>
           <a:p>
-            <a:pPr algn="ctr" indent="0" marL="0">
+            <a:pPr marL="0" indent="0" algn="ctr">
               <a:buNone/>
             </a:pPr>
             <a:r>
@@ -3708,9 +3571,24 @@
                   <a:srgbClr val="D95F0E"/>
                 </a:solidFill>
               </a:rPr>
-              <a:t>Antisense oligonucleotide</a:t>
+              <a:t> </a:t>
             </a:r>
-            <a:endParaRPr lang="en-US" sz="1400" dirty="0"/>
+            <a:r>
+              <a:rPr lang="en-US" sz="1400" b="1" dirty="0">
+                <a:solidFill>
+                  <a:srgbClr val="D95F0E"/>
+                </a:solidFill>
+                <a:highlight>
+                  <a:srgbClr val="FFFF00"/>
+                </a:highlight>
+              </a:rPr>
+              <a:t>oligonucleotide</a:t>
+            </a:r>
+            <a:endParaRPr lang="en-US" sz="1400" dirty="0">
+              <a:highlight>
+                <a:srgbClr val="FFFF00"/>
+              </a:highlight>
+            </a:endParaRPr>
           </a:p>
         </p:txBody>
       </p:sp>
@@ -3740,6 +3618,13 @@
             <a:prstDash val="solid"/>
           </a:ln>
         </p:spPr>
+        <p:txBody>
+          <a:bodyPr/>
+          <a:lstStyle/>
+          <a:p>
+            <a:endParaRPr lang="en-US"/>
+          </a:p>
+        </p:txBody>
       </p:sp>
       <p:sp>
         <p:nvSpPr>
@@ -3762,7 +3647,7 @@
           <a:bodyPr wrap="square" lIns="50800" tIns="50800" rIns="50800" bIns="50800" rtlCol="0" anchor="ctr"/>
           <a:lstStyle/>
           <a:p>
-            <a:pPr algn="ctr" indent="0" marL="0">
+            <a:pPr marL="0" indent="0" algn="ctr">
               <a:buNone/>
             </a:pPr>
             <a:r>
@@ -3801,6 +3686,13 @@
             <a:prstDash val="solid"/>
           </a:ln>
         </p:spPr>
+        <p:txBody>
+          <a:bodyPr/>
+          <a:lstStyle/>
+          <a:p>
+            <a:endParaRPr lang="en-US"/>
+          </a:p>
+        </p:txBody>
       </p:sp>
       <p:sp>
         <p:nvSpPr>
@@ -3823,7 +3715,7 @@
           <a:bodyPr wrap="square" lIns="0" tIns="0" rIns="0" bIns="0" rtlCol="0" anchor="t"/>
           <a:lstStyle/>
           <a:p>
-            <a:pPr algn="ctr" indent="0" marL="0">
+            <a:pPr marL="0" indent="0" algn="ctr">
               <a:buNone/>
             </a:pPr>
             <a:r>
@@ -3831,10 +3723,17 @@
                 <a:solidFill>
                   <a:srgbClr val="D95F0E"/>
                 </a:solidFill>
+                <a:highlight>
+                  <a:srgbClr val="FFFF00"/>
+                </a:highlight>
               </a:rPr>
               <a:t>Tideglusib</a:t>
             </a:r>
-            <a:endParaRPr lang="en-US" sz="1400" dirty="0"/>
+            <a:endParaRPr lang="en-US" sz="1400" b="1" dirty="0">
+              <a:highlight>
+                <a:srgbClr val="FFFF00"/>
+              </a:highlight>
+            </a:endParaRPr>
           </a:p>
         </p:txBody>
       </p:sp>
@@ -3864,6 +3763,13 @@
             <a:prstDash val="solid"/>
           </a:ln>
         </p:spPr>
+        <p:txBody>
+          <a:bodyPr/>
+          <a:lstStyle/>
+          <a:p>
+            <a:endParaRPr lang="en-US"/>
+          </a:p>
+        </p:txBody>
       </p:sp>
       <p:sp>
         <p:nvSpPr>
@@ -3886,7 +3792,7 @@
           <a:bodyPr wrap="square" lIns="50800" tIns="50800" rIns="50800" bIns="50800" rtlCol="0" anchor="ctr"/>
           <a:lstStyle/>
           <a:p>
-            <a:pPr algn="ctr" indent="0" marL="0">
+            <a:pPr marL="0" indent="0" algn="ctr">
               <a:buNone/>
             </a:pPr>
             <a:r>
@@ -3925,6 +3831,13 @@
             <a:prstDash val="solid"/>
           </a:ln>
         </p:spPr>
+        <p:txBody>
+          <a:bodyPr/>
+          <a:lstStyle/>
+          <a:p>
+            <a:endParaRPr lang="en-US"/>
+          </a:p>
+        </p:txBody>
       </p:sp>
       <p:sp>
         <p:nvSpPr>
@@ -3952,6 +3865,13 @@
             <a:prstDash val="solid"/>
           </a:ln>
         </p:spPr>
+        <p:txBody>
+          <a:bodyPr/>
+          <a:lstStyle/>
+          <a:p>
+            <a:endParaRPr lang="en-US"/>
+          </a:p>
+        </p:txBody>
       </p:sp>
       <p:sp>
         <p:nvSpPr>
@@ -3974,7 +3894,7 @@
           <a:bodyPr wrap="square" lIns="50800" tIns="50800" rIns="50800" bIns="50800" rtlCol="0" anchor="ctr"/>
           <a:lstStyle/>
           <a:p>
-            <a:pPr algn="ctr" indent="0" marL="0">
+            <a:pPr marL="0" indent="0" algn="ctr">
               <a:buNone/>
             </a:pPr>
             <a:r>
@@ -4010,7 +3930,7 @@
           <a:bodyPr wrap="square" lIns="0" tIns="0" rIns="0" bIns="0" rtlCol="0" anchor="t"/>
           <a:lstStyle/>
           <a:p>
-            <a:pPr algn="ctr" indent="0" marL="0">
+            <a:pPr marL="0" indent="0" algn="ctr">
               <a:buNone/>
             </a:pPr>
             <a:r>
@@ -4018,10 +3938,17 @@
                 <a:solidFill>
                   <a:srgbClr val="D95F0E"/>
                 </a:solidFill>
+                <a:highlight>
+                  <a:srgbClr val="FFFF00"/>
+                </a:highlight>
               </a:rPr>
               <a:t>Mexiletine</a:t>
             </a:r>
-            <a:endParaRPr lang="en-US" sz="1400" dirty="0"/>
+            <a:endParaRPr lang="en-US" sz="1400" dirty="0">
+              <a:highlight>
+                <a:srgbClr val="FFFF00"/>
+              </a:highlight>
+            </a:endParaRPr>
           </a:p>
         </p:txBody>
       </p:sp>
@@ -4046,7 +3973,7 @@
           <a:bodyPr wrap="square" lIns="0" tIns="0" rIns="0" bIns="0" rtlCol="0" anchor="ctr"/>
           <a:lstStyle/>
           <a:p>
-            <a:pPr indent="0" marL="0">
+            <a:pPr marL="0" indent="0">
               <a:buNone/>
             </a:pPr>
             <a:r>
@@ -4158,7 +4085,7 @@
           <a:bodyPr wrap="square" lIns="0" tIns="0" rIns="0" bIns="0" rtlCol="0" anchor="ctr"/>
           <a:lstStyle/>
           <a:p>
-            <a:pPr indent="0" marL="0">
+            <a:pPr marL="0" indent="0">
               <a:buNone/>
             </a:pPr>
             <a:r>
@@ -4283,6 +4210,7 @@
         <a:solidFill>
           <a:srgbClr val="FFFFFF"/>
         </a:solidFill>
+        <a:effectLst/>
       </p:bgPr>
     </p:bg>
     <p:spTree>
@@ -4302,9 +4230,11 @@
       <p:sp>
         <p:nvSpPr>
           <p:cNvPr id="2" name="Text 0"/>
-          <p:cNvSpPr/>
+          <p:cNvSpPr>
+            <a:spLocks noGrp="1"/>
+          </p:cNvSpPr>
           <p:nvPr>
-            <p:ph idx="100" type="title" hasCustomPrompt="1"/>
+            <p:ph type="title" idx="100" hasCustomPrompt="1"/>
           </p:nvPr>
         </p:nvSpPr>
         <p:spPr>
@@ -4322,7 +4252,7 @@
           <a:bodyPr wrap="square" lIns="0" tIns="0" rIns="0" bIns="0" rtlCol="0" anchor="t"/>
           <a:lstStyle/>
           <a:p>
-            <a:pPr algn="l" indent="0" marL="0">
+            <a:pPr marL="0" indent="0" algn="l">
               <a:buNone/>
             </a:pPr>
             <a:r>
@@ -4339,14 +4269,14 @@
       </p:sp>
       <p:pic>
         <p:nvPicPr>
-          <p:cNvPr id="3" name="Image 0" descr="/Users/euibeoms/Desktop/ACoP/hackathon/slides/figs/fig_forest_slide.png">    </p:cNvPr>
+          <p:cNvPr id="3" name="Image 0" descr="/Users/euibeoms/Desktop/ACoP/hackathon/slides/figs/fig_forest_slide.png"/>
           <p:cNvPicPr>
             <a:picLocks noChangeAspect="1"/>
           </p:cNvPicPr>
           <p:nvPr/>
         </p:nvPicPr>
         <p:blipFill>
-          <a:blip r:embed="rId1"/>
+          <a:blip r:embed="rId3"/>
           <a:stretch>
             <a:fillRect/>
           </a:stretch>
@@ -4382,7 +4312,7 @@
           <a:bodyPr wrap="square" lIns="0" tIns="0" rIns="0" bIns="0" rtlCol="0" anchor="ctr"/>
           <a:lstStyle/>
           <a:p>
-            <a:pPr indent="0" marL="0">
+            <a:pPr marL="0" indent="0">
               <a:buNone/>
             </a:pPr>
             <a:r>
@@ -4418,7 +4348,7 @@
           <a:bodyPr wrap="square" lIns="0" tIns="0" rIns="0" bIns="0" rtlCol="0" anchor="t"/>
           <a:lstStyle/>
           <a:p>
-            <a:pPr indent="0" marL="0">
+            <a:pPr marL="0" indent="0">
               <a:buNone/>
             </a:pPr>
             <a:r>
@@ -4454,7 +4384,7 @@
           <a:bodyPr wrap="square" lIns="0" tIns="0" rIns="0" bIns="0" rtlCol="0" anchor="ctr"/>
           <a:lstStyle/>
           <a:p>
-            <a:pPr indent="0" marL="0">
+            <a:pPr marL="0" indent="0">
               <a:buNone/>
             </a:pPr>
             <a:r>
@@ -4490,7 +4420,7 @@
           <a:bodyPr wrap="square" lIns="0" tIns="0" rIns="0" bIns="0" rtlCol="0" anchor="t"/>
           <a:lstStyle/>
           <a:p>
-            <a:pPr indent="0" marL="0">
+            <a:pPr marL="0" indent="0">
               <a:buNone/>
             </a:pPr>
             <a:r>
@@ -4526,7 +4456,7 @@
           <a:bodyPr wrap="square" lIns="0" tIns="0" rIns="0" bIns="0" rtlCol="0" anchor="ctr"/>
           <a:lstStyle/>
           <a:p>
-            <a:pPr indent="0" marL="0">
+            <a:pPr marL="0" indent="0">
               <a:buNone/>
             </a:pPr>
             <a:r>
@@ -4562,7 +4492,7 @@
           <a:bodyPr wrap="square" lIns="0" tIns="0" rIns="0" bIns="0" rtlCol="0" anchor="t"/>
           <a:lstStyle/>
           <a:p>
-            <a:pPr indent="0" marL="0">
+            <a:pPr marL="0" indent="0">
               <a:buNone/>
             </a:pPr>
             <a:r>
@@ -4603,6 +4533,13 @@
             <a:prstDash val="solid"/>
           </a:ln>
         </p:spPr>
+        <p:txBody>
+          <a:bodyPr/>
+          <a:lstStyle/>
+          <a:p>
+            <a:endParaRPr lang="en-US"/>
+          </a:p>
+        </p:txBody>
       </p:sp>
       <p:sp>
         <p:nvSpPr>
@@ -4625,7 +4562,7 @@
           <a:bodyPr wrap="square" lIns="0" tIns="0" rIns="0" bIns="0" rtlCol="0" anchor="ctr"/>
           <a:lstStyle/>
           <a:p>
-            <a:pPr indent="0" marL="0">
+            <a:pPr marL="0" indent="0">
               <a:buNone/>
             </a:pPr>
             <a:r>
@@ -4636,9 +4573,6 @@
               </a:rPr>
               <a:t>Independently replicated: </a:t>
             </a:r>
-            <a:pPr indent="0" marL="0">
-              <a:buNone/>
-            </a:pPr>
             <a:r>
               <a:rPr lang="en-US" sz="1500" dirty="0">
                 <a:solidFill>
@@ -4667,6 +4601,7 @@
         <a:solidFill>
           <a:srgbClr val="FFFFFF"/>
         </a:solidFill>
+        <a:effectLst/>
       </p:bgPr>
     </p:bg>
     <p:spTree>
@@ -4686,9 +4621,11 @@
       <p:sp>
         <p:nvSpPr>
           <p:cNvPr id="2" name="Text 0"/>
-          <p:cNvSpPr/>
+          <p:cNvSpPr>
+            <a:spLocks noGrp="1"/>
+          </p:cNvSpPr>
           <p:nvPr>
-            <p:ph idx="100" type="title" hasCustomPrompt="1"/>
+            <p:ph type="title" idx="100" hasCustomPrompt="1"/>
           </p:nvPr>
         </p:nvSpPr>
         <p:spPr>
@@ -4706,7 +4643,7 @@
           <a:bodyPr wrap="square" lIns="0" tIns="0" rIns="0" bIns="0" rtlCol="0" anchor="t"/>
           <a:lstStyle/>
           <a:p>
-            <a:pPr algn="l" indent="0" marL="0">
+            <a:pPr marL="0" indent="0" algn="l">
               <a:buNone/>
             </a:pPr>
             <a:r>
@@ -4723,14 +4660,14 @@
       </p:sp>
       <p:pic>
         <p:nvPicPr>
-          <p:cNvPr id="3" name="Image 0" descr="/Users/euibeoms/Desktop/ACoP/hackathon/slides/figs/fig_scoreboard.png">    </p:cNvPr>
+          <p:cNvPr id="3" name="Image 0" descr="/Users/euibeoms/Desktop/ACoP/hackathon/slides/figs/fig_scoreboard.png"/>
           <p:cNvPicPr>
             <a:picLocks noChangeAspect="1"/>
           </p:cNvPicPr>
           <p:nvPr/>
         </p:nvPicPr>
         <p:blipFill>
-          <a:blip r:embed="rId1"/>
+          <a:blip r:embed="rId3"/>
           <a:stretch>
             <a:fillRect/>
           </a:stretch>
@@ -4766,7 +4703,7 @@
           <a:bodyPr wrap="square" lIns="0" tIns="0" rIns="0" bIns="0" rtlCol="0" anchor="ctr"/>
           <a:lstStyle/>
           <a:p>
-            <a:pPr indent="0" marL="0">
+            <a:pPr marL="0" indent="0">
               <a:buNone/>
             </a:pPr>
             <a:r>
@@ -4802,7 +4739,7 @@
           <a:bodyPr wrap="square" lIns="0" tIns="0" rIns="0" bIns="0" rtlCol="0" anchor="t"/>
           <a:lstStyle/>
           <a:p>
-            <a:pPr indent="0" marL="0">
+            <a:pPr marL="0" indent="0">
               <a:buNone/>
             </a:pPr>
             <a:r>
@@ -4838,7 +4775,7 @@
           <a:bodyPr wrap="square" lIns="0" tIns="0" rIns="0" bIns="0" rtlCol="0" anchor="ctr"/>
           <a:lstStyle/>
           <a:p>
-            <a:pPr indent="0" marL="0">
+            <a:pPr marL="0" indent="0">
               <a:buNone/>
             </a:pPr>
             <a:r>
@@ -4874,7 +4811,7 @@
           <a:bodyPr wrap="square" lIns="0" tIns="0" rIns="0" bIns="0" rtlCol="0" anchor="t"/>
           <a:lstStyle/>
           <a:p>
-            <a:pPr indent="0" marL="0">
+            <a:pPr marL="0" indent="0">
               <a:buNone/>
             </a:pPr>
             <a:r>
@@ -4910,7 +4847,7 @@
           <a:bodyPr wrap="square" lIns="0" tIns="0" rIns="0" bIns="0" rtlCol="0" anchor="ctr"/>
           <a:lstStyle/>
           <a:p>
-            <a:pPr indent="0" marL="0">
+            <a:pPr marL="0" indent="0">
               <a:buNone/>
             </a:pPr>
             <a:r>
@@ -4946,7 +4883,7 @@
           <a:bodyPr wrap="square" lIns="0" tIns="0" rIns="0" bIns="0" rtlCol="0" anchor="t"/>
           <a:lstStyle/>
           <a:p>
-            <a:pPr indent="0" marL="0">
+            <a:pPr marL="0" indent="0">
               <a:buNone/>
             </a:pPr>
             <a:r>
@@ -4977,6 +4914,7 @@
         <a:solidFill>
           <a:srgbClr val="FFFFFF"/>
         </a:solidFill>
+        <a:effectLst/>
       </p:bgPr>
     </p:bg>
     <p:spTree>
@@ -4996,9 +4934,11 @@
       <p:sp>
         <p:nvSpPr>
           <p:cNvPr id="2" name="Text 0"/>
-          <p:cNvSpPr/>
+          <p:cNvSpPr>
+            <a:spLocks noGrp="1"/>
+          </p:cNvSpPr>
           <p:nvPr>
-            <p:ph idx="100" type="title" hasCustomPrompt="1"/>
+            <p:ph type="title" idx="100" hasCustomPrompt="1"/>
           </p:nvPr>
         </p:nvSpPr>
         <p:spPr>
@@ -5016,7 +4956,7 @@
           <a:bodyPr wrap="square" lIns="0" tIns="0" rIns="0" bIns="0" rtlCol="0" anchor="t"/>
           <a:lstStyle/>
           <a:p>
-            <a:pPr algn="l" indent="0" marL="0">
+            <a:pPr marL="0" indent="0" algn="l">
               <a:buNone/>
             </a:pPr>
             <a:r>
@@ -5047,18 +4987,48 @@
         </p:nvGraphicFramePr>
         <p:xfrm>
           <a:off x="548640" y="1417320"/>
-          <a:ext cx="11064240" cy="914400"/>
+          <a:ext cx="11064240" cy="2611120"/>
         </p:xfrm>
         <a:graphic>
           <a:graphicData uri="http://schemas.openxmlformats.org/drawingml/2006/table">
             <a:tbl>
               <a:tblPr/>
               <a:tblGrid>
-                <a:gridCol w="2103120"/>
-                <a:gridCol w="1828800"/>
-                <a:gridCol w="1371600"/>
-                <a:gridCol w="2834640"/>
-                <a:gridCol w="2926080"/>
+                <a:gridCol w="2103120">
+                  <a:extLst>
+                    <a:ext uri="{9D8B030D-6E8A-4147-A177-3AD203B41FA5}">
+                      <a16:colId xmlns:a16="http://schemas.microsoft.com/office/drawing/2014/main" val="20000"/>
+                    </a:ext>
+                  </a:extLst>
+                </a:gridCol>
+                <a:gridCol w="1828800">
+                  <a:extLst>
+                    <a:ext uri="{9D8B030D-6E8A-4147-A177-3AD203B41FA5}">
+                      <a16:colId xmlns:a16="http://schemas.microsoft.com/office/drawing/2014/main" val="20001"/>
+                    </a:ext>
+                  </a:extLst>
+                </a:gridCol>
+                <a:gridCol w="1371600">
+                  <a:extLst>
+                    <a:ext uri="{9D8B030D-6E8A-4147-A177-3AD203B41FA5}">
+                      <a16:colId xmlns:a16="http://schemas.microsoft.com/office/drawing/2014/main" val="20002"/>
+                    </a:ext>
+                  </a:extLst>
+                </a:gridCol>
+                <a:gridCol w="2834640">
+                  <a:extLst>
+                    <a:ext uri="{9D8B030D-6E8A-4147-A177-3AD203B41FA5}">
+                      <a16:colId xmlns:a16="http://schemas.microsoft.com/office/drawing/2014/main" val="20003"/>
+                    </a:ext>
+                  </a:extLst>
+                </a:gridCol>
+                <a:gridCol w="2926080">
+                  <a:extLst>
+                    <a:ext uri="{9D8B030D-6E8A-4147-A177-3AD203B41FA5}">
+                      <a16:colId xmlns:a16="http://schemas.microsoft.com/office/drawing/2014/main" val="20004"/>
+                    </a:ext>
+                  </a:extLst>
+                </a:gridCol>
               </a:tblGrid>
               <a:tr h="548640">
                 <a:tc>
@@ -5066,7 +5036,7 @@
                     <a:bodyPr/>
                     <a:lstStyle/>
                     <a:p>
-                      <a:pPr indent="0" marL="0">
+                      <a:pPr marL="0" indent="0">
                         <a:buNone/>
                       </a:pPr>
                       <a:r>
@@ -5127,7 +5097,7 @@
                     <a:bodyPr/>
                     <a:lstStyle/>
                     <a:p>
-                      <a:pPr indent="0" marL="0">
+                      <a:pPr marL="0" indent="0">
                         <a:buNone/>
                       </a:pPr>
                       <a:r>
@@ -5188,7 +5158,7 @@
                     <a:bodyPr/>
                     <a:lstStyle/>
                     <a:p>
-                      <a:pPr indent="0" marL="0">
+                      <a:pPr marL="0" indent="0">
                         <a:buNone/>
                       </a:pPr>
                       <a:r>
@@ -5249,7 +5219,7 @@
                     <a:bodyPr/>
                     <a:lstStyle/>
                     <a:p>
-                      <a:pPr indent="0" marL="0">
+                      <a:pPr marL="0" indent="0">
                         <a:buNone/>
                       </a:pPr>
                       <a:r>
@@ -5310,7 +5280,7 @@
                     <a:bodyPr/>
                     <a:lstStyle/>
                     <a:p>
-                      <a:pPr indent="0" marL="0">
+                      <a:pPr marL="0" indent="0">
                         <a:buNone/>
                       </a:pPr>
                       <a:r>
@@ -5366,6 +5336,11 @@
                     </a:solidFill>
                   </a:tcPr>
                 </a:tc>
+                <a:extLst>
+                  <a:ext uri="{0D108BD9-81ED-4DB2-BD59-A6C34878D82A}">
+                    <a16:rowId xmlns:a16="http://schemas.microsoft.com/office/drawing/2014/main" val="10000"/>
+                  </a:ext>
+                </a:extLst>
               </a:tr>
               <a:tr h="685800">
                 <a:tc>
@@ -5373,7 +5348,7 @@
                     <a:bodyPr/>
                     <a:lstStyle/>
                     <a:p>
-                      <a:pPr indent="0" marL="0">
+                      <a:pPr marL="0" indent="0">
                         <a:buNone/>
                       </a:pPr>
                       <a:r>
@@ -5431,7 +5406,7 @@
                     <a:bodyPr/>
                     <a:lstStyle/>
                     <a:p>
-                      <a:pPr indent="0" marL="0">
+                      <a:pPr marL="0" indent="0">
                         <a:buNone/>
                       </a:pPr>
                       <a:r>
@@ -5489,7 +5464,7 @@
                     <a:bodyPr/>
                     <a:lstStyle/>
                     <a:p>
-                      <a:pPr indent="0" marL="0">
+                      <a:pPr marL="0" indent="0">
                         <a:buNone/>
                       </a:pPr>
                       <a:r>
@@ -5547,7 +5522,7 @@
                     <a:bodyPr/>
                     <a:lstStyle/>
                     <a:p>
-                      <a:pPr indent="0" marL="0">
+                      <a:pPr marL="0" indent="0">
                         <a:buNone/>
                       </a:pPr>
                       <a:r>
@@ -5605,7 +5580,7 @@
                     <a:bodyPr/>
                     <a:lstStyle/>
                     <a:p>
-                      <a:pPr indent="0" marL="0">
+                      <a:pPr marL="0" indent="0">
                         <a:buNone/>
                       </a:pPr>
                       <a:r>
@@ -5658,6 +5633,11 @@
                     </a:lnB>
                   </a:tcPr>
                 </a:tc>
+                <a:extLst>
+                  <a:ext uri="{0D108BD9-81ED-4DB2-BD59-A6C34878D82A}">
+                    <a16:rowId xmlns:a16="http://schemas.microsoft.com/office/drawing/2014/main" val="10001"/>
+                  </a:ext>
+                </a:extLst>
               </a:tr>
               <a:tr h="685800">
                 <a:tc>
@@ -5665,7 +5645,7 @@
                     <a:bodyPr/>
                     <a:lstStyle/>
                     <a:p>
-                      <a:pPr indent="0" marL="0">
+                      <a:pPr marL="0" indent="0">
                         <a:buNone/>
                       </a:pPr>
                       <a:r>
@@ -5723,7 +5703,7 @@
                     <a:bodyPr/>
                     <a:lstStyle/>
                     <a:p>
-                      <a:pPr indent="0" marL="0">
+                      <a:pPr marL="0" indent="0">
                         <a:buNone/>
                       </a:pPr>
                       <a:r>
@@ -5781,7 +5761,7 @@
                     <a:bodyPr/>
                     <a:lstStyle/>
                     <a:p>
-                      <a:pPr indent="0" marL="0">
+                      <a:pPr marL="0" indent="0">
                         <a:buNone/>
                       </a:pPr>
                       <a:r>
@@ -5839,7 +5819,7 @@
                     <a:bodyPr/>
                     <a:lstStyle/>
                     <a:p>
-                      <a:pPr indent="0" marL="0">
+                      <a:pPr marL="0" indent="0">
                         <a:buNone/>
                       </a:pPr>
                       <a:r>
@@ -5897,7 +5877,7 @@
                     <a:bodyPr/>
                     <a:lstStyle/>
                     <a:p>
-                      <a:pPr indent="0" marL="0">
+                      <a:pPr marL="0" indent="0">
                         <a:buNone/>
                       </a:pPr>
                       <a:r>
@@ -5950,6 +5930,11 @@
                     </a:lnB>
                   </a:tcPr>
                 </a:tc>
+                <a:extLst>
+                  <a:ext uri="{0D108BD9-81ED-4DB2-BD59-A6C34878D82A}">
+                    <a16:rowId xmlns:a16="http://schemas.microsoft.com/office/drawing/2014/main" val="10002"/>
+                  </a:ext>
+                </a:extLst>
               </a:tr>
               <a:tr h="685800">
                 <a:tc>
@@ -5957,7 +5942,7 @@
                     <a:bodyPr/>
                     <a:lstStyle/>
                     <a:p>
-                      <a:pPr indent="0" marL="0">
+                      <a:pPr marL="0" indent="0">
                         <a:buNone/>
                       </a:pPr>
                       <a:r>
@@ -6015,7 +6000,7 @@
                     <a:bodyPr/>
                     <a:lstStyle/>
                     <a:p>
-                      <a:pPr indent="0" marL="0">
+                      <a:pPr marL="0" indent="0">
                         <a:buNone/>
                       </a:pPr>
                       <a:r>
@@ -6073,7 +6058,7 @@
                     <a:bodyPr/>
                     <a:lstStyle/>
                     <a:p>
-                      <a:pPr indent="0" marL="0">
+                      <a:pPr marL="0" indent="0">
                         <a:buNone/>
                       </a:pPr>
                       <a:r>
@@ -6131,7 +6116,7 @@
                     <a:bodyPr/>
                     <a:lstStyle/>
                     <a:p>
-                      <a:pPr indent="0" marL="0">
+                      <a:pPr marL="0" indent="0">
                         <a:buNone/>
                       </a:pPr>
                       <a:r>
@@ -6189,7 +6174,7 @@
                     <a:bodyPr/>
                     <a:lstStyle/>
                     <a:p>
-                      <a:pPr indent="0" marL="0">
+                      <a:pPr marL="0" indent="0">
                         <a:buNone/>
                       </a:pPr>
                       <a:r>
@@ -6242,6 +6227,11 @@
                     </a:lnB>
                   </a:tcPr>
                 </a:tc>
+                <a:extLst>
+                  <a:ext uri="{0D108BD9-81ED-4DB2-BD59-A6C34878D82A}">
+                    <a16:rowId xmlns:a16="http://schemas.microsoft.com/office/drawing/2014/main" val="10003"/>
+                  </a:ext>
+                </a:extLst>
               </a:tr>
             </a:tbl>
           </a:graphicData>
@@ -6268,7 +6258,7 @@
           <a:bodyPr wrap="square" lIns="0" tIns="0" rIns="0" bIns="0" rtlCol="0" anchor="ctr"/>
           <a:lstStyle/>
           <a:p>
-            <a:pPr indent="0" marL="0">
+            <a:pPr marL="0" indent="0">
               <a:buNone/>
             </a:pPr>
             <a:r>
@@ -6380,7 +6370,7 @@
           <a:bodyPr wrap="square" lIns="0" tIns="0" rIns="0" bIns="0" rtlCol="0" anchor="ctr"/>
           <a:lstStyle/>
           <a:p>
-            <a:pPr indent="0" marL="0">
+            <a:pPr marL="0" indent="0">
               <a:buNone/>
             </a:pPr>
             <a:r>
@@ -6397,7 +6387,7 @@
       </p:sp>
       <p:sp>
         <p:nvSpPr>
-          <p:cNvPr id="7" name="Shape 4"/>
+          <p:cNvPr id="3" name="Shape 4"/>
           <p:cNvSpPr/>
           <p:nvPr/>
         </p:nvSpPr>
@@ -6421,6 +6411,13 @@
             <a:prstDash val="solid"/>
           </a:ln>
         </p:spPr>
+        <p:txBody>
+          <a:bodyPr/>
+          <a:lstStyle/>
+          <a:p>
+            <a:endParaRPr lang="en-US"/>
+          </a:p>
+        </p:txBody>
       </p:sp>
       <p:sp>
         <p:nvSpPr>
@@ -6443,7 +6440,7 @@
           <a:bodyPr wrap="square" lIns="0" tIns="0" rIns="0" bIns="0" rtlCol="0" anchor="ctr"/>
           <a:lstStyle/>
           <a:p>
-            <a:pPr indent="0" marL="0">
+            <a:pPr marL="0" indent="0">
               <a:buNone/>
             </a:pPr>
             <a:r>
@@ -6474,6 +6471,7 @@
         <a:solidFill>
           <a:srgbClr val="FFFFFF"/>
         </a:solidFill>
+        <a:effectLst/>
       </p:bgPr>
     </p:bg>
     <p:spTree>
@@ -6493,9 +6491,11 @@
       <p:sp>
         <p:nvSpPr>
           <p:cNvPr id="2" name="Text 0"/>
-          <p:cNvSpPr/>
+          <p:cNvSpPr>
+            <a:spLocks noGrp="1"/>
+          </p:cNvSpPr>
           <p:nvPr>
-            <p:ph idx="100" type="title" hasCustomPrompt="1"/>
+            <p:ph type="title" idx="100" hasCustomPrompt="1"/>
           </p:nvPr>
         </p:nvSpPr>
         <p:spPr>
@@ -6513,7 +6513,7 @@
           <a:bodyPr wrap="square" lIns="0" tIns="0" rIns="0" bIns="0" rtlCol="0" anchor="t"/>
           <a:lstStyle/>
           <a:p>
-            <a:pPr algn="l" indent="0" marL="0">
+            <a:pPr marL="0" indent="0" algn="l">
               <a:buNone/>
             </a:pPr>
             <a:r>
@@ -6530,14 +6530,14 @@
       </p:sp>
       <p:pic>
         <p:nvPicPr>
-          <p:cNvPr id="3" name="Image 0" descr="/Users/euibeoms/Desktop/ACoP/hackathon/slides/figs/fig_sensitivity_splits.png">    </p:cNvPr>
+          <p:cNvPr id="3" name="Image 0" descr="/Users/euibeoms/Desktop/ACoP/hackathon/slides/figs/fig_sensitivity_splits.png"/>
           <p:cNvPicPr>
             <a:picLocks noChangeAspect="1"/>
           </p:cNvPicPr>
           <p:nvPr/>
         </p:nvPicPr>
         <p:blipFill>
-          <a:blip r:embed="rId1"/>
+          <a:blip r:embed="rId3"/>
           <a:stretch>
             <a:fillRect/>
           </a:stretch>
@@ -6573,7 +6573,7 @@
           <a:bodyPr wrap="square" lIns="0" tIns="0" rIns="0" bIns="0" rtlCol="0" anchor="t"/>
           <a:lstStyle/>
           <a:p>
-            <a:pPr indent="0" marL="0">
+            <a:pPr marL="0" indent="0">
               <a:buNone/>
             </a:pPr>
             <a:r>
@@ -6604,6 +6604,7 @@
         <a:solidFill>
           <a:srgbClr val="FFFFFF"/>
         </a:solidFill>
+        <a:effectLst/>
       </p:bgPr>
     </p:bg>
     <p:spTree>
@@ -6623,9 +6624,11 @@
       <p:sp>
         <p:nvSpPr>
           <p:cNvPr id="2" name="Text 0"/>
-          <p:cNvSpPr/>
+          <p:cNvSpPr>
+            <a:spLocks noGrp="1"/>
+          </p:cNvSpPr>
           <p:nvPr>
-            <p:ph idx="100" type="title" hasCustomPrompt="1"/>
+            <p:ph type="title" idx="100" hasCustomPrompt="1"/>
           </p:nvPr>
         </p:nvSpPr>
         <p:spPr>
@@ -6643,7 +6646,7 @@
           <a:bodyPr wrap="square" lIns="0" tIns="0" rIns="0" bIns="0" rtlCol="0" anchor="t"/>
           <a:lstStyle/>
           <a:p>
-            <a:pPr algn="l" indent="0" marL="0">
+            <a:pPr marL="0" indent="0" algn="l">
               <a:buNone/>
             </a:pPr>
             <a:r>
@@ -6660,14 +6663,14 @@
       </p:sp>
       <p:pic>
         <p:nvPicPr>
-          <p:cNvPr id="3" name="Image 0" descr="/Users/euibeoms/Desktop/ACoP/hackathon/slides/figs/fig_covariate_matrix.png">    </p:cNvPr>
+          <p:cNvPr id="3" name="Image 0" descr="/Users/euibeoms/Desktop/ACoP/hackathon/slides/figs/fig_covariate_matrix.png"/>
           <p:cNvPicPr>
             <a:picLocks noChangeAspect="1"/>
           </p:cNvPicPr>
           <p:nvPr/>
         </p:nvPicPr>
         <p:blipFill>
-          <a:blip r:embed="rId1"/>
+          <a:blip r:embed="rId3"/>
           <a:stretch>
             <a:fillRect/>
           </a:stretch>
@@ -6703,7 +6706,7 @@
           <a:bodyPr wrap="square" lIns="0" tIns="0" rIns="0" bIns="0" rtlCol="0" anchor="t"/>
           <a:lstStyle/>
           <a:p>
-            <a:pPr indent="0" marL="0">
+            <a:pPr marL="0" indent="0">
               <a:buNone/>
             </a:pPr>
             <a:r>
@@ -6734,6 +6737,7 @@
         <a:solidFill>
           <a:srgbClr val="FFFFFF"/>
         </a:solidFill>
+        <a:effectLst/>
       </p:bgPr>
     </p:bg>
     <p:spTree>
@@ -6753,9 +6757,11 @@
       <p:sp>
         <p:nvSpPr>
           <p:cNvPr id="2" name="Text 0"/>
-          <p:cNvSpPr/>
+          <p:cNvSpPr>
+            <a:spLocks noGrp="1"/>
+          </p:cNvSpPr>
           <p:nvPr>
-            <p:ph idx="100" type="title" hasCustomPrompt="1"/>
+            <p:ph type="title" idx="100" hasCustomPrompt="1"/>
           </p:nvPr>
         </p:nvSpPr>
         <p:spPr>
@@ -6773,7 +6779,7 @@
           <a:bodyPr wrap="square" lIns="0" tIns="0" rIns="0" bIns="0" rtlCol="0" anchor="t"/>
           <a:lstStyle/>
           <a:p>
-            <a:pPr algn="l" indent="0" marL="0">
+            <a:pPr marL="0" indent="0" algn="l">
               <a:buNone/>
             </a:pPr>
             <a:r>
@@ -6811,11 +6817,41 @@
             <a:tbl>
               <a:tblPr/>
               <a:tblGrid>
-                <a:gridCol w="3931920"/>
-                <a:gridCol w="1783080"/>
-                <a:gridCol w="1783080"/>
-                <a:gridCol w="1783080"/>
-                <a:gridCol w="1783080"/>
+                <a:gridCol w="3931920">
+                  <a:extLst>
+                    <a:ext uri="{9D8B030D-6E8A-4147-A177-3AD203B41FA5}">
+                      <a16:colId xmlns:a16="http://schemas.microsoft.com/office/drawing/2014/main" val="20000"/>
+                    </a:ext>
+                  </a:extLst>
+                </a:gridCol>
+                <a:gridCol w="1783080">
+                  <a:extLst>
+                    <a:ext uri="{9D8B030D-6E8A-4147-A177-3AD203B41FA5}">
+                      <a16:colId xmlns:a16="http://schemas.microsoft.com/office/drawing/2014/main" val="20001"/>
+                    </a:ext>
+                  </a:extLst>
+                </a:gridCol>
+                <a:gridCol w="1783080">
+                  <a:extLst>
+                    <a:ext uri="{9D8B030D-6E8A-4147-A177-3AD203B41FA5}">
+                      <a16:colId xmlns:a16="http://schemas.microsoft.com/office/drawing/2014/main" val="20002"/>
+                    </a:ext>
+                  </a:extLst>
+                </a:gridCol>
+                <a:gridCol w="1783080">
+                  <a:extLst>
+                    <a:ext uri="{9D8B030D-6E8A-4147-A177-3AD203B41FA5}">
+                      <a16:colId xmlns:a16="http://schemas.microsoft.com/office/drawing/2014/main" val="20003"/>
+                    </a:ext>
+                  </a:extLst>
+                </a:gridCol>
+                <a:gridCol w="1783080">
+                  <a:extLst>
+                    <a:ext uri="{9D8B030D-6E8A-4147-A177-3AD203B41FA5}">
+                      <a16:colId xmlns:a16="http://schemas.microsoft.com/office/drawing/2014/main" val="20004"/>
+                    </a:ext>
+                  </a:extLst>
+                </a:gridCol>
               </a:tblGrid>
               <a:tr h="457200">
                 <a:tc>
@@ -6823,7 +6859,7 @@
                     <a:bodyPr/>
                     <a:lstStyle/>
                     <a:p>
-                      <a:pPr indent="0" marL="0">
+                      <a:pPr marL="0" indent="0">
                         <a:buNone/>
                       </a:pPr>
                       <a:r>
@@ -6884,7 +6920,7 @@
                     <a:bodyPr/>
                     <a:lstStyle/>
                     <a:p>
-                      <a:pPr indent="0" marL="0">
+                      <a:pPr marL="0" indent="0">
                         <a:buNone/>
                       </a:pPr>
                       <a:r>
@@ -6945,7 +6981,7 @@
                     <a:bodyPr/>
                     <a:lstStyle/>
                     <a:p>
-                      <a:pPr indent="0" marL="0">
+                      <a:pPr marL="0" indent="0">
                         <a:buNone/>
                       </a:pPr>
                       <a:r>
@@ -7006,7 +7042,7 @@
                     <a:bodyPr/>
                     <a:lstStyle/>
                     <a:p>
-                      <a:pPr indent="0" marL="0">
+                      <a:pPr marL="0" indent="0">
                         <a:buNone/>
                       </a:pPr>
                       <a:r>
@@ -7067,7 +7103,7 @@
                     <a:bodyPr/>
                     <a:lstStyle/>
                     <a:p>
-                      <a:pPr indent="0" marL="0">
+                      <a:pPr marL="0" indent="0">
                         <a:buNone/>
                       </a:pPr>
                       <a:r>
@@ -7123,6 +7159,11 @@
                     </a:solidFill>
                   </a:tcPr>
                 </a:tc>
+                <a:extLst>
+                  <a:ext uri="{0D108BD9-81ED-4DB2-BD59-A6C34878D82A}">
+                    <a16:rowId xmlns:a16="http://schemas.microsoft.com/office/drawing/2014/main" val="10000"/>
+                  </a:ext>
+                </a:extLst>
               </a:tr>
               <a:tr h="548640">
                 <a:tc>
@@ -7130,7 +7171,7 @@
                     <a:bodyPr/>
                     <a:lstStyle/>
                     <a:p>
-                      <a:pPr indent="0" marL="0">
+                      <a:pPr marL="0" indent="0">
                         <a:buNone/>
                       </a:pPr>
                       <a:r>
@@ -7188,7 +7229,7 @@
                     <a:bodyPr/>
                     <a:lstStyle/>
                     <a:p>
-                      <a:pPr indent="0" marL="0">
+                      <a:pPr marL="0" indent="0">
                         <a:buNone/>
                       </a:pPr>
                       <a:r>
@@ -7246,7 +7287,7 @@
                     <a:bodyPr/>
                     <a:lstStyle/>
                     <a:p>
-                      <a:pPr indent="0" marL="0">
+                      <a:pPr marL="0" indent="0">
                         <a:buNone/>
                       </a:pPr>
                       <a:r>
@@ -7304,7 +7345,7 @@
                     <a:bodyPr/>
                     <a:lstStyle/>
                     <a:p>
-                      <a:pPr indent="0" marL="0">
+                      <a:pPr marL="0" indent="0">
                         <a:buNone/>
                       </a:pPr>
                       <a:r>
@@ -7362,7 +7403,7 @@
                     <a:bodyPr/>
                     <a:lstStyle/>
                     <a:p>
-                      <a:pPr indent="0" marL="0">
+                      <a:pPr marL="0" indent="0">
                         <a:buNone/>
                       </a:pPr>
                       <a:r>
@@ -7415,6 +7456,11 @@
                     </a:lnB>
                   </a:tcPr>
                 </a:tc>
+                <a:extLst>
+                  <a:ext uri="{0D108BD9-81ED-4DB2-BD59-A6C34878D82A}">
+                    <a16:rowId xmlns:a16="http://schemas.microsoft.com/office/drawing/2014/main" val="10001"/>
+                  </a:ext>
+                </a:extLst>
               </a:tr>
               <a:tr h="548640">
                 <a:tc>
@@ -7422,7 +7468,7 @@
                     <a:bodyPr/>
                     <a:lstStyle/>
                     <a:p>
-                      <a:pPr indent="0" marL="0">
+                      <a:pPr marL="0" indent="0">
                         <a:buNone/>
                       </a:pPr>
                       <a:r>
@@ -7480,7 +7526,7 @@
                     <a:bodyPr/>
                     <a:lstStyle/>
                     <a:p>
-                      <a:pPr indent="0" marL="0">
+                      <a:pPr marL="0" indent="0">
                         <a:buNone/>
                       </a:pPr>
                       <a:r>
@@ -7538,7 +7584,7 @@
                     <a:bodyPr/>
                     <a:lstStyle/>
                     <a:p>
-                      <a:pPr indent="0" marL="0">
+                      <a:pPr marL="0" indent="0">
                         <a:buNone/>
                       </a:pPr>
                       <a:r>
@@ -7596,7 +7642,7 @@
                     <a:bodyPr/>
                     <a:lstStyle/>
                     <a:p>
-                      <a:pPr indent="0" marL="0">
+                      <a:pPr marL="0" indent="0">
                         <a:buNone/>
                       </a:pPr>
                       <a:r>
@@ -7654,7 +7700,7 @@
                     <a:bodyPr/>
                     <a:lstStyle/>
                     <a:p>
-                      <a:pPr indent="0" marL="0">
+                      <a:pPr marL="0" indent="0">
                         <a:buNone/>
                       </a:pPr>
                       <a:r>
@@ -7707,6 +7753,11 @@
                     </a:lnB>
                   </a:tcPr>
                 </a:tc>
+                <a:extLst>
+                  <a:ext uri="{0D108BD9-81ED-4DB2-BD59-A6C34878D82A}">
+                    <a16:rowId xmlns:a16="http://schemas.microsoft.com/office/drawing/2014/main" val="10002"/>
+                  </a:ext>
+                </a:extLst>
               </a:tr>
               <a:tr h="548640">
                 <a:tc>
@@ -7714,7 +7765,7 @@
                     <a:bodyPr/>
                     <a:lstStyle/>
                     <a:p>
-                      <a:pPr indent="0" marL="0">
+                      <a:pPr marL="0" indent="0">
                         <a:buNone/>
                       </a:pPr>
                       <a:r>
@@ -7772,7 +7823,7 @@
                     <a:bodyPr/>
                     <a:lstStyle/>
                     <a:p>
-                      <a:pPr indent="0" marL="0">
+                      <a:pPr marL="0" indent="0">
                         <a:buNone/>
                       </a:pPr>
                       <a:r>
@@ -7830,7 +7881,7 @@
                     <a:bodyPr/>
                     <a:lstStyle/>
                     <a:p>
-                      <a:pPr indent="0" marL="0">
+                      <a:pPr marL="0" indent="0">
                         <a:buNone/>
                       </a:pPr>
                       <a:r>
@@ -7888,7 +7939,7 @@
                     <a:bodyPr/>
                     <a:lstStyle/>
                     <a:p>
-                      <a:pPr indent="0" marL="0">
+                      <a:pPr marL="0" indent="0">
                         <a:buNone/>
                       </a:pPr>
                       <a:r>
@@ -7946,7 +7997,7 @@
                     <a:bodyPr/>
                     <a:lstStyle/>
                     <a:p>
-                      <a:pPr indent="0" marL="0">
+                      <a:pPr marL="0" indent="0">
                         <a:buNone/>
                       </a:pPr>
                       <a:r>
@@ -7999,6 +8050,11 @@
                     </a:lnB>
                   </a:tcPr>
                 </a:tc>
+                <a:extLst>
+                  <a:ext uri="{0D108BD9-81ED-4DB2-BD59-A6C34878D82A}">
+                    <a16:rowId xmlns:a16="http://schemas.microsoft.com/office/drawing/2014/main" val="10003"/>
+                  </a:ext>
+                </a:extLst>
               </a:tr>
             </a:tbl>
           </a:graphicData>
@@ -8025,7 +8081,7 @@
           <a:bodyPr wrap="square" lIns="0" tIns="0" rIns="0" bIns="0" rtlCol="0" anchor="ctr"/>
           <a:lstStyle/>
           <a:p>
-            <a:pPr indent="0" marL="0">
+            <a:pPr marL="0" indent="0">
               <a:buNone/>
             </a:pPr>
             <a:r>
@@ -8417,4 +8473,319 @@
     </a:ext>
   </a:extLst>
 </a:theme>
+</file>
+
+<file path=ppt/theme/theme2.xml><?xml version="1.0" encoding="utf-8"?>
+<a:theme xmlns:a="http://schemas.openxmlformats.org/drawingml/2006/main" name="Office Theme">
+  <a:themeElements>
+    <a:clrScheme name="Office">
+      <a:dk1>
+        <a:sysClr val="windowText" lastClr="000000"/>
+      </a:dk1>
+      <a:lt1>
+        <a:sysClr val="window" lastClr="FFFFFF"/>
+      </a:lt1>
+      <a:dk2>
+        <a:srgbClr val="0E2841"/>
+      </a:dk2>
+      <a:lt2>
+        <a:srgbClr val="E8E8E8"/>
+      </a:lt2>
+      <a:accent1>
+        <a:srgbClr val="156082"/>
+      </a:accent1>
+      <a:accent2>
+        <a:srgbClr val="E97132"/>
+      </a:accent2>
+      <a:accent3>
+        <a:srgbClr val="196B24"/>
+      </a:accent3>
+      <a:accent4>
+        <a:srgbClr val="0F9ED5"/>
+      </a:accent4>
+      <a:accent5>
+        <a:srgbClr val="A02B93"/>
+      </a:accent5>
+      <a:accent6>
+        <a:srgbClr val="4EA72E"/>
+      </a:accent6>
+      <a:hlink>
+        <a:srgbClr val="467886"/>
+      </a:hlink>
+      <a:folHlink>
+        <a:srgbClr val="96607D"/>
+      </a:folHlink>
+    </a:clrScheme>
+    <a:fontScheme name="Office">
+      <a:majorFont>
+        <a:latin typeface="Aptos Display" panose="02110004020202020204"/>
+        <a:ea typeface=""/>
+        <a:cs typeface=""/>
+        <a:font script="Jpan" typeface="游ゴシック Light"/>
+        <a:font script="Hang" typeface="맑은 고딕"/>
+        <a:font script="Hans" typeface="等线 Light"/>
+        <a:font script="Hant" typeface="新細明體"/>
+        <a:font script="Arab" typeface="Times New Roman"/>
+        <a:font script="Hebr" typeface="Times New Roman"/>
+        <a:font script="Thai" typeface="Angsana New"/>
+        <a:font script="Ethi" typeface="Nyala"/>
+        <a:font script="Beng" typeface="Vrinda"/>
+        <a:font script="Gujr" typeface="Shruti"/>
+        <a:font script="Khmr" typeface="MoolBoran"/>
+        <a:font script="Knda" typeface="Tunga"/>
+        <a:font script="Guru" typeface="Raavi"/>
+        <a:font script="Cans" typeface="Euphemia"/>
+        <a:font script="Cher" typeface="Plantagenet Cherokee"/>
+        <a:font script="Yiii" typeface="Microsoft Yi Baiti"/>
+        <a:font script="Tibt" typeface="Microsoft Himalaya"/>
+        <a:font script="Thaa" typeface="MV Boli"/>
+        <a:font script="Deva" typeface="Mangal"/>
+        <a:font script="Telu" typeface="Gautami"/>
+        <a:font script="Taml" typeface="Latha"/>
+        <a:font script="Syrc" typeface="Estrangelo Edessa"/>
+        <a:font script="Orya" typeface="Kalinga"/>
+        <a:font script="Mlym" typeface="Kartika"/>
+        <a:font script="Laoo" typeface="DokChampa"/>
+        <a:font script="Sinh" typeface="Iskoola Pota"/>
+        <a:font script="Mong" typeface="Mongolian Baiti"/>
+        <a:font script="Viet" typeface="Times New Roman"/>
+        <a:font script="Uigh" typeface="Microsoft Uighur"/>
+        <a:font script="Geor" typeface="Sylfaen"/>
+        <a:font script="Armn" typeface="Arial"/>
+        <a:font script="Bugi" typeface="Leelawadee UI"/>
+        <a:font script="Bopo" typeface="Microsoft JhengHei"/>
+        <a:font script="Java" typeface="Javanese Text"/>
+        <a:font script="Lisu" typeface="Segoe UI"/>
+        <a:font script="Mymr" typeface="Myanmar Text"/>
+        <a:font script="Nkoo" typeface="Ebrima"/>
+        <a:font script="Olck" typeface="Nirmala UI"/>
+        <a:font script="Osma" typeface="Ebrima"/>
+        <a:font script="Phag" typeface="Phagspa"/>
+        <a:font script="Syrn" typeface="Estrangelo Edessa"/>
+        <a:font script="Syrj" typeface="Estrangelo Edessa"/>
+        <a:font script="Syre" typeface="Estrangelo Edessa"/>
+        <a:font script="Sora" typeface="Nirmala UI"/>
+        <a:font script="Tale" typeface="Microsoft Tai Le"/>
+        <a:font script="Talu" typeface="Microsoft New Tai Lue"/>
+        <a:font script="Tfng" typeface="Ebrima"/>
+      </a:majorFont>
+      <a:minorFont>
+        <a:latin typeface="Aptos" panose="02110004020202020204"/>
+        <a:ea typeface=""/>
+        <a:cs typeface=""/>
+        <a:font script="Jpan" typeface="游ゴシック"/>
+        <a:font script="Hang" typeface="맑은 고딕"/>
+        <a:font script="Hans" typeface="等线"/>
+        <a:font script="Hant" typeface="新細明體"/>
+        <a:font script="Arab" typeface="Arial"/>
+        <a:font script="Hebr" typeface="Arial"/>
+        <a:font script="Thai" typeface="Cordia New"/>
+        <a:font script="Ethi" typeface="Nyala"/>
+        <a:font script="Beng" typeface="Vrinda"/>
+        <a:font script="Gujr" typeface="Shruti"/>
+        <a:font script="Khmr" typeface="DaunPenh"/>
+        <a:font script="Knda" typeface="Tunga"/>
+        <a:font script="Guru" typeface="Raavi"/>
+        <a:font script="Cans" typeface="Euphemia"/>
+        <a:font script="Cher" typeface="Plantagenet Cherokee"/>
+        <a:font script="Yiii" typeface="Microsoft Yi Baiti"/>
+        <a:font script="Tibt" typeface="Microsoft Himalaya"/>
+        <a:font script="Thaa" typeface="MV Boli"/>
+        <a:font script="Deva" typeface="Mangal"/>
+        <a:font script="Telu" typeface="Gautami"/>
+        <a:font script="Taml" typeface="Latha"/>
+        <a:font script="Syrc" typeface="Estrangelo Edessa"/>
+        <a:font script="Orya" typeface="Kalinga"/>
+        <a:font script="Mlym" typeface="Kartika"/>
+        <a:font script="Laoo" typeface="DokChampa"/>
+        <a:font script="Sinh" typeface="Iskoola Pota"/>
+        <a:font script="Mong" typeface="Mongolian Baiti"/>
+        <a:font script="Viet" typeface="Arial"/>
+        <a:font script="Uigh" typeface="Microsoft Uighur"/>
+        <a:font script="Geor" typeface="Sylfaen"/>
+        <a:font script="Armn" typeface="Arial"/>
+        <a:font script="Bugi" typeface="Leelawadee UI"/>
+        <a:font script="Bopo" typeface="Microsoft JhengHei"/>
+        <a:font script="Java" typeface="Javanese Text"/>
+        <a:font script="Lisu" typeface="Segoe UI"/>
+        <a:font script="Mymr" typeface="Myanmar Text"/>
+        <a:font script="Nkoo" typeface="Ebrima"/>
+        <a:font script="Olck" typeface="Nirmala UI"/>
+        <a:font script="Osma" typeface="Ebrima"/>
+        <a:font script="Phag" typeface="Phagspa"/>
+        <a:font script="Syrn" typeface="Estrangelo Edessa"/>
+        <a:font script="Syrj" typeface="Estrangelo Edessa"/>
+        <a:font script="Syre" typeface="Estrangelo Edessa"/>
+        <a:font script="Sora" typeface="Nirmala UI"/>
+        <a:font script="Tale" typeface="Microsoft Tai Le"/>
+        <a:font script="Talu" typeface="Microsoft New Tai Lue"/>
+        <a:font script="Tfng" typeface="Ebrima"/>
+      </a:minorFont>
+    </a:fontScheme>
+    <a:fmtScheme name="Office">
+      <a:fillStyleLst>
+        <a:solidFill>
+          <a:schemeClr val="phClr"/>
+        </a:solidFill>
+        <a:gradFill rotWithShape="1">
+          <a:gsLst>
+            <a:gs pos="0">
+              <a:schemeClr val="phClr">
+                <a:lumMod val="110000"/>
+                <a:satMod val="105000"/>
+                <a:tint val="67000"/>
+              </a:schemeClr>
+            </a:gs>
+            <a:gs pos="50000">
+              <a:schemeClr val="phClr">
+                <a:lumMod val="105000"/>
+                <a:satMod val="103000"/>
+                <a:tint val="73000"/>
+              </a:schemeClr>
+            </a:gs>
+            <a:gs pos="100000">
+              <a:schemeClr val="phClr">
+                <a:lumMod val="105000"/>
+                <a:satMod val="109000"/>
+                <a:tint val="81000"/>
+              </a:schemeClr>
+            </a:gs>
+          </a:gsLst>
+          <a:lin ang="5400000" scaled="0"/>
+        </a:gradFill>
+        <a:gradFill rotWithShape="1">
+          <a:gsLst>
+            <a:gs pos="0">
+              <a:schemeClr val="phClr">
+                <a:satMod val="103000"/>
+                <a:lumMod val="102000"/>
+                <a:tint val="94000"/>
+              </a:schemeClr>
+            </a:gs>
+            <a:gs pos="50000">
+              <a:schemeClr val="phClr">
+                <a:satMod val="110000"/>
+                <a:lumMod val="100000"/>
+                <a:shade val="100000"/>
+              </a:schemeClr>
+            </a:gs>
+            <a:gs pos="100000">
+              <a:schemeClr val="phClr">
+                <a:lumMod val="99000"/>
+                <a:satMod val="120000"/>
+                <a:shade val="78000"/>
+              </a:schemeClr>
+            </a:gs>
+          </a:gsLst>
+          <a:lin ang="5400000" scaled="0"/>
+        </a:gradFill>
+      </a:fillStyleLst>
+      <a:lnStyleLst>
+        <a:ln w="12700" cap="flat" cmpd="sng" algn="ctr">
+          <a:solidFill>
+            <a:schemeClr val="phClr"/>
+          </a:solidFill>
+          <a:prstDash val="solid"/>
+          <a:miter lim="800000"/>
+        </a:ln>
+        <a:ln w="19050" cap="flat" cmpd="sng" algn="ctr">
+          <a:solidFill>
+            <a:schemeClr val="phClr"/>
+          </a:solidFill>
+          <a:prstDash val="solid"/>
+          <a:miter lim="800000"/>
+        </a:ln>
+        <a:ln w="25400" cap="flat" cmpd="sng" algn="ctr">
+          <a:solidFill>
+            <a:schemeClr val="phClr"/>
+          </a:solidFill>
+          <a:prstDash val="solid"/>
+          <a:miter lim="800000"/>
+        </a:ln>
+      </a:lnStyleLst>
+      <a:effectStyleLst>
+        <a:effectStyle>
+          <a:effectLst/>
+        </a:effectStyle>
+        <a:effectStyle>
+          <a:effectLst/>
+        </a:effectStyle>
+        <a:effectStyle>
+          <a:effectLst>
+            <a:outerShdw blurRad="57150" dist="19050" dir="5400000" algn="ctr" rotWithShape="0">
+              <a:srgbClr val="000000">
+                <a:alpha val="63000"/>
+              </a:srgbClr>
+            </a:outerShdw>
+          </a:effectLst>
+        </a:effectStyle>
+      </a:effectStyleLst>
+      <a:bgFillStyleLst>
+        <a:solidFill>
+          <a:schemeClr val="phClr"/>
+        </a:solidFill>
+        <a:solidFill>
+          <a:schemeClr val="phClr">
+            <a:tint val="95000"/>
+            <a:satMod val="170000"/>
+          </a:schemeClr>
+        </a:solidFill>
+        <a:gradFill rotWithShape="1">
+          <a:gsLst>
+            <a:gs pos="0">
+              <a:schemeClr val="phClr">
+                <a:tint val="93000"/>
+                <a:satMod val="150000"/>
+                <a:shade val="98000"/>
+                <a:lumMod val="102000"/>
+              </a:schemeClr>
+            </a:gs>
+            <a:gs pos="50000">
+              <a:schemeClr val="phClr">
+                <a:tint val="98000"/>
+                <a:satMod val="130000"/>
+                <a:shade val="90000"/>
+                <a:lumMod val="103000"/>
+              </a:schemeClr>
+            </a:gs>
+            <a:gs pos="100000">
+              <a:schemeClr val="phClr">
+                <a:shade val="63000"/>
+                <a:satMod val="120000"/>
+              </a:schemeClr>
+            </a:gs>
+          </a:gsLst>
+          <a:lin ang="5400000" scaled="0"/>
+        </a:gradFill>
+      </a:bgFillStyleLst>
+    </a:fmtScheme>
+  </a:themeElements>
+  <a:objectDefaults>
+    <a:lnDef>
+      <a:spPr/>
+      <a:bodyPr/>
+      <a:lstStyle/>
+      <a:style>
+        <a:lnRef idx="2">
+          <a:schemeClr val="accent1"/>
+        </a:lnRef>
+        <a:fillRef idx="0">
+          <a:schemeClr val="accent1"/>
+        </a:fillRef>
+        <a:effectRef idx="1">
+          <a:schemeClr val="accent1"/>
+        </a:effectRef>
+        <a:fontRef idx="minor">
+          <a:schemeClr val="tx1"/>
+        </a:fontRef>
+      </a:style>
+    </a:lnDef>
+  </a:objectDefaults>
+  <a:extraClrSchemeLst/>
+  <a:extLst>
+    <a:ext uri="{05A4C25C-085E-4340-85A3-A5531E510DB2}">
+      <thm15:themeFamily xmlns:thm15="http://schemas.microsoft.com/office/thememl/2012/main" name="Office Theme" id="{2E142A2C-CD16-42D6-873A-C26D2A0506FA}" vid="{1BDDFF52-6CD6-40A5-AB3C-68EB2F1E4D0A}"/>
+    </a:ext>
+  </a:extLst>
+</a:theme>
 </file>
</xml_diff>

<commit_message>
Deck: slide 5 quotes 20-split medians; disease duration noted as a secondary candidate (after Wenzhe's pipeline)
Co-Authored-By: Claude Fable 5.1 <noreply@anthropic.com>
</commit_message>
<xml_diff>
--- a/slides/Team1_DM1_slides.pptx
+++ b/slides/Team1_DM1_slides.pptx
@@ -672,15 +672,54 @@
           <a:lstStyle/>
           <a:p>
             <a:r>
-              <a:rPr lang="en-US" dirty="0"/>
-              <a:t>[80 s]
-This is the covariate forest plot, in the standard pharmacometric format. For each arm, the reference patient has median covariates and adult onset; the dashed line is that patient's predicted probability of response. The rows show the dominant covariate at its 10th and 90th percentile, then each onset phenotype with everything else at reference. Lines are 90% bootstrap intervals, from training patients only.
-Mexiletine: from mild to severe myotonia, predicted response rises from 17% to 38%. A symptomatic drug: the effect scales with the symptom present. Late-onset patients respond less because their baseline myotonia is mild; there is little to treat.
-The oligonucleotide: from short to long repeats, 22% to 75%. The only predictor in the arm. A target-engaging drug: the effect scales with the amount of target transcript. Note that individual prediction stays poor, test R-squared under 0.1: we know the direction, not the person.
-Tideglusib: from impaired to intact cognition, 87% down to 14%, and it is a threshold near minus 0.5, not a gradient. The composite endpoint has a cognitive domain, so a patient with intact cognition has no room for measurable gain. A ceiling effect.
-Onset phenotype adds little once the dominant covariate is in the model: the phenotype rows straddle the reference line.
-Replication: three team members built three independent implementations, two in R and one in Python, with different splits, up to 30 methods, and 20 repeated splits. All found the same three covariates. CTG repeat length behaves like a prognostic marker across arms; cognitive function is specific to tideglusib.
-If asked what was noise: sex, BMI, smoking, cataracts, CK, PR interval and albumin in every arm; disease duration borderline everywhere.</a:t>
+              <a:t>[80 s]</a:t>
+            </a:r>
+          </a:p>
+          <a:p>
+            <a:r>
+              <a:t>This is the covariate forest plot, in the standard pharmacometric format. For each arm, the reference patient has median covariates and adult onset; the dashed line is that patient's predicted probability of response. The rows show the dominant covariate at its 10th and 90th percentile, then each onset phenotype with everything else at reference. Lines are 90% bootstrap intervals, from training patients only.</a:t>
+            </a:r>
+          </a:p>
+          <a:p/>
+          <a:p>
+            <a:r>
+              <a:t>Mexiletine: from mild to severe myotonia, predicted response rises from 17% to 38%. A symptomatic drug: the effect scales with the symptom present. Late-onset patients respond less because their baseline myotonia is mild; there is little to treat.</a:t>
+            </a:r>
+          </a:p>
+          <a:p/>
+          <a:p>
+            <a:r>
+              <a:t>The oligonucleotide: from short to long repeats, 22% to 75%. The only predictor in the arm. A target-engaging drug: the effect scales with the amount of target transcript. Note that individual prediction stays poor, test R-squared under 0.1: we know the direction, not the person.</a:t>
+            </a:r>
+          </a:p>
+          <a:p/>
+          <a:p>
+            <a:r>
+              <a:t>Tideglusib: from impaired to intact cognition, 87% down to 14%, and it is a threshold near minus 0.5, not a gradient. The composite endpoint has a cognitive domain, so a patient with intact cognition has no room for measurable gain. A ceiling effect.</a:t>
+            </a:r>
+          </a:p>
+          <a:p/>
+          <a:p>
+            <a:r>
+              <a:t>Onset phenotype adds little once the dominant covariate is in the model: the phenotype rows straddle the reference line.</a:t>
+            </a:r>
+          </a:p>
+          <a:p/>
+          <a:p>
+            <a:r>
+              <a:t>Replication: three team members built three independent implementations, two in R and one in Python, with different splits, up to 30 methods, and 20 repeated splits. All found the same three covariates. CTG repeat length behaves like a prognostic marker across arms; cognitive function is specific to tideglusib.</a:t>
+            </a:r>
+          </a:p>
+          <a:p/>
+          <a:p>
+            <a:r>
+              <a:t>If asked what was noise: sex, BMI, smoking, cataracts, CK, PR interval and albumin in every arm; disease duration borderline everywhere.</a:t>
+            </a:r>
+          </a:p>
+          <a:p/>
+          <a:p>
+            <a:r>
+              <a:t>Secondary candidate, if asked: disease duration. Borderline in our pipeline (3 to 4 of 5 votes, 24 to 48% stability), signal in Wenzhe's pipeline for mexiletine and tideglusib. Direction: longer disease duration, less response, in both arms. Clinically: a proxy for accumulated irreversible damage. We present it as a candidate for confirmation, not a finding.</a:t>
             </a:r>
           </a:p>
         </p:txBody>
@@ -766,13 +805,42 @@
           <a:lstStyle/>
           <a:p>
             <a:r>
-              <a:rPr lang="en-US" dirty="0"/>
-              <a:t>[60 s]
-The scoreboard. Blue bars are covariate models, orange bars are machine learning, test-set R-squared for the continuous endpoint, about 41 held-out patients per arm.
-Mexiletine: every method lands between 0.47 and 0.54. Equivalent. Across 20 repeated splits the top rank alternates between stepwise selection and tuned XGBoost.
-Oligonucleotide: every method is under 0.1, on every split. The repeat-length effect is consistent but between-patient variability dominates. We report that as it is.
-Tideglusib: random forest and tuned XGBoost reach 0.55; the straight-line models 0.24 to 0.30, on 19 of 20 splits. We know why: the effect is a threshold, and a straight line cannot draw a step. A linear model given that single threshold on cognition reaches 0.45. Tuned XGBoost chose depth-one trees in every arm, so there are no interactions to find.
-Intervals overlap within each arm, so we do not rank methods inside an arm. Machine learning was the check that nothing was missed: by permutation importance and SHAP it found the same leaders.</a:t>
+              <a:t>[60 s]</a:t>
+            </a:r>
+          </a:p>
+          <a:p>
+            <a:r>
+              <a:t>The scoreboard. Blue bars are covariate models, orange bars are machine learning, test-set R-squared for the continuous endpoint, about 41 held-out patients per arm.</a:t>
+            </a:r>
+          </a:p>
+          <a:p/>
+          <a:p>
+            <a:r>
+              <a:t>Mexiletine: every method lands between 0.47 and 0.54. Equivalent. Across 20 repeated splits the top rank alternates between stepwise selection and tuned XGBoost.</a:t>
+            </a:r>
+          </a:p>
+          <a:p/>
+          <a:p>
+            <a:r>
+              <a:t>Oligonucleotide: every method is under 0.1, on every split. The repeat-length effect is consistent but between-patient variability dominates. We report that as it is.</a:t>
+            </a:r>
+          </a:p>
+          <a:p/>
+          <a:p>
+            <a:r>
+              <a:t>Tideglusib: random forest and tuned XGBoost reach 0.55; the straight-line models 0.24 to 0.30, on 19 of 20 splits. We know why: the effect is a threshold, and a straight line cannot draw a step. A linear model given that single threshold on cognition reaches 0.45. Tuned XGBoost chose depth-one trees in every arm, so there are no interactions to find.</a:t>
+            </a:r>
+          </a:p>
+          <a:p/>
+          <a:p>
+            <a:r>
+              <a:t>Intervals overlap within each arm, so we do not rank methods inside an arm. Machine learning was the check that nothing was missed: by permutation importance and SHAP it found the same leaders.</a:t>
+            </a:r>
+          </a:p>
+          <a:p/>
+          <a:p>
+            <a:r>
+              <a:t>The three lines under the figure quote medians over 20 repeated splits rather than our single locked split, because single-split R² moves by up to 0.15 between draws. Our locked split: mexiletine 0.47 to 0.54, oligonucleotide under 0.1, tideglusib 0.55 vs 0.24 to 0.30. Wenzhe's independent 80/20 split: mexiletine 0.75, oligonucleotide 0.27, tideglusib tree ensembles ahead; same pattern.</a:t>
             </a:r>
           </a:p>
         </p:txBody>
@@ -4748,7 +4816,7 @@
                   <a:srgbClr val="1F2933"/>
                 </a:solidFill>
               </a:rPr>
-              <a:t>Equivalent: R² 0.47 to 0.54 for every method</a:t>
+              <a:t>Equivalent: median R² ≈ 0.6 across 20 splits; all methods within 0.05</a:t>
             </a:r>
             <a:endParaRPr lang="en-US" sz="1400" dirty="0"/>
           </a:p>
@@ -4820,7 +4888,7 @@
                   <a:srgbClr val="1F2933"/>
                 </a:solidFill>
               </a:rPr>
-              <a:t>Low predictability: R² &lt; 0.1 for every method</a:t>
+              <a:t>Low predictability: median R² 0.06 to 0.12 across 20 splits, every method</a:t>
             </a:r>
             <a:endParaRPr lang="en-US" sz="1400" dirty="0"/>
           </a:p>
@@ -4892,7 +4960,7 @@
                   <a:srgbClr val="1F2933"/>
                 </a:solidFill>
               </a:rPr>
-              <a:t>Tree ensembles 0.55 vs linear 0.24 to 0.30; one threshold brings linear to 0.45</a:t>
+              <a:t>Tree ensembles 0.54 vs linear 0.30 to 0.35 (20-split medians); one threshold brings linear to ≈ 0.45</a:t>
             </a:r>
             <a:endParaRPr lang="en-US" sz="1400" dirty="0"/>
           </a:p>
@@ -6716,6 +6784,9 @@
                 </a:solidFill>
               </a:rPr>
               <a:t>Filled dot = selected. Final call requires 4 of 5 methods and LASSO bootstrap stability ≥ 60% (signal); 2 votes and ≥ 20% (uncertain).</a:t>
+            </a:r>
+            <a:r>
+              <a:t> Secondary candidate seen in two of three pipelines: disease duration (longer duration, less response), borderline here.</a:t>
             </a:r>
             <a:endParaRPr lang="en-US" sz="1300" dirty="0"/>
           </a:p>

</xml_diff>

<commit_message>
Repository link on the methods slide, in the AI disclosure, the code headers and the READMEs
Co-Authored-By: Claude Fable 5.1 <noreply@anthropic.com>
</commit_message>
<xml_diff>
--- a/slides/Team1_DM1_slides.pptx
+++ b/slides/Team1_DM1_slides.pptx
@@ -4262,6 +4262,40 @@
           </a:p>
         </p:txBody>
       </p:sp>
+      <p:sp>
+        <p:nvSpPr>
+          <p:cNvPr id="24" name="TextBox 23"/>
+          <p:cNvSpPr txBox="1"/>
+          <p:nvPr/>
+        </p:nvSpPr>
+        <p:spPr>
+          <a:xfrm>
+            <a:off x="548640" y="6263640"/>
+            <a:ext cx="11064240" cy="320040"/>
+          </a:xfrm>
+          <a:prstGeom prst="rect">
+            <a:avLst/>
+          </a:prstGeom>
+          <a:noFill/>
+        </p:spPr>
+        <p:txBody>
+          <a:bodyPr wrap="none" lIns="0" rIns="0" tIns="0" bIns="0">
+            <a:spAutoFit/>
+          </a:bodyPr>
+          <a:lstStyle/>
+          <a:p>
+            <a:r>
+              <a:rPr sz="1200">
+                <a:solidFill>
+                  <a:srgbClr val="5B6B7A"/>
+                </a:solidFill>
+                <a:latin typeface="Calibri"/>
+              </a:rPr>
+              <a:t>Code, decision log, AI disclosure and all three team pipelines: github.com/euibeom135-cell/acop2026-hackathon-team1</a:t>
+            </a:r>
+          </a:p>
+        </p:txBody>
+      </p:sp>
     </p:spTree>
   </p:cSld>
   <p:clrMapOvr>
@@ -6518,6 +6552,9 @@
                 </a:solidFill>
               </a:rPr>
               <a:t>Claude (via Claude Code) and Codex drafted code, documentation and slides. All decisions and interpretations were reviewed by the team, which is accountable for the results.</a:t>
+            </a:r>
+            <a:r>
+              <a:t> Full record: github.com/euibeom135-cell/acop2026-hackathon-team1</a:t>
             </a:r>
             <a:endParaRPr lang="en-US" sz="1400" dirty="0"/>
           </a:p>

</xml_diff>

<commit_message>
Deck: match font size of the repository link in the AI disclosure
Co-Authored-By: Claude Fable 5.1 <noreply@anthropic.com>
</commit_message>
<xml_diff>
--- a/slides/Team1_DM1_slides.pptx
+++ b/slides/Team1_DM1_slides.pptx
@@ -6550,10 +6550,14 @@
                 <a:solidFill>
                   <a:srgbClr val="1F2933"/>
                 </a:solidFill>
+                <a:latin typeface="Calibri"/>
               </a:rPr>
               <a:t>Claude (via Claude Code) and Codex drafted code, documentation and slides. All decisions and interpretations were reviewed by the team, which is accountable for the results.</a:t>
             </a:r>
             <a:r>
+              <a:rPr sz="1400">
+                <a:latin typeface="Calibri"/>
+              </a:rPr>
               <a:t> Full record: github.com/euibeom135-cell/acop2026-hackathon-team1</a:t>
             </a:r>
             <a:endParaRPr lang="en-US" sz="1400" dirty="0"/>

</xml_diff>

<commit_message>
Deck: backup slide 8 caption in one font size
Co-Authored-By: Claude Fable 5.1 <noreply@anthropic.com>
</commit_message>
<xml_diff>
--- a/slides/Team1_DM1_slides.pptx
+++ b/slides/Team1_DM1_slides.pptx
@@ -680,43 +680,57 @@
               <a:t>This is the covariate forest plot, in the standard pharmacometric format. For each arm, the reference patient has median covariates and adult onset; the dashed line is that patient's predicted probability of response. The rows show the dominant covariate at its 10th and 90th percentile, then each onset phenotype with everything else at reference. Lines are 90% bootstrap intervals, from training patients only.</a:t>
             </a:r>
           </a:p>
-          <a:p/>
+          <a:p>
+            <a:endParaRPr/>
+          </a:p>
           <a:p>
             <a:r>
               <a:t>Mexiletine: from mild to severe myotonia, predicted response rises from 17% to 38%. A symptomatic drug: the effect scales with the symptom present. Late-onset patients respond less because their baseline myotonia is mild; there is little to treat.</a:t>
             </a:r>
           </a:p>
-          <a:p/>
+          <a:p>
+            <a:endParaRPr/>
+          </a:p>
           <a:p>
             <a:r>
               <a:t>The oligonucleotide: from short to long repeats, 22% to 75%. The only predictor in the arm. A target-engaging drug: the effect scales with the amount of target transcript. Note that individual prediction stays poor, test R-squared under 0.1: we know the direction, not the person.</a:t>
             </a:r>
           </a:p>
-          <a:p/>
+          <a:p>
+            <a:endParaRPr/>
+          </a:p>
           <a:p>
             <a:r>
               <a:t>Tideglusib: from impaired to intact cognition, 87% down to 14%, and it is a threshold near minus 0.5, not a gradient. The composite endpoint has a cognitive domain, so a patient with intact cognition has no room for measurable gain. A ceiling effect.</a:t>
             </a:r>
           </a:p>
-          <a:p/>
+          <a:p>
+            <a:endParaRPr/>
+          </a:p>
           <a:p>
             <a:r>
               <a:t>Onset phenotype adds little once the dominant covariate is in the model: the phenotype rows straddle the reference line.</a:t>
             </a:r>
           </a:p>
-          <a:p/>
+          <a:p>
+            <a:endParaRPr/>
+          </a:p>
           <a:p>
             <a:r>
               <a:t>Replication: three team members built three independent implementations, two in R and one in Python, with different splits, up to 30 methods, and 20 repeated splits. All found the same three covariates. CTG repeat length behaves like a prognostic marker across arms; cognitive function is specific to tideglusib.</a:t>
             </a:r>
           </a:p>
-          <a:p/>
+          <a:p>
+            <a:endParaRPr/>
+          </a:p>
           <a:p>
             <a:r>
               <a:t>If asked what was noise: sex, BMI, smoking, cataracts, CK, PR interval and albumin in every arm; disease duration borderline everywhere.</a:t>
             </a:r>
           </a:p>
-          <a:p/>
+          <a:p>
+            <a:endParaRPr/>
+          </a:p>
           <a:p>
             <a:r>
               <a:t>Secondary candidate, if asked: disease duration. Borderline in our pipeline (3 to 4 of 5 votes, 24 to 48% stability), signal in Wenzhe's pipeline for mexiletine and tideglusib. Direction: longer disease duration, less response, in both arms. Clinically: a proxy for accumulated irreversible damage. We present it as a candidate for confirmation, not a finding.</a:t>
@@ -813,31 +827,41 @@
               <a:t>The scoreboard. Blue bars are covariate models, orange bars are machine learning, test-set R-squared for the continuous endpoint, about 41 held-out patients per arm.</a:t>
             </a:r>
           </a:p>
-          <a:p/>
+          <a:p>
+            <a:endParaRPr/>
+          </a:p>
           <a:p>
             <a:r>
               <a:t>Mexiletine: every method lands between 0.47 and 0.54. Equivalent. Across 20 repeated splits the top rank alternates between stepwise selection and tuned XGBoost.</a:t>
             </a:r>
           </a:p>
-          <a:p/>
+          <a:p>
+            <a:endParaRPr/>
+          </a:p>
           <a:p>
             <a:r>
               <a:t>Oligonucleotide: every method is under 0.1, on every split. The repeat-length effect is consistent but between-patient variability dominates. We report that as it is.</a:t>
             </a:r>
           </a:p>
-          <a:p/>
+          <a:p>
+            <a:endParaRPr/>
+          </a:p>
           <a:p>
             <a:r>
               <a:t>Tideglusib: random forest and tuned XGBoost reach 0.55; the straight-line models 0.24 to 0.30, on 19 of 20 splits. We know why: the effect is a threshold, and a straight line cannot draw a step. A linear model given that single threshold on cognition reaches 0.45. Tuned XGBoost chose depth-one trees in every arm, so there are no interactions to find.</a:t>
             </a:r>
           </a:p>
-          <a:p/>
+          <a:p>
+            <a:endParaRPr/>
+          </a:p>
           <a:p>
             <a:r>
               <a:t>Intervals overlap within each arm, so we do not rank methods inside an arm. Machine learning was the check that nothing was missed: by permutation importance and SHAP it found the same leaders.</a:t>
             </a:r>
           </a:p>
-          <a:p/>
+          <a:p>
+            <a:endParaRPr/>
+          </a:p>
           <a:p>
             <a:r>
               <a:t>The three lines under the figure quote medians over 20 repeated splits rather than our single locked split, because single-split R² moves by up to 0.15 between draws. Our locked split: mexiletine 0.47 to 0.54, oligonucleotide under 0.1, tideglusib 0.55 vs 0.24 to 0.30. Wenzhe's independent 80/20 split: mexiletine 0.75, oligonucleotide 0.27, tideglusib tree ensembles ahead; same pattern.</a:t>
@@ -4271,7 +4295,7 @@
         <p:spPr>
           <a:xfrm>
             <a:off x="548640" y="6263640"/>
-            <a:ext cx="11064240" cy="320040"/>
+            <a:ext cx="6057236" cy="307777"/>
           </a:xfrm>
           <a:prstGeom prst="rect">
             <a:avLst/>
@@ -4279,19 +4303,28 @@
           <a:noFill/>
         </p:spPr>
         <p:txBody>
-          <a:bodyPr wrap="none" lIns="0" rIns="0" tIns="0" bIns="0">
+          <a:bodyPr wrap="none" lIns="0" tIns="0" rIns="0" bIns="0">
             <a:spAutoFit/>
           </a:bodyPr>
           <a:lstStyle/>
           <a:p>
             <a:r>
-              <a:rPr sz="1200">
+              <a:rPr sz="2000" dirty="0" err="1">
                 <a:solidFill>
                   <a:srgbClr val="5B6B7A"/>
                 </a:solidFill>
                 <a:latin typeface="Calibri"/>
               </a:rPr>
-              <a:t>Code, decision log, AI disclosure and all three team pipelines: github.com/euibeom135-cell/acop2026-hackathon-team1</a:t>
+              <a:t>github.com</a:t>
+            </a:r>
+            <a:r>
+              <a:rPr sz="2000" dirty="0">
+                <a:solidFill>
+                  <a:srgbClr val="5B6B7A"/>
+                </a:solidFill>
+                <a:latin typeface="Calibri"/>
+              </a:rPr>
+              <a:t>/euibeom135-cell/acop2026-hackathon-team1</a:t>
             </a:r>
           </a:p>
         </p:txBody>
@@ -6823,10 +6856,17 @@
                 <a:solidFill>
                   <a:srgbClr val="5B6B7A"/>
                 </a:solidFill>
+                <a:latin typeface="Calibri"/>
               </a:rPr>
               <a:t>Filled dot = selected. Final call requires 4 of 5 methods and LASSO bootstrap stability ≥ 60% (signal); 2 votes and ≥ 20% (uncertain).</a:t>
             </a:r>
             <a:r>
+              <a:rPr sz="1300">
+                <a:solidFill>
+                  <a:srgbClr val="5B6B7A"/>
+                </a:solidFill>
+                <a:latin typeface="Calibri"/>
+              </a:rPr>
               <a:t> Secondary candidate seen in two of three pipelines: disease duration (longer duration, less response), borderline here.</a:t>
             </a:r>
             <a:endParaRPr lang="en-US" sz="1300" dirty="0"/>

</xml_diff>

<commit_message>
Mexiletine told on the relative scale: room-to-improve stated, severity/CTG as one axis; notes and context updated after the team discussion
Co-Authored-By: Claude Fable 5.1 <noreply@anthropic.com>
</commit_message>
<xml_diff>
--- a/slides/Team1_DM1_slides.pptx
+++ b/slides/Team1_DM1_slides.pptx
@@ -487,14 +487,48 @@
           <a:lstStyle/>
           <a:p>
             <a:r>
-              <a:rPr lang="en-US" dirty="0"/>
-              <a:t>[45 s]
-This is the whole result. One row per arm.
-Mexiletine blocks muscle sodium channels; it treats the symptom. Its predictor is the symptom: baseline myotonia severity. Among held-out test patients, 48% above the cut-off responded versus 10% below.
-The antisense oligonucleotide degrades the toxic DMPK transcript; it acts on the cause. Its predictor is the amount of cause: CTG repeat length. 59% versus 31%.
-Tideglusib inhibits GSK3β and acts across several systems including the brain; the endpoint is a composite with a cognitive domain. Its predictor is baseline cognitive function. 74% versus 17%.
-Three points of evidence behind every row: stepwise selection, LASSO, elastic net, random forest and XGBoost all picked the same covariate; LASSO kept it in 90 to 100% of 200 bootstrap resamples; and a column of pure random numbers that we added as a negative control was never selected by any method in any arm.
-Machine learning, meaning random forest and XGBoost, ranked the same covariates first. It did not add a predictor.</a:t>
+              <a:t>[45 s]</a:t>
+            </a:r>
+          </a:p>
+          <a:p>
+            <a:r>
+              <a:t>This is the whole result. One row per arm.</a:t>
+            </a:r>
+          </a:p>
+          <a:p/>
+          <a:p>
+            <a:r>
+              <a:t>Mexiletine blocks muscle sodium channels; it treats the symptom. Its predictor is the symptom: baseline myotonia severity. Among held-out test patients, 48% above the cut-off responded versus 10% below.</a:t>
+            </a:r>
+          </a:p>
+          <a:p/>
+          <a:p>
+            <a:r>
+              <a:t>The antisense oligonucleotide degrades the toxic DMPK transcript; it acts on the cause. Its predictor is the amount of cause: CTG repeat length. 59% versus 31%.</a:t>
+            </a:r>
+          </a:p>
+          <a:p/>
+          <a:p>
+            <a:r>
+              <a:t>Tideglusib inhibits GSK3β and acts across several systems including the brain; the endpoint is a composite with a cognitive domain. Its predictor is baseline cognitive function. 74% versus 17%.</a:t>
+            </a:r>
+          </a:p>
+          <a:p/>
+          <a:p>
+            <a:r>
+              <a:t>Three points of evidence behind every row: stepwise selection, LASSO, elastic net, random forest and XGBoost all picked the same covariate; LASSO kept it in 90 to 100% of 200 bootstrap resamples; and a column of pure random numbers that we added as a negative control was never selected by any method in any arm.</a:t>
+            </a:r>
+          </a:p>
+          <a:p/>
+          <a:p>
+            <a:r>
+              <a:t>Machine learning, meaning random forest and XGBoost, ranked the same covariates first. It did not add a predictor.</a:t>
+            </a:r>
+          </a:p>
+          <a:p/>
+          <a:p>
+            <a:r>
+              <a:t>Mexiletine scale, if asked (team discussion 13 Oct): absolute change in myotonia is multiplicative in baseline (Wenzhe's variance diagnostic, theta about 1), so most of the R² of 0.6 to 0.7 on absolute change is room to improve, not drug biology. On relative change the same severity/CTG axis still predicts, but modestly: cross-validated R² about 0.15, Spearman 0.43, responder AUC 0.75; relative improvement rises from 32% in the mildest quarter to 45% in the most severe, and the responder share from 9% to 50%. So we present mexiletine on the responder rule (relative), name severity and CTG as one axis (VIF 4 to 5), and say the absolute-change fit is largely arithmetic. Ming's two-part framing of the whole talk: additional predictors from ML? No. Better stratification? Yes, in one way: ML found the shape of the cognition effect, and a one-term rule captures it.</a:t>
             </a:r>
           </a:p>
         </p:txBody>
@@ -2696,7 +2730,7 @@
                             <a:srgbClr val="1F2933"/>
                           </a:solidFill>
                         </a:rPr>
-                        <a:t>Myotonia severity</a:t>
+                        <a:t>Myotonia severity (one axis with CTG repeats)</a:t>
                       </a:r>
                       <a:endParaRPr lang="en-US" sz="1400" dirty="0"/>
                     </a:p>
@@ -4492,7 +4526,7 @@
                   <a:srgbClr val="1F2933"/>
                 </a:solidFill>
               </a:rPr>
-              <a:t>17% → 38%.  Symptomatic drug: effect scales with symptom burden.</a:t>
+              <a:t>17% → 38% on the ≥45% responder rule. Absolute change mostly reflects baseline (room to improve); on relative change the same axis still predicts, modestly (R² ≈ 0.15, AUC 0.75).</a:t>
             </a:r>
             <a:endParaRPr lang="en-US" sz="1500" dirty="0"/>
           </a:p>
@@ -4883,7 +4917,7 @@
                   <a:srgbClr val="1F2933"/>
                 </a:solidFill>
               </a:rPr>
-              <a:t>Equivalent: median R² ≈ 0.6 across 20 splits; all methods within 0.05</a:t>
+              <a:t>Equivalent: median R² ≈ 0.6 on absolute change, mostly baseline arithmetic; ≈ 0.15 on relative change, every method</a:t>
             </a:r>
             <a:endParaRPr lang="en-US" sz="1400" dirty="0"/>
           </a:p>

</xml_diff>

<commit_message>
Deck: Ming's two-part answer on slide 2, closing sentence on slide 6, backup title, notes with the three-criteria script
Co-Authored-By: Claude Fable 5.1 <noreply@anthropic.com>
</commit_message>
<xml_diff>
--- a/slides/Team1_DM1_slides.pptx
+++ b/slides/Team1_DM1_slides.pptx
@@ -984,13 +984,54 @@
           <a:lstStyle/>
           <a:p>
             <a:r>
-              <a:rPr lang="en-US" dirty="0"/>
-              <a:t>[40 s]
-What a clinician or a trialist does with this: measure the organ the drug acts on. Myotonia severity before mexiletine, repeat length before the antisense drug, cognitive function before tideglusib. One routine baseline assessment per drug, and response rates differ two- to five-fold between the groups it defines. Cut-offs are approximate: about 5, about 350, about minus 0.5.
-Trial design: for mexiletine, enrol on baseline myotonia severity rather than diagnosis alone, because mild cases dilute the effect, which is what the 2021 placebo-controlled trial found on walking distance. For the oligonucleotide, stratify randomisation on repeat length, a prognostic factor. For tideglusib, enrich for cognitive impairment: expected responder rate goes from 48% to 74%, which reduces the sample size needed to show an effect.
-Limitations we state ourselves: no placebo arm, so these are prognostic predictors within treated patients, not demonstrated effect modifiers. About 41 test patients per arm, so we give ranges and do not rank methods within an arm. One time point per patient; the natural next step is a longitudinal disease-progression model with these covariates on progression rate and drug effect.
-AI disclosure: Claude through Claude Code, and Codex, drafted code, documentation and these slides, as noted in the code headers. Every analysis decision and interpretation was reviewed by the team, and the team is accountable for the results.
-Robustness, if time: we repeated the split 20 times and the pattern held in every arm. Thank you.</a:t>
+              <a:t>[40 s]</a:t>
+            </a:r>
+          </a:p>
+          <a:p>
+            <a:r>
+              <a:t>What a clinician or a trialist does with this: measure the organ the drug acts on. Myotonia severity before mexiletine, repeat length before the antisense drug, cognitive function before tideglusib. One routine baseline assessment per drug, and response rates differ two- to five-fold between the groups it defines. Cut-offs are approximate: about 5, about 350, about minus 0.5.</a:t>
+            </a:r>
+          </a:p>
+          <a:p/>
+          <a:p>
+            <a:r>
+              <a:t>Trial design: for mexiletine, enrol on baseline myotonia severity rather than diagnosis alone, because mild cases dilute the effect, which is what the 2021 placebo-controlled trial found on walking distance. For the oligonucleotide, stratify randomisation on repeat length, a prognostic factor. For tideglusib, enrich for cognitive impairment: expected responder rate goes from 48% to 74%, which reduces the sample size needed to show an effect.</a:t>
+            </a:r>
+          </a:p>
+          <a:p/>
+          <a:p>
+            <a:r>
+              <a:t>Limitations we state ourselves: no placebo arm, so these are prognostic predictors within treated patients, not demonstrated effect modifiers. About 41 test patients per arm, so we give ranges and do not rank methods within an arm. One time point per patient; the natural next step is a longitudinal disease-progression model with these covariates on progression rate and drug effect.</a:t>
+            </a:r>
+          </a:p>
+          <a:p/>
+          <a:p>
+            <a:r>
+              <a:t>AI disclosure: Claude through Claude Code, and Codex, drafted code, documentation and these slides, as noted in the code headers. Every analysis decision and interpretation was reviewed by the team, and the team is accountable for the results.</a:t>
+            </a:r>
+          </a:p>
+          <a:p/>
+          <a:p>
+            <a:r>
+              <a:t>Robustness, if time: we repeated the split 20 times and the pattern held in every arm. Thank you.</a:t>
+            </a:r>
+          </a:p>
+          <a:p/>
+          <a:p>
+            <a:r>
+              <a:t>Closing, in Ming's two-part form: Additional predictors from ML? No: traditional and ML methods pick the same covariates in every arm; across repeated splits cognition is selected about 100% of the time, CTG repeats about 90%, myotonia about 85 to 100%. Better stratification? Yes, in one specific way: in the tideglusib arm the random forest showed the cognition effect is a step, not a line; a one-term rule, cognition below about -0.5, captures it on held-out patients. In the other two arms ML did not beat the simple models, and we say so. ML's contribution was the functional form, not new features.</a:t>
+            </a:r>
+          </a:p>
+          <a:p/>
+          <a:p>
+            <a:r>
+              <a:t>How we meet the three criteria, if asked: Technical: six-step workflow, locked test set scored once, every method on the same test patients, tuned and untuned side by side, stated cut-off rule, bootstrap intervals and 20-split spread, so small gaps are ties. Clinical: a covariate counts only if it survives resampling and beats a noise control (Ming's pipeline adds a shuffled-outcome null and a pre-registered hypothesis sheet); the rule rejected candidates too (mexiletine severity on relative change is modest, oligonucleotide insulin resistance dropped). Communication: one storyline, one table answer, mechanism per drug.</a:t>
+            </a:r>
+          </a:p>
+          <a:p/>
+          <a:p>
+            <a:r>
+              <a:t>Extra rigour available in backup: pre-registration before scoring, shuffled-outcome null, 20-seed sensitivity, four independent pipelines.</a:t>
             </a:r>
           </a:p>
         </p:txBody>
@@ -1076,8 +1117,13 @@
           <a:lstStyle/>
           <a:p>
             <a:r>
-              <a:rPr lang="en-US" dirty="0"/>
               <a:t>Mexiletine: methods equivalent, median about 0.6. Oligonucleotide: all weak, medians 0.06 to 0.12. Absolute R² varies by up to 0.15 between splits, hence ranges rather than point estimates.</a:t>
+            </a:r>
+          </a:p>
+          <a:p/>
+          <a:p>
+            <a:r>
+              <a:t>Ming's cross-seed selection frequencies agree: cognition 100%, CTG repeats 90%, myotonia 85%. Hence the line: the split moves the scores, not the covariates.</a:t>
             </a:r>
           </a:p>
         </p:txBody>
@@ -3384,7 +3430,31 @@
                   <a:srgbClr val="1F2933"/>
                 </a:solidFill>
               </a:rPr>
-              <a:t>Selected by all five methods in every arm.  Machine learning added no predictor.  A pure-noise control covariate was never selected.</a:t>
+              <a:t>Additional predictors from machine learning? No: </a:t>
+            </a:r>
+            <a:r>
+              <a:rPr b="0" sz="1700">
+                <a:solidFill>
+                  <a:srgbClr val="1F2933"/>
+                </a:solidFill>
+              </a:rPr>
+              <a:t>the same covariates in every arm, selected by all five methods; a pure-noise control was never selected.  </a:t>
+            </a:r>
+            <a:r>
+              <a:rPr b="1" sz="1700">
+                <a:solidFill>
+                  <a:srgbClr val="1F2933"/>
+                </a:solidFill>
+              </a:rPr>
+              <a:t>Better stratification? Yes, in one way: </a:t>
+            </a:r>
+            <a:r>
+              <a:rPr b="0" sz="1700">
+                <a:solidFill>
+                  <a:srgbClr val="1F2933"/>
+                </a:solidFill>
+              </a:rPr>
+              <a:t>ML found the shape of the cognition effect, and a one-term rule captures it.</a:t>
             </a:r>
             <a:endParaRPr lang="en-US" sz="1700" dirty="0"/>
           </a:p>
@@ -6414,7 +6484,7 @@
         </p:nvSpPr>
         <p:spPr>
           <a:xfrm>
-            <a:off x="548640" y="4206240"/>
+            <a:off x="548640" y="4663440"/>
             <a:ext cx="5486400" cy="365760"/>
           </a:xfrm>
           <a:prstGeom prst="rect">
@@ -6450,7 +6520,7 @@
         </p:nvSpPr>
         <p:spPr>
           <a:xfrm>
-            <a:off x="548640" y="4617720"/>
+            <a:off x="548640" y="5074920"/>
             <a:ext cx="5486400" cy="1737360"/>
           </a:xfrm>
           <a:prstGeom prst="rect">
@@ -6526,7 +6596,7 @@
         </p:nvSpPr>
         <p:spPr>
           <a:xfrm>
-            <a:off x="6492240" y="4206240"/>
+            <a:off x="6492240" y="4663440"/>
             <a:ext cx="5120640" cy="365760"/>
           </a:xfrm>
           <a:prstGeom prst="rect">
@@ -6562,7 +6632,7 @@
         </p:nvSpPr>
         <p:spPr>
           <a:xfrm>
-            <a:off x="6492240" y="4617720"/>
+            <a:off x="6492240" y="5074920"/>
             <a:ext cx="5120640" cy="1463040"/>
           </a:xfrm>
           <a:prstGeom prst="roundRect">
@@ -6596,7 +6666,7 @@
         </p:nvSpPr>
         <p:spPr>
           <a:xfrm>
-            <a:off x="6720840" y="4709160"/>
+            <a:off x="6720840" y="5166360"/>
             <a:ext cx="4663440" cy="1280160"/>
           </a:xfrm>
           <a:prstGeom prst="rect">
@@ -6628,6 +6698,40 @@
               <a:t> Full record: github.com/euibeom135-cell/acop2026-hackathon-team1</a:t>
             </a:r>
             <a:endParaRPr lang="en-US" sz="1400" dirty="0"/>
+          </a:p>
+        </p:txBody>
+      </p:sp>
+      <p:sp>
+        <p:nvSpPr>
+          <p:cNvPr id="9" name="TextBox 8"/>
+          <p:cNvSpPr txBox="1"/>
+          <p:nvPr/>
+        </p:nvSpPr>
+        <p:spPr>
+          <a:xfrm>
+            <a:off x="548640" y="4069080"/>
+            <a:ext cx="11064240" cy="502920"/>
+          </a:xfrm>
+          <a:prstGeom prst="rect">
+            <a:avLst/>
+          </a:prstGeom>
+          <a:noFill/>
+        </p:spPr>
+        <p:txBody>
+          <a:bodyPr wrap="square" lIns="0" rIns="0" tIns="0" bIns="0">
+            <a:spAutoFit/>
+          </a:bodyPr>
+          <a:lstStyle/>
+          <a:p>
+            <a:r>
+              <a:rPr sz="1500" b="1">
+                <a:solidFill>
+                  <a:srgbClr val="000000"/>
+                </a:solidFill>
+                <a:latin typeface="Calibri"/>
+              </a:rPr>
+              <a:t>Machine learning's contribution was the functional form, not new features: a reproducible cognition threshold that a one-term rule captures. The split moves the scores, not the covariates.</a:t>
+            </a:r>
           </a:p>
         </p:txBody>
       </p:sp>
@@ -6698,7 +6802,7 @@
                   <a:srgbClr val="000000"/>
                 </a:solidFill>
               </a:rPr>
-              <a:t>Backup: results are robust to the train/test split (20 seeds)</a:t>
+              <a:t>Backup: the split moves the scores, not the covariates (20 seeds)</a:t>
             </a:r>
             <a:endParaRPr lang="en-US" sz="2800" dirty="0"/>
           </a:p>

</xml_diff>

<commit_message>
Slide 6: held-out metrics column (AUC, R²) and the mexiletine relative-change note
Co-Authored-By: Claude Fable 5.1 <noreply@anthropic.com>
</commit_message>
<xml_diff>
--- a/slides/Team1_DM1_slides.pptx
+++ b/slides/Team1_DM1_slides.pptx
@@ -1032,6 +1032,12 @@
           <a:p>
             <a:r>
               <a:t>Extra rigour available in backup: pre-registration before scoring, shuffled-outcome null, 20-seed sensitivity, four independent pipelines.</a:t>
+            </a:r>
+          </a:p>
+          <a:p/>
+          <a:p>
+            <a:r>
+              <a:t>Metrics column sources: AUC and R² from analysis/dm1_outputs/scoreboard_all_arms.csv (consensus linear / linear with cut-off / random forest rows); the mexiletine relative-change R² of about 0.15 is 5-fold cross-validation on training patients (team check, 13 Oct). On relative change CTG repeats edges ahead of myotonia severity (CV R² 0.15 vs 0.14); they are one axis, r = 0.88.</a:t>
             </a:r>
           </a:p>
         </p:txBody>
@@ -5210,1272 +5216,6 @@
           </a:p>
         </p:txBody>
       </p:sp>
-      <p:graphicFrame>
-        <p:nvGraphicFramePr>
-          <p:cNvPr id="7" name="Table 0"/>
-          <p:cNvGraphicFramePr>
-            <a:graphicFrameLocks noGrp="1"/>
-          </p:cNvGraphicFramePr>
-          <p:nvPr>
-            <p:extLst>
-              <p:ext uri="{D42A27DB-BD31-4B8C-83A1-F6EECF244321}">
-                <p14:modId xmlns:p14="http://schemas.microsoft.com/office/powerpoint/2010/main" val="1579011935"/>
-              </p:ext>
-            </p:extLst>
-          </p:nvPr>
-        </p:nvGraphicFramePr>
-        <p:xfrm>
-          <a:off x="548640" y="1417320"/>
-          <a:ext cx="11064240" cy="2611120"/>
-        </p:xfrm>
-        <a:graphic>
-          <a:graphicData uri="http://schemas.openxmlformats.org/drawingml/2006/table">
-            <a:tbl>
-              <a:tblPr/>
-              <a:tblGrid>
-                <a:gridCol w="2103120">
-                  <a:extLst>
-                    <a:ext uri="{9D8B030D-6E8A-4147-A177-3AD203B41FA5}">
-                      <a16:colId xmlns:a16="http://schemas.microsoft.com/office/drawing/2014/main" val="20000"/>
-                    </a:ext>
-                  </a:extLst>
-                </a:gridCol>
-                <a:gridCol w="1828800">
-                  <a:extLst>
-                    <a:ext uri="{9D8B030D-6E8A-4147-A177-3AD203B41FA5}">
-                      <a16:colId xmlns:a16="http://schemas.microsoft.com/office/drawing/2014/main" val="20001"/>
-                    </a:ext>
-                  </a:extLst>
-                </a:gridCol>
-                <a:gridCol w="1371600">
-                  <a:extLst>
-                    <a:ext uri="{9D8B030D-6E8A-4147-A177-3AD203B41FA5}">
-                      <a16:colId xmlns:a16="http://schemas.microsoft.com/office/drawing/2014/main" val="20002"/>
-                    </a:ext>
-                  </a:extLst>
-                </a:gridCol>
-                <a:gridCol w="2834640">
-                  <a:extLst>
-                    <a:ext uri="{9D8B030D-6E8A-4147-A177-3AD203B41FA5}">
-                      <a16:colId xmlns:a16="http://schemas.microsoft.com/office/drawing/2014/main" val="20003"/>
-                    </a:ext>
-                  </a:extLst>
-                </a:gridCol>
-                <a:gridCol w="2926080">
-                  <a:extLst>
-                    <a:ext uri="{9D8B030D-6E8A-4147-A177-3AD203B41FA5}">
-                      <a16:colId xmlns:a16="http://schemas.microsoft.com/office/drawing/2014/main" val="20004"/>
-                    </a:ext>
-                  </a:extLst>
-                </a:gridCol>
-              </a:tblGrid>
-              <a:tr h="548640">
-                <a:tc>
-                  <a:txBody>
-                    <a:bodyPr/>
-                    <a:lstStyle/>
-                    <a:p>
-                      <a:pPr marL="0" indent="0">
-                        <a:buNone/>
-                      </a:pPr>
-                      <a:r>
-                        <a:rPr lang="en-US" sz="1400" b="1" dirty="0">
-                          <a:solidFill>
-                            <a:srgbClr val="000000"/>
-                          </a:solidFill>
-                        </a:rPr>
-                        <a:t>Treatment</a:t>
-                      </a:r>
-                      <a:endParaRPr lang="en-US" sz="1400" dirty="0"/>
-                    </a:p>
-                  </a:txBody>
-                  <a:tcPr marL="88900" marR="88900" marT="63500" marB="63500" anchor="ctr">
-                    <a:lnL w="9525" cap="flat" cmpd="sng" algn="ctr">
-                      <a:solidFill>
-                        <a:srgbClr val="D5DAE0"/>
-                      </a:solidFill>
-                      <a:prstDash val="solid"/>
-                      <a:round/>
-                      <a:headEnd type="none" w="med" len="med"/>
-                      <a:tailEnd type="none" w="med" len="med"/>
-                    </a:lnL>
-                    <a:lnR w="9525" cap="flat" cmpd="sng" algn="ctr">
-                      <a:solidFill>
-                        <a:srgbClr val="D5DAE0"/>
-                      </a:solidFill>
-                      <a:prstDash val="solid"/>
-                      <a:round/>
-                      <a:headEnd type="none" w="med" len="med"/>
-                      <a:tailEnd type="none" w="med" len="med"/>
-                    </a:lnR>
-                    <a:lnT w="9525" cap="flat" cmpd="sng" algn="ctr">
-                      <a:solidFill>
-                        <a:srgbClr val="D5DAE0"/>
-                      </a:solidFill>
-                      <a:prstDash val="solid"/>
-                      <a:round/>
-                      <a:headEnd type="none" w="med" len="med"/>
-                      <a:tailEnd type="none" w="med" len="med"/>
-                    </a:lnT>
-                    <a:lnB w="9525" cap="flat" cmpd="sng" algn="ctr">
-                      <a:solidFill>
-                        <a:srgbClr val="D5DAE0"/>
-                      </a:solidFill>
-                      <a:prstDash val="solid"/>
-                      <a:round/>
-                      <a:headEnd type="none" w="med" len="med"/>
-                      <a:tailEnd type="none" w="med" len="med"/>
-                    </a:lnB>
-                    <a:solidFill>
-                      <a:srgbClr val="F2F2F2"/>
-                    </a:solidFill>
-                  </a:tcPr>
-                </a:tc>
-                <a:tc>
-                  <a:txBody>
-                    <a:bodyPr/>
-                    <a:lstStyle/>
-                    <a:p>
-                      <a:pPr marL="0" indent="0">
-                        <a:buNone/>
-                      </a:pPr>
-                      <a:r>
-                        <a:rPr lang="en-US" sz="1400" b="1" dirty="0">
-                          <a:solidFill>
-                            <a:srgbClr val="000000"/>
-                          </a:solidFill>
-                        </a:rPr>
-                        <a:t>Measure at baseline</a:t>
-                      </a:r>
-                      <a:endParaRPr lang="en-US" sz="1400" dirty="0"/>
-                    </a:p>
-                  </a:txBody>
-                  <a:tcPr marL="88900" marR="88900" marT="63500" marB="63500" anchor="ctr">
-                    <a:lnL w="9525" cap="flat" cmpd="sng" algn="ctr">
-                      <a:solidFill>
-                        <a:srgbClr val="D5DAE0"/>
-                      </a:solidFill>
-                      <a:prstDash val="solid"/>
-                      <a:round/>
-                      <a:headEnd type="none" w="med" len="med"/>
-                      <a:tailEnd type="none" w="med" len="med"/>
-                    </a:lnL>
-                    <a:lnR w="9525" cap="flat" cmpd="sng" algn="ctr">
-                      <a:solidFill>
-                        <a:srgbClr val="D5DAE0"/>
-                      </a:solidFill>
-                      <a:prstDash val="solid"/>
-                      <a:round/>
-                      <a:headEnd type="none" w="med" len="med"/>
-                      <a:tailEnd type="none" w="med" len="med"/>
-                    </a:lnR>
-                    <a:lnT w="9525" cap="flat" cmpd="sng" algn="ctr">
-                      <a:solidFill>
-                        <a:srgbClr val="D5DAE0"/>
-                      </a:solidFill>
-                      <a:prstDash val="solid"/>
-                      <a:round/>
-                      <a:headEnd type="none" w="med" len="med"/>
-                      <a:tailEnd type="none" w="med" len="med"/>
-                    </a:lnT>
-                    <a:lnB w="9525" cap="flat" cmpd="sng" algn="ctr">
-                      <a:solidFill>
-                        <a:srgbClr val="D5DAE0"/>
-                      </a:solidFill>
-                      <a:prstDash val="solid"/>
-                      <a:round/>
-                      <a:headEnd type="none" w="med" len="med"/>
-                      <a:tailEnd type="none" w="med" len="med"/>
-                    </a:lnB>
-                    <a:solidFill>
-                      <a:srgbClr val="F2F2F2"/>
-                    </a:solidFill>
-                  </a:tcPr>
-                </a:tc>
-                <a:tc>
-                  <a:txBody>
-                    <a:bodyPr/>
-                    <a:lstStyle/>
-                    <a:p>
-                      <a:pPr marL="0" indent="0">
-                        <a:buNone/>
-                      </a:pPr>
-                      <a:r>
-                        <a:rPr lang="en-US" sz="1400" b="1" dirty="0">
-                          <a:solidFill>
-                            <a:srgbClr val="000000"/>
-                          </a:solidFill>
-                        </a:rPr>
-                        <a:t>Cut-off</a:t>
-                      </a:r>
-                      <a:endParaRPr lang="en-US" sz="1400" dirty="0"/>
-                    </a:p>
-                  </a:txBody>
-                  <a:tcPr marL="88900" marR="88900" marT="63500" marB="63500" anchor="ctr">
-                    <a:lnL w="9525" cap="flat" cmpd="sng" algn="ctr">
-                      <a:solidFill>
-                        <a:srgbClr val="D5DAE0"/>
-                      </a:solidFill>
-                      <a:prstDash val="solid"/>
-                      <a:round/>
-                      <a:headEnd type="none" w="med" len="med"/>
-                      <a:tailEnd type="none" w="med" len="med"/>
-                    </a:lnL>
-                    <a:lnR w="9525" cap="flat" cmpd="sng" algn="ctr">
-                      <a:solidFill>
-                        <a:srgbClr val="D5DAE0"/>
-                      </a:solidFill>
-                      <a:prstDash val="solid"/>
-                      <a:round/>
-                      <a:headEnd type="none" w="med" len="med"/>
-                      <a:tailEnd type="none" w="med" len="med"/>
-                    </a:lnR>
-                    <a:lnT w="9525" cap="flat" cmpd="sng" algn="ctr">
-                      <a:solidFill>
-                        <a:srgbClr val="D5DAE0"/>
-                      </a:solidFill>
-                      <a:prstDash val="solid"/>
-                      <a:round/>
-                      <a:headEnd type="none" w="med" len="med"/>
-                      <a:tailEnd type="none" w="med" len="med"/>
-                    </a:lnT>
-                    <a:lnB w="9525" cap="flat" cmpd="sng" algn="ctr">
-                      <a:solidFill>
-                        <a:srgbClr val="D5DAE0"/>
-                      </a:solidFill>
-                      <a:prstDash val="solid"/>
-                      <a:round/>
-                      <a:headEnd type="none" w="med" len="med"/>
-                      <a:tailEnd type="none" w="med" len="med"/>
-                    </a:lnB>
-                    <a:solidFill>
-                      <a:srgbClr val="F2F2F2"/>
-                    </a:solidFill>
-                  </a:tcPr>
-                </a:tc>
-                <a:tc>
-                  <a:txBody>
-                    <a:bodyPr/>
-                    <a:lstStyle/>
-                    <a:p>
-                      <a:pPr marL="0" indent="0">
-                        <a:buNone/>
-                      </a:pPr>
-                      <a:r>
-                        <a:rPr lang="en-US" sz="1400" b="1" dirty="0">
-                          <a:solidFill>
-                            <a:srgbClr val="000000"/>
-                          </a:solidFill>
-                        </a:rPr>
-                        <a:t>Test patients who responded: above vs below cut-off</a:t>
-                      </a:r>
-                      <a:endParaRPr lang="en-US" sz="1400" dirty="0"/>
-                    </a:p>
-                  </a:txBody>
-                  <a:tcPr marL="88900" marR="88900" marT="63500" marB="63500" anchor="ctr">
-                    <a:lnL w="9525" cap="flat" cmpd="sng" algn="ctr">
-                      <a:solidFill>
-                        <a:srgbClr val="D5DAE0"/>
-                      </a:solidFill>
-                      <a:prstDash val="solid"/>
-                      <a:round/>
-                      <a:headEnd type="none" w="med" len="med"/>
-                      <a:tailEnd type="none" w="med" len="med"/>
-                    </a:lnL>
-                    <a:lnR w="9525" cap="flat" cmpd="sng" algn="ctr">
-                      <a:solidFill>
-                        <a:srgbClr val="D5DAE0"/>
-                      </a:solidFill>
-                      <a:prstDash val="solid"/>
-                      <a:round/>
-                      <a:headEnd type="none" w="med" len="med"/>
-                      <a:tailEnd type="none" w="med" len="med"/>
-                    </a:lnR>
-                    <a:lnT w="9525" cap="flat" cmpd="sng" algn="ctr">
-                      <a:solidFill>
-                        <a:srgbClr val="D5DAE0"/>
-                      </a:solidFill>
-                      <a:prstDash val="solid"/>
-                      <a:round/>
-                      <a:headEnd type="none" w="med" len="med"/>
-                      <a:tailEnd type="none" w="med" len="med"/>
-                    </a:lnT>
-                    <a:lnB w="9525" cap="flat" cmpd="sng" algn="ctr">
-                      <a:solidFill>
-                        <a:srgbClr val="D5DAE0"/>
-                      </a:solidFill>
-                      <a:prstDash val="solid"/>
-                      <a:round/>
-                      <a:headEnd type="none" w="med" len="med"/>
-                      <a:tailEnd type="none" w="med" len="med"/>
-                    </a:lnB>
-                    <a:solidFill>
-                      <a:srgbClr val="F2F2F2"/>
-                    </a:solidFill>
-                  </a:tcPr>
-                </a:tc>
-                <a:tc>
-                  <a:txBody>
-                    <a:bodyPr/>
-                    <a:lstStyle/>
-                    <a:p>
-                      <a:pPr marL="0" indent="0">
-                        <a:buNone/>
-                      </a:pPr>
-                      <a:r>
-                        <a:rPr lang="en-US" sz="1400" b="1" dirty="0">
-                          <a:solidFill>
-                            <a:srgbClr val="000000"/>
-                          </a:solidFill>
-                        </a:rPr>
-                        <a:t>Trial design</a:t>
-                      </a:r>
-                      <a:endParaRPr lang="en-US" sz="1400" dirty="0"/>
-                    </a:p>
-                  </a:txBody>
-                  <a:tcPr marL="88900" marR="88900" marT="63500" marB="63500" anchor="ctr">
-                    <a:lnL w="9525" cap="flat" cmpd="sng" algn="ctr">
-                      <a:solidFill>
-                        <a:srgbClr val="D5DAE0"/>
-                      </a:solidFill>
-                      <a:prstDash val="solid"/>
-                      <a:round/>
-                      <a:headEnd type="none" w="med" len="med"/>
-                      <a:tailEnd type="none" w="med" len="med"/>
-                    </a:lnL>
-                    <a:lnR w="9525" cap="flat" cmpd="sng" algn="ctr">
-                      <a:solidFill>
-                        <a:srgbClr val="D5DAE0"/>
-                      </a:solidFill>
-                      <a:prstDash val="solid"/>
-                      <a:round/>
-                      <a:headEnd type="none" w="med" len="med"/>
-                      <a:tailEnd type="none" w="med" len="med"/>
-                    </a:lnR>
-                    <a:lnT w="9525" cap="flat" cmpd="sng" algn="ctr">
-                      <a:solidFill>
-                        <a:srgbClr val="D5DAE0"/>
-                      </a:solidFill>
-                      <a:prstDash val="solid"/>
-                      <a:round/>
-                      <a:headEnd type="none" w="med" len="med"/>
-                      <a:tailEnd type="none" w="med" len="med"/>
-                    </a:lnT>
-                    <a:lnB w="9525" cap="flat" cmpd="sng" algn="ctr">
-                      <a:solidFill>
-                        <a:srgbClr val="D5DAE0"/>
-                      </a:solidFill>
-                      <a:prstDash val="solid"/>
-                      <a:round/>
-                      <a:headEnd type="none" w="med" len="med"/>
-                      <a:tailEnd type="none" w="med" len="med"/>
-                    </a:lnB>
-                    <a:solidFill>
-                      <a:srgbClr val="F2F2F2"/>
-                    </a:solidFill>
-                  </a:tcPr>
-                </a:tc>
-                <a:extLst>
-                  <a:ext uri="{0D108BD9-81ED-4DB2-BD59-A6C34878D82A}">
-                    <a16:rowId xmlns:a16="http://schemas.microsoft.com/office/drawing/2014/main" val="10000"/>
-                  </a:ext>
-                </a:extLst>
-              </a:tr>
-              <a:tr h="685800">
-                <a:tc>
-                  <a:txBody>
-                    <a:bodyPr/>
-                    <a:lstStyle/>
-                    <a:p>
-                      <a:pPr marL="0" indent="0">
-                        <a:buNone/>
-                      </a:pPr>
-                      <a:r>
-                        <a:rPr lang="en-US" sz="1400" b="1" dirty="0">
-                          <a:solidFill>
-                            <a:srgbClr val="1F2933"/>
-                          </a:solidFill>
-                        </a:rPr>
-                        <a:t>Mexiletine</a:t>
-                      </a:r>
-                      <a:endParaRPr lang="en-US" sz="1400" dirty="0"/>
-                    </a:p>
-                  </a:txBody>
-                  <a:tcPr marL="88900" marR="88900" marT="63500" marB="63500" anchor="ctr">
-                    <a:lnL w="9525" cap="flat" cmpd="sng" algn="ctr">
-                      <a:solidFill>
-                        <a:srgbClr val="D5DAE0"/>
-                      </a:solidFill>
-                      <a:prstDash val="solid"/>
-                      <a:round/>
-                      <a:headEnd type="none" w="med" len="med"/>
-                      <a:tailEnd type="none" w="med" len="med"/>
-                    </a:lnL>
-                    <a:lnR w="9525" cap="flat" cmpd="sng" algn="ctr">
-                      <a:solidFill>
-                        <a:srgbClr val="D5DAE0"/>
-                      </a:solidFill>
-                      <a:prstDash val="solid"/>
-                      <a:round/>
-                      <a:headEnd type="none" w="med" len="med"/>
-                      <a:tailEnd type="none" w="med" len="med"/>
-                    </a:lnR>
-                    <a:lnT w="9525" cap="flat" cmpd="sng" algn="ctr">
-                      <a:solidFill>
-                        <a:srgbClr val="D5DAE0"/>
-                      </a:solidFill>
-                      <a:prstDash val="solid"/>
-                      <a:round/>
-                      <a:headEnd type="none" w="med" len="med"/>
-                      <a:tailEnd type="none" w="med" len="med"/>
-                    </a:lnT>
-                    <a:lnB w="9525" cap="flat" cmpd="sng" algn="ctr">
-                      <a:solidFill>
-                        <a:srgbClr val="D5DAE0"/>
-                      </a:solidFill>
-                      <a:prstDash val="solid"/>
-                      <a:round/>
-                      <a:headEnd type="none" w="med" len="med"/>
-                      <a:tailEnd type="none" w="med" len="med"/>
-                    </a:lnB>
-                  </a:tcPr>
-                </a:tc>
-                <a:tc>
-                  <a:txBody>
-                    <a:bodyPr/>
-                    <a:lstStyle/>
-                    <a:p>
-                      <a:pPr marL="0" indent="0">
-                        <a:buNone/>
-                      </a:pPr>
-                      <a:r>
-                        <a:rPr lang="en-US" sz="1400" dirty="0">
-                          <a:solidFill>
-                            <a:srgbClr val="1F2933"/>
-                          </a:solidFill>
-                        </a:rPr>
-                        <a:t>Myotonia severity</a:t>
-                      </a:r>
-                      <a:endParaRPr lang="en-US" sz="1400" dirty="0"/>
-                    </a:p>
-                  </a:txBody>
-                  <a:tcPr marL="88900" marR="88900" marT="63500" marB="63500" anchor="ctr">
-                    <a:lnL w="9525" cap="flat" cmpd="sng" algn="ctr">
-                      <a:solidFill>
-                        <a:srgbClr val="D5DAE0"/>
-                      </a:solidFill>
-                      <a:prstDash val="solid"/>
-                      <a:round/>
-                      <a:headEnd type="none" w="med" len="med"/>
-                      <a:tailEnd type="none" w="med" len="med"/>
-                    </a:lnL>
-                    <a:lnR w="9525" cap="flat" cmpd="sng" algn="ctr">
-                      <a:solidFill>
-                        <a:srgbClr val="D5DAE0"/>
-                      </a:solidFill>
-                      <a:prstDash val="solid"/>
-                      <a:round/>
-                      <a:headEnd type="none" w="med" len="med"/>
-                      <a:tailEnd type="none" w="med" len="med"/>
-                    </a:lnR>
-                    <a:lnT w="9525" cap="flat" cmpd="sng" algn="ctr">
-                      <a:solidFill>
-                        <a:srgbClr val="D5DAE0"/>
-                      </a:solidFill>
-                      <a:prstDash val="solid"/>
-                      <a:round/>
-                      <a:headEnd type="none" w="med" len="med"/>
-                      <a:tailEnd type="none" w="med" len="med"/>
-                    </a:lnT>
-                    <a:lnB w="9525" cap="flat" cmpd="sng" algn="ctr">
-                      <a:solidFill>
-                        <a:srgbClr val="D5DAE0"/>
-                      </a:solidFill>
-                      <a:prstDash val="solid"/>
-                      <a:round/>
-                      <a:headEnd type="none" w="med" len="med"/>
-                      <a:tailEnd type="none" w="med" len="med"/>
-                    </a:lnB>
-                  </a:tcPr>
-                </a:tc>
-                <a:tc>
-                  <a:txBody>
-                    <a:bodyPr/>
-                    <a:lstStyle/>
-                    <a:p>
-                      <a:pPr marL="0" indent="0">
-                        <a:buNone/>
-                      </a:pPr>
-                      <a:r>
-                        <a:rPr lang="en-US" sz="1400" dirty="0">
-                          <a:solidFill>
-                            <a:srgbClr val="1F2933"/>
-                          </a:solidFill>
-                        </a:rPr>
-                        <a:t>≥ about 5</a:t>
-                      </a:r>
-                      <a:endParaRPr lang="en-US" sz="1400" dirty="0"/>
-                    </a:p>
-                  </a:txBody>
-                  <a:tcPr marL="88900" marR="88900" marT="63500" marB="63500" anchor="ctr">
-                    <a:lnL w="9525" cap="flat" cmpd="sng" algn="ctr">
-                      <a:solidFill>
-                        <a:srgbClr val="D5DAE0"/>
-                      </a:solidFill>
-                      <a:prstDash val="solid"/>
-                      <a:round/>
-                      <a:headEnd type="none" w="med" len="med"/>
-                      <a:tailEnd type="none" w="med" len="med"/>
-                    </a:lnL>
-                    <a:lnR w="9525" cap="flat" cmpd="sng" algn="ctr">
-                      <a:solidFill>
-                        <a:srgbClr val="D5DAE0"/>
-                      </a:solidFill>
-                      <a:prstDash val="solid"/>
-                      <a:round/>
-                      <a:headEnd type="none" w="med" len="med"/>
-                      <a:tailEnd type="none" w="med" len="med"/>
-                    </a:lnR>
-                    <a:lnT w="9525" cap="flat" cmpd="sng" algn="ctr">
-                      <a:solidFill>
-                        <a:srgbClr val="D5DAE0"/>
-                      </a:solidFill>
-                      <a:prstDash val="solid"/>
-                      <a:round/>
-                      <a:headEnd type="none" w="med" len="med"/>
-                      <a:tailEnd type="none" w="med" len="med"/>
-                    </a:lnT>
-                    <a:lnB w="9525" cap="flat" cmpd="sng" algn="ctr">
-                      <a:solidFill>
-                        <a:srgbClr val="D5DAE0"/>
-                      </a:solidFill>
-                      <a:prstDash val="solid"/>
-                      <a:round/>
-                      <a:headEnd type="none" w="med" len="med"/>
-                      <a:tailEnd type="none" w="med" len="med"/>
-                    </a:lnB>
-                  </a:tcPr>
-                </a:tc>
-                <a:tc>
-                  <a:txBody>
-                    <a:bodyPr/>
-                    <a:lstStyle/>
-                    <a:p>
-                      <a:pPr marL="0" indent="0">
-                        <a:buNone/>
-                      </a:pPr>
-                      <a:r>
-                        <a:rPr lang="en-US" sz="1400" dirty="0">
-                          <a:solidFill>
-                            <a:srgbClr val="1F2933"/>
-                          </a:solidFill>
-                        </a:rPr>
-                        <a:t>10 of 21 (48%) vs 2 of 20 (10%)</a:t>
-                      </a:r>
-                      <a:endParaRPr lang="en-US" sz="1400" dirty="0"/>
-                    </a:p>
-                  </a:txBody>
-                  <a:tcPr marL="88900" marR="88900" marT="63500" marB="63500" anchor="ctr">
-                    <a:lnL w="9525" cap="flat" cmpd="sng" algn="ctr">
-                      <a:solidFill>
-                        <a:srgbClr val="D5DAE0"/>
-                      </a:solidFill>
-                      <a:prstDash val="solid"/>
-                      <a:round/>
-                      <a:headEnd type="none" w="med" len="med"/>
-                      <a:tailEnd type="none" w="med" len="med"/>
-                    </a:lnL>
-                    <a:lnR w="9525" cap="flat" cmpd="sng" algn="ctr">
-                      <a:solidFill>
-                        <a:srgbClr val="D5DAE0"/>
-                      </a:solidFill>
-                      <a:prstDash val="solid"/>
-                      <a:round/>
-                      <a:headEnd type="none" w="med" len="med"/>
-                      <a:tailEnd type="none" w="med" len="med"/>
-                    </a:lnR>
-                    <a:lnT w="9525" cap="flat" cmpd="sng" algn="ctr">
-                      <a:solidFill>
-                        <a:srgbClr val="D5DAE0"/>
-                      </a:solidFill>
-                      <a:prstDash val="solid"/>
-                      <a:round/>
-                      <a:headEnd type="none" w="med" len="med"/>
-                      <a:tailEnd type="none" w="med" len="med"/>
-                    </a:lnT>
-                    <a:lnB w="9525" cap="flat" cmpd="sng" algn="ctr">
-                      <a:solidFill>
-                        <a:srgbClr val="D5DAE0"/>
-                      </a:solidFill>
-                      <a:prstDash val="solid"/>
-                      <a:round/>
-                      <a:headEnd type="none" w="med" len="med"/>
-                      <a:tailEnd type="none" w="med" len="med"/>
-                    </a:lnB>
-                  </a:tcPr>
-                </a:tc>
-                <a:tc>
-                  <a:txBody>
-                    <a:bodyPr/>
-                    <a:lstStyle/>
-                    <a:p>
-                      <a:pPr marL="0" indent="0">
-                        <a:buNone/>
-                      </a:pPr>
-                      <a:r>
-                        <a:rPr lang="en-US" sz="1400" dirty="0">
-                          <a:solidFill>
-                            <a:srgbClr val="1F2933"/>
-                          </a:solidFill>
-                        </a:rPr>
-                        <a:t>Enrol on symptom severity, not diagnosis alone</a:t>
-                      </a:r>
-                      <a:endParaRPr lang="en-US" sz="1400" dirty="0"/>
-                    </a:p>
-                  </a:txBody>
-                  <a:tcPr marL="88900" marR="88900" marT="63500" marB="63500" anchor="ctr">
-                    <a:lnL w="9525" cap="flat" cmpd="sng" algn="ctr">
-                      <a:solidFill>
-                        <a:srgbClr val="D5DAE0"/>
-                      </a:solidFill>
-                      <a:prstDash val="solid"/>
-                      <a:round/>
-                      <a:headEnd type="none" w="med" len="med"/>
-                      <a:tailEnd type="none" w="med" len="med"/>
-                    </a:lnL>
-                    <a:lnR w="9525" cap="flat" cmpd="sng" algn="ctr">
-                      <a:solidFill>
-                        <a:srgbClr val="D5DAE0"/>
-                      </a:solidFill>
-                      <a:prstDash val="solid"/>
-                      <a:round/>
-                      <a:headEnd type="none" w="med" len="med"/>
-                      <a:tailEnd type="none" w="med" len="med"/>
-                    </a:lnR>
-                    <a:lnT w="9525" cap="flat" cmpd="sng" algn="ctr">
-                      <a:solidFill>
-                        <a:srgbClr val="D5DAE0"/>
-                      </a:solidFill>
-                      <a:prstDash val="solid"/>
-                      <a:round/>
-                      <a:headEnd type="none" w="med" len="med"/>
-                      <a:tailEnd type="none" w="med" len="med"/>
-                    </a:lnT>
-                    <a:lnB w="9525" cap="flat" cmpd="sng" algn="ctr">
-                      <a:solidFill>
-                        <a:srgbClr val="D5DAE0"/>
-                      </a:solidFill>
-                      <a:prstDash val="solid"/>
-                      <a:round/>
-                      <a:headEnd type="none" w="med" len="med"/>
-                      <a:tailEnd type="none" w="med" len="med"/>
-                    </a:lnB>
-                  </a:tcPr>
-                </a:tc>
-                <a:extLst>
-                  <a:ext uri="{0D108BD9-81ED-4DB2-BD59-A6C34878D82A}">
-                    <a16:rowId xmlns:a16="http://schemas.microsoft.com/office/drawing/2014/main" val="10001"/>
-                  </a:ext>
-                </a:extLst>
-              </a:tr>
-              <a:tr h="685800">
-                <a:tc>
-                  <a:txBody>
-                    <a:bodyPr/>
-                    <a:lstStyle/>
-                    <a:p>
-                      <a:pPr marL="0" indent="0">
-                        <a:buNone/>
-                      </a:pPr>
-                      <a:r>
-                        <a:rPr lang="en-US" sz="1400" b="1" dirty="0">
-                          <a:solidFill>
-                            <a:srgbClr val="1F2933"/>
-                          </a:solidFill>
-                        </a:rPr>
-                        <a:t>Antisense oligonucleotide</a:t>
-                      </a:r>
-                      <a:endParaRPr lang="en-US" sz="1400" dirty="0"/>
-                    </a:p>
-                  </a:txBody>
-                  <a:tcPr marL="88900" marR="88900" marT="63500" marB="63500" anchor="ctr">
-                    <a:lnL w="9525" cap="flat" cmpd="sng" algn="ctr">
-                      <a:solidFill>
-                        <a:srgbClr val="D5DAE0"/>
-                      </a:solidFill>
-                      <a:prstDash val="solid"/>
-                      <a:round/>
-                      <a:headEnd type="none" w="med" len="med"/>
-                      <a:tailEnd type="none" w="med" len="med"/>
-                    </a:lnL>
-                    <a:lnR w="9525" cap="flat" cmpd="sng" algn="ctr">
-                      <a:solidFill>
-                        <a:srgbClr val="D5DAE0"/>
-                      </a:solidFill>
-                      <a:prstDash val="solid"/>
-                      <a:round/>
-                      <a:headEnd type="none" w="med" len="med"/>
-                      <a:tailEnd type="none" w="med" len="med"/>
-                    </a:lnR>
-                    <a:lnT w="9525" cap="flat" cmpd="sng" algn="ctr">
-                      <a:solidFill>
-                        <a:srgbClr val="D5DAE0"/>
-                      </a:solidFill>
-                      <a:prstDash val="solid"/>
-                      <a:round/>
-                      <a:headEnd type="none" w="med" len="med"/>
-                      <a:tailEnd type="none" w="med" len="med"/>
-                    </a:lnT>
-                    <a:lnB w="9525" cap="flat" cmpd="sng" algn="ctr">
-                      <a:solidFill>
-                        <a:srgbClr val="D5DAE0"/>
-                      </a:solidFill>
-                      <a:prstDash val="solid"/>
-                      <a:round/>
-                      <a:headEnd type="none" w="med" len="med"/>
-                      <a:tailEnd type="none" w="med" len="med"/>
-                    </a:lnB>
-                  </a:tcPr>
-                </a:tc>
-                <a:tc>
-                  <a:txBody>
-                    <a:bodyPr/>
-                    <a:lstStyle/>
-                    <a:p>
-                      <a:pPr marL="0" indent="0">
-                        <a:buNone/>
-                      </a:pPr>
-                      <a:r>
-                        <a:rPr lang="en-US" sz="1400" dirty="0">
-                          <a:solidFill>
-                            <a:srgbClr val="1F2933"/>
-                          </a:solidFill>
-                        </a:rPr>
-                        <a:t>CTG repeat length</a:t>
-                      </a:r>
-                      <a:endParaRPr lang="en-US" sz="1400" dirty="0"/>
-                    </a:p>
-                  </a:txBody>
-                  <a:tcPr marL="88900" marR="88900" marT="63500" marB="63500" anchor="ctr">
-                    <a:lnL w="9525" cap="flat" cmpd="sng" algn="ctr">
-                      <a:solidFill>
-                        <a:srgbClr val="D5DAE0"/>
-                      </a:solidFill>
-                      <a:prstDash val="solid"/>
-                      <a:round/>
-                      <a:headEnd type="none" w="med" len="med"/>
-                      <a:tailEnd type="none" w="med" len="med"/>
-                    </a:lnL>
-                    <a:lnR w="9525" cap="flat" cmpd="sng" algn="ctr">
-                      <a:solidFill>
-                        <a:srgbClr val="D5DAE0"/>
-                      </a:solidFill>
-                      <a:prstDash val="solid"/>
-                      <a:round/>
-                      <a:headEnd type="none" w="med" len="med"/>
-                      <a:tailEnd type="none" w="med" len="med"/>
-                    </a:lnR>
-                    <a:lnT w="9525" cap="flat" cmpd="sng" algn="ctr">
-                      <a:solidFill>
-                        <a:srgbClr val="D5DAE0"/>
-                      </a:solidFill>
-                      <a:prstDash val="solid"/>
-                      <a:round/>
-                      <a:headEnd type="none" w="med" len="med"/>
-                      <a:tailEnd type="none" w="med" len="med"/>
-                    </a:lnT>
-                    <a:lnB w="9525" cap="flat" cmpd="sng" algn="ctr">
-                      <a:solidFill>
-                        <a:srgbClr val="D5DAE0"/>
-                      </a:solidFill>
-                      <a:prstDash val="solid"/>
-                      <a:round/>
-                      <a:headEnd type="none" w="med" len="med"/>
-                      <a:tailEnd type="none" w="med" len="med"/>
-                    </a:lnB>
-                  </a:tcPr>
-                </a:tc>
-                <a:tc>
-                  <a:txBody>
-                    <a:bodyPr/>
-                    <a:lstStyle/>
-                    <a:p>
-                      <a:pPr marL="0" indent="0">
-                        <a:buNone/>
-                      </a:pPr>
-                      <a:r>
-                        <a:rPr lang="en-US" sz="1400" dirty="0">
-                          <a:solidFill>
-                            <a:srgbClr val="1F2933"/>
-                          </a:solidFill>
-                        </a:rPr>
-                        <a:t>≥ about 350</a:t>
-                      </a:r>
-                      <a:endParaRPr lang="en-US" sz="1400" dirty="0"/>
-                    </a:p>
-                  </a:txBody>
-                  <a:tcPr marL="88900" marR="88900" marT="63500" marB="63500" anchor="ctr">
-                    <a:lnL w="9525" cap="flat" cmpd="sng" algn="ctr">
-                      <a:solidFill>
-                        <a:srgbClr val="D5DAE0"/>
-                      </a:solidFill>
-                      <a:prstDash val="solid"/>
-                      <a:round/>
-                      <a:headEnd type="none" w="med" len="med"/>
-                      <a:tailEnd type="none" w="med" len="med"/>
-                    </a:lnL>
-                    <a:lnR w="9525" cap="flat" cmpd="sng" algn="ctr">
-                      <a:solidFill>
-                        <a:srgbClr val="D5DAE0"/>
-                      </a:solidFill>
-                      <a:prstDash val="solid"/>
-                      <a:round/>
-                      <a:headEnd type="none" w="med" len="med"/>
-                      <a:tailEnd type="none" w="med" len="med"/>
-                    </a:lnR>
-                    <a:lnT w="9525" cap="flat" cmpd="sng" algn="ctr">
-                      <a:solidFill>
-                        <a:srgbClr val="D5DAE0"/>
-                      </a:solidFill>
-                      <a:prstDash val="solid"/>
-                      <a:round/>
-                      <a:headEnd type="none" w="med" len="med"/>
-                      <a:tailEnd type="none" w="med" len="med"/>
-                    </a:lnT>
-                    <a:lnB w="9525" cap="flat" cmpd="sng" algn="ctr">
-                      <a:solidFill>
-                        <a:srgbClr val="D5DAE0"/>
-                      </a:solidFill>
-                      <a:prstDash val="solid"/>
-                      <a:round/>
-                      <a:headEnd type="none" w="med" len="med"/>
-                      <a:tailEnd type="none" w="med" len="med"/>
-                    </a:lnB>
-                  </a:tcPr>
-                </a:tc>
-                <a:tc>
-                  <a:txBody>
-                    <a:bodyPr/>
-                    <a:lstStyle/>
-                    <a:p>
-                      <a:pPr marL="0" indent="0">
-                        <a:buNone/>
-                      </a:pPr>
-                      <a:r>
-                        <a:rPr lang="en-US" sz="1400" dirty="0">
-                          <a:solidFill>
-                            <a:srgbClr val="1F2933"/>
-                          </a:solidFill>
-                        </a:rPr>
-                        <a:t>10 of 17 (59%) vs 8 of 26 (31%)</a:t>
-                      </a:r>
-                      <a:endParaRPr lang="en-US" sz="1400" dirty="0"/>
-                    </a:p>
-                  </a:txBody>
-                  <a:tcPr marL="88900" marR="88900" marT="63500" marB="63500" anchor="ctr">
-                    <a:lnL w="9525" cap="flat" cmpd="sng" algn="ctr">
-                      <a:solidFill>
-                        <a:srgbClr val="D5DAE0"/>
-                      </a:solidFill>
-                      <a:prstDash val="solid"/>
-                      <a:round/>
-                      <a:headEnd type="none" w="med" len="med"/>
-                      <a:tailEnd type="none" w="med" len="med"/>
-                    </a:lnL>
-                    <a:lnR w="9525" cap="flat" cmpd="sng" algn="ctr">
-                      <a:solidFill>
-                        <a:srgbClr val="D5DAE0"/>
-                      </a:solidFill>
-                      <a:prstDash val="solid"/>
-                      <a:round/>
-                      <a:headEnd type="none" w="med" len="med"/>
-                      <a:tailEnd type="none" w="med" len="med"/>
-                    </a:lnR>
-                    <a:lnT w="9525" cap="flat" cmpd="sng" algn="ctr">
-                      <a:solidFill>
-                        <a:srgbClr val="D5DAE0"/>
-                      </a:solidFill>
-                      <a:prstDash val="solid"/>
-                      <a:round/>
-                      <a:headEnd type="none" w="med" len="med"/>
-                      <a:tailEnd type="none" w="med" len="med"/>
-                    </a:lnT>
-                    <a:lnB w="9525" cap="flat" cmpd="sng" algn="ctr">
-                      <a:solidFill>
-                        <a:srgbClr val="D5DAE0"/>
-                      </a:solidFill>
-                      <a:prstDash val="solid"/>
-                      <a:round/>
-                      <a:headEnd type="none" w="med" len="med"/>
-                      <a:tailEnd type="none" w="med" len="med"/>
-                    </a:lnB>
-                  </a:tcPr>
-                </a:tc>
-                <a:tc>
-                  <a:txBody>
-                    <a:bodyPr/>
-                    <a:lstStyle/>
-                    <a:p>
-                      <a:pPr marL="0" indent="0">
-                        <a:buNone/>
-                      </a:pPr>
-                      <a:r>
-                        <a:rPr lang="en-US" sz="1400" dirty="0">
-                          <a:solidFill>
-                            <a:srgbClr val="1F2933"/>
-                          </a:solidFill>
-                        </a:rPr>
-                        <a:t>Stratify randomisation on repeat length</a:t>
-                      </a:r>
-                      <a:endParaRPr lang="en-US" sz="1400" dirty="0"/>
-                    </a:p>
-                  </a:txBody>
-                  <a:tcPr marL="88900" marR="88900" marT="63500" marB="63500" anchor="ctr">
-                    <a:lnL w="9525" cap="flat" cmpd="sng" algn="ctr">
-                      <a:solidFill>
-                        <a:srgbClr val="D5DAE0"/>
-                      </a:solidFill>
-                      <a:prstDash val="solid"/>
-                      <a:round/>
-                      <a:headEnd type="none" w="med" len="med"/>
-                      <a:tailEnd type="none" w="med" len="med"/>
-                    </a:lnL>
-                    <a:lnR w="9525" cap="flat" cmpd="sng" algn="ctr">
-                      <a:solidFill>
-                        <a:srgbClr val="D5DAE0"/>
-                      </a:solidFill>
-                      <a:prstDash val="solid"/>
-                      <a:round/>
-                      <a:headEnd type="none" w="med" len="med"/>
-                      <a:tailEnd type="none" w="med" len="med"/>
-                    </a:lnR>
-                    <a:lnT w="9525" cap="flat" cmpd="sng" algn="ctr">
-                      <a:solidFill>
-                        <a:srgbClr val="D5DAE0"/>
-                      </a:solidFill>
-                      <a:prstDash val="solid"/>
-                      <a:round/>
-                      <a:headEnd type="none" w="med" len="med"/>
-                      <a:tailEnd type="none" w="med" len="med"/>
-                    </a:lnT>
-                    <a:lnB w="9525" cap="flat" cmpd="sng" algn="ctr">
-                      <a:solidFill>
-                        <a:srgbClr val="D5DAE0"/>
-                      </a:solidFill>
-                      <a:prstDash val="solid"/>
-                      <a:round/>
-                      <a:headEnd type="none" w="med" len="med"/>
-                      <a:tailEnd type="none" w="med" len="med"/>
-                    </a:lnB>
-                  </a:tcPr>
-                </a:tc>
-                <a:extLst>
-                  <a:ext uri="{0D108BD9-81ED-4DB2-BD59-A6C34878D82A}">
-                    <a16:rowId xmlns:a16="http://schemas.microsoft.com/office/drawing/2014/main" val="10002"/>
-                  </a:ext>
-                </a:extLst>
-              </a:tr>
-              <a:tr h="685800">
-                <a:tc>
-                  <a:txBody>
-                    <a:bodyPr/>
-                    <a:lstStyle/>
-                    <a:p>
-                      <a:pPr marL="0" indent="0">
-                        <a:buNone/>
-                      </a:pPr>
-                      <a:r>
-                        <a:rPr lang="en-US" sz="1400" b="1" dirty="0">
-                          <a:solidFill>
-                            <a:srgbClr val="1F2933"/>
-                          </a:solidFill>
-                        </a:rPr>
-                        <a:t>Tideglusib</a:t>
-                      </a:r>
-                      <a:endParaRPr lang="en-US" sz="1400" dirty="0"/>
-                    </a:p>
-                  </a:txBody>
-                  <a:tcPr marL="88900" marR="88900" marT="63500" marB="63500" anchor="ctr">
-                    <a:lnL w="9525" cap="flat" cmpd="sng" algn="ctr">
-                      <a:solidFill>
-                        <a:srgbClr val="D5DAE0"/>
-                      </a:solidFill>
-                      <a:prstDash val="solid"/>
-                      <a:round/>
-                      <a:headEnd type="none" w="med" len="med"/>
-                      <a:tailEnd type="none" w="med" len="med"/>
-                    </a:lnL>
-                    <a:lnR w="9525" cap="flat" cmpd="sng" algn="ctr">
-                      <a:solidFill>
-                        <a:srgbClr val="D5DAE0"/>
-                      </a:solidFill>
-                      <a:prstDash val="solid"/>
-                      <a:round/>
-                      <a:headEnd type="none" w="med" len="med"/>
-                      <a:tailEnd type="none" w="med" len="med"/>
-                    </a:lnR>
-                    <a:lnT w="9525" cap="flat" cmpd="sng" algn="ctr">
-                      <a:solidFill>
-                        <a:srgbClr val="D5DAE0"/>
-                      </a:solidFill>
-                      <a:prstDash val="solid"/>
-                      <a:round/>
-                      <a:headEnd type="none" w="med" len="med"/>
-                      <a:tailEnd type="none" w="med" len="med"/>
-                    </a:lnT>
-                    <a:lnB w="9525" cap="flat" cmpd="sng" algn="ctr">
-                      <a:solidFill>
-                        <a:srgbClr val="D5DAE0"/>
-                      </a:solidFill>
-                      <a:prstDash val="solid"/>
-                      <a:round/>
-                      <a:headEnd type="none" w="med" len="med"/>
-                      <a:tailEnd type="none" w="med" len="med"/>
-                    </a:lnB>
-                  </a:tcPr>
-                </a:tc>
-                <a:tc>
-                  <a:txBody>
-                    <a:bodyPr/>
-                    <a:lstStyle/>
-                    <a:p>
-                      <a:pPr marL="0" indent="0">
-                        <a:buNone/>
-                      </a:pPr>
-                      <a:r>
-                        <a:rPr lang="en-US" sz="1400" dirty="0">
-                          <a:solidFill>
-                            <a:srgbClr val="1F2933"/>
-                          </a:solidFill>
-                        </a:rPr>
-                        <a:t>Cognitive function</a:t>
-                      </a:r>
-                      <a:endParaRPr lang="en-US" sz="1400" dirty="0"/>
-                    </a:p>
-                  </a:txBody>
-                  <a:tcPr marL="88900" marR="88900" marT="63500" marB="63500" anchor="ctr">
-                    <a:lnL w="9525" cap="flat" cmpd="sng" algn="ctr">
-                      <a:solidFill>
-                        <a:srgbClr val="D5DAE0"/>
-                      </a:solidFill>
-                      <a:prstDash val="solid"/>
-                      <a:round/>
-                      <a:headEnd type="none" w="med" len="med"/>
-                      <a:tailEnd type="none" w="med" len="med"/>
-                    </a:lnL>
-                    <a:lnR w="9525" cap="flat" cmpd="sng" algn="ctr">
-                      <a:solidFill>
-                        <a:srgbClr val="D5DAE0"/>
-                      </a:solidFill>
-                      <a:prstDash val="solid"/>
-                      <a:round/>
-                      <a:headEnd type="none" w="med" len="med"/>
-                      <a:tailEnd type="none" w="med" len="med"/>
-                    </a:lnR>
-                    <a:lnT w="9525" cap="flat" cmpd="sng" algn="ctr">
-                      <a:solidFill>
-                        <a:srgbClr val="D5DAE0"/>
-                      </a:solidFill>
-                      <a:prstDash val="solid"/>
-                      <a:round/>
-                      <a:headEnd type="none" w="med" len="med"/>
-                      <a:tailEnd type="none" w="med" len="med"/>
-                    </a:lnT>
-                    <a:lnB w="9525" cap="flat" cmpd="sng" algn="ctr">
-                      <a:solidFill>
-                        <a:srgbClr val="D5DAE0"/>
-                      </a:solidFill>
-                      <a:prstDash val="solid"/>
-                      <a:round/>
-                      <a:headEnd type="none" w="med" len="med"/>
-                      <a:tailEnd type="none" w="med" len="med"/>
-                    </a:lnB>
-                  </a:tcPr>
-                </a:tc>
-                <a:tc>
-                  <a:txBody>
-                    <a:bodyPr/>
-                    <a:lstStyle/>
-                    <a:p>
-                      <a:pPr marL="0" indent="0">
-                        <a:buNone/>
-                      </a:pPr>
-                      <a:r>
-                        <a:rPr lang="en-US" sz="1400" dirty="0">
-                          <a:solidFill>
-                            <a:srgbClr val="1F2933"/>
-                          </a:solidFill>
-                        </a:rPr>
-                        <a:t>&lt; about -0.5</a:t>
-                      </a:r>
-                      <a:endParaRPr lang="en-US" sz="1400" dirty="0"/>
-                    </a:p>
-                  </a:txBody>
-                  <a:tcPr marL="88900" marR="88900" marT="63500" marB="63500" anchor="ctr">
-                    <a:lnL w="9525" cap="flat" cmpd="sng" algn="ctr">
-                      <a:solidFill>
-                        <a:srgbClr val="D5DAE0"/>
-                      </a:solidFill>
-                      <a:prstDash val="solid"/>
-                      <a:round/>
-                      <a:headEnd type="none" w="med" len="med"/>
-                      <a:tailEnd type="none" w="med" len="med"/>
-                    </a:lnL>
-                    <a:lnR w="9525" cap="flat" cmpd="sng" algn="ctr">
-                      <a:solidFill>
-                        <a:srgbClr val="D5DAE0"/>
-                      </a:solidFill>
-                      <a:prstDash val="solid"/>
-                      <a:round/>
-                      <a:headEnd type="none" w="med" len="med"/>
-                      <a:tailEnd type="none" w="med" len="med"/>
-                    </a:lnR>
-                    <a:lnT w="9525" cap="flat" cmpd="sng" algn="ctr">
-                      <a:solidFill>
-                        <a:srgbClr val="D5DAE0"/>
-                      </a:solidFill>
-                      <a:prstDash val="solid"/>
-                      <a:round/>
-                      <a:headEnd type="none" w="med" len="med"/>
-                      <a:tailEnd type="none" w="med" len="med"/>
-                    </a:lnT>
-                    <a:lnB w="9525" cap="flat" cmpd="sng" algn="ctr">
-                      <a:solidFill>
-                        <a:srgbClr val="D5DAE0"/>
-                      </a:solidFill>
-                      <a:prstDash val="solid"/>
-                      <a:round/>
-                      <a:headEnd type="none" w="med" len="med"/>
-                      <a:tailEnd type="none" w="med" len="med"/>
-                    </a:lnB>
-                  </a:tcPr>
-                </a:tc>
-                <a:tc>
-                  <a:txBody>
-                    <a:bodyPr/>
-                    <a:lstStyle/>
-                    <a:p>
-                      <a:pPr marL="0" indent="0">
-                        <a:buNone/>
-                      </a:pPr>
-                      <a:r>
-                        <a:rPr lang="en-US" sz="1400" dirty="0">
-                          <a:solidFill>
-                            <a:srgbClr val="1F2933"/>
-                          </a:solidFill>
-                        </a:rPr>
-                        <a:t>17 of 23 (74%) vs 3 of 18 (17%)</a:t>
-                      </a:r>
-                      <a:endParaRPr lang="en-US" sz="1400" dirty="0"/>
-                    </a:p>
-                  </a:txBody>
-                  <a:tcPr marL="88900" marR="88900" marT="63500" marB="63500" anchor="ctr">
-                    <a:lnL w="9525" cap="flat" cmpd="sng" algn="ctr">
-                      <a:solidFill>
-                        <a:srgbClr val="D5DAE0"/>
-                      </a:solidFill>
-                      <a:prstDash val="solid"/>
-                      <a:round/>
-                      <a:headEnd type="none" w="med" len="med"/>
-                      <a:tailEnd type="none" w="med" len="med"/>
-                    </a:lnL>
-                    <a:lnR w="9525" cap="flat" cmpd="sng" algn="ctr">
-                      <a:solidFill>
-                        <a:srgbClr val="D5DAE0"/>
-                      </a:solidFill>
-                      <a:prstDash val="solid"/>
-                      <a:round/>
-                      <a:headEnd type="none" w="med" len="med"/>
-                      <a:tailEnd type="none" w="med" len="med"/>
-                    </a:lnR>
-                    <a:lnT w="9525" cap="flat" cmpd="sng" algn="ctr">
-                      <a:solidFill>
-                        <a:srgbClr val="D5DAE0"/>
-                      </a:solidFill>
-                      <a:prstDash val="solid"/>
-                      <a:round/>
-                      <a:headEnd type="none" w="med" len="med"/>
-                      <a:tailEnd type="none" w="med" len="med"/>
-                    </a:lnT>
-                    <a:lnB w="9525" cap="flat" cmpd="sng" algn="ctr">
-                      <a:solidFill>
-                        <a:srgbClr val="D5DAE0"/>
-                      </a:solidFill>
-                      <a:prstDash val="solid"/>
-                      <a:round/>
-                      <a:headEnd type="none" w="med" len="med"/>
-                      <a:tailEnd type="none" w="med" len="med"/>
-                    </a:lnB>
-                  </a:tcPr>
-                </a:tc>
-                <a:tc>
-                  <a:txBody>
-                    <a:bodyPr/>
-                    <a:lstStyle/>
-                    <a:p>
-                      <a:pPr marL="0" indent="0">
-                        <a:buNone/>
-                      </a:pPr>
-                      <a:r>
-                        <a:rPr lang="en-US" sz="1400" dirty="0">
-                          <a:solidFill>
-                            <a:srgbClr val="1F2933"/>
-                          </a:solidFill>
-                        </a:rPr>
-                        <a:t>Enrich for cognitive impairment: 48% → 74% responders</a:t>
-                      </a:r>
-                      <a:endParaRPr lang="en-US" sz="1400" dirty="0"/>
-                    </a:p>
-                  </a:txBody>
-                  <a:tcPr marL="88900" marR="88900" marT="63500" marB="63500" anchor="ctr">
-                    <a:lnL w="9525" cap="flat" cmpd="sng" algn="ctr">
-                      <a:solidFill>
-                        <a:srgbClr val="D5DAE0"/>
-                      </a:solidFill>
-                      <a:prstDash val="solid"/>
-                      <a:round/>
-                      <a:headEnd type="none" w="med" len="med"/>
-                      <a:tailEnd type="none" w="med" len="med"/>
-                    </a:lnL>
-                    <a:lnR w="9525" cap="flat" cmpd="sng" algn="ctr">
-                      <a:solidFill>
-                        <a:srgbClr val="D5DAE0"/>
-                      </a:solidFill>
-                      <a:prstDash val="solid"/>
-                      <a:round/>
-                      <a:headEnd type="none" w="med" len="med"/>
-                      <a:tailEnd type="none" w="med" len="med"/>
-                    </a:lnR>
-                    <a:lnT w="9525" cap="flat" cmpd="sng" algn="ctr">
-                      <a:solidFill>
-                        <a:srgbClr val="D5DAE0"/>
-                      </a:solidFill>
-                      <a:prstDash val="solid"/>
-                      <a:round/>
-                      <a:headEnd type="none" w="med" len="med"/>
-                      <a:tailEnd type="none" w="med" len="med"/>
-                    </a:lnT>
-                    <a:lnB w="9525" cap="flat" cmpd="sng" algn="ctr">
-                      <a:solidFill>
-                        <a:srgbClr val="D5DAE0"/>
-                      </a:solidFill>
-                      <a:prstDash val="solid"/>
-                      <a:round/>
-                      <a:headEnd type="none" w="med" len="med"/>
-                      <a:tailEnd type="none" w="med" len="med"/>
-                    </a:lnB>
-                  </a:tcPr>
-                </a:tc>
-                <a:extLst>
-                  <a:ext uri="{0D108BD9-81ED-4DB2-BD59-A6C34878D82A}">
-                    <a16:rowId xmlns:a16="http://schemas.microsoft.com/office/drawing/2014/main" val="10003"/>
-                  </a:ext>
-                </a:extLst>
-              </a:tr>
-            </a:tbl>
-          </a:graphicData>
-        </a:graphic>
-      </p:graphicFrame>
       <p:sp>
         <p:nvSpPr>
           <p:cNvPr id="4" name="Text 1"/>
@@ -6735,6 +5475,1148 @@
           </a:p>
         </p:txBody>
       </p:sp>
+      <p:graphicFrame>
+        <p:nvGraphicFramePr>
+          <p:cNvPr id="10" name="Table 9"/>
+          <p:cNvGraphicFramePr>
+            <a:graphicFrameLocks noGrp="1"/>
+          </p:cNvGraphicFramePr>
+          <p:nvPr/>
+        </p:nvGraphicFramePr>
+        <p:xfrm>
+          <a:off x="548640" y="1417320"/>
+          <a:ext cx="11064240" cy="2368296"/>
+        </p:xfrm>
+        <a:graphic>
+          <a:graphicData uri="http://schemas.openxmlformats.org/drawingml/2006/table">
+            <a:tbl>
+              <a:tblPr firstRow="0" bandRow="0">
+                <a:tableStyleId>{5C22544A-7EE6-4342-B048-85BDC9FD1C3A}</a:tableStyleId>
+              </a:tblPr>
+              <a:tblGrid>
+                <a:gridCol w="1737360"/>
+                <a:gridCol w="2377440"/>
+                <a:gridCol w="1097280"/>
+                <a:gridCol w="2103120"/>
+                <a:gridCol w="2011680"/>
+                <a:gridCol w="1737360"/>
+              </a:tblGrid>
+              <a:tr h="502920">
+                <a:tc>
+                  <a:txBody>
+                    <a:bodyPr/>
+                    <a:lstStyle/>
+                    <a:p>
+                      <a:r>
+                        <a:rPr sz="1250" b="1">
+                          <a:solidFill>
+                            <a:srgbClr val="000000"/>
+                          </a:solidFill>
+                          <a:latin typeface="Calibri"/>
+                        </a:rPr>
+                        <a:t>Treatment</a:t>
+                      </a:r>
+                    </a:p>
+                  </a:txBody>
+                  <a:tcPr marL="64008" marR="64008" marT="45720" marB="45720">
+                    <a:solidFill>
+                      <a:srgbClr val="F2F2F2"/>
+                    </a:solidFill>
+                    <a:lnL w="9525" cap="flat" cmpd="sng" algn="ctr">
+                      <a:solidFill>
+                        <a:srgbClr val="D5DAE0"/>
+                      </a:solidFill>
+                      <a:prstDash val="solid"/>
+                    </a:lnL>
+                    <a:lnR w="9525" cap="flat" cmpd="sng" algn="ctr">
+                      <a:solidFill>
+                        <a:srgbClr val="D5DAE0"/>
+                      </a:solidFill>
+                      <a:prstDash val="solid"/>
+                    </a:lnR>
+                    <a:lnT w="9525" cap="flat" cmpd="sng" algn="ctr">
+                      <a:solidFill>
+                        <a:srgbClr val="D5DAE0"/>
+                      </a:solidFill>
+                      <a:prstDash val="solid"/>
+                    </a:lnT>
+                    <a:lnB w="9525" cap="flat" cmpd="sng" algn="ctr">
+                      <a:solidFill>
+                        <a:srgbClr val="D5DAE0"/>
+                      </a:solidFill>
+                      <a:prstDash val="solid"/>
+                    </a:lnB>
+                  </a:tcPr>
+                </a:tc>
+                <a:tc>
+                  <a:txBody>
+                    <a:bodyPr/>
+                    <a:lstStyle/>
+                    <a:p>
+                      <a:r>
+                        <a:rPr sz="1250" b="1">
+                          <a:solidFill>
+                            <a:srgbClr val="000000"/>
+                          </a:solidFill>
+                          <a:latin typeface="Calibri"/>
+                        </a:rPr>
+                        <a:t>Measure at baseline</a:t>
+                      </a:r>
+                    </a:p>
+                  </a:txBody>
+                  <a:tcPr marL="64008" marR="64008" marT="45720" marB="45720">
+                    <a:solidFill>
+                      <a:srgbClr val="F2F2F2"/>
+                    </a:solidFill>
+                    <a:lnL w="9525" cap="flat" cmpd="sng" algn="ctr">
+                      <a:solidFill>
+                        <a:srgbClr val="D5DAE0"/>
+                      </a:solidFill>
+                      <a:prstDash val="solid"/>
+                    </a:lnL>
+                    <a:lnR w="9525" cap="flat" cmpd="sng" algn="ctr">
+                      <a:solidFill>
+                        <a:srgbClr val="D5DAE0"/>
+                      </a:solidFill>
+                      <a:prstDash val="solid"/>
+                    </a:lnR>
+                    <a:lnT w="9525" cap="flat" cmpd="sng" algn="ctr">
+                      <a:solidFill>
+                        <a:srgbClr val="D5DAE0"/>
+                      </a:solidFill>
+                      <a:prstDash val="solid"/>
+                    </a:lnT>
+                    <a:lnB w="9525" cap="flat" cmpd="sng" algn="ctr">
+                      <a:solidFill>
+                        <a:srgbClr val="D5DAE0"/>
+                      </a:solidFill>
+                      <a:prstDash val="solid"/>
+                    </a:lnB>
+                  </a:tcPr>
+                </a:tc>
+                <a:tc>
+                  <a:txBody>
+                    <a:bodyPr/>
+                    <a:lstStyle/>
+                    <a:p>
+                      <a:r>
+                        <a:rPr sz="1250" b="1">
+                          <a:solidFill>
+                            <a:srgbClr val="000000"/>
+                          </a:solidFill>
+                          <a:latin typeface="Calibri"/>
+                        </a:rPr>
+                        <a:t>Cut-off</a:t>
+                      </a:r>
+                    </a:p>
+                  </a:txBody>
+                  <a:tcPr marL="64008" marR="64008" marT="45720" marB="45720">
+                    <a:solidFill>
+                      <a:srgbClr val="F2F2F2"/>
+                    </a:solidFill>
+                    <a:lnL w="9525" cap="flat" cmpd="sng" algn="ctr">
+                      <a:solidFill>
+                        <a:srgbClr val="D5DAE0"/>
+                      </a:solidFill>
+                      <a:prstDash val="solid"/>
+                    </a:lnL>
+                    <a:lnR w="9525" cap="flat" cmpd="sng" algn="ctr">
+                      <a:solidFill>
+                        <a:srgbClr val="D5DAE0"/>
+                      </a:solidFill>
+                      <a:prstDash val="solid"/>
+                    </a:lnR>
+                    <a:lnT w="9525" cap="flat" cmpd="sng" algn="ctr">
+                      <a:solidFill>
+                        <a:srgbClr val="D5DAE0"/>
+                      </a:solidFill>
+                      <a:prstDash val="solid"/>
+                    </a:lnT>
+                    <a:lnB w="9525" cap="flat" cmpd="sng" algn="ctr">
+                      <a:solidFill>
+                        <a:srgbClr val="D5DAE0"/>
+                      </a:solidFill>
+                      <a:prstDash val="solid"/>
+                    </a:lnB>
+                  </a:tcPr>
+                </a:tc>
+                <a:tc>
+                  <a:txBody>
+                    <a:bodyPr/>
+                    <a:lstStyle/>
+                    <a:p>
+                      <a:r>
+                        <a:rPr sz="1250" b="1">
+                          <a:solidFill>
+                            <a:srgbClr val="000000"/>
+                          </a:solidFill>
+                          <a:latin typeface="Calibri"/>
+                        </a:rPr>
+                        <a:t>Test patients who responded: above vs below</a:t>
+                      </a:r>
+                    </a:p>
+                  </a:txBody>
+                  <a:tcPr marL="64008" marR="64008" marT="45720" marB="45720">
+                    <a:solidFill>
+                      <a:srgbClr val="F2F2F2"/>
+                    </a:solidFill>
+                    <a:lnL w="9525" cap="flat" cmpd="sng" algn="ctr">
+                      <a:solidFill>
+                        <a:srgbClr val="D5DAE0"/>
+                      </a:solidFill>
+                      <a:prstDash val="solid"/>
+                    </a:lnL>
+                    <a:lnR w="9525" cap="flat" cmpd="sng" algn="ctr">
+                      <a:solidFill>
+                        <a:srgbClr val="D5DAE0"/>
+                      </a:solidFill>
+                      <a:prstDash val="solid"/>
+                    </a:lnR>
+                    <a:lnT w="9525" cap="flat" cmpd="sng" algn="ctr">
+                      <a:solidFill>
+                        <a:srgbClr val="D5DAE0"/>
+                      </a:solidFill>
+                      <a:prstDash val="solid"/>
+                    </a:lnT>
+                    <a:lnB w="9525" cap="flat" cmpd="sng" algn="ctr">
+                      <a:solidFill>
+                        <a:srgbClr val="D5DAE0"/>
+                      </a:solidFill>
+                      <a:prstDash val="solid"/>
+                    </a:lnB>
+                  </a:tcPr>
+                </a:tc>
+                <a:tc>
+                  <a:txBody>
+                    <a:bodyPr/>
+                    <a:lstStyle/>
+                    <a:p>
+                      <a:r>
+                        <a:rPr sz="1250" b="1">
+                          <a:solidFill>
+                            <a:srgbClr val="000000"/>
+                          </a:solidFill>
+                          <a:latin typeface="Calibri"/>
+                        </a:rPr>
+                        <a:t>Held-out metrics</a:t>
+                      </a:r>
+                    </a:p>
+                  </a:txBody>
+                  <a:tcPr marL="64008" marR="64008" marT="45720" marB="45720">
+                    <a:solidFill>
+                      <a:srgbClr val="F2F2F2"/>
+                    </a:solidFill>
+                    <a:lnL w="9525" cap="flat" cmpd="sng" algn="ctr">
+                      <a:solidFill>
+                        <a:srgbClr val="D5DAE0"/>
+                      </a:solidFill>
+                      <a:prstDash val="solid"/>
+                    </a:lnL>
+                    <a:lnR w="9525" cap="flat" cmpd="sng" algn="ctr">
+                      <a:solidFill>
+                        <a:srgbClr val="D5DAE0"/>
+                      </a:solidFill>
+                      <a:prstDash val="solid"/>
+                    </a:lnR>
+                    <a:lnT w="9525" cap="flat" cmpd="sng" algn="ctr">
+                      <a:solidFill>
+                        <a:srgbClr val="D5DAE0"/>
+                      </a:solidFill>
+                      <a:prstDash val="solid"/>
+                    </a:lnT>
+                    <a:lnB w="9525" cap="flat" cmpd="sng" algn="ctr">
+                      <a:solidFill>
+                        <a:srgbClr val="D5DAE0"/>
+                      </a:solidFill>
+                      <a:prstDash val="solid"/>
+                    </a:lnB>
+                  </a:tcPr>
+                </a:tc>
+                <a:tc>
+                  <a:txBody>
+                    <a:bodyPr/>
+                    <a:lstStyle/>
+                    <a:p>
+                      <a:r>
+                        <a:rPr sz="1250" b="1">
+                          <a:solidFill>
+                            <a:srgbClr val="000000"/>
+                          </a:solidFill>
+                          <a:latin typeface="Calibri"/>
+                        </a:rPr>
+                        <a:t>Trial design</a:t>
+                      </a:r>
+                    </a:p>
+                  </a:txBody>
+                  <a:tcPr marL="64008" marR="64008" marT="45720" marB="45720">
+                    <a:solidFill>
+                      <a:srgbClr val="F2F2F2"/>
+                    </a:solidFill>
+                    <a:lnL w="9525" cap="flat" cmpd="sng" algn="ctr">
+                      <a:solidFill>
+                        <a:srgbClr val="D5DAE0"/>
+                      </a:solidFill>
+                      <a:prstDash val="solid"/>
+                    </a:lnL>
+                    <a:lnR w="9525" cap="flat" cmpd="sng" algn="ctr">
+                      <a:solidFill>
+                        <a:srgbClr val="D5DAE0"/>
+                      </a:solidFill>
+                      <a:prstDash val="solid"/>
+                    </a:lnR>
+                    <a:lnT w="9525" cap="flat" cmpd="sng" algn="ctr">
+                      <a:solidFill>
+                        <a:srgbClr val="D5DAE0"/>
+                      </a:solidFill>
+                      <a:prstDash val="solid"/>
+                    </a:lnT>
+                    <a:lnB w="9525" cap="flat" cmpd="sng" algn="ctr">
+                      <a:solidFill>
+                        <a:srgbClr val="D5DAE0"/>
+                      </a:solidFill>
+                      <a:prstDash val="solid"/>
+                    </a:lnB>
+                  </a:tcPr>
+                </a:tc>
+              </a:tr>
+              <a:tr h="621792">
+                <a:tc>
+                  <a:txBody>
+                    <a:bodyPr/>
+                    <a:lstStyle/>
+                    <a:p>
+                      <a:r>
+                        <a:rPr sz="1250" b="1">
+                          <a:solidFill>
+                            <a:srgbClr val="1F2933"/>
+                          </a:solidFill>
+                          <a:latin typeface="Calibri"/>
+                        </a:rPr>
+                        <a:t>Mexiletine</a:t>
+                      </a:r>
+                    </a:p>
+                  </a:txBody>
+                  <a:tcPr marL="64008" marR="64008" marT="45720" marB="45720">
+                    <a:solidFill>
+                      <a:srgbClr val="FFFFFF"/>
+                    </a:solidFill>
+                    <a:lnL w="9525" cap="flat" cmpd="sng" algn="ctr">
+                      <a:solidFill>
+                        <a:srgbClr val="D5DAE0"/>
+                      </a:solidFill>
+                      <a:prstDash val="solid"/>
+                    </a:lnL>
+                    <a:lnR w="9525" cap="flat" cmpd="sng" algn="ctr">
+                      <a:solidFill>
+                        <a:srgbClr val="D5DAE0"/>
+                      </a:solidFill>
+                      <a:prstDash val="solid"/>
+                    </a:lnR>
+                    <a:lnT w="9525" cap="flat" cmpd="sng" algn="ctr">
+                      <a:solidFill>
+                        <a:srgbClr val="D5DAE0"/>
+                      </a:solidFill>
+                      <a:prstDash val="solid"/>
+                    </a:lnT>
+                    <a:lnB w="9525" cap="flat" cmpd="sng" algn="ctr">
+                      <a:solidFill>
+                        <a:srgbClr val="D5DAE0"/>
+                      </a:solidFill>
+                      <a:prstDash val="solid"/>
+                    </a:lnB>
+                  </a:tcPr>
+                </a:tc>
+                <a:tc>
+                  <a:txBody>
+                    <a:bodyPr/>
+                    <a:lstStyle/>
+                    <a:p>
+                      <a:r>
+                        <a:rPr sz="1250" b="0">
+                          <a:solidFill>
+                            <a:srgbClr val="1F2933"/>
+                          </a:solidFill>
+                          <a:latin typeface="Calibri"/>
+                        </a:rPr>
+                        <a:t>Myotonia severity (one axis with CTG repeats; CTG leads on relative change)</a:t>
+                      </a:r>
+                    </a:p>
+                  </a:txBody>
+                  <a:tcPr marL="64008" marR="64008" marT="45720" marB="45720">
+                    <a:solidFill>
+                      <a:srgbClr val="FFFFFF"/>
+                    </a:solidFill>
+                    <a:lnL w="9525" cap="flat" cmpd="sng" algn="ctr">
+                      <a:solidFill>
+                        <a:srgbClr val="D5DAE0"/>
+                      </a:solidFill>
+                      <a:prstDash val="solid"/>
+                    </a:lnL>
+                    <a:lnR w="9525" cap="flat" cmpd="sng" algn="ctr">
+                      <a:solidFill>
+                        <a:srgbClr val="D5DAE0"/>
+                      </a:solidFill>
+                      <a:prstDash val="solid"/>
+                    </a:lnR>
+                    <a:lnT w="9525" cap="flat" cmpd="sng" algn="ctr">
+                      <a:solidFill>
+                        <a:srgbClr val="D5DAE0"/>
+                      </a:solidFill>
+                      <a:prstDash val="solid"/>
+                    </a:lnT>
+                    <a:lnB w="9525" cap="flat" cmpd="sng" algn="ctr">
+                      <a:solidFill>
+                        <a:srgbClr val="D5DAE0"/>
+                      </a:solidFill>
+                      <a:prstDash val="solid"/>
+                    </a:lnB>
+                  </a:tcPr>
+                </a:tc>
+                <a:tc>
+                  <a:txBody>
+                    <a:bodyPr/>
+                    <a:lstStyle/>
+                    <a:p>
+                      <a:r>
+                        <a:rPr sz="1250" b="0">
+                          <a:solidFill>
+                            <a:srgbClr val="1F2933"/>
+                          </a:solidFill>
+                          <a:latin typeface="Calibri"/>
+                        </a:rPr>
+                        <a:t>≥ about 5</a:t>
+                      </a:r>
+                    </a:p>
+                  </a:txBody>
+                  <a:tcPr marL="64008" marR="64008" marT="45720" marB="45720">
+                    <a:solidFill>
+                      <a:srgbClr val="FFFFFF"/>
+                    </a:solidFill>
+                    <a:lnL w="9525" cap="flat" cmpd="sng" algn="ctr">
+                      <a:solidFill>
+                        <a:srgbClr val="D5DAE0"/>
+                      </a:solidFill>
+                      <a:prstDash val="solid"/>
+                    </a:lnL>
+                    <a:lnR w="9525" cap="flat" cmpd="sng" algn="ctr">
+                      <a:solidFill>
+                        <a:srgbClr val="D5DAE0"/>
+                      </a:solidFill>
+                      <a:prstDash val="solid"/>
+                    </a:lnR>
+                    <a:lnT w="9525" cap="flat" cmpd="sng" algn="ctr">
+                      <a:solidFill>
+                        <a:srgbClr val="D5DAE0"/>
+                      </a:solidFill>
+                      <a:prstDash val="solid"/>
+                    </a:lnT>
+                    <a:lnB w="9525" cap="flat" cmpd="sng" algn="ctr">
+                      <a:solidFill>
+                        <a:srgbClr val="D5DAE0"/>
+                      </a:solidFill>
+                      <a:prstDash val="solid"/>
+                    </a:lnB>
+                  </a:tcPr>
+                </a:tc>
+                <a:tc>
+                  <a:txBody>
+                    <a:bodyPr/>
+                    <a:lstStyle/>
+                    <a:p>
+                      <a:r>
+                        <a:rPr sz="1250" b="0">
+                          <a:solidFill>
+                            <a:srgbClr val="1F2933"/>
+                          </a:solidFill>
+                          <a:latin typeface="Calibri"/>
+                        </a:rPr>
+                        <a:t>10 of 21 (48%) vs 2 of 20 (10%)</a:t>
+                      </a:r>
+                    </a:p>
+                  </a:txBody>
+                  <a:tcPr marL="64008" marR="64008" marT="45720" marB="45720">
+                    <a:solidFill>
+                      <a:srgbClr val="FFFFFF"/>
+                    </a:solidFill>
+                    <a:lnL w="9525" cap="flat" cmpd="sng" algn="ctr">
+                      <a:solidFill>
+                        <a:srgbClr val="D5DAE0"/>
+                      </a:solidFill>
+                      <a:prstDash val="solid"/>
+                    </a:lnL>
+                    <a:lnR w="9525" cap="flat" cmpd="sng" algn="ctr">
+                      <a:solidFill>
+                        <a:srgbClr val="D5DAE0"/>
+                      </a:solidFill>
+                      <a:prstDash val="solid"/>
+                    </a:lnR>
+                    <a:lnT w="9525" cap="flat" cmpd="sng" algn="ctr">
+                      <a:solidFill>
+                        <a:srgbClr val="D5DAE0"/>
+                      </a:solidFill>
+                      <a:prstDash val="solid"/>
+                    </a:lnT>
+                    <a:lnB w="9525" cap="flat" cmpd="sng" algn="ctr">
+                      <a:solidFill>
+                        <a:srgbClr val="D5DAE0"/>
+                      </a:solidFill>
+                      <a:prstDash val="solid"/>
+                    </a:lnB>
+                  </a:tcPr>
+                </a:tc>
+                <a:tc>
+                  <a:txBody>
+                    <a:bodyPr/>
+                    <a:lstStyle/>
+                    <a:p>
+                      <a:r>
+                        <a:rPr sz="1250" b="0">
+                          <a:solidFill>
+                            <a:srgbClr val="1F2933"/>
+                          </a:solidFill>
+                          <a:latin typeface="Calibri"/>
+                        </a:rPr>
+                        <a:t>AUC 0.77; R² 0.5 on absolute change, ≈0.15 on relative</a:t>
+                      </a:r>
+                    </a:p>
+                  </a:txBody>
+                  <a:tcPr marL="64008" marR="64008" marT="45720" marB="45720">
+                    <a:solidFill>
+                      <a:srgbClr val="FFFFFF"/>
+                    </a:solidFill>
+                    <a:lnL w="9525" cap="flat" cmpd="sng" algn="ctr">
+                      <a:solidFill>
+                        <a:srgbClr val="D5DAE0"/>
+                      </a:solidFill>
+                      <a:prstDash val="solid"/>
+                    </a:lnL>
+                    <a:lnR w="9525" cap="flat" cmpd="sng" algn="ctr">
+                      <a:solidFill>
+                        <a:srgbClr val="D5DAE0"/>
+                      </a:solidFill>
+                      <a:prstDash val="solid"/>
+                    </a:lnR>
+                    <a:lnT w="9525" cap="flat" cmpd="sng" algn="ctr">
+                      <a:solidFill>
+                        <a:srgbClr val="D5DAE0"/>
+                      </a:solidFill>
+                      <a:prstDash val="solid"/>
+                    </a:lnT>
+                    <a:lnB w="9525" cap="flat" cmpd="sng" algn="ctr">
+                      <a:solidFill>
+                        <a:srgbClr val="D5DAE0"/>
+                      </a:solidFill>
+                      <a:prstDash val="solid"/>
+                    </a:lnB>
+                  </a:tcPr>
+                </a:tc>
+                <a:tc>
+                  <a:txBody>
+                    <a:bodyPr/>
+                    <a:lstStyle/>
+                    <a:p>
+                      <a:r>
+                        <a:rPr sz="1250" b="0">
+                          <a:solidFill>
+                            <a:srgbClr val="1F2933"/>
+                          </a:solidFill>
+                          <a:latin typeface="Calibri"/>
+                        </a:rPr>
+                        <a:t>Enrol on symptom severity, not diagnosis alone</a:t>
+                      </a:r>
+                    </a:p>
+                  </a:txBody>
+                  <a:tcPr marL="64008" marR="64008" marT="45720" marB="45720">
+                    <a:solidFill>
+                      <a:srgbClr val="FFFFFF"/>
+                    </a:solidFill>
+                    <a:lnL w="9525" cap="flat" cmpd="sng" algn="ctr">
+                      <a:solidFill>
+                        <a:srgbClr val="D5DAE0"/>
+                      </a:solidFill>
+                      <a:prstDash val="solid"/>
+                    </a:lnL>
+                    <a:lnR w="9525" cap="flat" cmpd="sng" algn="ctr">
+                      <a:solidFill>
+                        <a:srgbClr val="D5DAE0"/>
+                      </a:solidFill>
+                      <a:prstDash val="solid"/>
+                    </a:lnR>
+                    <a:lnT w="9525" cap="flat" cmpd="sng" algn="ctr">
+                      <a:solidFill>
+                        <a:srgbClr val="D5DAE0"/>
+                      </a:solidFill>
+                      <a:prstDash val="solid"/>
+                    </a:lnT>
+                    <a:lnB w="9525" cap="flat" cmpd="sng" algn="ctr">
+                      <a:solidFill>
+                        <a:srgbClr val="D5DAE0"/>
+                      </a:solidFill>
+                      <a:prstDash val="solid"/>
+                    </a:lnB>
+                  </a:tcPr>
+                </a:tc>
+              </a:tr>
+              <a:tr h="621792">
+                <a:tc>
+                  <a:txBody>
+                    <a:bodyPr/>
+                    <a:lstStyle/>
+                    <a:p>
+                      <a:r>
+                        <a:rPr sz="1250" b="1">
+                          <a:solidFill>
+                            <a:srgbClr val="1F2933"/>
+                          </a:solidFill>
+                          <a:latin typeface="Calibri"/>
+                        </a:rPr>
+                        <a:t>Antisense oligonucleotide</a:t>
+                      </a:r>
+                    </a:p>
+                  </a:txBody>
+                  <a:tcPr marL="64008" marR="64008" marT="45720" marB="45720">
+                    <a:solidFill>
+                      <a:srgbClr val="FFFFFF"/>
+                    </a:solidFill>
+                    <a:lnL w="9525" cap="flat" cmpd="sng" algn="ctr">
+                      <a:solidFill>
+                        <a:srgbClr val="D5DAE0"/>
+                      </a:solidFill>
+                      <a:prstDash val="solid"/>
+                    </a:lnL>
+                    <a:lnR w="9525" cap="flat" cmpd="sng" algn="ctr">
+                      <a:solidFill>
+                        <a:srgbClr val="D5DAE0"/>
+                      </a:solidFill>
+                      <a:prstDash val="solid"/>
+                    </a:lnR>
+                    <a:lnT w="9525" cap="flat" cmpd="sng" algn="ctr">
+                      <a:solidFill>
+                        <a:srgbClr val="D5DAE0"/>
+                      </a:solidFill>
+                      <a:prstDash val="solid"/>
+                    </a:lnT>
+                    <a:lnB w="9525" cap="flat" cmpd="sng" algn="ctr">
+                      <a:solidFill>
+                        <a:srgbClr val="D5DAE0"/>
+                      </a:solidFill>
+                      <a:prstDash val="solid"/>
+                    </a:lnB>
+                  </a:tcPr>
+                </a:tc>
+                <a:tc>
+                  <a:txBody>
+                    <a:bodyPr/>
+                    <a:lstStyle/>
+                    <a:p>
+                      <a:r>
+                        <a:rPr sz="1250" b="0">
+                          <a:solidFill>
+                            <a:srgbClr val="1F2933"/>
+                          </a:solidFill>
+                          <a:latin typeface="Calibri"/>
+                        </a:rPr>
+                        <a:t>CTG repeat length</a:t>
+                      </a:r>
+                    </a:p>
+                  </a:txBody>
+                  <a:tcPr marL="64008" marR="64008" marT="45720" marB="45720">
+                    <a:solidFill>
+                      <a:srgbClr val="FFFFFF"/>
+                    </a:solidFill>
+                    <a:lnL w="9525" cap="flat" cmpd="sng" algn="ctr">
+                      <a:solidFill>
+                        <a:srgbClr val="D5DAE0"/>
+                      </a:solidFill>
+                      <a:prstDash val="solid"/>
+                    </a:lnL>
+                    <a:lnR w="9525" cap="flat" cmpd="sng" algn="ctr">
+                      <a:solidFill>
+                        <a:srgbClr val="D5DAE0"/>
+                      </a:solidFill>
+                      <a:prstDash val="solid"/>
+                    </a:lnR>
+                    <a:lnT w="9525" cap="flat" cmpd="sng" algn="ctr">
+                      <a:solidFill>
+                        <a:srgbClr val="D5DAE0"/>
+                      </a:solidFill>
+                      <a:prstDash val="solid"/>
+                    </a:lnT>
+                    <a:lnB w="9525" cap="flat" cmpd="sng" algn="ctr">
+                      <a:solidFill>
+                        <a:srgbClr val="D5DAE0"/>
+                      </a:solidFill>
+                      <a:prstDash val="solid"/>
+                    </a:lnB>
+                  </a:tcPr>
+                </a:tc>
+                <a:tc>
+                  <a:txBody>
+                    <a:bodyPr/>
+                    <a:lstStyle/>
+                    <a:p>
+                      <a:r>
+                        <a:rPr sz="1250" b="0">
+                          <a:solidFill>
+                            <a:srgbClr val="1F2933"/>
+                          </a:solidFill>
+                          <a:latin typeface="Calibri"/>
+                        </a:rPr>
+                        <a:t>≥ about 350</a:t>
+                      </a:r>
+                    </a:p>
+                  </a:txBody>
+                  <a:tcPr marL="64008" marR="64008" marT="45720" marB="45720">
+                    <a:solidFill>
+                      <a:srgbClr val="FFFFFF"/>
+                    </a:solidFill>
+                    <a:lnL w="9525" cap="flat" cmpd="sng" algn="ctr">
+                      <a:solidFill>
+                        <a:srgbClr val="D5DAE0"/>
+                      </a:solidFill>
+                      <a:prstDash val="solid"/>
+                    </a:lnL>
+                    <a:lnR w="9525" cap="flat" cmpd="sng" algn="ctr">
+                      <a:solidFill>
+                        <a:srgbClr val="D5DAE0"/>
+                      </a:solidFill>
+                      <a:prstDash val="solid"/>
+                    </a:lnR>
+                    <a:lnT w="9525" cap="flat" cmpd="sng" algn="ctr">
+                      <a:solidFill>
+                        <a:srgbClr val="D5DAE0"/>
+                      </a:solidFill>
+                      <a:prstDash val="solid"/>
+                    </a:lnT>
+                    <a:lnB w="9525" cap="flat" cmpd="sng" algn="ctr">
+                      <a:solidFill>
+                        <a:srgbClr val="D5DAE0"/>
+                      </a:solidFill>
+                      <a:prstDash val="solid"/>
+                    </a:lnB>
+                  </a:tcPr>
+                </a:tc>
+                <a:tc>
+                  <a:txBody>
+                    <a:bodyPr/>
+                    <a:lstStyle/>
+                    <a:p>
+                      <a:r>
+                        <a:rPr sz="1250" b="0">
+                          <a:solidFill>
+                            <a:srgbClr val="1F2933"/>
+                          </a:solidFill>
+                          <a:latin typeface="Calibri"/>
+                        </a:rPr>
+                        <a:t>10 of 17 (59%) vs 8 of 26 (31%)</a:t>
+                      </a:r>
+                    </a:p>
+                  </a:txBody>
+                  <a:tcPr marL="64008" marR="64008" marT="45720" marB="45720">
+                    <a:solidFill>
+                      <a:srgbClr val="FFFFFF"/>
+                    </a:solidFill>
+                    <a:lnL w="9525" cap="flat" cmpd="sng" algn="ctr">
+                      <a:solidFill>
+                        <a:srgbClr val="D5DAE0"/>
+                      </a:solidFill>
+                      <a:prstDash val="solid"/>
+                    </a:lnL>
+                    <a:lnR w="9525" cap="flat" cmpd="sng" algn="ctr">
+                      <a:solidFill>
+                        <a:srgbClr val="D5DAE0"/>
+                      </a:solidFill>
+                      <a:prstDash val="solid"/>
+                    </a:lnR>
+                    <a:lnT w="9525" cap="flat" cmpd="sng" algn="ctr">
+                      <a:solidFill>
+                        <a:srgbClr val="D5DAE0"/>
+                      </a:solidFill>
+                      <a:prstDash val="solid"/>
+                    </a:lnT>
+                    <a:lnB w="9525" cap="flat" cmpd="sng" algn="ctr">
+                      <a:solidFill>
+                        <a:srgbClr val="D5DAE0"/>
+                      </a:solidFill>
+                      <a:prstDash val="solid"/>
+                    </a:lnB>
+                  </a:tcPr>
+                </a:tc>
+                <a:tc>
+                  <a:txBody>
+                    <a:bodyPr/>
+                    <a:lstStyle/>
+                    <a:p>
+                      <a:r>
+                        <a:rPr sz="1250" b="0">
+                          <a:solidFill>
+                            <a:srgbClr val="1F2933"/>
+                          </a:solidFill>
+                          <a:latin typeface="Calibri"/>
+                        </a:rPr>
+                        <a:t>AUC 0.72; R² &lt; 0.1</a:t>
+                      </a:r>
+                    </a:p>
+                  </a:txBody>
+                  <a:tcPr marL="64008" marR="64008" marT="45720" marB="45720">
+                    <a:solidFill>
+                      <a:srgbClr val="FFFFFF"/>
+                    </a:solidFill>
+                    <a:lnL w="9525" cap="flat" cmpd="sng" algn="ctr">
+                      <a:solidFill>
+                        <a:srgbClr val="D5DAE0"/>
+                      </a:solidFill>
+                      <a:prstDash val="solid"/>
+                    </a:lnL>
+                    <a:lnR w="9525" cap="flat" cmpd="sng" algn="ctr">
+                      <a:solidFill>
+                        <a:srgbClr val="D5DAE0"/>
+                      </a:solidFill>
+                      <a:prstDash val="solid"/>
+                    </a:lnR>
+                    <a:lnT w="9525" cap="flat" cmpd="sng" algn="ctr">
+                      <a:solidFill>
+                        <a:srgbClr val="D5DAE0"/>
+                      </a:solidFill>
+                      <a:prstDash val="solid"/>
+                    </a:lnT>
+                    <a:lnB w="9525" cap="flat" cmpd="sng" algn="ctr">
+                      <a:solidFill>
+                        <a:srgbClr val="D5DAE0"/>
+                      </a:solidFill>
+                      <a:prstDash val="solid"/>
+                    </a:lnB>
+                  </a:tcPr>
+                </a:tc>
+                <a:tc>
+                  <a:txBody>
+                    <a:bodyPr/>
+                    <a:lstStyle/>
+                    <a:p>
+                      <a:r>
+                        <a:rPr sz="1250" b="0">
+                          <a:solidFill>
+                            <a:srgbClr val="1F2933"/>
+                          </a:solidFill>
+                          <a:latin typeface="Calibri"/>
+                        </a:rPr>
+                        <a:t>Stratify randomisation on repeat length</a:t>
+                      </a:r>
+                    </a:p>
+                  </a:txBody>
+                  <a:tcPr marL="64008" marR="64008" marT="45720" marB="45720">
+                    <a:solidFill>
+                      <a:srgbClr val="FFFFFF"/>
+                    </a:solidFill>
+                    <a:lnL w="9525" cap="flat" cmpd="sng" algn="ctr">
+                      <a:solidFill>
+                        <a:srgbClr val="D5DAE0"/>
+                      </a:solidFill>
+                      <a:prstDash val="solid"/>
+                    </a:lnL>
+                    <a:lnR w="9525" cap="flat" cmpd="sng" algn="ctr">
+                      <a:solidFill>
+                        <a:srgbClr val="D5DAE0"/>
+                      </a:solidFill>
+                      <a:prstDash val="solid"/>
+                    </a:lnR>
+                    <a:lnT w="9525" cap="flat" cmpd="sng" algn="ctr">
+                      <a:solidFill>
+                        <a:srgbClr val="D5DAE0"/>
+                      </a:solidFill>
+                      <a:prstDash val="solid"/>
+                    </a:lnT>
+                    <a:lnB w="9525" cap="flat" cmpd="sng" algn="ctr">
+                      <a:solidFill>
+                        <a:srgbClr val="D5DAE0"/>
+                      </a:solidFill>
+                      <a:prstDash val="solid"/>
+                    </a:lnB>
+                  </a:tcPr>
+                </a:tc>
+              </a:tr>
+              <a:tr h="621792">
+                <a:tc>
+                  <a:txBody>
+                    <a:bodyPr/>
+                    <a:lstStyle/>
+                    <a:p>
+                      <a:r>
+                        <a:rPr sz="1250" b="1">
+                          <a:solidFill>
+                            <a:srgbClr val="1F2933"/>
+                          </a:solidFill>
+                          <a:latin typeface="Calibri"/>
+                        </a:rPr>
+                        <a:t>Tideglusib</a:t>
+                      </a:r>
+                    </a:p>
+                  </a:txBody>
+                  <a:tcPr marL="64008" marR="64008" marT="45720" marB="45720">
+                    <a:solidFill>
+                      <a:srgbClr val="FFFFFF"/>
+                    </a:solidFill>
+                    <a:lnL w="9525" cap="flat" cmpd="sng" algn="ctr">
+                      <a:solidFill>
+                        <a:srgbClr val="D5DAE0"/>
+                      </a:solidFill>
+                      <a:prstDash val="solid"/>
+                    </a:lnL>
+                    <a:lnR w="9525" cap="flat" cmpd="sng" algn="ctr">
+                      <a:solidFill>
+                        <a:srgbClr val="D5DAE0"/>
+                      </a:solidFill>
+                      <a:prstDash val="solid"/>
+                    </a:lnR>
+                    <a:lnT w="9525" cap="flat" cmpd="sng" algn="ctr">
+                      <a:solidFill>
+                        <a:srgbClr val="D5DAE0"/>
+                      </a:solidFill>
+                      <a:prstDash val="solid"/>
+                    </a:lnT>
+                    <a:lnB w="9525" cap="flat" cmpd="sng" algn="ctr">
+                      <a:solidFill>
+                        <a:srgbClr val="D5DAE0"/>
+                      </a:solidFill>
+                      <a:prstDash val="solid"/>
+                    </a:lnB>
+                  </a:tcPr>
+                </a:tc>
+                <a:tc>
+                  <a:txBody>
+                    <a:bodyPr/>
+                    <a:lstStyle/>
+                    <a:p>
+                      <a:r>
+                        <a:rPr sz="1250" b="0">
+                          <a:solidFill>
+                            <a:srgbClr val="1F2933"/>
+                          </a:solidFill>
+                          <a:latin typeface="Calibri"/>
+                        </a:rPr>
+                        <a:t>Cognitive function</a:t>
+                      </a:r>
+                    </a:p>
+                  </a:txBody>
+                  <a:tcPr marL="64008" marR="64008" marT="45720" marB="45720">
+                    <a:solidFill>
+                      <a:srgbClr val="FFFFFF"/>
+                    </a:solidFill>
+                    <a:lnL w="9525" cap="flat" cmpd="sng" algn="ctr">
+                      <a:solidFill>
+                        <a:srgbClr val="D5DAE0"/>
+                      </a:solidFill>
+                      <a:prstDash val="solid"/>
+                    </a:lnL>
+                    <a:lnR w="9525" cap="flat" cmpd="sng" algn="ctr">
+                      <a:solidFill>
+                        <a:srgbClr val="D5DAE0"/>
+                      </a:solidFill>
+                      <a:prstDash val="solid"/>
+                    </a:lnR>
+                    <a:lnT w="9525" cap="flat" cmpd="sng" algn="ctr">
+                      <a:solidFill>
+                        <a:srgbClr val="D5DAE0"/>
+                      </a:solidFill>
+                      <a:prstDash val="solid"/>
+                    </a:lnT>
+                    <a:lnB w="9525" cap="flat" cmpd="sng" algn="ctr">
+                      <a:solidFill>
+                        <a:srgbClr val="D5DAE0"/>
+                      </a:solidFill>
+                      <a:prstDash val="solid"/>
+                    </a:lnB>
+                  </a:tcPr>
+                </a:tc>
+                <a:tc>
+                  <a:txBody>
+                    <a:bodyPr/>
+                    <a:lstStyle/>
+                    <a:p>
+                      <a:r>
+                        <a:rPr sz="1250" b="0">
+                          <a:solidFill>
+                            <a:srgbClr val="1F2933"/>
+                          </a:solidFill>
+                          <a:latin typeface="Calibri"/>
+                        </a:rPr>
+                        <a:t>&lt; about -0.5</a:t>
+                      </a:r>
+                    </a:p>
+                  </a:txBody>
+                  <a:tcPr marL="64008" marR="64008" marT="45720" marB="45720">
+                    <a:solidFill>
+                      <a:srgbClr val="FFFFFF"/>
+                    </a:solidFill>
+                    <a:lnL w="9525" cap="flat" cmpd="sng" algn="ctr">
+                      <a:solidFill>
+                        <a:srgbClr val="D5DAE0"/>
+                      </a:solidFill>
+                      <a:prstDash val="solid"/>
+                    </a:lnL>
+                    <a:lnR w="9525" cap="flat" cmpd="sng" algn="ctr">
+                      <a:solidFill>
+                        <a:srgbClr val="D5DAE0"/>
+                      </a:solidFill>
+                      <a:prstDash val="solid"/>
+                    </a:lnR>
+                    <a:lnT w="9525" cap="flat" cmpd="sng" algn="ctr">
+                      <a:solidFill>
+                        <a:srgbClr val="D5DAE0"/>
+                      </a:solidFill>
+                      <a:prstDash val="solid"/>
+                    </a:lnT>
+                    <a:lnB w="9525" cap="flat" cmpd="sng" algn="ctr">
+                      <a:solidFill>
+                        <a:srgbClr val="D5DAE0"/>
+                      </a:solidFill>
+                      <a:prstDash val="solid"/>
+                    </a:lnB>
+                  </a:tcPr>
+                </a:tc>
+                <a:tc>
+                  <a:txBody>
+                    <a:bodyPr/>
+                    <a:lstStyle/>
+                    <a:p>
+                      <a:r>
+                        <a:rPr sz="1250" b="0">
+                          <a:solidFill>
+                            <a:srgbClr val="1F2933"/>
+                          </a:solidFill>
+                          <a:latin typeface="Calibri"/>
+                        </a:rPr>
+                        <a:t>17 of 23 (74%) vs 3 of 18 (17%)</a:t>
+                      </a:r>
+                    </a:p>
+                  </a:txBody>
+                  <a:tcPr marL="64008" marR="64008" marT="45720" marB="45720">
+                    <a:solidFill>
+                      <a:srgbClr val="FFFFFF"/>
+                    </a:solidFill>
+                    <a:lnL w="9525" cap="flat" cmpd="sng" algn="ctr">
+                      <a:solidFill>
+                        <a:srgbClr val="D5DAE0"/>
+                      </a:solidFill>
+                      <a:prstDash val="solid"/>
+                    </a:lnL>
+                    <a:lnR w="9525" cap="flat" cmpd="sng" algn="ctr">
+                      <a:solidFill>
+                        <a:srgbClr val="D5DAE0"/>
+                      </a:solidFill>
+                      <a:prstDash val="solid"/>
+                    </a:lnR>
+                    <a:lnT w="9525" cap="flat" cmpd="sng" algn="ctr">
+                      <a:solidFill>
+                        <a:srgbClr val="D5DAE0"/>
+                      </a:solidFill>
+                      <a:prstDash val="solid"/>
+                    </a:lnT>
+                    <a:lnB w="9525" cap="flat" cmpd="sng" algn="ctr">
+                      <a:solidFill>
+                        <a:srgbClr val="D5DAE0"/>
+                      </a:solidFill>
+                      <a:prstDash val="solid"/>
+                    </a:lnB>
+                  </a:tcPr>
+                </a:tc>
+                <a:tc>
+                  <a:txBody>
+                    <a:bodyPr/>
+                    <a:lstStyle/>
+                    <a:p>
+                      <a:r>
+                        <a:rPr sz="1250" b="0">
+                          <a:solidFill>
+                            <a:srgbClr val="1F2933"/>
+                          </a:solidFill>
+                          <a:latin typeface="Calibri"/>
+                        </a:rPr>
+                        <a:t>AUC 0.78 (linear with cut-off), 0.87 (forest); R² 0.45 / 0.56</a:t>
+                      </a:r>
+                    </a:p>
+                  </a:txBody>
+                  <a:tcPr marL="64008" marR="64008" marT="45720" marB="45720">
+                    <a:solidFill>
+                      <a:srgbClr val="FFFFFF"/>
+                    </a:solidFill>
+                    <a:lnL w="9525" cap="flat" cmpd="sng" algn="ctr">
+                      <a:solidFill>
+                        <a:srgbClr val="D5DAE0"/>
+                      </a:solidFill>
+                      <a:prstDash val="solid"/>
+                    </a:lnL>
+                    <a:lnR w="9525" cap="flat" cmpd="sng" algn="ctr">
+                      <a:solidFill>
+                        <a:srgbClr val="D5DAE0"/>
+                      </a:solidFill>
+                      <a:prstDash val="solid"/>
+                    </a:lnR>
+                    <a:lnT w="9525" cap="flat" cmpd="sng" algn="ctr">
+                      <a:solidFill>
+                        <a:srgbClr val="D5DAE0"/>
+                      </a:solidFill>
+                      <a:prstDash val="solid"/>
+                    </a:lnT>
+                    <a:lnB w="9525" cap="flat" cmpd="sng" algn="ctr">
+                      <a:solidFill>
+                        <a:srgbClr val="D5DAE0"/>
+                      </a:solidFill>
+                      <a:prstDash val="solid"/>
+                    </a:lnB>
+                  </a:tcPr>
+                </a:tc>
+                <a:tc>
+                  <a:txBody>
+                    <a:bodyPr/>
+                    <a:lstStyle/>
+                    <a:p>
+                      <a:r>
+                        <a:rPr sz="1250" b="0">
+                          <a:solidFill>
+                            <a:srgbClr val="1F2933"/>
+                          </a:solidFill>
+                          <a:latin typeface="Calibri"/>
+                        </a:rPr>
+                        <a:t>Enrich for cognitive impairment: 48% → 74% responders</a:t>
+                      </a:r>
+                    </a:p>
+                  </a:txBody>
+                  <a:tcPr marL="64008" marR="64008" marT="45720" marB="45720">
+                    <a:solidFill>
+                      <a:srgbClr val="FFFFFF"/>
+                    </a:solidFill>
+                    <a:lnL w="9525" cap="flat" cmpd="sng" algn="ctr">
+                      <a:solidFill>
+                        <a:srgbClr val="D5DAE0"/>
+                      </a:solidFill>
+                      <a:prstDash val="solid"/>
+                    </a:lnL>
+                    <a:lnR w="9525" cap="flat" cmpd="sng" algn="ctr">
+                      <a:solidFill>
+                        <a:srgbClr val="D5DAE0"/>
+                      </a:solidFill>
+                      <a:prstDash val="solid"/>
+                    </a:lnR>
+                    <a:lnT w="9525" cap="flat" cmpd="sng" algn="ctr">
+                      <a:solidFill>
+                        <a:srgbClr val="D5DAE0"/>
+                      </a:solidFill>
+                      <a:prstDash val="solid"/>
+                    </a:lnT>
+                    <a:lnB w="9525" cap="flat" cmpd="sng" algn="ctr">
+                      <a:solidFill>
+                        <a:srgbClr val="D5DAE0"/>
+                      </a:solidFill>
+                      <a:prstDash val="solid"/>
+                    </a:lnB>
+                  </a:tcPr>
+                </a:tc>
+              </a:tr>
+            </a:tbl>
+          </a:graphicData>
+        </a:graphic>
+      </p:graphicFrame>
     </p:spTree>
   </p:cSld>
   <p:clrMapOvr>

</xml_diff>

<commit_message>
Backup slide: four independent pipelines, one answer (credits each teammate's work)
Co-Authored-By: Claude Fable 5.1 <noreply@anthropic.com>
</commit_message>
<xml_diff>
--- a/slides/Team1_DM1_slides.pptx
+++ b/slides/Team1_DM1_slides.pptx
@@ -18,9 +18,10 @@
     <p:sldId id="266" r:id="rId12"/>
     <p:sldId id="267" r:id="rId13"/>
     <p:sldId id="268" r:id="rId14"/>
+    <p:sldId id="269" r:id="rId15"/>
   </p:sldIdLst>
   <p:notesMasterIdLst>
-    <p:notesMasterId r:id="rId15"/>
+    <p:notesMasterId r:id="rId16"/>
   </p:notesMasterIdLst>
   <p:sldSz cx="12192000" cy="6858000"/>
   <p:notesSz cx="6858000" cy="12192000"/>
@@ -119,7 +120,7 @@
   <p:extLst>
     <p:ext uri="{521415D9-36F7-43E2-AB2F-B90AF26B5E84}">
       <p14:sectionLst xmlns:p14="http://schemas.microsoft.com/office/powerpoint/2010/main">
-        <p14:section name="Talk" id="{714136dd-dd65-b501-c924-911c55353c00}">
+        <p14:section name="Talk" id="{0f0ce21d-74ba-4154-fcbe-0afa6d39d23b}">
           <p14:sldIdLst>
             <p14:sldId id="256"/>
             <p14:sldId id="257"/>
@@ -131,13 +132,14 @@
             <p14:sldId id="263"/>
           </p14:sldIdLst>
         </p14:section>
-        <p14:section name="Backup" id="{d42aad2f-608c-de45-3675-7db6b9d6a017}">
+        <p14:section name="Backup" id="{c0dd6b7c-3ded-48ae-66f9-d83a9068aaa4}">
           <p14:sldIdLst>
             <p14:sldId id="264"/>
             <p14:sldId id="265"/>
             <p14:sldId id="266"/>
             <p14:sldId id="267"/>
             <p14:sldId id="268"/>
+            <p14:sldId id="269"/>
           </p14:sldIdLst>
         </p14:section>
       </p14:sectionLst>
@@ -896,7 +898,7 @@
           <a:p>
             <a:r>
               <a:rPr lang="en-US" dirty="0"/>
-              <a:t/>
+              <a:t>If asked how we know the covariates are not an artefact of one person's choices: four pipelines, written independently in R and Python with different splits and different method sets, found the same three covariates. The talk slides quote one pipeline so that every number comes from the same held-out patients; the others are replication.</a:t>
             </a:r>
             <a:endParaRPr lang="en-US" dirty="0"/>
           </a:p>
@@ -920,6 +922,94 @@
             <a:fld id="{F7021451-1387-4CA6-816F-3879F97B5CBC}" type="slidenum">
               <a:rPr lang="en-US"/>
               <a:t>13</a:t>
+            </a:fld>
+            <a:endParaRPr lang="en-US"/>
+          </a:p>
+        </p:txBody>
+      </p:sp>
+    </p:spTree>
+    <p:extLst>
+      <p:ext uri="{BB962C8B-B14F-4D97-AF65-F5344CB8AC3E}">
+        <p14:creationId xmlns:p14="http://schemas.microsoft.com/office/powerpoint/2010/main" val="1024086991"/>
+      </p:ext>
+    </p:extLst>
+  </p:cSld>
+  <p:clrMapOvr>
+    <a:masterClrMapping/>
+  </p:clrMapOvr>
+</p:notes>
+</file>
+
+<file path=ppt/notesSlides/notesSlide14.xml><?xml version="1.0" encoding="utf-8"?>
+<p:notes xmlns:a="http://schemas.openxmlformats.org/drawingml/2006/main" xmlns:r="http://schemas.openxmlformats.org/officeDocument/2006/relationships" xmlns:p="http://schemas.openxmlformats.org/presentationml/2006/main">
+  <p:cSld>
+    <p:spTree>
+      <p:nvGrpSpPr>
+        <p:cNvPr id="1" name=""/>
+        <p:cNvGrpSpPr/>
+        <p:nvPr/>
+      </p:nvGrpSpPr>
+      <p:grpSpPr>
+        <a:xfrm>
+          <a:off x="0" y="0"/>
+          <a:ext cx="0" cy="0"/>
+          <a:chOff x="0" y="0"/>
+          <a:chExt cx="0" cy="0"/>
+        </a:xfrm>
+      </p:grpSpPr>
+      <p:sp>
+        <p:nvSpPr>
+          <p:cNvPr id="2" name="Slide Image Placeholder 1"/>
+          <p:cNvSpPr>
+            <a:spLocks noGrp="1" noRot="1" noChangeAspect="1"/>
+          </p:cNvSpPr>
+          <p:nvPr>
+            <p:ph type="sldImg"/>
+          </p:nvPr>
+        </p:nvSpPr>
+        <p:spPr/>
+      </p:sp>
+      <p:sp>
+        <p:nvSpPr>
+          <p:cNvPr id="3" name="Notes Placeholder 2"/>
+          <p:cNvSpPr>
+            <a:spLocks noGrp="1"/>
+          </p:cNvSpPr>
+          <p:nvPr>
+            <p:ph type="body" idx="1"/>
+          </p:nvPr>
+        </p:nvSpPr>
+        <p:spPr/>
+        <p:txBody>
+          <a:bodyPr/>
+          <a:lstStyle/>
+          <a:p>
+            <a:r>
+              <a:rPr lang="en-US" dirty="0"/>
+              <a:t/>
+            </a:r>
+            <a:endParaRPr lang="en-US" dirty="0"/>
+          </a:p>
+        </p:txBody>
+      </p:sp>
+      <p:sp>
+        <p:nvSpPr>
+          <p:cNvPr id="4" name="Slide Number Placeholder 3"/>
+          <p:cNvSpPr>
+            <a:spLocks noGrp="1"/>
+          </p:cNvSpPr>
+          <p:nvPr>
+            <p:ph type="sldNum" sz="quarter" idx="10"/>
+          </p:nvPr>
+        </p:nvSpPr>
+        <p:spPr/>
+        <p:txBody>
+          <a:bodyPr/>
+          <a:lstStyle/>
+          <a:p>
+            <a:fld id="{F7021451-1387-4CA6-816F-3879F97B5CBC}" type="slidenum">
+              <a:rPr lang="en-US"/>
+              <a:t>14</a:t>
             </a:fld>
             <a:endParaRPr lang="en-US"/>
           </a:p>
@@ -4014,6 +4104,1326 @@
                   <a:srgbClr val="000000"/>
                 </a:solidFill>
               </a:rPr>
+              <a:t>Backup: four independent pipelines, one answer</a:t>
+            </a:r>
+            <a:endParaRPr lang="en-US" sz="2600" dirty="0"/>
+          </a:p>
+        </p:txBody>
+      </p:sp>
+      <p:graphicFrame>
+        <p:nvGraphicFramePr>
+          <p:cNvPr id="14" name="Table 0"/>
+          <p:cNvGraphicFramePr>
+            <a:graphicFrameLocks noGrp="1"/>
+          </p:cNvGraphicFramePr>
+          <p:nvPr>
+            <p:extLst>
+              <p:ext uri="{D42A27DB-BD31-4B8C-83A1-F6EECF244321}">
+                <p14:modId xmlns:p14="http://schemas.microsoft.com/office/powerpoint/2010/main" val="1579011935"/>
+              </p:ext>
+            </p:extLst>
+          </p:nvPr>
+        </p:nvGraphicFramePr>
+        <p:xfrm>
+          <a:off x="548640" y="1417320"/>
+          <a:ext cx="11064240" cy="914400"/>
+        </p:xfrm>
+        <a:graphic>
+          <a:graphicData uri="http://schemas.openxmlformats.org/drawingml/2006/table">
+            <a:tbl>
+              <a:tblPr/>
+              <a:tblGrid>
+                <a:gridCol w="1554480"/>
+                <a:gridCol w="2743200"/>
+                <a:gridCol w="4206240"/>
+                <a:gridCol w="2560320"/>
+              </a:tblGrid>
+              <a:tr h="457200">
+                <a:tc>
+                  <a:txBody>
+                    <a:bodyPr/>
+                    <a:lstStyle/>
+                    <a:p>
+                      <a:pPr indent="0" marL="0">
+                        <a:buNone/>
+                      </a:pPr>
+                      <a:r>
+                        <a:rPr lang="en-US" sz="1250" b="1" dirty="0">
+                          <a:solidFill>
+                            <a:srgbClr val="000000"/>
+                          </a:solidFill>
+                        </a:rPr>
+                        <a:t>Who</a:t>
+                      </a:r>
+                      <a:endParaRPr lang="en-US" sz="1250" dirty="0"/>
+                    </a:p>
+                  </a:txBody>
+                  <a:tcPr marL="76200" marR="76200" marT="50800" marB="50800" anchor="ctr">
+                    <a:lnL w="9525" cap="flat" cmpd="sng" algn="ctr">
+                      <a:solidFill>
+                        <a:srgbClr val="D5DAE0"/>
+                      </a:solidFill>
+                      <a:prstDash val="solid"/>
+                      <a:round/>
+                      <a:headEnd type="none" w="med" len="med"/>
+                      <a:tailEnd type="none" w="med" len="med"/>
+                    </a:lnL>
+                    <a:lnR w="9525" cap="flat" cmpd="sng" algn="ctr">
+                      <a:solidFill>
+                        <a:srgbClr val="D5DAE0"/>
+                      </a:solidFill>
+                      <a:prstDash val="solid"/>
+                      <a:round/>
+                      <a:headEnd type="none" w="med" len="med"/>
+                      <a:tailEnd type="none" w="med" len="med"/>
+                    </a:lnR>
+                    <a:lnT w="9525" cap="flat" cmpd="sng" algn="ctr">
+                      <a:solidFill>
+                        <a:srgbClr val="D5DAE0"/>
+                      </a:solidFill>
+                      <a:prstDash val="solid"/>
+                      <a:round/>
+                      <a:headEnd type="none" w="med" len="med"/>
+                      <a:tailEnd type="none" w="med" len="med"/>
+                    </a:lnT>
+                    <a:lnB w="9525" cap="flat" cmpd="sng" algn="ctr">
+                      <a:solidFill>
+                        <a:srgbClr val="D5DAE0"/>
+                      </a:solidFill>
+                      <a:prstDash val="solid"/>
+                      <a:round/>
+                      <a:headEnd type="none" w="med" len="med"/>
+                      <a:tailEnd type="none" w="med" len="med"/>
+                    </a:lnB>
+                    <a:solidFill>
+                      <a:srgbClr val="F2F2F2"/>
+                    </a:solidFill>
+                  </a:tcPr>
+                </a:tc>
+                <a:tc>
+                  <a:txBody>
+                    <a:bodyPr/>
+                    <a:lstStyle/>
+                    <a:p>
+                      <a:pPr indent="0" marL="0">
+                        <a:buNone/>
+                      </a:pPr>
+                      <a:r>
+                        <a:rPr lang="en-US" sz="1250" b="1" dirty="0">
+                          <a:solidFill>
+                            <a:srgbClr val="000000"/>
+                          </a:solidFill>
+                        </a:rPr>
+                        <a:t>Code and split</a:t>
+                      </a:r>
+                      <a:endParaRPr lang="en-US" sz="1250" dirty="0"/>
+                    </a:p>
+                  </a:txBody>
+                  <a:tcPr marL="76200" marR="76200" marT="50800" marB="50800" anchor="ctr">
+                    <a:lnL w="9525" cap="flat" cmpd="sng" algn="ctr">
+                      <a:solidFill>
+                        <a:srgbClr val="D5DAE0"/>
+                      </a:solidFill>
+                      <a:prstDash val="solid"/>
+                      <a:round/>
+                      <a:headEnd type="none" w="med" len="med"/>
+                      <a:tailEnd type="none" w="med" len="med"/>
+                    </a:lnL>
+                    <a:lnR w="9525" cap="flat" cmpd="sng" algn="ctr">
+                      <a:solidFill>
+                        <a:srgbClr val="D5DAE0"/>
+                      </a:solidFill>
+                      <a:prstDash val="solid"/>
+                      <a:round/>
+                      <a:headEnd type="none" w="med" len="med"/>
+                      <a:tailEnd type="none" w="med" len="med"/>
+                    </a:lnR>
+                    <a:lnT w="9525" cap="flat" cmpd="sng" algn="ctr">
+                      <a:solidFill>
+                        <a:srgbClr val="D5DAE0"/>
+                      </a:solidFill>
+                      <a:prstDash val="solid"/>
+                      <a:round/>
+                      <a:headEnd type="none" w="med" len="med"/>
+                      <a:tailEnd type="none" w="med" len="med"/>
+                    </a:lnT>
+                    <a:lnB w="9525" cap="flat" cmpd="sng" algn="ctr">
+                      <a:solidFill>
+                        <a:srgbClr val="D5DAE0"/>
+                      </a:solidFill>
+                      <a:prstDash val="solid"/>
+                      <a:round/>
+                      <a:headEnd type="none" w="med" len="med"/>
+                      <a:tailEnd type="none" w="med" len="med"/>
+                    </a:lnB>
+                    <a:solidFill>
+                      <a:srgbClr val="F2F2F2"/>
+                    </a:solidFill>
+                  </a:tcPr>
+                </a:tc>
+                <a:tc>
+                  <a:txBody>
+                    <a:bodyPr/>
+                    <a:lstStyle/>
+                    <a:p>
+                      <a:pPr indent="0" marL="0">
+                        <a:buNone/>
+                      </a:pPr>
+                      <a:r>
+                        <a:rPr lang="en-US" sz="1250" b="1" dirty="0">
+                          <a:solidFill>
+                            <a:srgbClr val="000000"/>
+                          </a:solidFill>
+                        </a:rPr>
+                        <a:t>Methods and checks</a:t>
+                      </a:r>
+                      <a:endParaRPr lang="en-US" sz="1250" dirty="0"/>
+                    </a:p>
+                  </a:txBody>
+                  <a:tcPr marL="76200" marR="76200" marT="50800" marB="50800" anchor="ctr">
+                    <a:lnL w="9525" cap="flat" cmpd="sng" algn="ctr">
+                      <a:solidFill>
+                        <a:srgbClr val="D5DAE0"/>
+                      </a:solidFill>
+                      <a:prstDash val="solid"/>
+                      <a:round/>
+                      <a:headEnd type="none" w="med" len="med"/>
+                      <a:tailEnd type="none" w="med" len="med"/>
+                    </a:lnL>
+                    <a:lnR w="9525" cap="flat" cmpd="sng" algn="ctr">
+                      <a:solidFill>
+                        <a:srgbClr val="D5DAE0"/>
+                      </a:solidFill>
+                      <a:prstDash val="solid"/>
+                      <a:round/>
+                      <a:headEnd type="none" w="med" len="med"/>
+                      <a:tailEnd type="none" w="med" len="med"/>
+                    </a:lnR>
+                    <a:lnT w="9525" cap="flat" cmpd="sng" algn="ctr">
+                      <a:solidFill>
+                        <a:srgbClr val="D5DAE0"/>
+                      </a:solidFill>
+                      <a:prstDash val="solid"/>
+                      <a:round/>
+                      <a:headEnd type="none" w="med" len="med"/>
+                      <a:tailEnd type="none" w="med" len="med"/>
+                    </a:lnT>
+                    <a:lnB w="9525" cap="flat" cmpd="sng" algn="ctr">
+                      <a:solidFill>
+                        <a:srgbClr val="D5DAE0"/>
+                      </a:solidFill>
+                      <a:prstDash val="solid"/>
+                      <a:round/>
+                      <a:headEnd type="none" w="med" len="med"/>
+                      <a:tailEnd type="none" w="med" len="med"/>
+                    </a:lnB>
+                    <a:solidFill>
+                      <a:srgbClr val="F2F2F2"/>
+                    </a:solidFill>
+                  </a:tcPr>
+                </a:tc>
+                <a:tc>
+                  <a:txBody>
+                    <a:bodyPr/>
+                    <a:lstStyle/>
+                    <a:p>
+                      <a:pPr indent="0" marL="0">
+                        <a:buNone/>
+                      </a:pPr>
+                      <a:r>
+                        <a:rPr lang="en-US" sz="1250" b="1" dirty="0">
+                          <a:solidFill>
+                            <a:srgbClr val="000000"/>
+                          </a:solidFill>
+                        </a:rPr>
+                        <a:t>Lead covariate: mexiletine / oligonucleotide / tideglusib</a:t>
+                      </a:r>
+                      <a:endParaRPr lang="en-US" sz="1250" dirty="0"/>
+                    </a:p>
+                  </a:txBody>
+                  <a:tcPr marL="76200" marR="76200" marT="50800" marB="50800" anchor="ctr">
+                    <a:lnL w="9525" cap="flat" cmpd="sng" algn="ctr">
+                      <a:solidFill>
+                        <a:srgbClr val="D5DAE0"/>
+                      </a:solidFill>
+                      <a:prstDash val="solid"/>
+                      <a:round/>
+                      <a:headEnd type="none" w="med" len="med"/>
+                      <a:tailEnd type="none" w="med" len="med"/>
+                    </a:lnL>
+                    <a:lnR w="9525" cap="flat" cmpd="sng" algn="ctr">
+                      <a:solidFill>
+                        <a:srgbClr val="D5DAE0"/>
+                      </a:solidFill>
+                      <a:prstDash val="solid"/>
+                      <a:round/>
+                      <a:headEnd type="none" w="med" len="med"/>
+                      <a:tailEnd type="none" w="med" len="med"/>
+                    </a:lnR>
+                    <a:lnT w="9525" cap="flat" cmpd="sng" algn="ctr">
+                      <a:solidFill>
+                        <a:srgbClr val="D5DAE0"/>
+                      </a:solidFill>
+                      <a:prstDash val="solid"/>
+                      <a:round/>
+                      <a:headEnd type="none" w="med" len="med"/>
+                      <a:tailEnd type="none" w="med" len="med"/>
+                    </a:lnT>
+                    <a:lnB w="9525" cap="flat" cmpd="sng" algn="ctr">
+                      <a:solidFill>
+                        <a:srgbClr val="D5DAE0"/>
+                      </a:solidFill>
+                      <a:prstDash val="solid"/>
+                      <a:round/>
+                      <a:headEnd type="none" w="med" len="med"/>
+                      <a:tailEnd type="none" w="med" len="med"/>
+                    </a:lnB>
+                    <a:solidFill>
+                      <a:srgbClr val="F2F2F2"/>
+                    </a:solidFill>
+                  </a:tcPr>
+                </a:tc>
+              </a:tr>
+              <a:tr h="777240">
+                <a:tc>
+                  <a:txBody>
+                    <a:bodyPr/>
+                    <a:lstStyle/>
+                    <a:p>
+                      <a:pPr indent="0" marL="0">
+                        <a:buNone/>
+                      </a:pPr>
+                      <a:r>
+                        <a:rPr lang="en-US" sz="1250" b="1" dirty="0">
+                          <a:solidFill>
+                            <a:srgbClr val="1F2933"/>
+                          </a:solidFill>
+                        </a:rPr>
+                        <a:t>Euibeom Shin</a:t>
+                      </a:r>
+                      <a:endParaRPr lang="en-US" sz="1250" dirty="0"/>
+                    </a:p>
+                  </a:txBody>
+                  <a:tcPr marL="76200" marR="76200" marT="50800" marB="50800" anchor="ctr">
+                    <a:lnL w="9525" cap="flat" cmpd="sng" algn="ctr">
+                      <a:solidFill>
+                        <a:srgbClr val="D5DAE0"/>
+                      </a:solidFill>
+                      <a:prstDash val="solid"/>
+                      <a:round/>
+                      <a:headEnd type="none" w="med" len="med"/>
+                      <a:tailEnd type="none" w="med" len="med"/>
+                    </a:lnL>
+                    <a:lnR w="9525" cap="flat" cmpd="sng" algn="ctr">
+                      <a:solidFill>
+                        <a:srgbClr val="D5DAE0"/>
+                      </a:solidFill>
+                      <a:prstDash val="solid"/>
+                      <a:round/>
+                      <a:headEnd type="none" w="med" len="med"/>
+                      <a:tailEnd type="none" w="med" len="med"/>
+                    </a:lnR>
+                    <a:lnT w="9525" cap="flat" cmpd="sng" algn="ctr">
+                      <a:solidFill>
+                        <a:srgbClr val="D5DAE0"/>
+                      </a:solidFill>
+                      <a:prstDash val="solid"/>
+                      <a:round/>
+                      <a:headEnd type="none" w="med" len="med"/>
+                      <a:tailEnd type="none" w="med" len="med"/>
+                    </a:lnT>
+                    <a:lnB w="9525" cap="flat" cmpd="sng" algn="ctr">
+                      <a:solidFill>
+                        <a:srgbClr val="D5DAE0"/>
+                      </a:solidFill>
+                      <a:prstDash val="solid"/>
+                      <a:round/>
+                      <a:headEnd type="none" w="med" len="med"/>
+                      <a:tailEnd type="none" w="med" len="med"/>
+                    </a:lnB>
+                  </a:tcPr>
+                </a:tc>
+                <a:tc>
+                  <a:txBody>
+                    <a:bodyPr/>
+                    <a:lstStyle/>
+                    <a:p>
+                      <a:pPr indent="0" marL="0">
+                        <a:buNone/>
+                      </a:pPr>
+                      <a:r>
+                        <a:rPr lang="en-US" sz="1250" dirty="0">
+                          <a:solidFill>
+                            <a:srgbClr val="1F2933"/>
+                          </a:solidFill>
+                        </a:rPr>
+                        <a:t>R; 75/25 stratified by response and onset, seed 20261011; 20-seed sensitivity</a:t>
+                      </a:r>
+                      <a:endParaRPr lang="en-US" sz="1250" dirty="0"/>
+                    </a:p>
+                  </a:txBody>
+                  <a:tcPr marL="76200" marR="76200" marT="50800" marB="50800" anchor="ctr">
+                    <a:lnL w="9525" cap="flat" cmpd="sng" algn="ctr">
+                      <a:solidFill>
+                        <a:srgbClr val="D5DAE0"/>
+                      </a:solidFill>
+                      <a:prstDash val="solid"/>
+                      <a:round/>
+                      <a:headEnd type="none" w="med" len="med"/>
+                      <a:tailEnd type="none" w="med" len="med"/>
+                    </a:lnL>
+                    <a:lnR w="9525" cap="flat" cmpd="sng" algn="ctr">
+                      <a:solidFill>
+                        <a:srgbClr val="D5DAE0"/>
+                      </a:solidFill>
+                      <a:prstDash val="solid"/>
+                      <a:round/>
+                      <a:headEnd type="none" w="med" len="med"/>
+                      <a:tailEnd type="none" w="med" len="med"/>
+                    </a:lnR>
+                    <a:lnT w="9525" cap="flat" cmpd="sng" algn="ctr">
+                      <a:solidFill>
+                        <a:srgbClr val="D5DAE0"/>
+                      </a:solidFill>
+                      <a:prstDash val="solid"/>
+                      <a:round/>
+                      <a:headEnd type="none" w="med" len="med"/>
+                      <a:tailEnd type="none" w="med" len="med"/>
+                    </a:lnT>
+                    <a:lnB w="9525" cap="flat" cmpd="sng" algn="ctr">
+                      <a:solidFill>
+                        <a:srgbClr val="D5DAE0"/>
+                      </a:solidFill>
+                      <a:prstDash val="solid"/>
+                      <a:round/>
+                      <a:headEnd type="none" w="med" len="med"/>
+                      <a:tailEnd type="none" w="med" len="med"/>
+                    </a:lnB>
+                  </a:tcPr>
+                </a:tc>
+                <a:tc>
+                  <a:txBody>
+                    <a:bodyPr/>
+                    <a:lstStyle/>
+                    <a:p>
+                      <a:pPr indent="0" marL="0">
+                        <a:buNone/>
+                      </a:pPr>
+                      <a:r>
+                        <a:rPr lang="en-US" sz="1250" dirty="0">
+                          <a:solidFill>
+                            <a:srgbClr val="1F2933"/>
+                          </a:solidFill>
+                        </a:rPr>
+                        <a:t>Stepwise, LASSO, elastic net, random forest, XGBoost; pure-noise covariate, 200 bootstrap resamples, 5-method vote. Source of every number on the talk slides</a:t>
+                      </a:r>
+                      <a:endParaRPr lang="en-US" sz="1250" dirty="0"/>
+                    </a:p>
+                  </a:txBody>
+                  <a:tcPr marL="76200" marR="76200" marT="50800" marB="50800" anchor="ctr">
+                    <a:lnL w="9525" cap="flat" cmpd="sng" algn="ctr">
+                      <a:solidFill>
+                        <a:srgbClr val="D5DAE0"/>
+                      </a:solidFill>
+                      <a:prstDash val="solid"/>
+                      <a:round/>
+                      <a:headEnd type="none" w="med" len="med"/>
+                      <a:tailEnd type="none" w="med" len="med"/>
+                    </a:lnL>
+                    <a:lnR w="9525" cap="flat" cmpd="sng" algn="ctr">
+                      <a:solidFill>
+                        <a:srgbClr val="D5DAE0"/>
+                      </a:solidFill>
+                      <a:prstDash val="solid"/>
+                      <a:round/>
+                      <a:headEnd type="none" w="med" len="med"/>
+                      <a:tailEnd type="none" w="med" len="med"/>
+                    </a:lnR>
+                    <a:lnT w="9525" cap="flat" cmpd="sng" algn="ctr">
+                      <a:solidFill>
+                        <a:srgbClr val="D5DAE0"/>
+                      </a:solidFill>
+                      <a:prstDash val="solid"/>
+                      <a:round/>
+                      <a:headEnd type="none" w="med" len="med"/>
+                      <a:tailEnd type="none" w="med" len="med"/>
+                    </a:lnT>
+                    <a:lnB w="9525" cap="flat" cmpd="sng" algn="ctr">
+                      <a:solidFill>
+                        <a:srgbClr val="D5DAE0"/>
+                      </a:solidFill>
+                      <a:prstDash val="solid"/>
+                      <a:round/>
+                      <a:headEnd type="none" w="med" len="med"/>
+                      <a:tailEnd type="none" w="med" len="med"/>
+                    </a:lnB>
+                  </a:tcPr>
+                </a:tc>
+                <a:tc>
+                  <a:txBody>
+                    <a:bodyPr/>
+                    <a:lstStyle/>
+                    <a:p>
+                      <a:pPr indent="0" marL="0">
+                        <a:buNone/>
+                      </a:pPr>
+                      <a:r>
+                        <a:rPr lang="en-US" sz="1250" dirty="0">
+                          <a:solidFill>
+                            <a:srgbClr val="1F2933"/>
+                          </a:solidFill>
+                        </a:rPr>
+                        <a:t>Myotonia severity / CTG repeats / cognitive function</a:t>
+                      </a:r>
+                      <a:endParaRPr lang="en-US" sz="1250" dirty="0"/>
+                    </a:p>
+                  </a:txBody>
+                  <a:tcPr marL="76200" marR="76200" marT="50800" marB="50800" anchor="ctr">
+                    <a:lnL w="9525" cap="flat" cmpd="sng" algn="ctr">
+                      <a:solidFill>
+                        <a:srgbClr val="D5DAE0"/>
+                      </a:solidFill>
+                      <a:prstDash val="solid"/>
+                      <a:round/>
+                      <a:headEnd type="none" w="med" len="med"/>
+                      <a:tailEnd type="none" w="med" len="med"/>
+                    </a:lnL>
+                    <a:lnR w="9525" cap="flat" cmpd="sng" algn="ctr">
+                      <a:solidFill>
+                        <a:srgbClr val="D5DAE0"/>
+                      </a:solidFill>
+                      <a:prstDash val="solid"/>
+                      <a:round/>
+                      <a:headEnd type="none" w="med" len="med"/>
+                      <a:tailEnd type="none" w="med" len="med"/>
+                    </a:lnR>
+                    <a:lnT w="9525" cap="flat" cmpd="sng" algn="ctr">
+                      <a:solidFill>
+                        <a:srgbClr val="D5DAE0"/>
+                      </a:solidFill>
+                      <a:prstDash val="solid"/>
+                      <a:round/>
+                      <a:headEnd type="none" w="med" len="med"/>
+                      <a:tailEnd type="none" w="med" len="med"/>
+                    </a:lnT>
+                    <a:lnB w="9525" cap="flat" cmpd="sng" algn="ctr">
+                      <a:solidFill>
+                        <a:srgbClr val="D5DAE0"/>
+                      </a:solidFill>
+                      <a:prstDash val="solid"/>
+                      <a:round/>
+                      <a:headEnd type="none" w="med" len="med"/>
+                      <a:tailEnd type="none" w="med" len="med"/>
+                    </a:lnB>
+                  </a:tcPr>
+                </a:tc>
+              </a:tr>
+              <a:tr h="777240">
+                <a:tc>
+                  <a:txBody>
+                    <a:bodyPr/>
+                    <a:lstStyle/>
+                    <a:p>
+                      <a:pPr indent="0" marL="0">
+                        <a:buNone/>
+                      </a:pPr>
+                      <a:r>
+                        <a:rPr lang="en-US" sz="1250" b="1" dirty="0">
+                          <a:solidFill>
+                            <a:srgbClr val="1F2933"/>
+                          </a:solidFill>
+                        </a:rPr>
+                        <a:t>Wenzhe Ma</a:t>
+                      </a:r>
+                      <a:endParaRPr lang="en-US" sz="1250" dirty="0"/>
+                    </a:p>
+                  </a:txBody>
+                  <a:tcPr marL="76200" marR="76200" marT="50800" marB="50800" anchor="ctr">
+                    <a:lnL w="9525" cap="flat" cmpd="sng" algn="ctr">
+                      <a:solidFill>
+                        <a:srgbClr val="D5DAE0"/>
+                      </a:solidFill>
+                      <a:prstDash val="solid"/>
+                      <a:round/>
+                      <a:headEnd type="none" w="med" len="med"/>
+                      <a:tailEnd type="none" w="med" len="med"/>
+                    </a:lnL>
+                    <a:lnR w="9525" cap="flat" cmpd="sng" algn="ctr">
+                      <a:solidFill>
+                        <a:srgbClr val="D5DAE0"/>
+                      </a:solidFill>
+                      <a:prstDash val="solid"/>
+                      <a:round/>
+                      <a:headEnd type="none" w="med" len="med"/>
+                      <a:tailEnd type="none" w="med" len="med"/>
+                    </a:lnR>
+                    <a:lnT w="9525" cap="flat" cmpd="sng" algn="ctr">
+                      <a:solidFill>
+                        <a:srgbClr val="D5DAE0"/>
+                      </a:solidFill>
+                      <a:prstDash val="solid"/>
+                      <a:round/>
+                      <a:headEnd type="none" w="med" len="med"/>
+                      <a:tailEnd type="none" w="med" len="med"/>
+                    </a:lnT>
+                    <a:lnB w="9525" cap="flat" cmpd="sng" algn="ctr">
+                      <a:solidFill>
+                        <a:srgbClr val="D5DAE0"/>
+                      </a:solidFill>
+                      <a:prstDash val="solid"/>
+                      <a:round/>
+                      <a:headEnd type="none" w="med" len="med"/>
+                      <a:tailEnd type="none" w="med" len="med"/>
+                    </a:lnB>
+                  </a:tcPr>
+                </a:tc>
+                <a:tc>
+                  <a:txBody>
+                    <a:bodyPr/>
+                    <a:lstStyle/>
+                    <a:p>
+                      <a:pPr indent="0" marL="0">
+                        <a:buNone/>
+                      </a:pPr>
+                      <a:r>
+                        <a:rPr lang="en-US" sz="1250" dirty="0">
+                          <a:solidFill>
+                            <a:srgbClr val="1F2933"/>
+                          </a:solidFill>
+                        </a:rPr>
+                        <a:t>Python + R; 80/20 (seed 42) and 20 re-randomised splits</a:t>
+                      </a:r>
+                      <a:endParaRPr lang="en-US" sz="1250" dirty="0"/>
+                    </a:p>
+                  </a:txBody>
+                  <a:tcPr marL="76200" marR="76200" marT="50800" marB="50800" anchor="ctr">
+                    <a:lnL w="9525" cap="flat" cmpd="sng" algn="ctr">
+                      <a:solidFill>
+                        <a:srgbClr val="D5DAE0"/>
+                      </a:solidFill>
+                      <a:prstDash val="solid"/>
+                      <a:round/>
+                      <a:headEnd type="none" w="med" len="med"/>
+                      <a:tailEnd type="none" w="med" len="med"/>
+                    </a:lnL>
+                    <a:lnR w="9525" cap="flat" cmpd="sng" algn="ctr">
+                      <a:solidFill>
+                        <a:srgbClr val="D5DAE0"/>
+                      </a:solidFill>
+                      <a:prstDash val="solid"/>
+                      <a:round/>
+                      <a:headEnd type="none" w="med" len="med"/>
+                      <a:tailEnd type="none" w="med" len="med"/>
+                    </a:lnR>
+                    <a:lnT w="9525" cap="flat" cmpd="sng" algn="ctr">
+                      <a:solidFill>
+                        <a:srgbClr val="D5DAE0"/>
+                      </a:solidFill>
+                      <a:prstDash val="solid"/>
+                      <a:round/>
+                      <a:headEnd type="none" w="med" len="med"/>
+                      <a:tailEnd type="none" w="med" len="med"/>
+                    </a:lnT>
+                    <a:lnB w="9525" cap="flat" cmpd="sng" algn="ctr">
+                      <a:solidFill>
+                        <a:srgbClr val="D5DAE0"/>
+                      </a:solidFill>
+                      <a:prstDash val="solid"/>
+                      <a:round/>
+                      <a:headEnd type="none" w="med" len="med"/>
+                      <a:tailEnd type="none" w="med" len="med"/>
+                    </a:lnB>
+                  </a:tcPr>
+                </a:tc>
+                <a:tc>
+                  <a:txBody>
+                    <a:bodyPr/>
+                    <a:lstStyle/>
+                    <a:p>
+                      <a:pPr indent="0" marL="0">
+                        <a:buNone/>
+                      </a:pPr>
+                      <a:r>
+                        <a:rPr lang="en-US" sz="1250" dirty="0">
+                          <a:solidFill>
+                            <a:srgbClr val="1F2933"/>
+                          </a:solidFill>
+                        </a:rPr>
+                        <a:t>30 methods, single pre-stated signal rule, variance diagnostic that set the mexiletine scale, three-pipeline comparison</a:t>
+                      </a:r>
+                      <a:endParaRPr lang="en-US" sz="1250" dirty="0"/>
+                    </a:p>
+                  </a:txBody>
+                  <a:tcPr marL="76200" marR="76200" marT="50800" marB="50800" anchor="ctr">
+                    <a:lnL w="9525" cap="flat" cmpd="sng" algn="ctr">
+                      <a:solidFill>
+                        <a:srgbClr val="D5DAE0"/>
+                      </a:solidFill>
+                      <a:prstDash val="solid"/>
+                      <a:round/>
+                      <a:headEnd type="none" w="med" len="med"/>
+                      <a:tailEnd type="none" w="med" len="med"/>
+                    </a:lnL>
+                    <a:lnR w="9525" cap="flat" cmpd="sng" algn="ctr">
+                      <a:solidFill>
+                        <a:srgbClr val="D5DAE0"/>
+                      </a:solidFill>
+                      <a:prstDash val="solid"/>
+                      <a:round/>
+                      <a:headEnd type="none" w="med" len="med"/>
+                      <a:tailEnd type="none" w="med" len="med"/>
+                    </a:lnR>
+                    <a:lnT w="9525" cap="flat" cmpd="sng" algn="ctr">
+                      <a:solidFill>
+                        <a:srgbClr val="D5DAE0"/>
+                      </a:solidFill>
+                      <a:prstDash val="solid"/>
+                      <a:round/>
+                      <a:headEnd type="none" w="med" len="med"/>
+                      <a:tailEnd type="none" w="med" len="med"/>
+                    </a:lnT>
+                    <a:lnB w="9525" cap="flat" cmpd="sng" algn="ctr">
+                      <a:solidFill>
+                        <a:srgbClr val="D5DAE0"/>
+                      </a:solidFill>
+                      <a:prstDash val="solid"/>
+                      <a:round/>
+                      <a:headEnd type="none" w="med" len="med"/>
+                      <a:tailEnd type="none" w="med" len="med"/>
+                    </a:lnB>
+                  </a:tcPr>
+                </a:tc>
+                <a:tc>
+                  <a:txBody>
+                    <a:bodyPr/>
+                    <a:lstStyle/>
+                    <a:p>
+                      <a:pPr indent="0" marL="0">
+                        <a:buNone/>
+                      </a:pPr>
+                      <a:r>
+                        <a:rPr lang="en-US" sz="1250" dirty="0">
+                          <a:solidFill>
+                            <a:srgbClr val="1F2933"/>
+                          </a:solidFill>
+                        </a:rPr>
+                        <a:t>Myotonia severity / CTG repeats / cognitive function</a:t>
+                      </a:r>
+                      <a:endParaRPr lang="en-US" sz="1250" dirty="0"/>
+                    </a:p>
+                  </a:txBody>
+                  <a:tcPr marL="76200" marR="76200" marT="50800" marB="50800" anchor="ctr">
+                    <a:lnL w="9525" cap="flat" cmpd="sng" algn="ctr">
+                      <a:solidFill>
+                        <a:srgbClr val="D5DAE0"/>
+                      </a:solidFill>
+                      <a:prstDash val="solid"/>
+                      <a:round/>
+                      <a:headEnd type="none" w="med" len="med"/>
+                      <a:tailEnd type="none" w="med" len="med"/>
+                    </a:lnL>
+                    <a:lnR w="9525" cap="flat" cmpd="sng" algn="ctr">
+                      <a:solidFill>
+                        <a:srgbClr val="D5DAE0"/>
+                      </a:solidFill>
+                      <a:prstDash val="solid"/>
+                      <a:round/>
+                      <a:headEnd type="none" w="med" len="med"/>
+                      <a:tailEnd type="none" w="med" len="med"/>
+                    </a:lnR>
+                    <a:lnT w="9525" cap="flat" cmpd="sng" algn="ctr">
+                      <a:solidFill>
+                        <a:srgbClr val="D5DAE0"/>
+                      </a:solidFill>
+                      <a:prstDash val="solid"/>
+                      <a:round/>
+                      <a:headEnd type="none" w="med" len="med"/>
+                      <a:tailEnd type="none" w="med" len="med"/>
+                    </a:lnT>
+                    <a:lnB w="9525" cap="flat" cmpd="sng" algn="ctr">
+                      <a:solidFill>
+                        <a:srgbClr val="D5DAE0"/>
+                      </a:solidFill>
+                      <a:prstDash val="solid"/>
+                      <a:round/>
+                      <a:headEnd type="none" w="med" len="med"/>
+                      <a:tailEnd type="none" w="med" len="med"/>
+                    </a:lnB>
+                  </a:tcPr>
+                </a:tc>
+              </a:tr>
+              <a:tr h="777240">
+                <a:tc>
+                  <a:txBody>
+                    <a:bodyPr/>
+                    <a:lstStyle/>
+                    <a:p>
+                      <a:pPr indent="0" marL="0">
+                        <a:buNone/>
+                      </a:pPr>
+                      <a:r>
+                        <a:rPr lang="en-US" sz="1250" b="1" dirty="0">
+                          <a:solidFill>
+                            <a:srgbClr val="1F2933"/>
+                          </a:solidFill>
+                        </a:rPr>
+                        <a:t>Ming Gao</a:t>
+                      </a:r>
+                      <a:endParaRPr lang="en-US" sz="1250" dirty="0"/>
+                    </a:p>
+                  </a:txBody>
+                  <a:tcPr marL="76200" marR="76200" marT="50800" marB="50800" anchor="ctr">
+                    <a:lnL w="9525" cap="flat" cmpd="sng" algn="ctr">
+                      <a:solidFill>
+                        <a:srgbClr val="D5DAE0"/>
+                      </a:solidFill>
+                      <a:prstDash val="solid"/>
+                      <a:round/>
+                      <a:headEnd type="none" w="med" len="med"/>
+                      <a:tailEnd type="none" w="med" len="med"/>
+                    </a:lnL>
+                    <a:lnR w="9525" cap="flat" cmpd="sng" algn="ctr">
+                      <a:solidFill>
+                        <a:srgbClr val="D5DAE0"/>
+                      </a:solidFill>
+                      <a:prstDash val="solid"/>
+                      <a:round/>
+                      <a:headEnd type="none" w="med" len="med"/>
+                      <a:tailEnd type="none" w="med" len="med"/>
+                    </a:lnR>
+                    <a:lnT w="9525" cap="flat" cmpd="sng" algn="ctr">
+                      <a:solidFill>
+                        <a:srgbClr val="D5DAE0"/>
+                      </a:solidFill>
+                      <a:prstDash val="solid"/>
+                      <a:round/>
+                      <a:headEnd type="none" w="med" len="med"/>
+                      <a:tailEnd type="none" w="med" len="med"/>
+                    </a:lnT>
+                    <a:lnB w="9525" cap="flat" cmpd="sng" algn="ctr">
+                      <a:solidFill>
+                        <a:srgbClr val="D5DAE0"/>
+                      </a:solidFill>
+                      <a:prstDash val="solid"/>
+                      <a:round/>
+                      <a:headEnd type="none" w="med" len="med"/>
+                      <a:tailEnd type="none" w="med" len="med"/>
+                    </a:lnB>
+                  </a:tcPr>
+                </a:tc>
+                <a:tc>
+                  <a:txBody>
+                    <a:bodyPr/>
+                    <a:lstStyle/>
+                    <a:p>
+                      <a:pPr indent="0" marL="0">
+                        <a:buNone/>
+                      </a:pPr>
+                      <a:r>
+                        <a:rPr lang="en-US" sz="1250" dirty="0">
+                          <a:solidFill>
+                            <a:srgbClr val="1F2933"/>
+                          </a:solidFill>
+                        </a:rPr>
+                        <a:t>Python; locked fold on Bei's split, rehearsal on a pseudo-test; 20 seeds</a:t>
+                      </a:r>
+                      <a:endParaRPr lang="en-US" sz="1250" dirty="0"/>
+                    </a:p>
+                  </a:txBody>
+                  <a:tcPr marL="76200" marR="76200" marT="50800" marB="50800" anchor="ctr">
+                    <a:lnL w="9525" cap="flat" cmpd="sng" algn="ctr">
+                      <a:solidFill>
+                        <a:srgbClr val="D5DAE0"/>
+                      </a:solidFill>
+                      <a:prstDash val="solid"/>
+                      <a:round/>
+                      <a:headEnd type="none" w="med" len="med"/>
+                      <a:tailEnd type="none" w="med" len="med"/>
+                    </a:lnL>
+                    <a:lnR w="9525" cap="flat" cmpd="sng" algn="ctr">
+                      <a:solidFill>
+                        <a:srgbClr val="D5DAE0"/>
+                      </a:solidFill>
+                      <a:prstDash val="solid"/>
+                      <a:round/>
+                      <a:headEnd type="none" w="med" len="med"/>
+                      <a:tailEnd type="none" w="med" len="med"/>
+                    </a:lnR>
+                    <a:lnT w="9525" cap="flat" cmpd="sng" algn="ctr">
+                      <a:solidFill>
+                        <a:srgbClr val="D5DAE0"/>
+                      </a:solidFill>
+                      <a:prstDash val="solid"/>
+                      <a:round/>
+                      <a:headEnd type="none" w="med" len="med"/>
+                      <a:tailEnd type="none" w="med" len="med"/>
+                    </a:lnT>
+                    <a:lnB w="9525" cap="flat" cmpd="sng" algn="ctr">
+                      <a:solidFill>
+                        <a:srgbClr val="D5DAE0"/>
+                      </a:solidFill>
+                      <a:prstDash val="solid"/>
+                      <a:round/>
+                      <a:headEnd type="none" w="med" len="med"/>
+                      <a:tailEnd type="none" w="med" len="med"/>
+                    </a:lnB>
+                  </a:tcPr>
+                </a:tc>
+                <a:tc>
+                  <a:txBody>
+                    <a:bodyPr/>
+                    <a:lstStyle/>
+                    <a:p>
+                      <a:pPr indent="0" marL="0">
+                        <a:buNone/>
+                      </a:pPr>
+                      <a:r>
+                        <a:rPr lang="en-US" sz="1250" dirty="0">
+                          <a:solidFill>
+                            <a:srgbClr val="1F2933"/>
+                          </a:solidFill>
+                        </a:rPr>
+                        <a:t>14 methods, pre-registered hypothesis sheet, stability selection plus shuffled-outcome null, partial dependence, enrichment rules</a:t>
+                      </a:r>
+                      <a:endParaRPr lang="en-US" sz="1250" dirty="0"/>
+                    </a:p>
+                  </a:txBody>
+                  <a:tcPr marL="76200" marR="76200" marT="50800" marB="50800" anchor="ctr">
+                    <a:lnL w="9525" cap="flat" cmpd="sng" algn="ctr">
+                      <a:solidFill>
+                        <a:srgbClr val="D5DAE0"/>
+                      </a:solidFill>
+                      <a:prstDash val="solid"/>
+                      <a:round/>
+                      <a:headEnd type="none" w="med" len="med"/>
+                      <a:tailEnd type="none" w="med" len="med"/>
+                    </a:lnL>
+                    <a:lnR w="9525" cap="flat" cmpd="sng" algn="ctr">
+                      <a:solidFill>
+                        <a:srgbClr val="D5DAE0"/>
+                      </a:solidFill>
+                      <a:prstDash val="solid"/>
+                      <a:round/>
+                      <a:headEnd type="none" w="med" len="med"/>
+                      <a:tailEnd type="none" w="med" len="med"/>
+                    </a:lnR>
+                    <a:lnT w="9525" cap="flat" cmpd="sng" algn="ctr">
+                      <a:solidFill>
+                        <a:srgbClr val="D5DAE0"/>
+                      </a:solidFill>
+                      <a:prstDash val="solid"/>
+                      <a:round/>
+                      <a:headEnd type="none" w="med" len="med"/>
+                      <a:tailEnd type="none" w="med" len="med"/>
+                    </a:lnT>
+                    <a:lnB w="9525" cap="flat" cmpd="sng" algn="ctr">
+                      <a:solidFill>
+                        <a:srgbClr val="D5DAE0"/>
+                      </a:solidFill>
+                      <a:prstDash val="solid"/>
+                      <a:round/>
+                      <a:headEnd type="none" w="med" len="med"/>
+                      <a:tailEnd type="none" w="med" len="med"/>
+                    </a:lnB>
+                  </a:tcPr>
+                </a:tc>
+                <a:tc>
+                  <a:txBody>
+                    <a:bodyPr/>
+                    <a:lstStyle/>
+                    <a:p>
+                      <a:pPr indent="0" marL="0">
+                        <a:buNone/>
+                      </a:pPr>
+                      <a:r>
+                        <a:rPr lang="en-US" sz="1250" dirty="0">
+                          <a:solidFill>
+                            <a:srgbClr val="1F2933"/>
+                          </a:solidFill>
+                        </a:rPr>
+                        <a:t>Myotonia (suggestive on relative change) / CTG repeats / cognitive function</a:t>
+                      </a:r>
+                      <a:endParaRPr lang="en-US" sz="1250" dirty="0"/>
+                    </a:p>
+                  </a:txBody>
+                  <a:tcPr marL="76200" marR="76200" marT="50800" marB="50800" anchor="ctr">
+                    <a:lnL w="9525" cap="flat" cmpd="sng" algn="ctr">
+                      <a:solidFill>
+                        <a:srgbClr val="D5DAE0"/>
+                      </a:solidFill>
+                      <a:prstDash val="solid"/>
+                      <a:round/>
+                      <a:headEnd type="none" w="med" len="med"/>
+                      <a:tailEnd type="none" w="med" len="med"/>
+                    </a:lnL>
+                    <a:lnR w="9525" cap="flat" cmpd="sng" algn="ctr">
+                      <a:solidFill>
+                        <a:srgbClr val="D5DAE0"/>
+                      </a:solidFill>
+                      <a:prstDash val="solid"/>
+                      <a:round/>
+                      <a:headEnd type="none" w="med" len="med"/>
+                      <a:tailEnd type="none" w="med" len="med"/>
+                    </a:lnR>
+                    <a:lnT w="9525" cap="flat" cmpd="sng" algn="ctr">
+                      <a:solidFill>
+                        <a:srgbClr val="D5DAE0"/>
+                      </a:solidFill>
+                      <a:prstDash val="solid"/>
+                      <a:round/>
+                      <a:headEnd type="none" w="med" len="med"/>
+                      <a:tailEnd type="none" w="med" len="med"/>
+                    </a:lnT>
+                    <a:lnB w="9525" cap="flat" cmpd="sng" algn="ctr">
+                      <a:solidFill>
+                        <a:srgbClr val="D5DAE0"/>
+                      </a:solidFill>
+                      <a:prstDash val="solid"/>
+                      <a:round/>
+                      <a:headEnd type="none" w="med" len="med"/>
+                      <a:tailEnd type="none" w="med" len="med"/>
+                    </a:lnB>
+                  </a:tcPr>
+                </a:tc>
+              </a:tr>
+              <a:tr h="777240">
+                <a:tc>
+                  <a:txBody>
+                    <a:bodyPr/>
+                    <a:lstStyle/>
+                    <a:p>
+                      <a:pPr indent="0" marL="0">
+                        <a:buNone/>
+                      </a:pPr>
+                      <a:r>
+                        <a:rPr lang="en-US" sz="1250" b="1" dirty="0">
+                          <a:solidFill>
+                            <a:srgbClr val="1F2933"/>
+                          </a:solidFill>
+                        </a:rPr>
+                        <a:t>Leo Vuong, Bei Zhao</a:t>
+                      </a:r>
+                      <a:endParaRPr lang="en-US" sz="1250" dirty="0"/>
+                    </a:p>
+                  </a:txBody>
+                  <a:tcPr marL="76200" marR="76200" marT="50800" marB="50800" anchor="ctr">
+                    <a:lnL w="9525" cap="flat" cmpd="sng" algn="ctr">
+                      <a:solidFill>
+                        <a:srgbClr val="D5DAE0"/>
+                      </a:solidFill>
+                      <a:prstDash val="solid"/>
+                      <a:round/>
+                      <a:headEnd type="none" w="med" len="med"/>
+                      <a:tailEnd type="none" w="med" len="med"/>
+                    </a:lnL>
+                    <a:lnR w="9525" cap="flat" cmpd="sng" algn="ctr">
+                      <a:solidFill>
+                        <a:srgbClr val="D5DAE0"/>
+                      </a:solidFill>
+                      <a:prstDash val="solid"/>
+                      <a:round/>
+                      <a:headEnd type="none" w="med" len="med"/>
+                      <a:tailEnd type="none" w="med" len="med"/>
+                    </a:lnR>
+                    <a:lnT w="9525" cap="flat" cmpd="sng" algn="ctr">
+                      <a:solidFill>
+                        <a:srgbClr val="D5DAE0"/>
+                      </a:solidFill>
+                      <a:prstDash val="solid"/>
+                      <a:round/>
+                      <a:headEnd type="none" w="med" len="med"/>
+                      <a:tailEnd type="none" w="med" len="med"/>
+                    </a:lnT>
+                    <a:lnB w="9525" cap="flat" cmpd="sng" algn="ctr">
+                      <a:solidFill>
+                        <a:srgbClr val="D5DAE0"/>
+                      </a:solidFill>
+                      <a:prstDash val="solid"/>
+                      <a:round/>
+                      <a:headEnd type="none" w="med" len="med"/>
+                      <a:tailEnd type="none" w="med" len="med"/>
+                    </a:lnB>
+                  </a:tcPr>
+                </a:tc>
+                <a:tc>
+                  <a:txBody>
+                    <a:bodyPr/>
+                    <a:lstStyle/>
+                    <a:p>
+                      <a:pPr indent="0" marL="0">
+                        <a:buNone/>
+                      </a:pPr>
+                      <a:r>
+                        <a:rPr lang="en-US" sz="1250" dirty="0">
+                          <a:solidFill>
+                            <a:srgbClr val="1F2933"/>
+                          </a:solidFill>
+                        </a:rPr>
+                        <a:t>R (Leo); Python correlation screen on an 80/20 split (Bei)</a:t>
+                      </a:r>
+                      <a:endParaRPr lang="en-US" sz="1250" dirty="0"/>
+                    </a:p>
+                  </a:txBody>
+                  <a:tcPr marL="76200" marR="76200" marT="50800" marB="50800" anchor="ctr">
+                    <a:lnL w="9525" cap="flat" cmpd="sng" algn="ctr">
+                      <a:solidFill>
+                        <a:srgbClr val="D5DAE0"/>
+                      </a:solidFill>
+                      <a:prstDash val="solid"/>
+                      <a:round/>
+                      <a:headEnd type="none" w="med" len="med"/>
+                      <a:tailEnd type="none" w="med" len="med"/>
+                    </a:lnL>
+                    <a:lnR w="9525" cap="flat" cmpd="sng" algn="ctr">
+                      <a:solidFill>
+                        <a:srgbClr val="D5DAE0"/>
+                      </a:solidFill>
+                      <a:prstDash val="solid"/>
+                      <a:round/>
+                      <a:headEnd type="none" w="med" len="med"/>
+                      <a:tailEnd type="none" w="med" len="med"/>
+                    </a:lnR>
+                    <a:lnT w="9525" cap="flat" cmpd="sng" algn="ctr">
+                      <a:solidFill>
+                        <a:srgbClr val="D5DAE0"/>
+                      </a:solidFill>
+                      <a:prstDash val="solid"/>
+                      <a:round/>
+                      <a:headEnd type="none" w="med" len="med"/>
+                      <a:tailEnd type="none" w="med" len="med"/>
+                    </a:lnT>
+                    <a:lnB w="9525" cap="flat" cmpd="sng" algn="ctr">
+                      <a:solidFill>
+                        <a:srgbClr val="D5DAE0"/>
+                      </a:solidFill>
+                      <a:prstDash val="solid"/>
+                      <a:round/>
+                      <a:headEnd type="none" w="med" len="med"/>
+                      <a:tailEnd type="none" w="med" len="med"/>
+                    </a:lnB>
+                  </a:tcPr>
+                </a:tc>
+                <a:tc>
+                  <a:txBody>
+                    <a:bodyPr/>
+                    <a:lstStyle/>
+                    <a:p>
+                      <a:pPr indent="0" marL="0">
+                        <a:buNone/>
+                      </a:pPr>
+                      <a:r>
+                        <a:rPr lang="en-US" sz="1250" dirty="0">
+                          <a:solidFill>
+                            <a:srgbClr val="1F2933"/>
+                          </a:solidFill>
+                        </a:rPr>
+                        <a:t>Six covariate and ML methods (Leo); marginal associations with bootstrap intervals and FDR, covariate dictionary (Bei)</a:t>
+                      </a:r>
+                      <a:endParaRPr lang="en-US" sz="1250" dirty="0"/>
+                    </a:p>
+                  </a:txBody>
+                  <a:tcPr marL="76200" marR="76200" marT="50800" marB="50800" anchor="ctr">
+                    <a:lnL w="9525" cap="flat" cmpd="sng" algn="ctr">
+                      <a:solidFill>
+                        <a:srgbClr val="D5DAE0"/>
+                      </a:solidFill>
+                      <a:prstDash val="solid"/>
+                      <a:round/>
+                      <a:headEnd type="none" w="med" len="med"/>
+                      <a:tailEnd type="none" w="med" len="med"/>
+                    </a:lnL>
+                    <a:lnR w="9525" cap="flat" cmpd="sng" algn="ctr">
+                      <a:solidFill>
+                        <a:srgbClr val="D5DAE0"/>
+                      </a:solidFill>
+                      <a:prstDash val="solid"/>
+                      <a:round/>
+                      <a:headEnd type="none" w="med" len="med"/>
+                      <a:tailEnd type="none" w="med" len="med"/>
+                    </a:lnR>
+                    <a:lnT w="9525" cap="flat" cmpd="sng" algn="ctr">
+                      <a:solidFill>
+                        <a:srgbClr val="D5DAE0"/>
+                      </a:solidFill>
+                      <a:prstDash val="solid"/>
+                      <a:round/>
+                      <a:headEnd type="none" w="med" len="med"/>
+                      <a:tailEnd type="none" w="med" len="med"/>
+                    </a:lnT>
+                    <a:lnB w="9525" cap="flat" cmpd="sng" algn="ctr">
+                      <a:solidFill>
+                        <a:srgbClr val="D5DAE0"/>
+                      </a:solidFill>
+                      <a:prstDash val="solid"/>
+                      <a:round/>
+                      <a:headEnd type="none" w="med" len="med"/>
+                      <a:tailEnd type="none" w="med" len="med"/>
+                    </a:lnB>
+                  </a:tcPr>
+                </a:tc>
+                <a:tc>
+                  <a:txBody>
+                    <a:bodyPr/>
+                    <a:lstStyle/>
+                    <a:p>
+                      <a:pPr indent="0" marL="0">
+                        <a:buNone/>
+                      </a:pPr>
+                      <a:r>
+                        <a:rPr lang="en-US" sz="1250" dirty="0">
+                          <a:solidFill>
+                            <a:srgbClr val="1F2933"/>
+                          </a:solidFill>
+                        </a:rPr>
+                        <a:t>Myotonia severity / CTG repeats / cognitive function</a:t>
+                      </a:r>
+                      <a:endParaRPr lang="en-US" sz="1250" dirty="0"/>
+                    </a:p>
+                  </a:txBody>
+                  <a:tcPr marL="76200" marR="76200" marT="50800" marB="50800" anchor="ctr">
+                    <a:lnL w="9525" cap="flat" cmpd="sng" algn="ctr">
+                      <a:solidFill>
+                        <a:srgbClr val="D5DAE0"/>
+                      </a:solidFill>
+                      <a:prstDash val="solid"/>
+                      <a:round/>
+                      <a:headEnd type="none" w="med" len="med"/>
+                      <a:tailEnd type="none" w="med" len="med"/>
+                    </a:lnL>
+                    <a:lnR w="9525" cap="flat" cmpd="sng" algn="ctr">
+                      <a:solidFill>
+                        <a:srgbClr val="D5DAE0"/>
+                      </a:solidFill>
+                      <a:prstDash val="solid"/>
+                      <a:round/>
+                      <a:headEnd type="none" w="med" len="med"/>
+                      <a:tailEnd type="none" w="med" len="med"/>
+                    </a:lnR>
+                    <a:lnT w="9525" cap="flat" cmpd="sng" algn="ctr">
+                      <a:solidFill>
+                        <a:srgbClr val="D5DAE0"/>
+                      </a:solidFill>
+                      <a:prstDash val="solid"/>
+                      <a:round/>
+                      <a:headEnd type="none" w="med" len="med"/>
+                      <a:tailEnd type="none" w="med" len="med"/>
+                    </a:lnT>
+                    <a:lnB w="9525" cap="flat" cmpd="sng" algn="ctr">
+                      <a:solidFill>
+                        <a:srgbClr val="D5DAE0"/>
+                      </a:solidFill>
+                      <a:prstDash val="solid"/>
+                      <a:round/>
+                      <a:headEnd type="none" w="med" len="med"/>
+                      <a:tailEnd type="none" w="med" len="med"/>
+                    </a:lnB>
+                  </a:tcPr>
+                </a:tc>
+              </a:tr>
+            </a:tbl>
+          </a:graphicData>
+        </a:graphic>
+      </p:graphicFrame>
+      <p:sp>
+        <p:nvSpPr>
+          <p:cNvPr id="4" name="Text 1"/>
+          <p:cNvSpPr txBox="1"/>
+          <p:nvPr/>
+        </p:nvSpPr>
+        <p:spPr>
+          <a:xfrm>
+            <a:off x="548640" y="5486400"/>
+            <a:ext cx="11064240" cy="640080"/>
+          </a:xfrm>
+          <a:prstGeom prst="rect">
+            <a:avLst/>
+          </a:prstGeom>
+          <a:noFill/>
+          <a:ln/>
+        </p:spPr>
+        <p:txBody>
+          <a:bodyPr wrap="square" lIns="0" tIns="0" rIns="0" bIns="0" rtlCol="0" anchor="t"/>
+          <a:lstStyle/>
+          <a:p>
+            <a:pPr indent="0" marL="0">
+              <a:buNone/>
+            </a:pPr>
+            <a:r>
+              <a:rPr lang="en-US" sz="1250" dirty="0">
+                <a:solidFill>
+                  <a:srgbClr val="5B6B7A"/>
+                </a:solidFill>
+              </a:rPr>
+              <a:t>Different code, different splits, different method sets: the same three covariates. Izumi Hamada: clinical review and the relative-change check for mexiletine. All pipelines are in the repository under analysis/explorations/.</a:t>
+            </a:r>
+            <a:endParaRPr lang="en-US" sz="1250" dirty="0"/>
+          </a:p>
+        </p:txBody>
+      </p:sp>
+    </p:spTree>
+  </p:cSld>
+  <p:clrMapOvr>
+    <a:masterClrMapping/>
+  </p:clrMapOvr>
+</p:sld>
+</file>
+
+<file path=ppt/slides/slide14.xml><?xml version="1.0" encoding="utf-8"?>
+<p:sld xmlns:a="http://schemas.openxmlformats.org/drawingml/2006/main" xmlns:r="http://schemas.openxmlformats.org/officeDocument/2006/relationships" xmlns:p="http://schemas.openxmlformats.org/presentationml/2006/main">
+  <p:cSld name="Slide 14">
+    <p:bg>
+      <p:bgPr>
+        <a:solidFill>
+          <a:srgbClr val="FFFFFF"/>
+        </a:solidFill>
+      </p:bgPr>
+    </p:bg>
+    <p:spTree>
+      <p:nvGrpSpPr>
+        <p:cNvPr id="1" name=""/>
+        <p:cNvGrpSpPr/>
+        <p:nvPr/>
+      </p:nvGrpSpPr>
+      <p:grpSpPr>
+        <a:xfrm>
+          <a:off x="0" y="0"/>
+          <a:ext cx="0" cy="0"/>
+          <a:chOff x="0" y="0"/>
+          <a:chExt cx="0" cy="0"/>
+        </a:xfrm>
+      </p:grpSpPr>
+      <p:sp>
+        <p:nvSpPr>
+          <p:cNvPr id="2" name="Text 0"/>
+          <p:cNvSpPr/>
+          <p:nvPr>
+            <p:ph idx="100" type="title" hasCustomPrompt="1"/>
+          </p:nvPr>
+        </p:nvSpPr>
+        <p:spPr>
+          <a:xfrm>
+            <a:off x="548640" y="365760"/>
+            <a:ext cx="11064240" cy="868680"/>
+          </a:xfrm>
+          <a:prstGeom prst="rect">
+            <a:avLst/>
+          </a:prstGeom>
+          <a:noFill/>
+          <a:ln/>
+        </p:spPr>
+        <p:txBody>
+          <a:bodyPr wrap="square" lIns="0" tIns="0" rIns="0" bIns="0" rtlCol="0" anchor="t"/>
+          <a:lstStyle/>
+          <a:p>
+            <a:pPr algn="l" indent="0" marL="0">
+              <a:buNone/>
+            </a:pPr>
+            <a:r>
+              <a:rPr lang="en-US" sz="2600" b="1" dirty="0">
+                <a:solidFill>
+                  <a:srgbClr val="000000"/>
+                </a:solidFill>
+              </a:rPr>
               <a:t>Backup: references</a:t>
             </a:r>
             <a:endParaRPr lang="en-US" sz="2600" dirty="0"/>

</xml_diff>

<commit_message>
Deck wording: 'test set' instead of 'held-out'; 'Exploratory analysis' header
Co-Authored-By: Claude Fable 5.1 <noreply@anthropic.com>
</commit_message>
<xml_diff>
--- a/slides/Team1_DM1_slides.pptx
+++ b/slides/Team1_DM1_slides.pptx
@@ -120,7 +120,7 @@
   <p:extLst>
     <p:ext uri="{521415D9-36F7-43E2-AB2F-B90AF26B5E84}">
       <p14:sectionLst xmlns:p14="http://schemas.microsoft.com/office/powerpoint/2010/main">
-        <p14:section name="Talk" id="{0f0ce21d-74ba-4154-fcbe-0afa6d39d23b}">
+        <p14:section name="Talk" id="{f66a6991-4cbc-1a0d-e834-5ed3e1b6fd94}">
           <p14:sldIdLst>
             <p14:sldId id="256"/>
             <p14:sldId id="257"/>
@@ -132,7 +132,7 @@
             <p14:sldId id="263"/>
           </p14:sldIdLst>
         </p14:section>
-        <p14:section name="Backup" id="{c0dd6b7c-3ded-48ae-66f9-d83a9068aaa4}">
+        <p14:section name="Backup" id="{c94e5ad2-2682-8f27-d3cd-561c90fde2fe}">
           <p14:sldIdLst>
             <p14:sldId id="264"/>
             <p14:sldId id="265"/>
@@ -898,7 +898,7 @@
           <a:p>
             <a:r>
               <a:rPr lang="en-US" dirty="0"/>
-              <a:t>If asked how we know the covariates are not an artefact of one person's choices: four pipelines, written independently in R and Python with different splits and different method sets, found the same three covariates. The talk slides quote one pipeline so that every number comes from the same held-out patients; the others are replication.</a:t>
+              <a:t>If asked how we know the covariates are not an artefact of one person's choices: four pipelines, written independently in R and Python with different splits and different method sets, found the same three covariates. The talk slides quote one pipeline so that every number comes from the same test-set patients; the others are replication.</a:t>
             </a:r>
             <a:endParaRPr lang="en-US" dirty="0"/>
           </a:p>
@@ -1165,7 +1165,7 @@
           <a:p>
             <a:r>
               <a:rPr lang="en-US" dirty="0"/>
-              <a:t>[35 s] The workflow, four steps. Split first: a quarter of each arm is set aside, balanced on responders and onset type, with a fixed seed, and not opened until the end. Choose: every model setting, the penalty, the tree depth, the cut-off, is picked by 5-fold cross-validation inside the training part. Score once: every model is scored on the same held-out patients, about 41 per arm, with bootstrap intervals. Check: we added a column of random numbers as a fake covariate; any method that selects it is selecting noise. We also resampled 200 times for stability and required agreement across five methods.
+              <a:t>[35 s] The workflow, four steps. Split first: a quarter of each arm is set aside, balanced on responders and onset type, with a fixed seed, and not opened until the end. Choose: every model setting, the penalty, the tree depth, the cut-off, is picked by 5-fold cross-validation inside the training part. Score once: every model is scored on the same test-set patients, about 41 per arm, with bootstrap intervals. Check: we added a column of random numbers as a fake covariate; any method that selects it is selecting noise. We also resampled 200 times for stability and required agreement across five methods.
 Covariate models: stepwise, LASSO, elastic net, and a linear model on the agreed covariates. Machine learning: random forest and XGBoost, with importance read by permutation and SHAP.
 Same yardstick for all: test-set R² and AUC. Three team members repeated the analysis in separate code, and we repeated the split 20 times.</a:t>
             </a:r>
@@ -1258,7 +1258,7 @@
               <a:t>[50 s] Mexiletine blocks sodium channels and calms over-excitable muscle. It treats the symptom, myotonia, not the cause.
 The figure: the dashed line is the predicted response of a reference patient, median on every measure; each row moves one thing. From mild to severe baseline myotonia, predicted response rises from 17% to 38%. Onset type adds little once severity is in.
 The predictor is baseline myotonia severity, chosen by all five methods. CTG repeat length carries the same information, correlation 0.88, so we treat them as one axis.
-On held-out patients, severity about 5 or more: 10 of 21 responded, 48%; below, 2 of 20, 10%. AUC 0.77.
+On test-set patients, severity about 5 or more: 10 of 21 responded, 48%; below, 2 of 20, 10%. AUC 0.77.
 One caution we state ourselves: the R² of 0.5 to 0.6 on absolute change is mostly arithmetic; patients with more myotonia have more to lose. On relative change the same axis still predicts, modestly, R² about 0.15, and on that scale CTG edges ahead of severity. A simple linear model does all of this; machine learning tied it and added nothing.</a:t>
             </a:r>
             <a:endParaRPr lang="en-US" dirty="0"/>
@@ -1350,7 +1350,7 @@
               <a:t>[45 s] The antisense oligonucleotide binds the toxic RNA and degrades it; it acts on the cause.
 The predictor is CTG repeat length, which is the amount of the drug's target. It is the only measure selected, by all five methods, stable in 90% of resamples. From short to long repeats, predicted response rises from 22% to 75%.
 But no method predicts the individual outcome: R² below 0.15 on every one of 20 splits, machine learning included. Patients with the same repeat length still differ a lot. We report that as it is.
-On held-out patients, repeats about 350 or more: 10 of 17 responded, 59%; below, 8 of 26, 31%. AUC 0.72.
+On test-set patients, repeats about 350 or more: 10 of 17 responded, 59%; below, 8 of 26, 31%. AUC 0.72.
 Reading for a trialist: the direction is knowable, the individual is not. Use repeat length to stratify randomisation, not to predict a patient's score.</a:t>
             </a:r>
             <a:endParaRPr lang="en-US" dirty="0"/>
@@ -1442,7 +1442,7 @@
               <a:t>[50 s] Tideglusib blocks an over-active enzyme, GSK3-beta, with effects in several organs including the brain, and the outcome is a composite with a cognitive part.
 The predictor is baseline cognitive function, chosen by all five methods, stable in 100% of resamples. And the effect is a step, not a slope: from impaired to intact cognition, predicted response drops from 87% to 14%, with the drop near z = -0.5. The reading is a ceiling effect: a patient with normal cognition has no room to gain on a cognition-weighted score.
 This is the one place machine learning helped. Tree models reached R² 0.55 against 0.3 for straight lines, on 19 of 20 splits. Why: a straight line cannot draw a step. Give the linear model that one cut-off and it reaches 0.45. So machine learning found the shape of the effect, and we hand it back as a one-term rule.
-Held-out patients: cognition below -0.5, 17 of 23 responded, 74%; above, 3 of 18, 17%.</a:t>
+Test-set patients: cognition below -0.5, 17 of 23 responded, 74%; above, 3 of 18, 17%.</a:t>
             </a:r>
             <a:endParaRPr lang="en-US" dirty="0"/>
           </a:p>
@@ -1530,7 +1530,7 @@
           <a:p>
             <a:r>
               <a:rPr lang="en-US" dirty="0"/>
-              <a:t>[40 s] Pulling it together. One routine baseline measure per drug: myotonia severity before mexiletine, repeat length before the antisense drug, cognitive function before tideglusib. Each separates responders from non-responders two- to five-fold on held-out patients, and each sits where the drug acts.
+              <a:t>[40 s] Pulling it together. One routine baseline measure per drug: myotonia severity before mexiletine, repeat length before the antisense drug, cognitive function before tideglusib. Each separates responders from non-responders two- to five-fold in the test set, and each sits where the drug acts.
 The hackathon question, in two parts. Did machine learning find additional predictors? No: same covariates, chosen by both families of method, the random column never selected, confirmed by three independent implementations and 20 repeated splits. Did it improve stratification? Yes, in one specific way: it found that the cognition effect is a threshold, and a one-term rule captures it. Its contribution was the functional form, not new features.
 Across 20 splits the scores move by up to 0.15 in R², but the selected covariates barely move: the split moves the scores, not the covariates. That is why we never crown a winning model.</a:t>
             </a:r>
@@ -2446,7 +2446,7 @@
                   <a:srgbClr val="000000"/>
                 </a:solidFill>
               </a:rPr>
-              <a:t>Backup: covariate models and machine learning on the same held-out patients</a:t>
+              <a:t>Backup: covariate models and machine learning on the same test-set patients</a:t>
             </a:r>
             <a:endParaRPr lang="en-US" sz="2600" dirty="0"/>
           </a:p>
@@ -6357,7 +6357,7 @@
                   <a:srgbClr val="000000"/>
                 </a:solidFill>
               </a:rPr>
-              <a:t>What we saw before modelling</a:t>
+              <a:t>Exploratory analysis</a:t>
             </a:r>
             <a:endParaRPr lang="en-US" sz="1600" dirty="0"/>
           </a:p>
@@ -6539,7 +6539,7 @@
                   <a:srgbClr val="000000"/>
                 </a:solidFill>
               </a:rPr>
-              <a:t>We split first, chose every setting by cross-validation, scored the held-out patients once, and checked every method against planted noise</a:t>
+              <a:t>We split first, chose every setting by cross-validation, scored the test set once, and checked every method against planted noise</a:t>
             </a:r>
             <a:endParaRPr lang="en-US" sz="2600" dirty="0"/>
           </a:p>
@@ -6836,7 +6836,7 @@
                   <a:srgbClr val="1F2933"/>
                 </a:solidFill>
               </a:rPr>
-              <a:t>All models scored on the same held-out patients (about 41 per arm), with bootstrap intervals.</a:t>
+              <a:t>All models scored on the same test-set patients (about 41 per arm), with bootstrap intervals.</a:t>
             </a:r>
             <a:endParaRPr lang="en-US" sz="1300" dirty="0"/>
           </a:p>
@@ -7197,7 +7197,7 @@
                   <a:srgbClr val="1F2933"/>
                 </a:solidFill>
               </a:rPr>
-              <a:t>R² for the continuous outcome and AUC for the responder label, on the same held-out patients. Independently repeated by three team members in separate code (R and Python) and over 20 different splits.</a:t>
+              <a:t>R² for the continuous outcome and AUC for the responder label, on the same test-set patients. Independently repeated by three team members in separate code (R and Python) and over 20 different splits.</a:t>
             </a:r>
             <a:endParaRPr lang="en-US" sz="1350" dirty="0"/>
           </a:p>
@@ -7642,7 +7642,7 @@
                   <a:srgbClr val="1F2933"/>
                 </a:solidFill>
               </a:rPr>
-              <a:t>Held-out patients: </a:t>
+              <a:t>Test-set patients: </a:t>
             </a:r>
             <a:pPr indent="0" marL="0">
               <a:buNone/>
@@ -8120,7 +8120,7 @@
                   <a:srgbClr val="1F2933"/>
                 </a:solidFill>
               </a:rPr>
-              <a:t>Held-out patients: </a:t>
+              <a:t>Test-set patients: </a:t>
             </a:r>
             <a:pPr indent="0" marL="0">
               <a:buNone/>
@@ -8598,7 +8598,7 @@
                   <a:srgbClr val="1F2933"/>
                 </a:solidFill>
               </a:rPr>
-              <a:t>Held-out patients: </a:t>
+              <a:t>Test-set patients: </a:t>
             </a:r>
             <a:pPr indent="0" marL="0">
               <a:buNone/>
@@ -8737,7 +8737,7 @@
                   <a:srgbClr val="000000"/>
                 </a:solidFill>
               </a:rPr>
-              <a:t>One routine baseline measure per drug separates responders two- to five-fold; machine learning added the shape of one effect, not new predictors</a:t>
+              <a:t>One routine baseline measure per drug separates responders two- to five-fold in the test set; machine learning added the shape of one effect, not new predictors</a:t>
             </a:r>
             <a:endParaRPr lang="en-US" sz="2600" dirty="0"/>
           </a:p>
@@ -9032,7 +9032,7 @@
                             <a:srgbClr val="000000"/>
                           </a:solidFill>
                         </a:rPr>
-                        <a:t>Held-out metrics</a:t>
+                        <a:t>Test-set metrics</a:t>
                       </a:r>
                       <a:endParaRPr lang="en-US" sz="1250" dirty="0"/>
                     </a:p>

</xml_diff>

<commit_message>
Backup slide: mechanism of action explains the per-arm covariate (Bei's comparison, credited); Bei's takeaway in the conclusion notes
Co-Authored-By: Claude Fable 5.1 <noreply@anthropic.com>
</commit_message>
<xml_diff>
--- a/slides/Team1_DM1_slides.pptx
+++ b/slides/Team1_DM1_slides.pptx
@@ -19,9 +19,10 @@
     <p:sldId id="267" r:id="rId13"/>
     <p:sldId id="268" r:id="rId14"/>
     <p:sldId id="269" r:id="rId15"/>
+    <p:sldId id="270" r:id="rId16"/>
   </p:sldIdLst>
   <p:notesMasterIdLst>
-    <p:notesMasterId r:id="rId16"/>
+    <p:notesMasterId r:id="rId17"/>
   </p:notesMasterIdLst>
   <p:sldSz cx="12192000" cy="6858000"/>
   <p:notesSz cx="6858000" cy="12192000"/>
@@ -120,7 +121,7 @@
   <p:extLst>
     <p:ext uri="{521415D9-36F7-43E2-AB2F-B90AF26B5E84}">
       <p14:sectionLst xmlns:p14="http://schemas.microsoft.com/office/powerpoint/2010/main">
-        <p14:section name="Talk" id="{f66a6991-4cbc-1a0d-e834-5ed3e1b6fd94}">
+        <p14:section name="Talk" id="{f02932e3-7153-1cc6-8dd2-c081c49aed8b}">
           <p14:sldIdLst>
             <p14:sldId id="256"/>
             <p14:sldId id="257"/>
@@ -132,7 +133,7 @@
             <p14:sldId id="263"/>
           </p14:sldIdLst>
         </p14:section>
-        <p14:section name="Backup" id="{c94e5ad2-2682-8f27-d3cd-561c90fde2fe}">
+        <p14:section name="Backup" id="{b8e6d3d1-3096-7d79-9452-283b2196ace5}">
           <p14:sldIdLst>
             <p14:sldId id="264"/>
             <p14:sldId id="265"/>
@@ -140,6 +141,7 @@
             <p14:sldId id="267"/>
             <p14:sldId id="268"/>
             <p14:sldId id="269"/>
+            <p14:sldId id="270"/>
           </p14:sldIdLst>
         </p14:section>
       </p14:sectionLst>
@@ -898,7 +900,7 @@
           <a:p>
             <a:r>
               <a:rPr lang="en-US" dirty="0"/>
-              <a:t>If asked how we know the covariates are not an artefact of one person's choices: four pipelines, written independently in R and Python with different splits and different method sets, found the same three covariates. The talk slides quote one pipeline so that every number comes from the same test-set patients; the others are replication.</a:t>
+              <a:t>Bei's framing for Q&amp;A: a symptom-level drug tracks the symptom; a molecular drug tracks the genetic burden; a multisystem drug with a cognition-weighted endpoint tracks cognition. Cognition is only modestly correlated with the severity axis, which is why it is a separate predictor rather than a proxy.</a:t>
             </a:r>
             <a:endParaRPr lang="en-US" dirty="0"/>
           </a:p>
@@ -986,7 +988,7 @@
           <a:p>
             <a:r>
               <a:rPr lang="en-US" dirty="0"/>
-              <a:t/>
+              <a:t>If asked how we know the covariates are not an artefact of one person's choices: four pipelines, written independently in R and Python with different splits and different method sets, found the same three covariates. The talk slides quote one pipeline so that every number comes from the same test-set patients; the others are replication.</a:t>
             </a:r>
             <a:endParaRPr lang="en-US" dirty="0"/>
           </a:p>
@@ -1010,6 +1012,94 @@
             <a:fld id="{F7021451-1387-4CA6-816F-3879F97B5CBC}" type="slidenum">
               <a:rPr lang="en-US"/>
               <a:t>14</a:t>
+            </a:fld>
+            <a:endParaRPr lang="en-US"/>
+          </a:p>
+        </p:txBody>
+      </p:sp>
+    </p:spTree>
+    <p:extLst>
+      <p:ext uri="{BB962C8B-B14F-4D97-AF65-F5344CB8AC3E}">
+        <p14:creationId xmlns:p14="http://schemas.microsoft.com/office/powerpoint/2010/main" val="1024086991"/>
+      </p:ext>
+    </p:extLst>
+  </p:cSld>
+  <p:clrMapOvr>
+    <a:masterClrMapping/>
+  </p:clrMapOvr>
+</p:notes>
+</file>
+
+<file path=ppt/notesSlides/notesSlide15.xml><?xml version="1.0" encoding="utf-8"?>
+<p:notes xmlns:a="http://schemas.openxmlformats.org/drawingml/2006/main" xmlns:r="http://schemas.openxmlformats.org/officeDocument/2006/relationships" xmlns:p="http://schemas.openxmlformats.org/presentationml/2006/main">
+  <p:cSld>
+    <p:spTree>
+      <p:nvGrpSpPr>
+        <p:cNvPr id="1" name=""/>
+        <p:cNvGrpSpPr/>
+        <p:nvPr/>
+      </p:nvGrpSpPr>
+      <p:grpSpPr>
+        <a:xfrm>
+          <a:off x="0" y="0"/>
+          <a:ext cx="0" cy="0"/>
+          <a:chOff x="0" y="0"/>
+          <a:chExt cx="0" cy="0"/>
+        </a:xfrm>
+      </p:grpSpPr>
+      <p:sp>
+        <p:nvSpPr>
+          <p:cNvPr id="2" name="Slide Image Placeholder 1"/>
+          <p:cNvSpPr>
+            <a:spLocks noGrp="1" noRot="1" noChangeAspect="1"/>
+          </p:cNvSpPr>
+          <p:nvPr>
+            <p:ph type="sldImg"/>
+          </p:nvPr>
+        </p:nvSpPr>
+        <p:spPr/>
+      </p:sp>
+      <p:sp>
+        <p:nvSpPr>
+          <p:cNvPr id="3" name="Notes Placeholder 2"/>
+          <p:cNvSpPr>
+            <a:spLocks noGrp="1"/>
+          </p:cNvSpPr>
+          <p:nvPr>
+            <p:ph type="body" idx="1"/>
+          </p:nvPr>
+        </p:nvSpPr>
+        <p:spPr/>
+        <p:txBody>
+          <a:bodyPr/>
+          <a:lstStyle/>
+          <a:p>
+            <a:r>
+              <a:rPr lang="en-US" dirty="0"/>
+              <a:t/>
+            </a:r>
+            <a:endParaRPr lang="en-US" dirty="0"/>
+          </a:p>
+        </p:txBody>
+      </p:sp>
+      <p:sp>
+        <p:nvSpPr>
+          <p:cNvPr id="4" name="Slide Number Placeholder 3"/>
+          <p:cNvSpPr>
+            <a:spLocks noGrp="1"/>
+          </p:cNvSpPr>
+          <p:nvPr>
+            <p:ph type="sldNum" sz="quarter" idx="10"/>
+          </p:nvPr>
+        </p:nvSpPr>
+        <p:spPr/>
+        <p:txBody>
+          <a:bodyPr/>
+          <a:lstStyle/>
+          <a:p>
+            <a:fld id="{F7021451-1387-4CA6-816F-3879F97B5CBC}" type="slidenum">
+              <a:rPr lang="en-US"/>
+              <a:t>15</a:t>
             </a:fld>
             <a:endParaRPr lang="en-US"/>
           </a:p>
@@ -1531,6 +1621,7 @@
             <a:r>
               <a:rPr lang="en-US" dirty="0"/>
               <a:t>[40 s] Pulling it together. One routine baseline measure per drug: myotonia severity before mexiletine, repeat length before the antisense drug, cognitive function before tideglusib. Each separates responders from non-responders two- to five-fold in the test set, and each sits where the drug acts.
+Bei's one-line takeaway fits here: the strongest covariate depends on both the drug's mechanism of action and the endpoint being measured.
 The hackathon question, in two parts. Did machine learning find additional predictors? No: same covariates, chosen by both families of method, the random column never selected, confirmed by three independent implementations and 20 repeated splits. Did it improve stratification? Yes, in one specific way: it found that the cognition effect is a threshold, and a one-term rule captures it. Its contribution was the functional form, not new features.
 Across 20 splits the scores move by up to 0.15 in R², but the selected covariates barely move: the split moves the scores, not the covariates. That is why we never crown a winning model.</a:t>
             </a:r>
@@ -4104,6 +4195,733 @@
                   <a:srgbClr val="000000"/>
                 </a:solidFill>
               </a:rPr>
+              <a:t>Backup: mechanism of action explains why each arm selects a different covariate</a:t>
+            </a:r>
+            <a:endParaRPr lang="en-US" sz="2600" dirty="0"/>
+          </a:p>
+        </p:txBody>
+      </p:sp>
+      <p:sp>
+        <p:nvSpPr>
+          <p:cNvPr id="3" name="Shape 1"/>
+          <p:cNvSpPr/>
+          <p:nvPr/>
+        </p:nvSpPr>
+        <p:spPr>
+          <a:xfrm>
+            <a:off x="548640" y="1417320"/>
+            <a:ext cx="3566160" cy="4206240"/>
+          </a:xfrm>
+          <a:prstGeom prst="roundRect">
+            <a:avLst>
+              <a:gd name="adj" fmla="val 2051"/>
+            </a:avLst>
+          </a:prstGeom>
+          <a:solidFill>
+            <a:srgbClr val="F2F2F2"/>
+          </a:solidFill>
+          <a:ln w="12700">
+            <a:solidFill>
+              <a:srgbClr val="F2F2F2"/>
+            </a:solidFill>
+            <a:prstDash val="solid"/>
+          </a:ln>
+        </p:spPr>
+      </p:sp>
+      <p:sp>
+        <p:nvSpPr>
+          <p:cNvPr id="4" name="Text 2"/>
+          <p:cNvSpPr txBox="1"/>
+          <p:nvPr/>
+        </p:nvSpPr>
+        <p:spPr>
+          <a:xfrm>
+            <a:off x="731520" y="1508760"/>
+            <a:ext cx="3200400" cy="365760"/>
+          </a:xfrm>
+          <a:prstGeom prst="rect">
+            <a:avLst/>
+          </a:prstGeom>
+          <a:noFill/>
+          <a:ln/>
+        </p:spPr>
+        <p:txBody>
+          <a:bodyPr wrap="square" lIns="0" tIns="0" rIns="0" bIns="0" rtlCol="0" anchor="ctr"/>
+          <a:lstStyle/>
+          <a:p>
+            <a:pPr indent="0" marL="0">
+              <a:buNone/>
+            </a:pPr>
+            <a:r>
+              <a:rPr lang="en-US" sz="1600" b="1" dirty="0">
+                <a:solidFill>
+                  <a:srgbClr val="000000"/>
+                </a:solidFill>
+              </a:rPr>
+              <a:t>Mexiletine</a:t>
+            </a:r>
+            <a:endParaRPr lang="en-US" sz="1600" dirty="0"/>
+          </a:p>
+        </p:txBody>
+      </p:sp>
+      <p:sp>
+        <p:nvSpPr>
+          <p:cNvPr id="5" name="Text 3"/>
+          <p:cNvSpPr txBox="1"/>
+          <p:nvPr/>
+        </p:nvSpPr>
+        <p:spPr>
+          <a:xfrm>
+            <a:off x="731520" y="1856232"/>
+            <a:ext cx="3200400" cy="274320"/>
+          </a:xfrm>
+          <a:prstGeom prst="rect">
+            <a:avLst/>
+          </a:prstGeom>
+          <a:noFill/>
+          <a:ln/>
+        </p:spPr>
+        <p:txBody>
+          <a:bodyPr wrap="square" lIns="0" tIns="0" rIns="0" bIns="0" rtlCol="0" anchor="ctr"/>
+          <a:lstStyle/>
+          <a:p>
+            <a:pPr indent="0" marL="0">
+              <a:buNone/>
+            </a:pPr>
+            <a:r>
+              <a:rPr lang="en-US" sz="1250" b="1" dirty="0">
+                <a:solidFill>
+                  <a:srgbClr val="D95F0E"/>
+                </a:solidFill>
+              </a:rPr>
+              <a:t>Symptom-level therapy</a:t>
+            </a:r>
+            <a:endParaRPr lang="en-US" sz="1250" dirty="0"/>
+          </a:p>
+        </p:txBody>
+      </p:sp>
+      <p:sp>
+        <p:nvSpPr>
+          <p:cNvPr id="6" name="Text 4"/>
+          <p:cNvSpPr txBox="1"/>
+          <p:nvPr/>
+        </p:nvSpPr>
+        <p:spPr>
+          <a:xfrm>
+            <a:off x="731520" y="2194560"/>
+            <a:ext cx="3200400" cy="822960"/>
+          </a:xfrm>
+          <a:prstGeom prst="rect">
+            <a:avLst/>
+          </a:prstGeom>
+          <a:noFill/>
+          <a:ln/>
+        </p:spPr>
+        <p:txBody>
+          <a:bodyPr wrap="square" lIns="0" tIns="0" rIns="0" bIns="0" rtlCol="0" anchor="t"/>
+          <a:lstStyle/>
+          <a:p>
+            <a:pPr indent="0" marL="0">
+              <a:buNone/>
+            </a:pPr>
+            <a:r>
+              <a:rPr lang="en-US" sz="1250" dirty="0">
+                <a:solidFill>
+                  <a:srgbClr val="1F2933"/>
+                </a:solidFill>
+              </a:rPr>
+              <a:t>Sodium-channel blockade; endpoint is myotonia change at week 12</a:t>
+            </a:r>
+            <a:endParaRPr lang="en-US" sz="1250" dirty="0"/>
+          </a:p>
+        </p:txBody>
+      </p:sp>
+      <p:sp>
+        <p:nvSpPr>
+          <p:cNvPr id="7" name="Text 5"/>
+          <p:cNvSpPr txBox="1"/>
+          <p:nvPr/>
+        </p:nvSpPr>
+        <p:spPr>
+          <a:xfrm>
+            <a:off x="731520" y="3063240"/>
+            <a:ext cx="3200400" cy="274320"/>
+          </a:xfrm>
+          <a:prstGeom prst="rect">
+            <a:avLst/>
+          </a:prstGeom>
+          <a:noFill/>
+          <a:ln/>
+        </p:spPr>
+        <p:txBody>
+          <a:bodyPr wrap="square" lIns="0" tIns="0" rIns="0" bIns="0" rtlCol="0" anchor="ctr"/>
+          <a:lstStyle/>
+          <a:p>
+            <a:pPr indent="0" marL="0">
+              <a:buNone/>
+            </a:pPr>
+            <a:r>
+              <a:rPr lang="en-US" sz="1250" b="1" dirty="0">
+                <a:solidFill>
+                  <a:srgbClr val="000000"/>
+                </a:solidFill>
+              </a:rPr>
+              <a:t>Covariate that predicts response</a:t>
+            </a:r>
+            <a:endParaRPr lang="en-US" sz="1250" dirty="0"/>
+          </a:p>
+        </p:txBody>
+      </p:sp>
+      <p:sp>
+        <p:nvSpPr>
+          <p:cNvPr id="8" name="Text 6"/>
+          <p:cNvSpPr txBox="1"/>
+          <p:nvPr/>
+        </p:nvSpPr>
+        <p:spPr>
+          <a:xfrm>
+            <a:off x="731520" y="3364992"/>
+            <a:ext cx="3200400" cy="2194560"/>
+          </a:xfrm>
+          <a:prstGeom prst="rect">
+            <a:avLst/>
+          </a:prstGeom>
+          <a:noFill/>
+          <a:ln/>
+        </p:spPr>
+        <p:txBody>
+          <a:bodyPr wrap="square" lIns="0" tIns="0" rIns="0" bIns="0" rtlCol="0" anchor="t"/>
+          <a:lstStyle/>
+          <a:p>
+            <a:pPr indent="0" marL="0">
+              <a:buNone/>
+            </a:pPr>
+            <a:r>
+              <a:rPr lang="en-US" sz="1250" dirty="0">
+                <a:solidFill>
+                  <a:srgbClr val="1F2933"/>
+                </a:solidFill>
+              </a:rPr>
+              <a:t>Baseline myotonia severity, the drug's direct symptom target. CTG repeats carry the same information (r 0.88): an upstream proxy, not a second predictor. Caveat: on absolute change part of this is room to improve; on relative change the axis still predicts, modestly.</a:t>
+            </a:r>
+            <a:endParaRPr lang="en-US" sz="1250" dirty="0"/>
+          </a:p>
+        </p:txBody>
+      </p:sp>
+      <p:sp>
+        <p:nvSpPr>
+          <p:cNvPr id="9" name="Shape 7"/>
+          <p:cNvSpPr/>
+          <p:nvPr/>
+        </p:nvSpPr>
+        <p:spPr>
+          <a:xfrm>
+            <a:off x="4297680" y="1417320"/>
+            <a:ext cx="3566160" cy="4206240"/>
+          </a:xfrm>
+          <a:prstGeom prst="roundRect">
+            <a:avLst>
+              <a:gd name="adj" fmla="val 2051"/>
+            </a:avLst>
+          </a:prstGeom>
+          <a:solidFill>
+            <a:srgbClr val="F2F2F2"/>
+          </a:solidFill>
+          <a:ln w="12700">
+            <a:solidFill>
+              <a:srgbClr val="F2F2F2"/>
+            </a:solidFill>
+            <a:prstDash val="solid"/>
+          </a:ln>
+        </p:spPr>
+      </p:sp>
+      <p:sp>
+        <p:nvSpPr>
+          <p:cNvPr id="10" name="Text 8"/>
+          <p:cNvSpPr txBox="1"/>
+          <p:nvPr/>
+        </p:nvSpPr>
+        <p:spPr>
+          <a:xfrm>
+            <a:off x="4480560" y="1508760"/>
+            <a:ext cx="3200400" cy="365760"/>
+          </a:xfrm>
+          <a:prstGeom prst="rect">
+            <a:avLst/>
+          </a:prstGeom>
+          <a:noFill/>
+          <a:ln/>
+        </p:spPr>
+        <p:txBody>
+          <a:bodyPr wrap="square" lIns="0" tIns="0" rIns="0" bIns="0" rtlCol="0" anchor="ctr"/>
+          <a:lstStyle/>
+          <a:p>
+            <a:pPr indent="0" marL="0">
+              <a:buNone/>
+            </a:pPr>
+            <a:r>
+              <a:rPr lang="en-US" sz="1600" b="1" dirty="0">
+                <a:solidFill>
+                  <a:srgbClr val="000000"/>
+                </a:solidFill>
+              </a:rPr>
+              <a:t>Antisense oligonucleotide</a:t>
+            </a:r>
+            <a:endParaRPr lang="en-US" sz="1600" dirty="0"/>
+          </a:p>
+        </p:txBody>
+      </p:sp>
+      <p:sp>
+        <p:nvSpPr>
+          <p:cNvPr id="11" name="Text 9"/>
+          <p:cNvSpPr txBox="1"/>
+          <p:nvPr/>
+        </p:nvSpPr>
+        <p:spPr>
+          <a:xfrm>
+            <a:off x="4480560" y="1856232"/>
+            <a:ext cx="3200400" cy="274320"/>
+          </a:xfrm>
+          <a:prstGeom prst="rect">
+            <a:avLst/>
+          </a:prstGeom>
+          <a:noFill/>
+          <a:ln/>
+        </p:spPr>
+        <p:txBody>
+          <a:bodyPr wrap="square" lIns="0" tIns="0" rIns="0" bIns="0" rtlCol="0" anchor="ctr"/>
+          <a:lstStyle/>
+          <a:p>
+            <a:pPr indent="0" marL="0">
+              <a:buNone/>
+            </a:pPr>
+            <a:r>
+              <a:rPr lang="en-US" sz="1250" b="1" dirty="0">
+                <a:solidFill>
+                  <a:srgbClr val="D95F0E"/>
+                </a:solidFill>
+              </a:rPr>
+              <a:t>Molecular therapy</a:t>
+            </a:r>
+            <a:endParaRPr lang="en-US" sz="1250" dirty="0"/>
+          </a:p>
+        </p:txBody>
+      </p:sp>
+      <p:sp>
+        <p:nvSpPr>
+          <p:cNvPr id="12" name="Text 10"/>
+          <p:cNvSpPr txBox="1"/>
+          <p:nvPr/>
+        </p:nvSpPr>
+        <p:spPr>
+          <a:xfrm>
+            <a:off x="4480560" y="2194560"/>
+            <a:ext cx="3200400" cy="822960"/>
+          </a:xfrm>
+          <a:prstGeom prst="rect">
+            <a:avLst/>
+          </a:prstGeom>
+          <a:noFill/>
+          <a:ln/>
+        </p:spPr>
+        <p:txBody>
+          <a:bodyPr wrap="square" lIns="0" tIns="0" rIns="0" bIns="0" rtlCol="0" anchor="t"/>
+          <a:lstStyle/>
+          <a:p>
+            <a:pPr indent="0" marL="0">
+              <a:buNone/>
+            </a:pPr>
+            <a:r>
+              <a:rPr lang="en-US" sz="1250" dirty="0">
+                <a:solidFill>
+                  <a:srgbClr val="1F2933"/>
+                </a:solidFill>
+              </a:rPr>
+              <a:t>Degrades the toxic DMPK RNA; endpoint is QMT strength gain at week 26</a:t>
+            </a:r>
+            <a:endParaRPr lang="en-US" sz="1250" dirty="0"/>
+          </a:p>
+        </p:txBody>
+      </p:sp>
+      <p:sp>
+        <p:nvSpPr>
+          <p:cNvPr id="13" name="Text 11"/>
+          <p:cNvSpPr txBox="1"/>
+          <p:nvPr/>
+        </p:nvSpPr>
+        <p:spPr>
+          <a:xfrm>
+            <a:off x="4480560" y="3063240"/>
+            <a:ext cx="3200400" cy="274320"/>
+          </a:xfrm>
+          <a:prstGeom prst="rect">
+            <a:avLst/>
+          </a:prstGeom>
+          <a:noFill/>
+          <a:ln/>
+        </p:spPr>
+        <p:txBody>
+          <a:bodyPr wrap="square" lIns="0" tIns="0" rIns="0" bIns="0" rtlCol="0" anchor="ctr"/>
+          <a:lstStyle/>
+          <a:p>
+            <a:pPr indent="0" marL="0">
+              <a:buNone/>
+            </a:pPr>
+            <a:r>
+              <a:rPr lang="en-US" sz="1250" b="1" dirty="0">
+                <a:solidFill>
+                  <a:srgbClr val="000000"/>
+                </a:solidFill>
+              </a:rPr>
+              <a:t>Covariate that predicts response</a:t>
+            </a:r>
+            <a:endParaRPr lang="en-US" sz="1250" dirty="0"/>
+          </a:p>
+        </p:txBody>
+      </p:sp>
+      <p:sp>
+        <p:nvSpPr>
+          <p:cNvPr id="14" name="Text 12"/>
+          <p:cNvSpPr txBox="1"/>
+          <p:nvPr/>
+        </p:nvSpPr>
+        <p:spPr>
+          <a:xfrm>
+            <a:off x="4480560" y="3364992"/>
+            <a:ext cx="3200400" cy="2194560"/>
+          </a:xfrm>
+          <a:prstGeom prst="rect">
+            <a:avLst/>
+          </a:prstGeom>
+          <a:noFill/>
+          <a:ln/>
+        </p:spPr>
+        <p:txBody>
+          <a:bodyPr wrap="square" lIns="0" tIns="0" rIns="0" bIns="0" rtlCol="0" anchor="t"/>
+          <a:lstStyle/>
+          <a:p>
+            <a:pPr indent="0" marL="0">
+              <a:buNone/>
+            </a:pPr>
+            <a:r>
+              <a:rPr lang="en-US" sz="1250" dirty="0">
+                <a:solidFill>
+                  <a:srgbClr val="1F2933"/>
+                </a:solidFill>
+              </a:rPr>
+              <a:t>CTG repeat length, the genetic burden the drug must clear. Myotonia and mosaicism share some of that information. Direction is clear; individual magnitude is not predictable.</a:t>
+            </a:r>
+            <a:endParaRPr lang="en-US" sz="1250" dirty="0"/>
+          </a:p>
+        </p:txBody>
+      </p:sp>
+      <p:sp>
+        <p:nvSpPr>
+          <p:cNvPr id="15" name="Shape 13"/>
+          <p:cNvSpPr/>
+          <p:nvPr/>
+        </p:nvSpPr>
+        <p:spPr>
+          <a:xfrm>
+            <a:off x="8046720" y="1417320"/>
+            <a:ext cx="3566160" cy="4206240"/>
+          </a:xfrm>
+          <a:prstGeom prst="roundRect">
+            <a:avLst>
+              <a:gd name="adj" fmla="val 2051"/>
+            </a:avLst>
+          </a:prstGeom>
+          <a:solidFill>
+            <a:srgbClr val="F2F2F2"/>
+          </a:solidFill>
+          <a:ln w="12700">
+            <a:solidFill>
+              <a:srgbClr val="F2F2F2"/>
+            </a:solidFill>
+            <a:prstDash val="solid"/>
+          </a:ln>
+        </p:spPr>
+      </p:sp>
+      <p:sp>
+        <p:nvSpPr>
+          <p:cNvPr id="16" name="Text 14"/>
+          <p:cNvSpPr txBox="1"/>
+          <p:nvPr/>
+        </p:nvSpPr>
+        <p:spPr>
+          <a:xfrm>
+            <a:off x="8229600" y="1508760"/>
+            <a:ext cx="3200400" cy="365760"/>
+          </a:xfrm>
+          <a:prstGeom prst="rect">
+            <a:avLst/>
+          </a:prstGeom>
+          <a:noFill/>
+          <a:ln/>
+        </p:spPr>
+        <p:txBody>
+          <a:bodyPr wrap="square" lIns="0" tIns="0" rIns="0" bIns="0" rtlCol="0" anchor="ctr"/>
+          <a:lstStyle/>
+          <a:p>
+            <a:pPr indent="0" marL="0">
+              <a:buNone/>
+            </a:pPr>
+            <a:r>
+              <a:rPr lang="en-US" sz="1600" b="1" dirty="0">
+                <a:solidFill>
+                  <a:srgbClr val="000000"/>
+                </a:solidFill>
+              </a:rPr>
+              <a:t>Tideglusib</a:t>
+            </a:r>
+            <a:endParaRPr lang="en-US" sz="1600" dirty="0"/>
+          </a:p>
+        </p:txBody>
+      </p:sp>
+      <p:sp>
+        <p:nvSpPr>
+          <p:cNvPr id="17" name="Text 15"/>
+          <p:cNvSpPr txBox="1"/>
+          <p:nvPr/>
+        </p:nvSpPr>
+        <p:spPr>
+          <a:xfrm>
+            <a:off x="8229600" y="1856232"/>
+            <a:ext cx="3200400" cy="274320"/>
+          </a:xfrm>
+          <a:prstGeom prst="rect">
+            <a:avLst/>
+          </a:prstGeom>
+          <a:noFill/>
+          <a:ln/>
+        </p:spPr>
+        <p:txBody>
+          <a:bodyPr wrap="square" lIns="0" tIns="0" rIns="0" bIns="0" rtlCol="0" anchor="ctr"/>
+          <a:lstStyle/>
+          <a:p>
+            <a:pPr indent="0" marL="0">
+              <a:buNone/>
+            </a:pPr>
+            <a:r>
+              <a:rPr lang="en-US" sz="1250" b="1" dirty="0">
+                <a:solidFill>
+                  <a:srgbClr val="D95F0E"/>
+                </a:solidFill>
+              </a:rPr>
+              <a:t>Multisystem therapy</a:t>
+            </a:r>
+            <a:endParaRPr lang="en-US" sz="1250" dirty="0"/>
+          </a:p>
+        </p:txBody>
+      </p:sp>
+      <p:sp>
+        <p:nvSpPr>
+          <p:cNvPr id="18" name="Text 16"/>
+          <p:cNvSpPr txBox="1"/>
+          <p:nvPr/>
+        </p:nvSpPr>
+        <p:spPr>
+          <a:xfrm>
+            <a:off x="8229600" y="2194560"/>
+            <a:ext cx="3200400" cy="822960"/>
+          </a:xfrm>
+          <a:prstGeom prst="rect">
+            <a:avLst/>
+          </a:prstGeom>
+          <a:noFill/>
+          <a:ln/>
+        </p:spPr>
+        <p:txBody>
+          <a:bodyPr wrap="square" lIns="0" tIns="0" rIns="0" bIns="0" rtlCol="0" anchor="t"/>
+          <a:lstStyle/>
+          <a:p>
+            <a:pPr indent="0" marL="0">
+              <a:buNone/>
+            </a:pPr>
+            <a:r>
+              <a:rPr lang="en-US" sz="1250" dirty="0">
+                <a:solidFill>
+                  <a:srgbClr val="1F2933"/>
+                </a:solidFill>
+              </a:rPr>
+              <a:t>GSK3β inhibition; endpoint is a cognitive-motor composite at week 26</a:t>
+            </a:r>
+            <a:endParaRPr lang="en-US" sz="1250" dirty="0"/>
+          </a:p>
+        </p:txBody>
+      </p:sp>
+      <p:sp>
+        <p:nvSpPr>
+          <p:cNvPr id="19" name="Text 17"/>
+          <p:cNvSpPr txBox="1"/>
+          <p:nvPr/>
+        </p:nvSpPr>
+        <p:spPr>
+          <a:xfrm>
+            <a:off x="8229600" y="3063240"/>
+            <a:ext cx="3200400" cy="274320"/>
+          </a:xfrm>
+          <a:prstGeom prst="rect">
+            <a:avLst/>
+          </a:prstGeom>
+          <a:noFill/>
+          <a:ln/>
+        </p:spPr>
+        <p:txBody>
+          <a:bodyPr wrap="square" lIns="0" tIns="0" rIns="0" bIns="0" rtlCol="0" anchor="ctr"/>
+          <a:lstStyle/>
+          <a:p>
+            <a:pPr indent="0" marL="0">
+              <a:buNone/>
+            </a:pPr>
+            <a:r>
+              <a:rPr lang="en-US" sz="1250" b="1" dirty="0">
+                <a:solidFill>
+                  <a:srgbClr val="000000"/>
+                </a:solidFill>
+              </a:rPr>
+              <a:t>Covariate that predicts response</a:t>
+            </a:r>
+            <a:endParaRPr lang="en-US" sz="1250" dirty="0"/>
+          </a:p>
+        </p:txBody>
+      </p:sp>
+      <p:sp>
+        <p:nvSpPr>
+          <p:cNvPr id="20" name="Text 18"/>
+          <p:cNvSpPr txBox="1"/>
+          <p:nvPr/>
+        </p:nvSpPr>
+        <p:spPr>
+          <a:xfrm>
+            <a:off x="8229600" y="3364992"/>
+            <a:ext cx="3200400" cy="2194560"/>
+          </a:xfrm>
+          <a:prstGeom prst="rect">
+            <a:avLst/>
+          </a:prstGeom>
+          <a:noFill/>
+          <a:ln/>
+        </p:spPr>
+        <p:txBody>
+          <a:bodyPr wrap="square" lIns="0" tIns="0" rIns="0" bIns="0" rtlCol="0" anchor="t"/>
+          <a:lstStyle/>
+          <a:p>
+            <a:pPr indent="0" marL="0">
+              <a:buNone/>
+            </a:pPr>
+            <a:r>
+              <a:rPr lang="en-US" sz="1250" dirty="0">
+                <a:solidFill>
+                  <a:srgbClr val="1F2933"/>
+                </a:solidFill>
+              </a:rPr>
+              <a:t>Baseline cognitive function, as a threshold near z = -0.5. Only modestly correlated with CTG and myotonia (about 0.3), so it is a distinct clinical axis; the cognitive part of the endpoint contributes.</a:t>
+            </a:r>
+            <a:endParaRPr lang="en-US" sz="1250" dirty="0"/>
+          </a:p>
+        </p:txBody>
+      </p:sp>
+      <p:sp>
+        <p:nvSpPr>
+          <p:cNvPr id="21" name="Text 19"/>
+          <p:cNvSpPr txBox="1"/>
+          <p:nvPr/>
+        </p:nvSpPr>
+        <p:spPr>
+          <a:xfrm>
+            <a:off x="548640" y="5760720"/>
+            <a:ext cx="11064240" cy="548640"/>
+          </a:xfrm>
+          <a:prstGeom prst="rect">
+            <a:avLst/>
+          </a:prstGeom>
+          <a:noFill/>
+          <a:ln/>
+        </p:spPr>
+        <p:txBody>
+          <a:bodyPr wrap="square" lIns="0" tIns="0" rIns="0" bIns="0" rtlCol="0" anchor="t"/>
+          <a:lstStyle/>
+          <a:p>
+            <a:pPr indent="0" marL="0">
+              <a:buNone/>
+            </a:pPr>
+            <a:r>
+              <a:rPr lang="en-US" sz="1250" dirty="0">
+                <a:solidFill>
+                  <a:srgbClr val="5B6B7A"/>
+                </a:solidFill>
+              </a:rPr>
+              <a:t>Takeaway: the strongest covariate depends on both the drug's mechanism of action and the endpoint being measured. Prepared with Bei Zhao's clinical-pharmacology summary; correlations in Bei's screen: myotonia +0.83 (absolute change), CTG +0.42, cognition -0.65.</a:t>
+            </a:r>
+            <a:endParaRPr lang="en-US" sz="1250" dirty="0"/>
+          </a:p>
+        </p:txBody>
+      </p:sp>
+    </p:spTree>
+  </p:cSld>
+  <p:clrMapOvr>
+    <a:masterClrMapping/>
+  </p:clrMapOvr>
+</p:sld>
+</file>
+
+<file path=ppt/slides/slide14.xml><?xml version="1.0" encoding="utf-8"?>
+<p:sld xmlns:a="http://schemas.openxmlformats.org/drawingml/2006/main" xmlns:r="http://schemas.openxmlformats.org/officeDocument/2006/relationships" xmlns:p="http://schemas.openxmlformats.org/presentationml/2006/main">
+  <p:cSld name="Slide 14">
+    <p:bg>
+      <p:bgPr>
+        <a:solidFill>
+          <a:srgbClr val="FFFFFF"/>
+        </a:solidFill>
+      </p:bgPr>
+    </p:bg>
+    <p:spTree>
+      <p:nvGrpSpPr>
+        <p:cNvPr id="1" name=""/>
+        <p:cNvGrpSpPr/>
+        <p:nvPr/>
+      </p:nvGrpSpPr>
+      <p:grpSpPr>
+        <a:xfrm>
+          <a:off x="0" y="0"/>
+          <a:ext cx="0" cy="0"/>
+          <a:chOff x="0" y="0"/>
+          <a:chExt cx="0" cy="0"/>
+        </a:xfrm>
+      </p:grpSpPr>
+      <p:sp>
+        <p:nvSpPr>
+          <p:cNvPr id="2" name="Text 0"/>
+          <p:cNvSpPr/>
+          <p:nvPr>
+            <p:ph idx="100" type="title" hasCustomPrompt="1"/>
+          </p:nvPr>
+        </p:nvSpPr>
+        <p:spPr>
+          <a:xfrm>
+            <a:off x="548640" y="365760"/>
+            <a:ext cx="11064240" cy="868680"/>
+          </a:xfrm>
+          <a:prstGeom prst="rect">
+            <a:avLst/>
+          </a:prstGeom>
+          <a:noFill/>
+          <a:ln/>
+        </p:spPr>
+        <p:txBody>
+          <a:bodyPr wrap="square" lIns="0" tIns="0" rIns="0" bIns="0" rtlCol="0" anchor="t"/>
+          <a:lstStyle/>
+          <a:p>
+            <a:pPr algn="l" indent="0" marL="0">
+              <a:buNone/>
+            </a:pPr>
+            <a:r>
+              <a:rPr lang="en-US" sz="2600" b="1" dirty="0">
+                <a:solidFill>
+                  <a:srgbClr val="000000"/>
+                </a:solidFill>
+              </a:rPr>
               <a:t>Backup: four independent pipelines, one answer</a:t>
             </a:r>
             <a:endParaRPr lang="en-US" sz="2600" dirty="0"/>
@@ -4112,7 +4930,7 @@
       </p:sp>
       <p:graphicFrame>
         <p:nvGraphicFramePr>
-          <p:cNvPr id="14" name="Table 0"/>
+          <p:cNvPr id="15" name="Table 0"/>
           <p:cNvGraphicFramePr>
             <a:graphicFrameLocks noGrp="1"/>
           </p:cNvGraphicFramePr>
@@ -5368,9 +6186,9 @@
 </p:sld>
 </file>
 
-<file path=ppt/slides/slide14.xml><?xml version="1.0" encoding="utf-8"?>
+<file path=ppt/slides/slide15.xml><?xml version="1.0" encoding="utf-8"?>
 <p:sld xmlns:a="http://schemas.openxmlformats.org/drawingml/2006/main" xmlns:r="http://schemas.openxmlformats.org/officeDocument/2006/relationships" xmlns:p="http://schemas.openxmlformats.org/presentationml/2006/main">
-  <p:cSld name="Slide 14">
+  <p:cSld name="Slide 15">
     <p:bg>
       <p:bgPr>
         <a:solidFill>

</xml_diff>

<commit_message>
Final clean-up for public release: README rewritten for judges, organizers' kickoff deck removed, results/ filled with the aggregate outputs
Co-Authored-By: Claude Fable 5.1 <noreply@anthropic.com>
</commit_message>
<xml_diff>
--- a/slides/Team1_DM1_slides.pptx
+++ b/slides/Team1_DM1_slides.pptx
@@ -4,6 +4,9 @@
   <p:sldMasterIdLst>
     <p:sldMasterId id="2147483648" r:id="rId1"/>
   </p:sldMasterIdLst>
+  <p:notesMasterIdLst>
+    <p:notesMasterId r:id="rId17"/>
+  </p:notesMasterIdLst>
   <p:sldIdLst>
     <p:sldId id="256" r:id="rId2"/>
     <p:sldId id="257" r:id="rId3"/>
@@ -21,9 +24,6 @@
     <p:sldId id="269" r:id="rId15"/>
     <p:sldId id="270" r:id="rId16"/>
   </p:sldIdLst>
-  <p:notesMasterIdLst>
-    <p:notesMasterId r:id="rId17"/>
-  </p:notesMasterIdLst>
   <p:sldSz cx="12192000" cy="6858000"/>
   <p:notesSz cx="6858000" cy="12192000"/>
   <p:defaultTextStyle>
@@ -121,7 +121,7 @@
   <p:extLst>
     <p:ext uri="{521415D9-36F7-43E2-AB2F-B90AF26B5E84}">
       <p14:sectionLst xmlns:p14="http://schemas.microsoft.com/office/powerpoint/2010/main">
-        <p14:section name="Talk" id="{f02932e3-7153-1cc6-8dd2-c081c49aed8b}">
+        <p14:section name="Talk" id="{F02932E3-7153-1CC6-8DD2-C081C49AED8B}">
           <p14:sldIdLst>
             <p14:sldId id="256"/>
             <p14:sldId id="257"/>
@@ -133,7 +133,7 @@
             <p14:sldId id="263"/>
           </p14:sldIdLst>
         </p14:section>
-        <p14:section name="Backup" id="{b8e6d3d1-3096-7d79-9452-283b2196ace5}">
+        <p14:section name="Backup" id="{B8E6D3D1-3096-7D79-9452-283B2196ACE5}">
           <p14:sldIdLst>
             <p14:sldId id="264"/>
             <p14:sldId id="265"/>
@@ -175,234 +175,10 @@
           <a:chExt cx="0" cy="0"/>
         </a:xfrm>
       </p:grpSpPr>
-      <p:sp>
-        <p:nvSpPr>
-          <p:cNvPr id="2" name="Header Placeholder 1"/>
-          <p:cNvSpPr>
-            <a:spLocks noGrp="1"/>
-          </p:cNvSpPr>
-          <p:nvPr>
-            <p:ph type="hdr" sz="quarter"/>
-          </p:nvPr>
-        </p:nvSpPr>
-        <p:spPr>
-          <a:xfrm>
-            <a:off x="0" y="0"/>
-            <a:ext cx="2971800" cy="458788"/>
-          </a:xfrm>
-          <a:prstGeom prst="rect">
-            <a:avLst/>
-          </a:prstGeom>
-        </p:spPr>
-        <p:txBody>
-          <a:bodyPr vert="horz" lIns="91440" tIns="45720" rIns="91440" bIns="45720" rtlCol="0"/>
-          <a:lstStyle>
-            <a:lvl1pPr algn="l">
-              <a:defRPr sz="1200"/>
-            </a:lvl1pPr>
-          </a:lstStyle>
-          <a:p>
-            <a:endParaRPr lang="en-US"/>
-          </a:p>
-        </p:txBody>
-      </p:sp>
-      <p:sp>
-        <p:nvSpPr>
-          <p:cNvPr id="3" name="Date Placeholder 2"/>
-          <p:cNvSpPr>
-            <a:spLocks noGrp="1"/>
-          </p:cNvSpPr>
-          <p:nvPr>
-            <p:ph type="dt" idx="1"/>
-          </p:nvPr>
-        </p:nvSpPr>
-        <p:spPr>
-          <a:xfrm>
-            <a:off x="3884613" y="0"/>
-            <a:ext cx="2971800" cy="458788"/>
-          </a:xfrm>
-          <a:prstGeom prst="rect">
-            <a:avLst/>
-          </a:prstGeom>
-        </p:spPr>
-        <p:txBody>
-          <a:bodyPr vert="horz" lIns="91440" tIns="45720" rIns="91440" bIns="45720" rtlCol="0"/>
-          <a:lstStyle>
-            <a:lvl1pPr algn="r">
-              <a:defRPr sz="1200"/>
-            </a:lvl1pPr>
-          </a:lstStyle>
-          <a:p>
-            <a:fld id="{5282F153-3F37-0F45-9E97-73ACFA13230C}" type="datetimeFigureOut">
-              <a:rPr lang="en-US"/>
-              <a:t>7/23/19</a:t>
-            </a:fld>
-            <a:endParaRPr lang="en-US"/>
-          </a:p>
-        </p:txBody>
-      </p:sp>
-      <p:sp>
-        <p:nvSpPr>
-          <p:cNvPr id="4" name="Slide Image Placeholder 3"/>
-          <p:cNvSpPr>
-            <a:spLocks noGrp="1" noRot="1" noChangeAspect="1"/>
-          </p:cNvSpPr>
-          <p:nvPr>
-            <p:ph type="sldImg" idx="2"/>
-          </p:nvPr>
-        </p:nvSpPr>
-        <p:spPr>
-          <a:xfrm>
-            <a:off x="685800" y="1143000"/>
-            <a:ext cx="5486400" cy="3086100"/>
-          </a:xfrm>
-          <a:prstGeom prst="rect">
-            <a:avLst/>
-          </a:prstGeom>
-          <a:noFill/>
-          <a:ln w="12700">
-            <a:solidFill>
-              <a:prstClr val="black"/>
-            </a:solidFill>
-          </a:ln>
-        </p:spPr>
-        <p:txBody>
-          <a:bodyPr vert="horz" lIns="91440" tIns="45720" rIns="91440" bIns="45720" rtlCol="0" anchor="ctr"/>
-          <a:lstStyle/>
-          <a:p>
-            <a:endParaRPr lang="en-US"/>
-          </a:p>
-        </p:txBody>
-      </p:sp>
-      <p:sp>
-        <p:nvSpPr>
-          <p:cNvPr id="5" name="Notes Placeholder 4"/>
-          <p:cNvSpPr>
-            <a:spLocks noGrp="1"/>
-          </p:cNvSpPr>
-          <p:nvPr>
-            <p:ph type="body" sz="quarter" idx="3"/>
-          </p:nvPr>
-        </p:nvSpPr>
-        <p:spPr>
-          <a:xfrm>
-            <a:off x="685800" y="4400550"/>
-            <a:ext cx="5486400" cy="3600450"/>
-          </a:xfrm>
-          <a:prstGeom prst="rect">
-            <a:avLst/>
-          </a:prstGeom>
-        </p:spPr>
-        <p:txBody>
-          <a:bodyPr vert="horz" lIns="91440" tIns="45720" rIns="91440" bIns="45720" rtlCol="0"/>
-          <a:lstStyle/>
-          <a:p>
-            <a:pPr lvl="0"/>
-            <a:r>
-              <a:rPr lang="en-US"/>
-              <a:t>Click to edit Master text styles</a:t>
-            </a:r>
-          </a:p>
-          <a:p>
-            <a:pPr lvl="1"/>
-            <a:r>
-              <a:rPr lang="en-US"/>
-              <a:t>Second level</a:t>
-            </a:r>
-          </a:p>
-          <a:p>
-            <a:pPr lvl="2"/>
-            <a:r>
-              <a:rPr lang="en-US"/>
-              <a:t>Third level</a:t>
-            </a:r>
-          </a:p>
-          <a:p>
-            <a:pPr lvl="3"/>
-            <a:r>
-              <a:rPr lang="en-US"/>
-              <a:t>Fourth level</a:t>
-            </a:r>
-          </a:p>
-          <a:p>
-            <a:pPr lvl="4"/>
-            <a:r>
-              <a:rPr lang="en-US"/>
-              <a:t>Fifth level</a:t>
-            </a:r>
-          </a:p>
-        </p:txBody>
-      </p:sp>
-      <p:sp>
-        <p:nvSpPr>
-          <p:cNvPr id="6" name="Footer Placeholder 5"/>
-          <p:cNvSpPr>
-            <a:spLocks noGrp="1"/>
-          </p:cNvSpPr>
-          <p:nvPr>
-            <p:ph type="ftr" sz="quarter" idx="4"/>
-          </p:nvPr>
-        </p:nvSpPr>
-        <p:spPr>
-          <a:xfrm>
-            <a:off x="0" y="8685213"/>
-            <a:ext cx="2971800" cy="458787"/>
-          </a:xfrm>
-          <a:prstGeom prst="rect">
-            <a:avLst/>
-          </a:prstGeom>
-        </p:spPr>
-        <p:txBody>
-          <a:bodyPr vert="horz" lIns="91440" tIns="45720" rIns="91440" bIns="45720" rtlCol="0" anchor="b"/>
-          <a:lstStyle>
-            <a:lvl1pPr algn="l">
-              <a:defRPr sz="1200"/>
-            </a:lvl1pPr>
-          </a:lstStyle>
-          <a:p>
-            <a:endParaRPr lang="en-US"/>
-          </a:p>
-        </p:txBody>
-      </p:sp>
-      <p:sp>
-        <p:nvSpPr>
-          <p:cNvPr id="7" name="Slide Number Placeholder 6"/>
-          <p:cNvSpPr>
-            <a:spLocks noGrp="1"/>
-          </p:cNvSpPr>
-          <p:nvPr>
-            <p:ph type="sldNum" sz="quarter" idx="5"/>
-          </p:nvPr>
-        </p:nvSpPr>
-        <p:spPr>
-          <a:xfrm>
-            <a:off x="3884613" y="8685213"/>
-            <a:ext cx="2971800" cy="458787"/>
-          </a:xfrm>
-          <a:prstGeom prst="rect">
-            <a:avLst/>
-          </a:prstGeom>
-        </p:spPr>
-        <p:txBody>
-          <a:bodyPr vert="horz" lIns="91440" tIns="45720" rIns="91440" bIns="45720" rtlCol="0" anchor="b"/>
-          <a:lstStyle>
-            <a:lvl1pPr algn="r">
-              <a:defRPr sz="1200"/>
-            </a:lvl1pPr>
-          </a:lstStyle>
-          <a:p>
-            <a:fld id="{CE5E9CC1-C706-0F49-92D6-E571CC5EEA8F}" type="slidenum">
-              <a:rPr lang="en-US"/>
-              <a:t>‹#›</a:t>
-            </a:fld>
-            <a:endParaRPr lang="en-US"/>
-          </a:p>
-        </p:txBody>
-      </p:sp>
     </p:spTree>
     <p:extLst>
       <p:ext uri="{BB962C8B-B14F-4D97-AF65-F5344CB8AC3E}">
-        <p14:creationId xmlns:p14="http://schemas.microsoft.com/office/powerpoint/2010/main" val="1024086991"/>
+        <p14:creationId xmlns:p14="http://schemas.microsoft.com/office/powerpoint/2010/main" val="1455999598"/>
       </p:ext>
     </p:extLst>
   </p:cSld>
@@ -550,7 +326,6 @@
               <a:rPr lang="en-US" dirty="0"/>
               <a:t>[20 s] Good morning, Team 1. Our question is the organizers' question: for each of three DM1 treatments, which baseline measurements tell us who will respond, and does machine learning find anything that standard covariate models miss? Direction reminder, once: for mexiletine a lower change in myotonia is better; for the other two, higher is better.</a:t>
             </a:r>
-            <a:endParaRPr lang="en-US" dirty="0"/>
           </a:p>
         </p:txBody>
       </p:sp>
@@ -634,10 +409,6 @@
           <a:bodyPr/>
           <a:lstStyle/>
           <a:p>
-            <a:r>
-              <a:rPr lang="en-US" dirty="0"/>
-              <a:t/>
-            </a:r>
             <a:endParaRPr lang="en-US" dirty="0"/>
           </a:p>
         </p:txBody>
@@ -722,10 +493,6 @@
           <a:bodyPr/>
           <a:lstStyle/>
           <a:p>
-            <a:r>
-              <a:rPr lang="en-US" dirty="0"/>
-              <a:t/>
-            </a:r>
             <a:endParaRPr lang="en-US" dirty="0"/>
           </a:p>
         </p:txBody>
@@ -810,10 +577,6 @@
           <a:bodyPr/>
           <a:lstStyle/>
           <a:p>
-            <a:r>
-              <a:rPr lang="en-US" dirty="0"/>
-              <a:t/>
-            </a:r>
             <a:endParaRPr lang="en-US" dirty="0"/>
           </a:p>
         </p:txBody>
@@ -902,7 +665,6 @@
               <a:rPr lang="en-US" dirty="0"/>
               <a:t>Bei's framing for Q&amp;A: a symptom-level drug tracks the symptom; a molecular drug tracks the genetic burden; a multisystem drug with a cognition-weighted endpoint tracks cognition. Cognition is only modestly correlated with the severity axis, which is why it is a separate predictor rather than a proxy.</a:t>
             </a:r>
-            <a:endParaRPr lang="en-US" dirty="0"/>
           </a:p>
         </p:txBody>
       </p:sp>
@@ -990,7 +752,6 @@
               <a:rPr lang="en-US" dirty="0"/>
               <a:t>If asked how we know the covariates are not an artefact of one person's choices: four pipelines, written independently in R and Python with different splits and different method sets, found the same three covariates. The talk slides quote one pipeline so that every number comes from the same test-set patients; the others are replication.</a:t>
             </a:r>
-            <a:endParaRPr lang="en-US" dirty="0"/>
           </a:p>
         </p:txBody>
       </p:sp>
@@ -1074,10 +835,6 @@
           <a:bodyPr/>
           <a:lstStyle/>
           <a:p>
-            <a:r>
-              <a:rPr lang="en-US" dirty="0"/>
-              <a:t/>
-            </a:r>
             <a:endParaRPr lang="en-US" dirty="0"/>
           </a:p>
         </p:txBody>
@@ -1169,7 +926,6 @@
 The data: 500 simulated patients, one drug each, 18 baseline measures covering every organ system the disease touches, some of them noise by design.
 Before modelling we looked: two clusters of measures move together, repeat length with myotonia severity (r 0.88) and age with onset age and duration; cognitive function stands apart. One cleaning finding: albumin was a single filled-in value for every mexiletine patient, so we excluded it there. No patient was removed.</a:t>
             </a:r>
-            <a:endParaRPr lang="en-US" dirty="0"/>
           </a:p>
         </p:txBody>
       </p:sp>
@@ -1259,7 +1015,6 @@
 Covariate models: stepwise, LASSO, elastic net, and a linear model on the agreed covariates. Machine learning: random forest and XGBoost, with importance read by permutation and SHAP.
 Same yardstick for all: test-set R² and AUC. Three team members repeated the analysis in separate code, and we repeated the split 20 times.</a:t>
             </a:r>
-            <a:endParaRPr lang="en-US" dirty="0"/>
           </a:p>
         </p:txBody>
       </p:sp>
@@ -1351,7 +1106,6 @@
 On test-set patients, severity about 5 or more: 10 of 21 responded, 48%; below, 2 of 20, 10%. AUC 0.77.
 One caution we state ourselves: the R² of 0.5 to 0.6 on absolute change is mostly arithmetic; patients with more myotonia have more to lose. On relative change the same axis still predicts, modestly, R² about 0.15, and on that scale CTG edges ahead of severity. A simple linear model does all of this; machine learning tied it and added nothing.</a:t>
             </a:r>
-            <a:endParaRPr lang="en-US" dirty="0"/>
           </a:p>
         </p:txBody>
       </p:sp>
@@ -1443,7 +1197,6 @@
 On test-set patients, repeats about 350 or more: 10 of 17 responded, 59%; below, 8 of 26, 31%. AUC 0.72.
 Reading for a trialist: the direction is knowable, the individual is not. Use repeat length to stratify randomisation, not to predict a patient's score.</a:t>
             </a:r>
-            <a:endParaRPr lang="en-US" dirty="0"/>
           </a:p>
         </p:txBody>
       </p:sp>
@@ -1534,7 +1287,6 @@
 This is the one place machine learning helped. Tree models reached R² 0.55 against 0.3 for straight lines, on 19 of 20 splits. Why: a straight line cannot draw a step. Give the linear model that one cut-off and it reaches 0.45. So machine learning found the shape of the effect, and we hand it back as a one-term rule.
 Test-set patients: cognition below -0.5, 17 of 23 responded, 74%; above, 3 of 18, 17%.</a:t>
             </a:r>
-            <a:endParaRPr lang="en-US" dirty="0"/>
           </a:p>
         </p:txBody>
       </p:sp>
@@ -1625,7 +1377,6 @@
 The hackathon question, in two parts. Did machine learning find additional predictors? No: same covariates, chosen by both families of method, the random column never selected, confirmed by three independent implementations and 20 repeated splits. Did it improve stratification? Yes, in one specific way: it found that the cognition effect is a threshold, and a one-term rule captures it. Its contribution was the functional form, not new features.
 Across 20 splits the scores move by up to 0.15 in R², but the selected covariates barely move: the split moves the scores, not the covariates. That is why we never crown a winning model.</a:t>
             </a:r>
-            <a:endParaRPr lang="en-US" dirty="0"/>
           </a:p>
         </p:txBody>
       </p:sp>
@@ -1713,7 +1464,6 @@
               <a:rPr lang="en-US" dirty="0"/>
               <a:t>[20 s] What we would not claim: there is no placebo arm, so these are predictors of doing well on the drug, not proof of who benefits from it. About 41 test patients per arm, so cut-offs are approximate and we do not rank methods inside an arm. One time point per patient; the next step is a longitudinal disease-progression model. AI disclosure: Claude and Codex drafted code, documentation and slides; every decision and interpretation was reviewed by the team, which is accountable. Everything is open in the repository. Thank you.</a:t>
             </a:r>
-            <a:endParaRPr lang="en-US" dirty="0"/>
           </a:p>
         </p:txBody>
       </p:sp>
@@ -1801,7 +1551,6 @@
               <a:rPr lang="en-US" dirty="0"/>
               <a:t>Absolute R² varies by up to 0.15 between splits, hence ranges rather than point estimates. Cross-seed selection frequencies in Ming's pipeline agree: cognition 100%, CTG repeats 90%, myotonia 85%.</a:t>
             </a:r>
-            <a:endParaRPr lang="en-US" dirty="0"/>
           </a:p>
         </p:txBody>
       </p:sp>
@@ -1879,6 +1628,7 @@
         <a:solidFill>
           <a:srgbClr val="FFFFFF"/>
         </a:solidFill>
+        <a:effectLst/>
       </p:bgPr>
     </p:bg>
     <p:spTree>
@@ -1898,9 +1648,11 @@
       <p:sp>
         <p:nvSpPr>
           <p:cNvPr id="2" name="Text 0"/>
-          <p:cNvSpPr/>
+          <p:cNvSpPr>
+            <a:spLocks noGrp="1"/>
+          </p:cNvSpPr>
           <p:nvPr>
-            <p:ph idx="100" type="title" hasCustomPrompt="1"/>
+            <p:ph type="title" idx="100" hasCustomPrompt="1"/>
           </p:nvPr>
         </p:nvSpPr>
         <p:spPr>
@@ -1917,7 +1669,7 @@
         <p:txBody>
           <a:bodyPr wrap="square" rtlCol="0"/>
           <a:lstStyle>
-            <a:lvl1pPr algn="l" indent="0" marL="0">
+            <a:lvl1pPr marL="0" indent="0" algn="l">
               <a:buNone/>
               <a:defRPr lang="en-US" sz="4000" b="1" dirty="0">
                 <a:solidFill>
@@ -1927,7 +1679,7 @@
             </a:lvl1pPr>
           </a:lstStyle>
           <a:p>
-            <a:pPr algn="l" indent="0" marL="0">
+            <a:pPr marL="0" indent="0" algn="l">
               <a:buNone/>
             </a:pPr>
             <a:endParaRPr lang="en-US" sz="4000" dirty="0"/>
@@ -1937,9 +1689,11 @@
       <p:sp>
         <p:nvSpPr>
           <p:cNvPr id="3" name="Text 0"/>
-          <p:cNvSpPr/>
+          <p:cNvSpPr>
+            <a:spLocks noGrp="1"/>
+          </p:cNvSpPr>
           <p:nvPr>
-            <p:ph idx="101" type="body" hasCustomPrompt="1"/>
+            <p:ph type="body" idx="101" hasCustomPrompt="1"/>
           </p:nvPr>
         </p:nvSpPr>
         <p:spPr>
@@ -1956,7 +1710,7 @@
         <p:txBody>
           <a:bodyPr wrap="square" rtlCol="0"/>
           <a:lstStyle>
-            <a:lvl1pPr algn="l" indent="0" marL="0">
+            <a:lvl1pPr marL="0" indent="0" algn="l">
               <a:buNone/>
               <a:defRPr lang="en-US" sz="1800" dirty="0">
                 <a:solidFill>
@@ -1966,7 +1720,7 @@
             </a:lvl1pPr>
           </a:lstStyle>
           <a:p>
-            <a:pPr algn="l" indent="0" marL="0">
+            <a:pPr marL="0" indent="0" algn="l">
               <a:buNone/>
             </a:pPr>
             <a:endParaRPr lang="en-US" sz="1800" dirty="0"/>
@@ -1989,6 +1743,7 @@
         <a:solidFill>
           <a:srgbClr val="FFFFFF"/>
         </a:solidFill>
+        <a:effectLst/>
       </p:bgPr>
     </p:bg>
     <p:spTree>
@@ -2008,9 +1763,11 @@
       <p:sp>
         <p:nvSpPr>
           <p:cNvPr id="2" name="Text 0"/>
-          <p:cNvSpPr/>
+          <p:cNvSpPr>
+            <a:spLocks noGrp="1"/>
+          </p:cNvSpPr>
           <p:nvPr>
-            <p:ph idx="100" type="title" hasCustomPrompt="1"/>
+            <p:ph type="title" idx="100" hasCustomPrompt="1"/>
           </p:nvPr>
         </p:nvSpPr>
         <p:spPr>
@@ -2027,7 +1784,7 @@
         <p:txBody>
           <a:bodyPr wrap="square" rtlCol="0"/>
           <a:lstStyle>
-            <a:lvl1pPr algn="l" indent="0" marL="0">
+            <a:lvl1pPr marL="0" indent="0" algn="l">
               <a:buNone/>
               <a:defRPr lang="en-US" sz="2600" b="1" dirty="0">
                 <a:solidFill>
@@ -2037,7 +1794,7 @@
             </a:lvl1pPr>
           </a:lstStyle>
           <a:p>
-            <a:pPr algn="l" indent="0" marL="0">
+            <a:pPr marL="0" indent="0" algn="l">
               <a:buNone/>
             </a:pPr>
             <a:endParaRPr lang="en-US" sz="2600" dirty="0"/>
@@ -2055,6 +1812,11 @@
 <file path=ppt/slideMasters/slideMaster1.xml><?xml version="1.0" encoding="utf-8"?>
 <p:sldMaster xmlns:a="http://schemas.openxmlformats.org/drawingml/2006/main" xmlns:r="http://schemas.openxmlformats.org/officeDocument/2006/relationships" xmlns:p="http://schemas.openxmlformats.org/presentationml/2006/main">
   <p:cSld>
+    <p:bg>
+      <p:bgRef idx="1001">
+        <a:schemeClr val="bg1"/>
+      </p:bgRef>
+    </p:bg>
     <p:spTree>
       <p:nvGrpSpPr>
         <p:cNvPr id="1" name=""/>
@@ -2339,6 +2101,7 @@
         <a:solidFill>
           <a:srgbClr val="FFFFFF"/>
         </a:solidFill>
+        <a:effectLst/>
       </p:bgPr>
     </p:bg>
     <p:spTree>
@@ -2358,9 +2121,11 @@
       <p:sp>
         <p:nvSpPr>
           <p:cNvPr id="2" name="Text 0"/>
-          <p:cNvSpPr/>
+          <p:cNvSpPr>
+            <a:spLocks noGrp="1"/>
+          </p:cNvSpPr>
           <p:nvPr>
-            <p:ph idx="100" type="title" hasCustomPrompt="1"/>
+            <p:ph type="title" idx="100" hasCustomPrompt="1"/>
           </p:nvPr>
         </p:nvSpPr>
         <p:spPr>
@@ -2378,7 +2143,7 @@
           <a:bodyPr wrap="square" lIns="0" tIns="0" rIns="0" bIns="0" rtlCol="0"/>
           <a:lstStyle/>
           <a:p>
-            <a:pPr algn="l" indent="0" marL="0">
+            <a:pPr marL="0" indent="0" algn="l">
               <a:buNone/>
             </a:pPr>
             <a:r>
@@ -2396,9 +2161,11 @@
       <p:sp>
         <p:nvSpPr>
           <p:cNvPr id="3" name="Text 0"/>
-          <p:cNvSpPr/>
+          <p:cNvSpPr>
+            <a:spLocks noGrp="1"/>
+          </p:cNvSpPr>
           <p:nvPr>
-            <p:ph idx="101" type="body" hasCustomPrompt="1"/>
+            <p:ph type="body" idx="101" hasCustomPrompt="1"/>
           </p:nvPr>
         </p:nvSpPr>
         <p:spPr>
@@ -2416,7 +2183,7 @@
           <a:bodyPr wrap="square" lIns="0" tIns="0" rIns="0" bIns="0" rtlCol="0"/>
           <a:lstStyle/>
           <a:p>
-            <a:pPr algn="l" indent="0" marL="0">
+            <a:pPr marL="0" indent="0" algn="l">
               <a:buNone/>
             </a:pPr>
             <a:r>
@@ -2430,7 +2197,7 @@
             <a:endParaRPr lang="en-US" sz="1800" dirty="0"/>
           </a:p>
           <a:p>
-            <a:pPr algn="l" indent="0" marL="0">
+            <a:pPr marL="0" indent="0" algn="l">
               <a:buNone/>
             </a:pPr>
             <a:r>
@@ -2444,7 +2211,7 @@
             <a:endParaRPr lang="en-US" sz="1800" dirty="0"/>
           </a:p>
           <a:p>
-            <a:pPr algn="l" indent="0" marL="0">
+            <a:pPr marL="0" indent="0" algn="l">
               <a:buNone/>
             </a:pPr>
             <a:r>
@@ -2458,7 +2225,7 @@
             <a:endParaRPr lang="en-US" sz="1800" dirty="0"/>
           </a:p>
           <a:p>
-            <a:pPr algn="l" indent="0" marL="0">
+            <a:pPr marL="0" indent="0" algn="l">
               <a:buNone/>
             </a:pPr>
             <a:r>
@@ -2489,6 +2256,7 @@
         <a:solidFill>
           <a:srgbClr val="FFFFFF"/>
         </a:solidFill>
+        <a:effectLst/>
       </p:bgPr>
     </p:bg>
     <p:spTree>
@@ -2508,9 +2276,11 @@
       <p:sp>
         <p:nvSpPr>
           <p:cNvPr id="2" name="Text 0"/>
-          <p:cNvSpPr/>
+          <p:cNvSpPr>
+            <a:spLocks noGrp="1"/>
+          </p:cNvSpPr>
           <p:nvPr>
-            <p:ph idx="100" type="title" hasCustomPrompt="1"/>
+            <p:ph type="title" idx="100" hasCustomPrompt="1"/>
           </p:nvPr>
         </p:nvSpPr>
         <p:spPr>
@@ -2528,7 +2298,7 @@
           <a:bodyPr wrap="square" lIns="0" tIns="0" rIns="0" bIns="0" rtlCol="0" anchor="t"/>
           <a:lstStyle/>
           <a:p>
-            <a:pPr algn="l" indent="0" marL="0">
+            <a:pPr marL="0" indent="0" algn="l">
               <a:buNone/>
             </a:pPr>
             <a:r>
@@ -2545,14 +2315,14 @@
       </p:sp>
       <p:pic>
         <p:nvPicPr>
-          <p:cNvPr id="3" name="Image 0" descr="/Users/euibeoms/Desktop/ACoP/hackathon/slides/figs/fig_scoreboard.png">    </p:cNvPr>
+          <p:cNvPr id="3" name="Image 0" descr="/Users/euibeoms/Desktop/ACoP/hackathon/slides/figs/fig_scoreboard.png"/>
           <p:cNvPicPr>
             <a:picLocks noChangeAspect="1"/>
           </p:cNvPicPr>
           <p:nvPr/>
         </p:nvPicPr>
         <p:blipFill>
-          <a:blip r:embed="rId1"/>
+          <a:blip r:embed="rId3"/>
           <a:stretch>
             <a:fillRect/>
           </a:stretch>
@@ -2588,7 +2358,7 @@
           <a:bodyPr wrap="square" lIns="0" tIns="0" rIns="0" bIns="0" rtlCol="0" anchor="t"/>
           <a:lstStyle/>
           <a:p>
-            <a:pPr indent="0" marL="0">
+            <a:pPr marL="0" indent="0">
               <a:buNone/>
             </a:pPr>
             <a:r>
@@ -2619,6 +2389,7 @@
         <a:solidFill>
           <a:srgbClr val="FFFFFF"/>
         </a:solidFill>
+        <a:effectLst/>
       </p:bgPr>
     </p:bg>
     <p:spTree>
@@ -2638,9 +2409,11 @@
       <p:sp>
         <p:nvSpPr>
           <p:cNvPr id="2" name="Text 0"/>
-          <p:cNvSpPr/>
+          <p:cNvSpPr>
+            <a:spLocks noGrp="1"/>
+          </p:cNvSpPr>
           <p:nvPr>
-            <p:ph idx="100" type="title" hasCustomPrompt="1"/>
+            <p:ph type="title" idx="100" hasCustomPrompt="1"/>
           </p:nvPr>
         </p:nvSpPr>
         <p:spPr>
@@ -2658,7 +2431,7 @@
           <a:bodyPr wrap="square" lIns="0" tIns="0" rIns="0" bIns="0" rtlCol="0" anchor="t"/>
           <a:lstStyle/>
           <a:p>
-            <a:pPr algn="l" indent="0" marL="0">
+            <a:pPr marL="0" indent="0" algn="l">
               <a:buNone/>
             </a:pPr>
             <a:r>
@@ -2675,14 +2448,14 @@
       </p:sp>
       <p:pic>
         <p:nvPicPr>
-          <p:cNvPr id="3" name="Image 0" descr="/Users/euibeoms/Desktop/ACoP/hackathon/slides/figs/fig_covariate_matrix.png">    </p:cNvPr>
+          <p:cNvPr id="3" name="Image 0" descr="/Users/euibeoms/Desktop/ACoP/hackathon/slides/figs/fig_covariate_matrix.png"/>
           <p:cNvPicPr>
             <a:picLocks noChangeAspect="1"/>
           </p:cNvPicPr>
           <p:nvPr/>
         </p:nvPicPr>
         <p:blipFill>
-          <a:blip r:embed="rId1"/>
+          <a:blip r:embed="rId3"/>
           <a:stretch>
             <a:fillRect/>
           </a:stretch>
@@ -2718,7 +2491,7 @@
           <a:bodyPr wrap="square" lIns="0" tIns="0" rIns="0" bIns="0" rtlCol="0" anchor="t"/>
           <a:lstStyle/>
           <a:p>
-            <a:pPr indent="0" marL="0">
+            <a:pPr marL="0" indent="0">
               <a:buNone/>
             </a:pPr>
             <a:r>
@@ -2749,6 +2522,7 @@
         <a:solidFill>
           <a:srgbClr val="FFFFFF"/>
         </a:solidFill>
+        <a:effectLst/>
       </p:bgPr>
     </p:bg>
     <p:spTree>
@@ -2768,9 +2542,11 @@
       <p:sp>
         <p:nvSpPr>
           <p:cNvPr id="2" name="Text 0"/>
-          <p:cNvSpPr/>
+          <p:cNvSpPr>
+            <a:spLocks noGrp="1"/>
+          </p:cNvSpPr>
           <p:nvPr>
-            <p:ph idx="100" type="title" hasCustomPrompt="1"/>
+            <p:ph type="title" idx="100" hasCustomPrompt="1"/>
           </p:nvPr>
         </p:nvSpPr>
         <p:spPr>
@@ -2788,7 +2564,7 @@
           <a:bodyPr wrap="square" lIns="0" tIns="0" rIns="0" bIns="0" rtlCol="0" anchor="t"/>
           <a:lstStyle/>
           <a:p>
-            <a:pPr algn="l" indent="0" marL="0">
+            <a:pPr marL="0" indent="0" algn="l">
               <a:buNone/>
             </a:pPr>
             <a:r>
@@ -2826,11 +2602,41 @@
             <a:tbl>
               <a:tblPr/>
               <a:tblGrid>
-                <a:gridCol w="3931920"/>
-                <a:gridCol w="1783080"/>
-                <a:gridCol w="1783080"/>
-                <a:gridCol w="1783080"/>
-                <a:gridCol w="1783080"/>
+                <a:gridCol w="3931920">
+                  <a:extLst>
+                    <a:ext uri="{9D8B030D-6E8A-4147-A177-3AD203B41FA5}">
+                      <a16:colId xmlns:a16="http://schemas.microsoft.com/office/drawing/2014/main" val="20000"/>
+                    </a:ext>
+                  </a:extLst>
+                </a:gridCol>
+                <a:gridCol w="1783080">
+                  <a:extLst>
+                    <a:ext uri="{9D8B030D-6E8A-4147-A177-3AD203B41FA5}">
+                      <a16:colId xmlns:a16="http://schemas.microsoft.com/office/drawing/2014/main" val="20001"/>
+                    </a:ext>
+                  </a:extLst>
+                </a:gridCol>
+                <a:gridCol w="1783080">
+                  <a:extLst>
+                    <a:ext uri="{9D8B030D-6E8A-4147-A177-3AD203B41FA5}">
+                      <a16:colId xmlns:a16="http://schemas.microsoft.com/office/drawing/2014/main" val="20002"/>
+                    </a:ext>
+                  </a:extLst>
+                </a:gridCol>
+                <a:gridCol w="1783080">
+                  <a:extLst>
+                    <a:ext uri="{9D8B030D-6E8A-4147-A177-3AD203B41FA5}">
+                      <a16:colId xmlns:a16="http://schemas.microsoft.com/office/drawing/2014/main" val="20003"/>
+                    </a:ext>
+                  </a:extLst>
+                </a:gridCol>
+                <a:gridCol w="1783080">
+                  <a:extLst>
+                    <a:ext uri="{9D8B030D-6E8A-4147-A177-3AD203B41FA5}">
+                      <a16:colId xmlns:a16="http://schemas.microsoft.com/office/drawing/2014/main" val="20004"/>
+                    </a:ext>
+                  </a:extLst>
+                </a:gridCol>
               </a:tblGrid>
               <a:tr h="457200">
                 <a:tc>
@@ -2838,7 +2644,7 @@
                     <a:bodyPr/>
                     <a:lstStyle/>
                     <a:p>
-                      <a:pPr indent="0" marL="0">
+                      <a:pPr marL="0" indent="0">
                         <a:buNone/>
                       </a:pPr>
                       <a:r>
@@ -2899,7 +2705,7 @@
                     <a:bodyPr/>
                     <a:lstStyle/>
                     <a:p>
-                      <a:pPr indent="0" marL="0">
+                      <a:pPr marL="0" indent="0">
                         <a:buNone/>
                       </a:pPr>
                       <a:r>
@@ -2960,7 +2766,7 @@
                     <a:bodyPr/>
                     <a:lstStyle/>
                     <a:p>
-                      <a:pPr indent="0" marL="0">
+                      <a:pPr marL="0" indent="0">
                         <a:buNone/>
                       </a:pPr>
                       <a:r>
@@ -3021,7 +2827,7 @@
                     <a:bodyPr/>
                     <a:lstStyle/>
                     <a:p>
-                      <a:pPr indent="0" marL="0">
+                      <a:pPr marL="0" indent="0">
                         <a:buNone/>
                       </a:pPr>
                       <a:r>
@@ -3082,7 +2888,7 @@
                     <a:bodyPr/>
                     <a:lstStyle/>
                     <a:p>
-                      <a:pPr indent="0" marL="0">
+                      <a:pPr marL="0" indent="0">
                         <a:buNone/>
                       </a:pPr>
                       <a:r>
@@ -3138,6 +2944,11 @@
                     </a:solidFill>
                   </a:tcPr>
                 </a:tc>
+                <a:extLst>
+                  <a:ext uri="{0D108BD9-81ED-4DB2-BD59-A6C34878D82A}">
+                    <a16:rowId xmlns:a16="http://schemas.microsoft.com/office/drawing/2014/main" val="10000"/>
+                  </a:ext>
+                </a:extLst>
               </a:tr>
               <a:tr h="548640">
                 <a:tc>
@@ -3145,7 +2956,7 @@
                     <a:bodyPr/>
                     <a:lstStyle/>
                     <a:p>
-                      <a:pPr indent="0" marL="0">
+                      <a:pPr marL="0" indent="0">
                         <a:buNone/>
                       </a:pPr>
                       <a:r>
@@ -3203,7 +3014,7 @@
                     <a:bodyPr/>
                     <a:lstStyle/>
                     <a:p>
-                      <a:pPr indent="0" marL="0">
+                      <a:pPr marL="0" indent="0">
                         <a:buNone/>
                       </a:pPr>
                       <a:r>
@@ -3261,7 +3072,7 @@
                     <a:bodyPr/>
                     <a:lstStyle/>
                     <a:p>
-                      <a:pPr indent="0" marL="0">
+                      <a:pPr marL="0" indent="0">
                         <a:buNone/>
                       </a:pPr>
                       <a:r>
@@ -3319,7 +3130,7 @@
                     <a:bodyPr/>
                     <a:lstStyle/>
                     <a:p>
-                      <a:pPr indent="0" marL="0">
+                      <a:pPr marL="0" indent="0">
                         <a:buNone/>
                       </a:pPr>
                       <a:r>
@@ -3377,7 +3188,7 @@
                     <a:bodyPr/>
                     <a:lstStyle/>
                     <a:p>
-                      <a:pPr indent="0" marL="0">
+                      <a:pPr marL="0" indent="0">
                         <a:buNone/>
                       </a:pPr>
                       <a:r>
@@ -3430,6 +3241,11 @@
                     </a:lnB>
                   </a:tcPr>
                 </a:tc>
+                <a:extLst>
+                  <a:ext uri="{0D108BD9-81ED-4DB2-BD59-A6C34878D82A}">
+                    <a16:rowId xmlns:a16="http://schemas.microsoft.com/office/drawing/2014/main" val="10001"/>
+                  </a:ext>
+                </a:extLst>
               </a:tr>
               <a:tr h="548640">
                 <a:tc>
@@ -3437,7 +3253,7 @@
                     <a:bodyPr/>
                     <a:lstStyle/>
                     <a:p>
-                      <a:pPr indent="0" marL="0">
+                      <a:pPr marL="0" indent="0">
                         <a:buNone/>
                       </a:pPr>
                       <a:r>
@@ -3495,7 +3311,7 @@
                     <a:bodyPr/>
                     <a:lstStyle/>
                     <a:p>
-                      <a:pPr indent="0" marL="0">
+                      <a:pPr marL="0" indent="0">
                         <a:buNone/>
                       </a:pPr>
                       <a:r>
@@ -3553,7 +3369,7 @@
                     <a:bodyPr/>
                     <a:lstStyle/>
                     <a:p>
-                      <a:pPr indent="0" marL="0">
+                      <a:pPr marL="0" indent="0">
                         <a:buNone/>
                       </a:pPr>
                       <a:r>
@@ -3611,7 +3427,7 @@
                     <a:bodyPr/>
                     <a:lstStyle/>
                     <a:p>
-                      <a:pPr indent="0" marL="0">
+                      <a:pPr marL="0" indent="0">
                         <a:buNone/>
                       </a:pPr>
                       <a:r>
@@ -3669,7 +3485,7 @@
                     <a:bodyPr/>
                     <a:lstStyle/>
                     <a:p>
-                      <a:pPr indent="0" marL="0">
+                      <a:pPr marL="0" indent="0">
                         <a:buNone/>
                       </a:pPr>
                       <a:r>
@@ -3722,6 +3538,11 @@
                     </a:lnB>
                   </a:tcPr>
                 </a:tc>
+                <a:extLst>
+                  <a:ext uri="{0D108BD9-81ED-4DB2-BD59-A6C34878D82A}">
+                    <a16:rowId xmlns:a16="http://schemas.microsoft.com/office/drawing/2014/main" val="10002"/>
+                  </a:ext>
+                </a:extLst>
               </a:tr>
               <a:tr h="548640">
                 <a:tc>
@@ -3729,7 +3550,7 @@
                     <a:bodyPr/>
                     <a:lstStyle/>
                     <a:p>
-                      <a:pPr indent="0" marL="0">
+                      <a:pPr marL="0" indent="0">
                         <a:buNone/>
                       </a:pPr>
                       <a:r>
@@ -3787,7 +3608,7 @@
                     <a:bodyPr/>
                     <a:lstStyle/>
                     <a:p>
-                      <a:pPr indent="0" marL="0">
+                      <a:pPr marL="0" indent="0">
                         <a:buNone/>
                       </a:pPr>
                       <a:r>
@@ -3845,7 +3666,7 @@
                     <a:bodyPr/>
                     <a:lstStyle/>
                     <a:p>
-                      <a:pPr indent="0" marL="0">
+                      <a:pPr marL="0" indent="0">
                         <a:buNone/>
                       </a:pPr>
                       <a:r>
@@ -3903,7 +3724,7 @@
                     <a:bodyPr/>
                     <a:lstStyle/>
                     <a:p>
-                      <a:pPr indent="0" marL="0">
+                      <a:pPr marL="0" indent="0">
                         <a:buNone/>
                       </a:pPr>
                       <a:r>
@@ -3961,7 +3782,7 @@
                     <a:bodyPr/>
                     <a:lstStyle/>
                     <a:p>
-                      <a:pPr indent="0" marL="0">
+                      <a:pPr marL="0" indent="0">
                         <a:buNone/>
                       </a:pPr>
                       <a:r>
@@ -4014,6 +3835,11 @@
                     </a:lnB>
                   </a:tcPr>
                 </a:tc>
+                <a:extLst>
+                  <a:ext uri="{0D108BD9-81ED-4DB2-BD59-A6C34878D82A}">
+                    <a16:rowId xmlns:a16="http://schemas.microsoft.com/office/drawing/2014/main" val="10003"/>
+                  </a:ext>
+                </a:extLst>
               </a:tr>
             </a:tbl>
           </a:graphicData>
@@ -4040,7 +3866,7 @@
           <a:bodyPr wrap="square" lIns="0" tIns="0" rIns="0" bIns="0" rtlCol="0" anchor="ctr"/>
           <a:lstStyle/>
           <a:p>
-            <a:pPr indent="0" marL="0">
+            <a:pPr marL="0" indent="0">
               <a:buNone/>
             </a:pPr>
             <a:r>
@@ -4147,6 +3973,7 @@
         <a:solidFill>
           <a:srgbClr val="FFFFFF"/>
         </a:solidFill>
+        <a:effectLst/>
       </p:bgPr>
     </p:bg>
     <p:spTree>
@@ -4166,9 +3993,11 @@
       <p:sp>
         <p:nvSpPr>
           <p:cNvPr id="2" name="Text 0"/>
-          <p:cNvSpPr/>
+          <p:cNvSpPr>
+            <a:spLocks noGrp="1"/>
+          </p:cNvSpPr>
           <p:nvPr>
-            <p:ph idx="100" type="title" hasCustomPrompt="1"/>
+            <p:ph type="title" idx="100" hasCustomPrompt="1"/>
           </p:nvPr>
         </p:nvSpPr>
         <p:spPr>
@@ -4186,7 +4015,7 @@
           <a:bodyPr wrap="square" lIns="0" tIns="0" rIns="0" bIns="0" rtlCol="0" anchor="t"/>
           <a:lstStyle/>
           <a:p>
-            <a:pPr algn="l" indent="0" marL="0">
+            <a:pPr marL="0" indent="0" algn="l">
               <a:buNone/>
             </a:pPr>
             <a:r>
@@ -4227,6 +4056,13 @@
             <a:prstDash val="solid"/>
           </a:ln>
         </p:spPr>
+        <p:txBody>
+          <a:bodyPr/>
+          <a:lstStyle/>
+          <a:p>
+            <a:endParaRPr lang="en-US"/>
+          </a:p>
+        </p:txBody>
       </p:sp>
       <p:sp>
         <p:nvSpPr>
@@ -4249,7 +4085,7 @@
           <a:bodyPr wrap="square" lIns="0" tIns="0" rIns="0" bIns="0" rtlCol="0" anchor="ctr"/>
           <a:lstStyle/>
           <a:p>
-            <a:pPr indent="0" marL="0">
+            <a:pPr marL="0" indent="0">
               <a:buNone/>
             </a:pPr>
             <a:r>
@@ -4285,7 +4121,7 @@
           <a:bodyPr wrap="square" lIns="0" tIns="0" rIns="0" bIns="0" rtlCol="0" anchor="ctr"/>
           <a:lstStyle/>
           <a:p>
-            <a:pPr indent="0" marL="0">
+            <a:pPr marL="0" indent="0">
               <a:buNone/>
             </a:pPr>
             <a:r>
@@ -4321,7 +4157,7 @@
           <a:bodyPr wrap="square" lIns="0" tIns="0" rIns="0" bIns="0" rtlCol="0" anchor="t"/>
           <a:lstStyle/>
           <a:p>
-            <a:pPr indent="0" marL="0">
+            <a:pPr marL="0" indent="0">
               <a:buNone/>
             </a:pPr>
             <a:r>
@@ -4357,7 +4193,7 @@
           <a:bodyPr wrap="square" lIns="0" tIns="0" rIns="0" bIns="0" rtlCol="0" anchor="ctr"/>
           <a:lstStyle/>
           <a:p>
-            <a:pPr indent="0" marL="0">
+            <a:pPr marL="0" indent="0">
               <a:buNone/>
             </a:pPr>
             <a:r>
@@ -4393,7 +4229,7 @@
           <a:bodyPr wrap="square" lIns="0" tIns="0" rIns="0" bIns="0" rtlCol="0" anchor="t"/>
           <a:lstStyle/>
           <a:p>
-            <a:pPr indent="0" marL="0">
+            <a:pPr marL="0" indent="0">
               <a:buNone/>
             </a:pPr>
             <a:r>
@@ -4434,6 +4270,13 @@
             <a:prstDash val="solid"/>
           </a:ln>
         </p:spPr>
+        <p:txBody>
+          <a:bodyPr/>
+          <a:lstStyle/>
+          <a:p>
+            <a:endParaRPr lang="en-US"/>
+          </a:p>
+        </p:txBody>
       </p:sp>
       <p:sp>
         <p:nvSpPr>
@@ -4456,7 +4299,7 @@
           <a:bodyPr wrap="square" lIns="0" tIns="0" rIns="0" bIns="0" rtlCol="0" anchor="ctr"/>
           <a:lstStyle/>
           <a:p>
-            <a:pPr indent="0" marL="0">
+            <a:pPr marL="0" indent="0">
               <a:buNone/>
             </a:pPr>
             <a:r>
@@ -4492,7 +4335,7 @@
           <a:bodyPr wrap="square" lIns="0" tIns="0" rIns="0" bIns="0" rtlCol="0" anchor="ctr"/>
           <a:lstStyle/>
           <a:p>
-            <a:pPr indent="0" marL="0">
+            <a:pPr marL="0" indent="0">
               <a:buNone/>
             </a:pPr>
             <a:r>
@@ -4528,7 +4371,7 @@
           <a:bodyPr wrap="square" lIns="0" tIns="0" rIns="0" bIns="0" rtlCol="0" anchor="t"/>
           <a:lstStyle/>
           <a:p>
-            <a:pPr indent="0" marL="0">
+            <a:pPr marL="0" indent="0">
               <a:buNone/>
             </a:pPr>
             <a:r>
@@ -4564,7 +4407,7 @@
           <a:bodyPr wrap="square" lIns="0" tIns="0" rIns="0" bIns="0" rtlCol="0" anchor="ctr"/>
           <a:lstStyle/>
           <a:p>
-            <a:pPr indent="0" marL="0">
+            <a:pPr marL="0" indent="0">
               <a:buNone/>
             </a:pPr>
             <a:r>
@@ -4600,7 +4443,7 @@
           <a:bodyPr wrap="square" lIns="0" tIns="0" rIns="0" bIns="0" rtlCol="0" anchor="t"/>
           <a:lstStyle/>
           <a:p>
-            <a:pPr indent="0" marL="0">
+            <a:pPr marL="0" indent="0">
               <a:buNone/>
             </a:pPr>
             <a:r>
@@ -4641,6 +4484,13 @@
             <a:prstDash val="solid"/>
           </a:ln>
         </p:spPr>
+        <p:txBody>
+          <a:bodyPr/>
+          <a:lstStyle/>
+          <a:p>
+            <a:endParaRPr lang="en-US"/>
+          </a:p>
+        </p:txBody>
       </p:sp>
       <p:sp>
         <p:nvSpPr>
@@ -4663,7 +4513,7 @@
           <a:bodyPr wrap="square" lIns="0" tIns="0" rIns="0" bIns="0" rtlCol="0" anchor="ctr"/>
           <a:lstStyle/>
           <a:p>
-            <a:pPr indent="0" marL="0">
+            <a:pPr marL="0" indent="0">
               <a:buNone/>
             </a:pPr>
             <a:r>
@@ -4699,7 +4549,7 @@
           <a:bodyPr wrap="square" lIns="0" tIns="0" rIns="0" bIns="0" rtlCol="0" anchor="ctr"/>
           <a:lstStyle/>
           <a:p>
-            <a:pPr indent="0" marL="0">
+            <a:pPr marL="0" indent="0">
               <a:buNone/>
             </a:pPr>
             <a:r>
@@ -4735,7 +4585,7 @@
           <a:bodyPr wrap="square" lIns="0" tIns="0" rIns="0" bIns="0" rtlCol="0" anchor="t"/>
           <a:lstStyle/>
           <a:p>
-            <a:pPr indent="0" marL="0">
+            <a:pPr marL="0" indent="0">
               <a:buNone/>
             </a:pPr>
             <a:r>
@@ -4771,7 +4621,7 @@
           <a:bodyPr wrap="square" lIns="0" tIns="0" rIns="0" bIns="0" rtlCol="0" anchor="ctr"/>
           <a:lstStyle/>
           <a:p>
-            <a:pPr indent="0" marL="0">
+            <a:pPr marL="0" indent="0">
               <a:buNone/>
             </a:pPr>
             <a:r>
@@ -4807,7 +4657,7 @@
           <a:bodyPr wrap="square" lIns="0" tIns="0" rIns="0" bIns="0" rtlCol="0" anchor="t"/>
           <a:lstStyle/>
           <a:p>
-            <a:pPr indent="0" marL="0">
+            <a:pPr marL="0" indent="0">
               <a:buNone/>
             </a:pPr>
             <a:r>
@@ -4843,7 +4693,7 @@
           <a:bodyPr wrap="square" lIns="0" tIns="0" rIns="0" bIns="0" rtlCol="0" anchor="t"/>
           <a:lstStyle/>
           <a:p>
-            <a:pPr indent="0" marL="0">
+            <a:pPr marL="0" indent="0">
               <a:buNone/>
             </a:pPr>
             <a:r>
@@ -4874,6 +4724,7 @@
         <a:solidFill>
           <a:srgbClr val="FFFFFF"/>
         </a:solidFill>
+        <a:effectLst/>
       </p:bgPr>
     </p:bg>
     <p:spTree>
@@ -4893,9 +4744,11 @@
       <p:sp>
         <p:nvSpPr>
           <p:cNvPr id="2" name="Text 0"/>
-          <p:cNvSpPr/>
+          <p:cNvSpPr>
+            <a:spLocks noGrp="1"/>
+          </p:cNvSpPr>
           <p:nvPr>
-            <p:ph idx="100" type="title" hasCustomPrompt="1"/>
+            <p:ph type="title" idx="100" hasCustomPrompt="1"/>
           </p:nvPr>
         </p:nvSpPr>
         <p:spPr>
@@ -4913,7 +4766,7 @@
           <a:bodyPr wrap="square" lIns="0" tIns="0" rIns="0" bIns="0" rtlCol="0" anchor="t"/>
           <a:lstStyle/>
           <a:p>
-            <a:pPr algn="l" indent="0" marL="0">
+            <a:pPr marL="0" indent="0" algn="l">
               <a:buNone/>
             </a:pPr>
             <a:r>
@@ -4951,10 +4804,34 @@
             <a:tbl>
               <a:tblPr/>
               <a:tblGrid>
-                <a:gridCol w="1554480"/>
-                <a:gridCol w="2743200"/>
-                <a:gridCol w="4206240"/>
-                <a:gridCol w="2560320"/>
+                <a:gridCol w="1554480">
+                  <a:extLst>
+                    <a:ext uri="{9D8B030D-6E8A-4147-A177-3AD203B41FA5}">
+                      <a16:colId xmlns:a16="http://schemas.microsoft.com/office/drawing/2014/main" val="20000"/>
+                    </a:ext>
+                  </a:extLst>
+                </a:gridCol>
+                <a:gridCol w="2743200">
+                  <a:extLst>
+                    <a:ext uri="{9D8B030D-6E8A-4147-A177-3AD203B41FA5}">
+                      <a16:colId xmlns:a16="http://schemas.microsoft.com/office/drawing/2014/main" val="20001"/>
+                    </a:ext>
+                  </a:extLst>
+                </a:gridCol>
+                <a:gridCol w="4206240">
+                  <a:extLst>
+                    <a:ext uri="{9D8B030D-6E8A-4147-A177-3AD203B41FA5}">
+                      <a16:colId xmlns:a16="http://schemas.microsoft.com/office/drawing/2014/main" val="20002"/>
+                    </a:ext>
+                  </a:extLst>
+                </a:gridCol>
+                <a:gridCol w="2560320">
+                  <a:extLst>
+                    <a:ext uri="{9D8B030D-6E8A-4147-A177-3AD203B41FA5}">
+                      <a16:colId xmlns:a16="http://schemas.microsoft.com/office/drawing/2014/main" val="20003"/>
+                    </a:ext>
+                  </a:extLst>
+                </a:gridCol>
               </a:tblGrid>
               <a:tr h="457200">
                 <a:tc>
@@ -4962,7 +4839,7 @@
                     <a:bodyPr/>
                     <a:lstStyle/>
                     <a:p>
-                      <a:pPr indent="0" marL="0">
+                      <a:pPr marL="0" indent="0">
                         <a:buNone/>
                       </a:pPr>
                       <a:r>
@@ -5023,7 +4900,7 @@
                     <a:bodyPr/>
                     <a:lstStyle/>
                     <a:p>
-                      <a:pPr indent="0" marL="0">
+                      <a:pPr marL="0" indent="0">
                         <a:buNone/>
                       </a:pPr>
                       <a:r>
@@ -5084,7 +4961,7 @@
                     <a:bodyPr/>
                     <a:lstStyle/>
                     <a:p>
-                      <a:pPr indent="0" marL="0">
+                      <a:pPr marL="0" indent="0">
                         <a:buNone/>
                       </a:pPr>
                       <a:r>
@@ -5145,7 +5022,7 @@
                     <a:bodyPr/>
                     <a:lstStyle/>
                     <a:p>
-                      <a:pPr indent="0" marL="0">
+                      <a:pPr marL="0" indent="0">
                         <a:buNone/>
                       </a:pPr>
                       <a:r>
@@ -5201,6 +5078,11 @@
                     </a:solidFill>
                   </a:tcPr>
                 </a:tc>
+                <a:extLst>
+                  <a:ext uri="{0D108BD9-81ED-4DB2-BD59-A6C34878D82A}">
+                    <a16:rowId xmlns:a16="http://schemas.microsoft.com/office/drawing/2014/main" val="10000"/>
+                  </a:ext>
+                </a:extLst>
               </a:tr>
               <a:tr h="777240">
                 <a:tc>
@@ -5208,7 +5090,7 @@
                     <a:bodyPr/>
                     <a:lstStyle/>
                     <a:p>
-                      <a:pPr indent="0" marL="0">
+                      <a:pPr marL="0" indent="0">
                         <a:buNone/>
                       </a:pPr>
                       <a:r>
@@ -5266,7 +5148,7 @@
                     <a:bodyPr/>
                     <a:lstStyle/>
                     <a:p>
-                      <a:pPr indent="0" marL="0">
+                      <a:pPr marL="0" indent="0">
                         <a:buNone/>
                       </a:pPr>
                       <a:r>
@@ -5324,7 +5206,7 @@
                     <a:bodyPr/>
                     <a:lstStyle/>
                     <a:p>
-                      <a:pPr indent="0" marL="0">
+                      <a:pPr marL="0" indent="0">
                         <a:buNone/>
                       </a:pPr>
                       <a:r>
@@ -5382,7 +5264,7 @@
                     <a:bodyPr/>
                     <a:lstStyle/>
                     <a:p>
-                      <a:pPr indent="0" marL="0">
+                      <a:pPr marL="0" indent="0">
                         <a:buNone/>
                       </a:pPr>
                       <a:r>
@@ -5435,6 +5317,11 @@
                     </a:lnB>
                   </a:tcPr>
                 </a:tc>
+                <a:extLst>
+                  <a:ext uri="{0D108BD9-81ED-4DB2-BD59-A6C34878D82A}">
+                    <a16:rowId xmlns:a16="http://schemas.microsoft.com/office/drawing/2014/main" val="10001"/>
+                  </a:ext>
+                </a:extLst>
               </a:tr>
               <a:tr h="777240">
                 <a:tc>
@@ -5442,7 +5329,7 @@
                     <a:bodyPr/>
                     <a:lstStyle/>
                     <a:p>
-                      <a:pPr indent="0" marL="0">
+                      <a:pPr marL="0" indent="0">
                         <a:buNone/>
                       </a:pPr>
                       <a:r>
@@ -5500,7 +5387,7 @@
                     <a:bodyPr/>
                     <a:lstStyle/>
                     <a:p>
-                      <a:pPr indent="0" marL="0">
+                      <a:pPr marL="0" indent="0">
                         <a:buNone/>
                       </a:pPr>
                       <a:r>
@@ -5558,7 +5445,7 @@
                     <a:bodyPr/>
                     <a:lstStyle/>
                     <a:p>
-                      <a:pPr indent="0" marL="0">
+                      <a:pPr marL="0" indent="0">
                         <a:buNone/>
                       </a:pPr>
                       <a:r>
@@ -5616,7 +5503,7 @@
                     <a:bodyPr/>
                     <a:lstStyle/>
                     <a:p>
-                      <a:pPr indent="0" marL="0">
+                      <a:pPr marL="0" indent="0">
                         <a:buNone/>
                       </a:pPr>
                       <a:r>
@@ -5669,6 +5556,11 @@
                     </a:lnB>
                   </a:tcPr>
                 </a:tc>
+                <a:extLst>
+                  <a:ext uri="{0D108BD9-81ED-4DB2-BD59-A6C34878D82A}">
+                    <a16:rowId xmlns:a16="http://schemas.microsoft.com/office/drawing/2014/main" val="10002"/>
+                  </a:ext>
+                </a:extLst>
               </a:tr>
               <a:tr h="777240">
                 <a:tc>
@@ -5676,7 +5568,7 @@
                     <a:bodyPr/>
                     <a:lstStyle/>
                     <a:p>
-                      <a:pPr indent="0" marL="0">
+                      <a:pPr marL="0" indent="0">
                         <a:buNone/>
                       </a:pPr>
                       <a:r>
@@ -5734,7 +5626,7 @@
                     <a:bodyPr/>
                     <a:lstStyle/>
                     <a:p>
-                      <a:pPr indent="0" marL="0">
+                      <a:pPr marL="0" indent="0">
                         <a:buNone/>
                       </a:pPr>
                       <a:r>
@@ -5792,7 +5684,7 @@
                     <a:bodyPr/>
                     <a:lstStyle/>
                     <a:p>
-                      <a:pPr indent="0" marL="0">
+                      <a:pPr marL="0" indent="0">
                         <a:buNone/>
                       </a:pPr>
                       <a:r>
@@ -5850,7 +5742,7 @@
                     <a:bodyPr/>
                     <a:lstStyle/>
                     <a:p>
-                      <a:pPr indent="0" marL="0">
+                      <a:pPr marL="0" indent="0">
                         <a:buNone/>
                       </a:pPr>
                       <a:r>
@@ -5903,6 +5795,11 @@
                     </a:lnB>
                   </a:tcPr>
                 </a:tc>
+                <a:extLst>
+                  <a:ext uri="{0D108BD9-81ED-4DB2-BD59-A6C34878D82A}">
+                    <a16:rowId xmlns:a16="http://schemas.microsoft.com/office/drawing/2014/main" val="10003"/>
+                  </a:ext>
+                </a:extLst>
               </a:tr>
               <a:tr h="777240">
                 <a:tc>
@@ -5910,7 +5807,7 @@
                     <a:bodyPr/>
                     <a:lstStyle/>
                     <a:p>
-                      <a:pPr indent="0" marL="0">
+                      <a:pPr marL="0" indent="0">
                         <a:buNone/>
                       </a:pPr>
                       <a:r>
@@ -5968,7 +5865,7 @@
                     <a:bodyPr/>
                     <a:lstStyle/>
                     <a:p>
-                      <a:pPr indent="0" marL="0">
+                      <a:pPr marL="0" indent="0">
                         <a:buNone/>
                       </a:pPr>
                       <a:r>
@@ -6026,7 +5923,7 @@
                     <a:bodyPr/>
                     <a:lstStyle/>
                     <a:p>
-                      <a:pPr indent="0" marL="0">
+                      <a:pPr marL="0" indent="0">
                         <a:buNone/>
                       </a:pPr>
                       <a:r>
@@ -6084,7 +5981,7 @@
                     <a:bodyPr/>
                     <a:lstStyle/>
                     <a:p>
-                      <a:pPr indent="0" marL="0">
+                      <a:pPr marL="0" indent="0">
                         <a:buNone/>
                       </a:pPr>
                       <a:r>
@@ -6137,6 +6034,11 @@
                     </a:lnB>
                   </a:tcPr>
                 </a:tc>
+                <a:extLst>
+                  <a:ext uri="{0D108BD9-81ED-4DB2-BD59-A6C34878D82A}">
+                    <a16:rowId xmlns:a16="http://schemas.microsoft.com/office/drawing/2014/main" val="10004"/>
+                  </a:ext>
+                </a:extLst>
               </a:tr>
             </a:tbl>
           </a:graphicData>
@@ -6163,7 +6065,7 @@
           <a:bodyPr wrap="square" lIns="0" tIns="0" rIns="0" bIns="0" rtlCol="0" anchor="t"/>
           <a:lstStyle/>
           <a:p>
-            <a:pPr indent="0" marL="0">
+            <a:pPr marL="0" indent="0">
               <a:buNone/>
             </a:pPr>
             <a:r>
@@ -6194,6 +6096,7 @@
         <a:solidFill>
           <a:srgbClr val="FFFFFF"/>
         </a:solidFill>
+        <a:effectLst/>
       </p:bgPr>
     </p:bg>
     <p:spTree>
@@ -6213,9 +6116,11 @@
       <p:sp>
         <p:nvSpPr>
           <p:cNvPr id="2" name="Text 0"/>
-          <p:cNvSpPr/>
+          <p:cNvSpPr>
+            <a:spLocks noGrp="1"/>
+          </p:cNvSpPr>
           <p:nvPr>
-            <p:ph idx="100" type="title" hasCustomPrompt="1"/>
+            <p:ph type="title" idx="100" hasCustomPrompt="1"/>
           </p:nvPr>
         </p:nvSpPr>
         <p:spPr>
@@ -6233,7 +6138,7 @@
           <a:bodyPr wrap="square" lIns="0" tIns="0" rIns="0" bIns="0" rtlCol="0" anchor="t"/>
           <a:lstStyle/>
           <a:p>
-            <a:pPr algn="l" indent="0" marL="0">
+            <a:pPr marL="0" indent="0" algn="l">
               <a:buNone/>
             </a:pPr>
             <a:r>
@@ -6269,7 +6174,7 @@
           <a:bodyPr wrap="square" lIns="0" tIns="0" rIns="0" bIns="0" rtlCol="0" anchor="t"/>
           <a:lstStyle/>
           <a:p>
-            <a:pPr indent="0" marL="0">
+            <a:pPr marL="0" indent="0">
               <a:spcAft>
                 <a:spcPts val="600"/>
               </a:spcAft>
@@ -6286,7 +6191,7 @@
             <a:endParaRPr lang="en-US" sz="1300" dirty="0"/>
           </a:p>
           <a:p>
-            <a:pPr indent="0" marL="0">
+            <a:pPr marL="0" indent="0">
               <a:spcAft>
                 <a:spcPts val="600"/>
               </a:spcAft>
@@ -6303,7 +6208,7 @@
             <a:endParaRPr lang="en-US" sz="1300" dirty="0"/>
           </a:p>
           <a:p>
-            <a:pPr indent="0" marL="0">
+            <a:pPr marL="0" indent="0">
               <a:spcAft>
                 <a:spcPts val="600"/>
               </a:spcAft>
@@ -6320,7 +6225,7 @@
             <a:endParaRPr lang="en-US" sz="1300" dirty="0"/>
           </a:p>
           <a:p>
-            <a:pPr indent="0" marL="0">
+            <a:pPr marL="0" indent="0">
               <a:spcAft>
                 <a:spcPts val="600"/>
               </a:spcAft>
@@ -6337,7 +6242,7 @@
             <a:endParaRPr lang="en-US" sz="1300" dirty="0"/>
           </a:p>
           <a:p>
-            <a:pPr indent="0" marL="0">
+            <a:pPr marL="0" indent="0">
               <a:spcAft>
                 <a:spcPts val="600"/>
               </a:spcAft>
@@ -6354,7 +6259,7 @@
             <a:endParaRPr lang="en-US" sz="1300" dirty="0"/>
           </a:p>
           <a:p>
-            <a:pPr indent="0" marL="0">
+            <a:pPr marL="0" indent="0">
               <a:spcAft>
                 <a:spcPts val="600"/>
               </a:spcAft>
@@ -6371,7 +6276,7 @@
             <a:endParaRPr lang="en-US" sz="1300" dirty="0"/>
           </a:p>
           <a:p>
-            <a:pPr indent="0" marL="0">
+            <a:pPr marL="0" indent="0">
               <a:spcAft>
                 <a:spcPts val="600"/>
               </a:spcAft>
@@ -6388,7 +6293,7 @@
             <a:endParaRPr lang="en-US" sz="1300" dirty="0"/>
           </a:p>
           <a:p>
-            <a:pPr indent="0" marL="0">
+            <a:pPr marL="0" indent="0">
               <a:spcAft>
                 <a:spcPts val="600"/>
               </a:spcAft>
@@ -6405,7 +6310,7 @@
             <a:endParaRPr lang="en-US" sz="1300" dirty="0"/>
           </a:p>
           <a:p>
-            <a:pPr indent="0" marL="0">
+            <a:pPr marL="0" indent="0">
               <a:spcAft>
                 <a:spcPts val="600"/>
               </a:spcAft>
@@ -6422,7 +6327,7 @@
             <a:endParaRPr lang="en-US" sz="1300" dirty="0"/>
           </a:p>
           <a:p>
-            <a:pPr indent="0" marL="0">
+            <a:pPr marL="0" indent="0">
               <a:spcAft>
                 <a:spcPts val="600"/>
               </a:spcAft>
@@ -6456,6 +6361,7 @@
         <a:solidFill>
           <a:srgbClr val="FFFFFF"/>
         </a:solidFill>
+        <a:effectLst/>
       </p:bgPr>
     </p:bg>
     <p:spTree>
@@ -6475,9 +6381,11 @@
       <p:sp>
         <p:nvSpPr>
           <p:cNvPr id="2" name="Text 0"/>
-          <p:cNvSpPr/>
+          <p:cNvSpPr>
+            <a:spLocks noGrp="1"/>
+          </p:cNvSpPr>
           <p:nvPr>
-            <p:ph idx="100" type="title" hasCustomPrompt="1"/>
+            <p:ph type="title" idx="100" hasCustomPrompt="1"/>
           </p:nvPr>
         </p:nvSpPr>
         <p:spPr>
@@ -6495,7 +6403,7 @@
           <a:bodyPr wrap="square" lIns="0" tIns="0" rIns="0" bIns="0" rtlCol="0" anchor="t"/>
           <a:lstStyle/>
           <a:p>
-            <a:pPr algn="l" indent="0" marL="0">
+            <a:pPr marL="0" indent="0" algn="l">
               <a:buNone/>
             </a:pPr>
             <a:r>
@@ -6536,6 +6444,13 @@
             <a:prstDash val="solid"/>
           </a:ln>
         </p:spPr>
+        <p:txBody>
+          <a:bodyPr/>
+          <a:lstStyle/>
+          <a:p>
+            <a:endParaRPr lang="en-US"/>
+          </a:p>
+        </p:txBody>
       </p:sp>
       <p:sp>
         <p:nvSpPr>
@@ -6558,7 +6473,7 @@
           <a:bodyPr wrap="square" lIns="50800" tIns="50800" rIns="50800" bIns="50800" rtlCol="0" anchor="ctr"/>
           <a:lstStyle/>
           <a:p>
-            <a:pPr algn="ctr" indent="0" marL="0">
+            <a:pPr marL="0" indent="0" algn="ctr">
               <a:buNone/>
             </a:pPr>
             <a:r>
@@ -6597,6 +6512,13 @@
             <a:prstDash val="solid"/>
           </a:ln>
         </p:spPr>
+        <p:txBody>
+          <a:bodyPr/>
+          <a:lstStyle/>
+          <a:p>
+            <a:endParaRPr lang="en-US"/>
+          </a:p>
+        </p:txBody>
       </p:sp>
       <p:sp>
         <p:nvSpPr>
@@ -6624,6 +6546,13 @@
             <a:prstDash val="solid"/>
           </a:ln>
         </p:spPr>
+        <p:txBody>
+          <a:bodyPr/>
+          <a:lstStyle/>
+          <a:p>
+            <a:endParaRPr lang="en-US"/>
+          </a:p>
+        </p:txBody>
       </p:sp>
       <p:sp>
         <p:nvSpPr>
@@ -6646,7 +6575,7 @@
           <a:bodyPr wrap="square" lIns="50800" tIns="50800" rIns="50800" bIns="50800" rtlCol="0" anchor="ctr"/>
           <a:lstStyle/>
           <a:p>
-            <a:pPr algn="ctr" indent="0" marL="0">
+            <a:pPr marL="0" indent="0" algn="ctr">
               <a:buNone/>
             </a:pPr>
             <a:r>
@@ -6685,6 +6614,13 @@
             <a:prstDash val="solid"/>
           </a:ln>
         </p:spPr>
+        <p:txBody>
+          <a:bodyPr/>
+          <a:lstStyle/>
+          <a:p>
+            <a:endParaRPr lang="en-US"/>
+          </a:p>
+        </p:txBody>
       </p:sp>
       <p:sp>
         <p:nvSpPr>
@@ -6707,7 +6643,7 @@
           <a:bodyPr wrap="square" lIns="0" tIns="0" rIns="0" bIns="0" rtlCol="0" anchor="t"/>
           <a:lstStyle/>
           <a:p>
-            <a:pPr algn="ctr" indent="0" marL="0">
+            <a:pPr marL="0" indent="0" algn="ctr">
               <a:buNone/>
             </a:pPr>
             <a:r>
@@ -6748,6 +6684,13 @@
             <a:prstDash val="solid"/>
           </a:ln>
         </p:spPr>
+        <p:txBody>
+          <a:bodyPr/>
+          <a:lstStyle/>
+          <a:p>
+            <a:endParaRPr lang="en-US"/>
+          </a:p>
+        </p:txBody>
       </p:sp>
       <p:sp>
         <p:nvSpPr>
@@ -6770,7 +6713,7 @@
           <a:bodyPr wrap="square" lIns="50800" tIns="50800" rIns="50800" bIns="50800" rtlCol="0" anchor="ctr"/>
           <a:lstStyle/>
           <a:p>
-            <a:pPr algn="ctr" indent="0" marL="0">
+            <a:pPr marL="0" indent="0" algn="ctr">
               <a:buNone/>
             </a:pPr>
             <a:r>
@@ -6809,6 +6752,13 @@
             <a:prstDash val="solid"/>
           </a:ln>
         </p:spPr>
+        <p:txBody>
+          <a:bodyPr/>
+          <a:lstStyle/>
+          <a:p>
+            <a:endParaRPr lang="en-US"/>
+          </a:p>
+        </p:txBody>
       </p:sp>
       <p:sp>
         <p:nvSpPr>
@@ -6831,7 +6781,7 @@
           <a:bodyPr wrap="square" lIns="0" tIns="0" rIns="0" bIns="0" rtlCol="0" anchor="t"/>
           <a:lstStyle/>
           <a:p>
-            <a:pPr algn="ctr" indent="0" marL="0">
+            <a:pPr marL="0" indent="0" algn="ctr">
               <a:buNone/>
             </a:pPr>
             <a:r>
@@ -6872,6 +6822,13 @@
             <a:prstDash val="solid"/>
           </a:ln>
         </p:spPr>
+        <p:txBody>
+          <a:bodyPr/>
+          <a:lstStyle/>
+          <a:p>
+            <a:endParaRPr lang="en-US"/>
+          </a:p>
+        </p:txBody>
       </p:sp>
       <p:sp>
         <p:nvSpPr>
@@ -6894,7 +6851,7 @@
           <a:bodyPr wrap="square" lIns="50800" tIns="50800" rIns="50800" bIns="50800" rtlCol="0" anchor="ctr"/>
           <a:lstStyle/>
           <a:p>
-            <a:pPr algn="ctr" indent="0" marL="0">
+            <a:pPr marL="0" indent="0" algn="ctr">
               <a:buNone/>
             </a:pPr>
             <a:r>
@@ -6933,6 +6890,13 @@
             <a:prstDash val="solid"/>
           </a:ln>
         </p:spPr>
+        <p:txBody>
+          <a:bodyPr/>
+          <a:lstStyle/>
+          <a:p>
+            <a:endParaRPr lang="en-US"/>
+          </a:p>
+        </p:txBody>
       </p:sp>
       <p:sp>
         <p:nvSpPr>
@@ -6960,6 +6924,13 @@
             <a:prstDash val="solid"/>
           </a:ln>
         </p:spPr>
+        <p:txBody>
+          <a:bodyPr/>
+          <a:lstStyle/>
+          <a:p>
+            <a:endParaRPr lang="en-US"/>
+          </a:p>
+        </p:txBody>
       </p:sp>
       <p:sp>
         <p:nvSpPr>
@@ -6982,7 +6953,7 @@
           <a:bodyPr wrap="square" lIns="50800" tIns="50800" rIns="50800" bIns="50800" rtlCol="0" anchor="ctr"/>
           <a:lstStyle/>
           <a:p>
-            <a:pPr algn="ctr" indent="0" marL="0">
+            <a:pPr marL="0" indent="0" algn="ctr">
               <a:buNone/>
             </a:pPr>
             <a:r>
@@ -7018,7 +6989,7 @@
           <a:bodyPr wrap="square" lIns="0" tIns="0" rIns="0" bIns="0" rtlCol="0" anchor="t"/>
           <a:lstStyle/>
           <a:p>
-            <a:pPr algn="ctr" indent="0" marL="0">
+            <a:pPr marL="0" indent="0" algn="ctr">
               <a:buNone/>
             </a:pPr>
             <a:r>
@@ -7054,7 +7025,7 @@
           <a:bodyPr wrap="square" lIns="0" tIns="0" rIns="0" bIns="0" rtlCol="0" anchor="ctr"/>
           <a:lstStyle/>
           <a:p>
-            <a:pPr indent="0" marL="0">
+            <a:pPr marL="0" indent="0">
               <a:buNone/>
             </a:pPr>
             <a:r>
@@ -7166,7 +7137,7 @@
           <a:bodyPr wrap="square" lIns="0" tIns="0" rIns="0" bIns="0" rtlCol="0" anchor="ctr"/>
           <a:lstStyle/>
           <a:p>
-            <a:pPr indent="0" marL="0">
+            <a:pPr marL="0" indent="0">
               <a:buNone/>
             </a:pPr>
             <a:r>
@@ -7278,7 +7249,7 @@
           <a:bodyPr wrap="square" lIns="0" tIns="0" rIns="0" bIns="0" rtlCol="0" anchor="t"/>
           <a:lstStyle/>
           <a:p>
-            <a:pPr indent="0" marL="0">
+            <a:pPr marL="0" indent="0">
               <a:buNone/>
             </a:pPr>
             <a:r>
@@ -7309,6 +7280,7 @@
         <a:solidFill>
           <a:srgbClr val="FFFFFF"/>
         </a:solidFill>
+        <a:effectLst/>
       </p:bgPr>
     </p:bg>
     <p:spTree>
@@ -7328,9 +7300,11 @@
       <p:sp>
         <p:nvSpPr>
           <p:cNvPr id="2" name="Text 0"/>
-          <p:cNvSpPr/>
+          <p:cNvSpPr>
+            <a:spLocks noGrp="1"/>
+          </p:cNvSpPr>
           <p:nvPr>
-            <p:ph idx="100" type="title" hasCustomPrompt="1"/>
+            <p:ph type="title" idx="100" hasCustomPrompt="1"/>
           </p:nvPr>
         </p:nvSpPr>
         <p:spPr>
@@ -7348,7 +7322,7 @@
           <a:bodyPr wrap="square" lIns="0" tIns="0" rIns="0" bIns="0" rtlCol="0" anchor="t"/>
           <a:lstStyle/>
           <a:p>
-            <a:pPr algn="l" indent="0" marL="0">
+            <a:pPr marL="0" indent="0" algn="l">
               <a:buNone/>
             </a:pPr>
             <a:r>
@@ -7389,6 +7363,13 @@
             <a:prstDash val="solid"/>
           </a:ln>
         </p:spPr>
+        <p:txBody>
+          <a:bodyPr/>
+          <a:lstStyle/>
+          <a:p>
+            <a:endParaRPr lang="en-US"/>
+          </a:p>
+        </p:txBody>
       </p:sp>
       <p:sp>
         <p:nvSpPr>
@@ -7411,7 +7392,7 @@
           <a:bodyPr wrap="square" lIns="0" tIns="0" rIns="0" bIns="0" rtlCol="0" anchor="ctr"/>
           <a:lstStyle/>
           <a:p>
-            <a:pPr indent="0" marL="0">
+            <a:pPr marL="0" indent="0">
               <a:buNone/>
             </a:pPr>
             <a:r>
@@ -7447,7 +7428,7 @@
           <a:bodyPr wrap="square" lIns="0" tIns="0" rIns="0" bIns="0" rtlCol="0" anchor="t"/>
           <a:lstStyle/>
           <a:p>
-            <a:pPr indent="0" marL="0">
+            <a:pPr marL="0" indent="0">
               <a:buNone/>
             </a:pPr>
             <a:r>
@@ -7488,6 +7469,13 @@
             <a:prstDash val="solid"/>
           </a:ln>
         </p:spPr>
+        <p:txBody>
+          <a:bodyPr/>
+          <a:lstStyle/>
+          <a:p>
+            <a:endParaRPr lang="en-US"/>
+          </a:p>
+        </p:txBody>
       </p:sp>
       <p:sp>
         <p:nvSpPr>
@@ -7510,7 +7498,7 @@
           <a:bodyPr wrap="square" lIns="0" tIns="0" rIns="0" bIns="0" rtlCol="0" anchor="ctr"/>
           <a:lstStyle/>
           <a:p>
-            <a:pPr indent="0" marL="0">
+            <a:pPr marL="0" indent="0">
               <a:buNone/>
             </a:pPr>
             <a:r>
@@ -7546,7 +7534,7 @@
           <a:bodyPr wrap="square" lIns="0" tIns="0" rIns="0" bIns="0" rtlCol="0" anchor="t"/>
           <a:lstStyle/>
           <a:p>
-            <a:pPr indent="0" marL="0">
+            <a:pPr marL="0" indent="0">
               <a:buNone/>
             </a:pPr>
             <a:r>
@@ -7587,6 +7575,13 @@
             <a:prstDash val="solid"/>
           </a:ln>
         </p:spPr>
+        <p:txBody>
+          <a:bodyPr/>
+          <a:lstStyle/>
+          <a:p>
+            <a:endParaRPr lang="en-US"/>
+          </a:p>
+        </p:txBody>
       </p:sp>
       <p:sp>
         <p:nvSpPr>
@@ -7609,7 +7604,7 @@
           <a:bodyPr wrap="square" lIns="0" tIns="0" rIns="0" bIns="0" rtlCol="0" anchor="ctr"/>
           <a:lstStyle/>
           <a:p>
-            <a:pPr indent="0" marL="0">
+            <a:pPr marL="0" indent="0">
               <a:buNone/>
             </a:pPr>
             <a:r>
@@ -7645,7 +7640,7 @@
           <a:bodyPr wrap="square" lIns="0" tIns="0" rIns="0" bIns="0" rtlCol="0" anchor="t"/>
           <a:lstStyle/>
           <a:p>
-            <a:pPr indent="0" marL="0">
+            <a:pPr marL="0" indent="0">
               <a:buNone/>
             </a:pPr>
             <a:r>
@@ -7686,6 +7681,13 @@
             <a:prstDash val="solid"/>
           </a:ln>
         </p:spPr>
+        <p:txBody>
+          <a:bodyPr/>
+          <a:lstStyle/>
+          <a:p>
+            <a:endParaRPr lang="en-US"/>
+          </a:p>
+        </p:txBody>
       </p:sp>
       <p:sp>
         <p:nvSpPr>
@@ -7708,7 +7710,7 @@
           <a:bodyPr wrap="square" lIns="0" tIns="0" rIns="0" bIns="0" rtlCol="0" anchor="ctr"/>
           <a:lstStyle/>
           <a:p>
-            <a:pPr indent="0" marL="0">
+            <a:pPr marL="0" indent="0">
               <a:buNone/>
             </a:pPr>
             <a:r>
@@ -7744,7 +7746,7 @@
           <a:bodyPr wrap="square" lIns="0" tIns="0" rIns="0" bIns="0" rtlCol="0" anchor="t"/>
           <a:lstStyle/>
           <a:p>
-            <a:pPr indent="0" marL="0">
+            <a:pPr marL="0" indent="0">
               <a:buNone/>
             </a:pPr>
             <a:r>
@@ -7780,7 +7782,7 @@
           <a:bodyPr wrap="square" lIns="0" tIns="0" rIns="0" bIns="0" rtlCol="0" anchor="ctr"/>
           <a:lstStyle/>
           <a:p>
-            <a:pPr indent="0" marL="0">
+            <a:pPr marL="0" indent="0">
               <a:buNone/>
             </a:pPr>
             <a:r>
@@ -7874,7 +7876,7 @@
           <a:bodyPr wrap="square" lIns="0" tIns="0" rIns="0" bIns="0" rtlCol="0" anchor="ctr"/>
           <a:lstStyle/>
           <a:p>
-            <a:pPr indent="0" marL="0">
+            <a:pPr marL="0" indent="0">
               <a:buNone/>
             </a:pPr>
             <a:r>
@@ -7973,6 +7975,13 @@
             <a:prstDash val="solid"/>
           </a:ln>
         </p:spPr>
+        <p:txBody>
+          <a:bodyPr/>
+          <a:lstStyle/>
+          <a:p>
+            <a:endParaRPr lang="en-US"/>
+          </a:p>
+        </p:txBody>
       </p:sp>
       <p:sp>
         <p:nvSpPr>
@@ -7995,7 +8004,7 @@
           <a:bodyPr wrap="square" lIns="0" tIns="0" rIns="0" bIns="0" rtlCol="0" anchor="ctr"/>
           <a:lstStyle/>
           <a:p>
-            <a:pPr indent="0" marL="0">
+            <a:pPr marL="0" indent="0">
               <a:buNone/>
             </a:pPr>
             <a:r>
@@ -8006,9 +8015,6 @@
               </a:rPr>
               <a:t>Same yardstick for every method: </a:t>
             </a:r>
-            <a:pPr indent="0" marL="0">
-              <a:buNone/>
-            </a:pPr>
             <a:r>
               <a:rPr lang="en-US" sz="1350" dirty="0">
                 <a:solidFill>
@@ -8042,7 +8048,7 @@
           <a:bodyPr wrap="square" lIns="0" tIns="0" rIns="0" bIns="0" rtlCol="0" anchor="t"/>
           <a:lstStyle/>
           <a:p>
-            <a:pPr indent="0" marL="0">
+            <a:pPr marL="0" indent="0">
               <a:buNone/>
             </a:pPr>
             <a:r>
@@ -8073,6 +8079,7 @@
         <a:solidFill>
           <a:srgbClr val="FFFFFF"/>
         </a:solidFill>
+        <a:effectLst/>
       </p:bgPr>
     </p:bg>
     <p:spTree>
@@ -8092,9 +8099,11 @@
       <p:sp>
         <p:nvSpPr>
           <p:cNvPr id="2" name="Text 0"/>
-          <p:cNvSpPr/>
+          <p:cNvSpPr>
+            <a:spLocks noGrp="1"/>
+          </p:cNvSpPr>
           <p:nvPr>
-            <p:ph idx="100" type="title" hasCustomPrompt="1"/>
+            <p:ph type="title" idx="100" hasCustomPrompt="1"/>
           </p:nvPr>
         </p:nvSpPr>
         <p:spPr>
@@ -8112,7 +8121,7 @@
           <a:bodyPr wrap="square" lIns="0" tIns="0" rIns="0" bIns="0" rtlCol="0" anchor="t"/>
           <a:lstStyle/>
           <a:p>
-            <a:pPr algn="l" indent="0" marL="0">
+            <a:pPr marL="0" indent="0" algn="l">
               <a:buNone/>
             </a:pPr>
             <a:r>
@@ -8129,14 +8138,14 @@
       </p:sp>
       <p:pic>
         <p:nvPicPr>
-          <p:cNvPr id="3" name="Image 0" descr="/Users/euibeoms/Desktop/ACoP/hackathon/slides/figs/fig_forest_Mexiletine.png">    </p:cNvPr>
+          <p:cNvPr id="3" name="Image 0" descr="/Users/euibeoms/Desktop/ACoP/hackathon/slides/figs/fig_forest_Mexiletine.png"/>
           <p:cNvPicPr>
             <a:picLocks noChangeAspect="1"/>
           </p:cNvPicPr>
           <p:nvPr/>
         </p:nvPicPr>
         <p:blipFill>
-          <a:blip r:embed="rId1"/>
+          <a:blip r:embed="rId3"/>
           <a:stretch>
             <a:fillRect/>
           </a:stretch>
@@ -8172,7 +8181,7 @@
           <a:bodyPr wrap="square" lIns="0" tIns="0" rIns="0" bIns="0" rtlCol="0" anchor="t"/>
           <a:lstStyle/>
           <a:p>
-            <a:pPr indent="0" marL="0">
+            <a:pPr marL="0" indent="0">
               <a:buNone/>
             </a:pPr>
             <a:r>
@@ -8208,7 +8217,7 @@
           <a:bodyPr wrap="square" lIns="0" tIns="0" rIns="0" bIns="0" rtlCol="0" anchor="ctr"/>
           <a:lstStyle/>
           <a:p>
-            <a:pPr indent="0" marL="0">
+            <a:pPr marL="0" indent="0">
               <a:buNone/>
             </a:pPr>
             <a:r>
@@ -8244,7 +8253,7 @@
           <a:bodyPr wrap="square" lIns="0" tIns="0" rIns="0" bIns="0" rtlCol="0" anchor="t"/>
           <a:lstStyle/>
           <a:p>
-            <a:pPr indent="0" marL="0">
+            <a:pPr marL="0" indent="0">
               <a:buNone/>
             </a:pPr>
             <a:r>
@@ -8280,7 +8289,7 @@
           <a:bodyPr wrap="square" lIns="0" tIns="0" rIns="0" bIns="0" rtlCol="0" anchor="ctr"/>
           <a:lstStyle/>
           <a:p>
-            <a:pPr indent="0" marL="0">
+            <a:pPr marL="0" indent="0">
               <a:buNone/>
             </a:pPr>
             <a:r>
@@ -8316,7 +8325,7 @@
           <a:bodyPr wrap="square" lIns="0" tIns="0" rIns="0" bIns="0" rtlCol="0" anchor="t"/>
           <a:lstStyle/>
           <a:p>
-            <a:pPr indent="0" marL="0">
+            <a:pPr marL="0" indent="0">
               <a:buNone/>
             </a:pPr>
             <a:r>
@@ -8352,7 +8361,7 @@
           <a:bodyPr wrap="square" lIns="0" tIns="0" rIns="0" bIns="0" rtlCol="0" anchor="ctr"/>
           <a:lstStyle/>
           <a:p>
-            <a:pPr indent="0" marL="0">
+            <a:pPr marL="0" indent="0">
               <a:buNone/>
             </a:pPr>
             <a:r>
@@ -8388,7 +8397,7 @@
           <a:bodyPr wrap="square" lIns="0" tIns="0" rIns="0" bIns="0" rtlCol="0" anchor="t"/>
           <a:lstStyle/>
           <a:p>
-            <a:pPr indent="0" marL="0">
+            <a:pPr marL="0" indent="0">
               <a:buNone/>
             </a:pPr>
             <a:r>
@@ -8429,6 +8438,13 @@
             <a:prstDash val="solid"/>
           </a:ln>
         </p:spPr>
+        <p:txBody>
+          <a:bodyPr/>
+          <a:lstStyle/>
+          <a:p>
+            <a:endParaRPr lang="en-US"/>
+          </a:p>
+        </p:txBody>
       </p:sp>
       <p:sp>
         <p:nvSpPr>
@@ -8451,7 +8467,7 @@
           <a:bodyPr wrap="square" lIns="0" tIns="0" rIns="0" bIns="0" rtlCol="0" anchor="ctr"/>
           <a:lstStyle/>
           <a:p>
-            <a:pPr indent="0" marL="0">
+            <a:pPr marL="0" indent="0">
               <a:buNone/>
             </a:pPr>
             <a:r>
@@ -8462,9 +8478,6 @@
               </a:rPr>
               <a:t>Test-set patients: </a:t>
             </a:r>
-            <a:pPr indent="0" marL="0">
-              <a:buNone/>
-            </a:pPr>
             <a:r>
               <a:rPr lang="en-US" sz="1350" dirty="0">
                 <a:solidFill>
@@ -8473,9 +8486,6 @@
               </a:rPr>
               <a:t>severity about 5 or more: 10 of 21 responded (48%); below: 2 of 20 (10%). Responder AUC 0.77. </a:t>
             </a:r>
-            <a:pPr indent="0" marL="0">
-              <a:buNone/>
-            </a:pPr>
             <a:r>
               <a:rPr lang="en-US" sz="1350" b="1" dirty="0">
                 <a:solidFill>
@@ -8484,9 +8494,6 @@
               </a:rPr>
               <a:t>A caution: </a:t>
             </a:r>
-            <a:pPr indent="0" marL="0">
-              <a:buNone/>
-            </a:pPr>
             <a:r>
               <a:rPr lang="en-US" sz="1350" dirty="0">
                 <a:solidFill>
@@ -8520,7 +8527,7 @@
           <a:bodyPr wrap="square" lIns="0" tIns="0" rIns="0" bIns="0" rtlCol="0" anchor="t"/>
           <a:lstStyle/>
           <a:p>
-            <a:pPr indent="0" marL="0">
+            <a:pPr marL="0" indent="0">
               <a:buNone/>
             </a:pPr>
             <a:r>
@@ -8551,6 +8558,7 @@
         <a:solidFill>
           <a:srgbClr val="FFFFFF"/>
         </a:solidFill>
+        <a:effectLst/>
       </p:bgPr>
     </p:bg>
     <p:spTree>
@@ -8570,9 +8578,11 @@
       <p:sp>
         <p:nvSpPr>
           <p:cNvPr id="2" name="Text 0"/>
-          <p:cNvSpPr/>
+          <p:cNvSpPr>
+            <a:spLocks noGrp="1"/>
+          </p:cNvSpPr>
           <p:nvPr>
-            <p:ph idx="100" type="title" hasCustomPrompt="1"/>
+            <p:ph type="title" idx="100" hasCustomPrompt="1"/>
           </p:nvPr>
         </p:nvSpPr>
         <p:spPr>
@@ -8590,7 +8600,7 @@
           <a:bodyPr wrap="square" lIns="0" tIns="0" rIns="0" bIns="0" rtlCol="0" anchor="t"/>
           <a:lstStyle/>
           <a:p>
-            <a:pPr algn="l" indent="0" marL="0">
+            <a:pPr marL="0" indent="0" algn="l">
               <a:buNone/>
             </a:pPr>
             <a:r>
@@ -8607,14 +8617,14 @@
       </p:sp>
       <p:pic>
         <p:nvPicPr>
-          <p:cNvPr id="3" name="Image 0" descr="/Users/euibeoms/Desktop/ACoP/hackathon/slides/figs/fig_forest_Oligonucleotide.png">    </p:cNvPr>
+          <p:cNvPr id="3" name="Image 0" descr="/Users/euibeoms/Desktop/ACoP/hackathon/slides/figs/fig_forest_Oligonucleotide.png"/>
           <p:cNvPicPr>
             <a:picLocks noChangeAspect="1"/>
           </p:cNvPicPr>
           <p:nvPr/>
         </p:nvPicPr>
         <p:blipFill>
-          <a:blip r:embed="rId1"/>
+          <a:blip r:embed="rId3"/>
           <a:stretch>
             <a:fillRect/>
           </a:stretch>
@@ -8650,7 +8660,7 @@
           <a:bodyPr wrap="square" lIns="0" tIns="0" rIns="0" bIns="0" rtlCol="0" anchor="t"/>
           <a:lstStyle/>
           <a:p>
-            <a:pPr indent="0" marL="0">
+            <a:pPr marL="0" indent="0">
               <a:buNone/>
             </a:pPr>
             <a:r>
@@ -8686,7 +8696,7 @@
           <a:bodyPr wrap="square" lIns="0" tIns="0" rIns="0" bIns="0" rtlCol="0" anchor="ctr"/>
           <a:lstStyle/>
           <a:p>
-            <a:pPr indent="0" marL="0">
+            <a:pPr marL="0" indent="0">
               <a:buNone/>
             </a:pPr>
             <a:r>
@@ -8722,7 +8732,7 @@
           <a:bodyPr wrap="square" lIns="0" tIns="0" rIns="0" bIns="0" rtlCol="0" anchor="t"/>
           <a:lstStyle/>
           <a:p>
-            <a:pPr indent="0" marL="0">
+            <a:pPr marL="0" indent="0">
               <a:buNone/>
             </a:pPr>
             <a:r>
@@ -8758,7 +8768,7 @@
           <a:bodyPr wrap="square" lIns="0" tIns="0" rIns="0" bIns="0" rtlCol="0" anchor="ctr"/>
           <a:lstStyle/>
           <a:p>
-            <a:pPr indent="0" marL="0">
+            <a:pPr marL="0" indent="0">
               <a:buNone/>
             </a:pPr>
             <a:r>
@@ -8794,7 +8804,7 @@
           <a:bodyPr wrap="square" lIns="0" tIns="0" rIns="0" bIns="0" rtlCol="0" anchor="t"/>
           <a:lstStyle/>
           <a:p>
-            <a:pPr indent="0" marL="0">
+            <a:pPr marL="0" indent="0">
               <a:buNone/>
             </a:pPr>
             <a:r>
@@ -8830,7 +8840,7 @@
           <a:bodyPr wrap="square" lIns="0" tIns="0" rIns="0" bIns="0" rtlCol="0" anchor="ctr"/>
           <a:lstStyle/>
           <a:p>
-            <a:pPr indent="0" marL="0">
+            <a:pPr marL="0" indent="0">
               <a:buNone/>
             </a:pPr>
             <a:r>
@@ -8866,7 +8876,7 @@
           <a:bodyPr wrap="square" lIns="0" tIns="0" rIns="0" bIns="0" rtlCol="0" anchor="t"/>
           <a:lstStyle/>
           <a:p>
-            <a:pPr indent="0" marL="0">
+            <a:pPr marL="0" indent="0">
               <a:buNone/>
             </a:pPr>
             <a:r>
@@ -8907,6 +8917,13 @@
             <a:prstDash val="solid"/>
           </a:ln>
         </p:spPr>
+        <p:txBody>
+          <a:bodyPr/>
+          <a:lstStyle/>
+          <a:p>
+            <a:endParaRPr lang="en-US"/>
+          </a:p>
+        </p:txBody>
       </p:sp>
       <p:sp>
         <p:nvSpPr>
@@ -8929,7 +8946,7 @@
           <a:bodyPr wrap="square" lIns="0" tIns="0" rIns="0" bIns="0" rtlCol="0" anchor="ctr"/>
           <a:lstStyle/>
           <a:p>
-            <a:pPr indent="0" marL="0">
+            <a:pPr marL="0" indent="0">
               <a:buNone/>
             </a:pPr>
             <a:r>
@@ -8940,9 +8957,6 @@
               </a:rPr>
               <a:t>Test-set patients: </a:t>
             </a:r>
-            <a:pPr indent="0" marL="0">
-              <a:buNone/>
-            </a:pPr>
             <a:r>
               <a:rPr lang="en-US" sz="1350" dirty="0">
                 <a:solidFill>
@@ -8951,9 +8965,6 @@
               </a:rPr>
               <a:t>repeats about 350 or more: 10 of 17 responded (59%); below: 8 of 26 (31%). Responder AUC 0.72; R² under 0.1. </a:t>
             </a:r>
-            <a:pPr indent="0" marL="0">
-              <a:buNone/>
-            </a:pPr>
             <a:r>
               <a:rPr lang="en-US" sz="1350" b="1" dirty="0">
                 <a:solidFill>
@@ -8962,9 +8973,6 @@
               </a:rPr>
               <a:t>Reading: </a:t>
             </a:r>
-            <a:pPr indent="0" marL="0">
-              <a:buNone/>
-            </a:pPr>
             <a:r>
               <a:rPr lang="en-US" sz="1350" dirty="0">
                 <a:solidFill>
@@ -8998,7 +9006,7 @@
           <a:bodyPr wrap="square" lIns="0" tIns="0" rIns="0" bIns="0" rtlCol="0" anchor="t"/>
           <a:lstStyle/>
           <a:p>
-            <a:pPr indent="0" marL="0">
+            <a:pPr marL="0" indent="0">
               <a:buNone/>
             </a:pPr>
             <a:r>
@@ -9029,6 +9037,7 @@
         <a:solidFill>
           <a:srgbClr val="FFFFFF"/>
         </a:solidFill>
+        <a:effectLst/>
       </p:bgPr>
     </p:bg>
     <p:spTree>
@@ -9048,9 +9057,11 @@
       <p:sp>
         <p:nvSpPr>
           <p:cNvPr id="2" name="Text 0"/>
-          <p:cNvSpPr/>
+          <p:cNvSpPr>
+            <a:spLocks noGrp="1"/>
+          </p:cNvSpPr>
           <p:nvPr>
-            <p:ph idx="100" type="title" hasCustomPrompt="1"/>
+            <p:ph type="title" idx="100" hasCustomPrompt="1"/>
           </p:nvPr>
         </p:nvSpPr>
         <p:spPr>
@@ -9068,7 +9079,7 @@
           <a:bodyPr wrap="square" lIns="0" tIns="0" rIns="0" bIns="0" rtlCol="0" anchor="t"/>
           <a:lstStyle/>
           <a:p>
-            <a:pPr algn="l" indent="0" marL="0">
+            <a:pPr marL="0" indent="0" algn="l">
               <a:buNone/>
             </a:pPr>
             <a:r>
@@ -9085,14 +9096,14 @@
       </p:sp>
       <p:pic>
         <p:nvPicPr>
-          <p:cNvPr id="3" name="Image 0" descr="/Users/euibeoms/Desktop/ACoP/hackathon/slides/figs/fig_forest_Tideglusib.png">    </p:cNvPr>
+          <p:cNvPr id="3" name="Image 0" descr="/Users/euibeoms/Desktop/ACoP/hackathon/slides/figs/fig_forest_Tideglusib.png"/>
           <p:cNvPicPr>
             <a:picLocks noChangeAspect="1"/>
           </p:cNvPicPr>
           <p:nvPr/>
         </p:nvPicPr>
         <p:blipFill>
-          <a:blip r:embed="rId1"/>
+          <a:blip r:embed="rId3"/>
           <a:stretch>
             <a:fillRect/>
           </a:stretch>
@@ -9128,7 +9139,7 @@
           <a:bodyPr wrap="square" lIns="0" tIns="0" rIns="0" bIns="0" rtlCol="0" anchor="t"/>
           <a:lstStyle/>
           <a:p>
-            <a:pPr indent="0" marL="0">
+            <a:pPr marL="0" indent="0">
               <a:buNone/>
             </a:pPr>
             <a:r>
@@ -9164,7 +9175,7 @@
           <a:bodyPr wrap="square" lIns="0" tIns="0" rIns="0" bIns="0" rtlCol="0" anchor="ctr"/>
           <a:lstStyle/>
           <a:p>
-            <a:pPr indent="0" marL="0">
+            <a:pPr marL="0" indent="0">
               <a:buNone/>
             </a:pPr>
             <a:r>
@@ -9200,7 +9211,7 @@
           <a:bodyPr wrap="square" lIns="0" tIns="0" rIns="0" bIns="0" rtlCol="0" anchor="t"/>
           <a:lstStyle/>
           <a:p>
-            <a:pPr indent="0" marL="0">
+            <a:pPr marL="0" indent="0">
               <a:buNone/>
             </a:pPr>
             <a:r>
@@ -9236,7 +9247,7 @@
           <a:bodyPr wrap="square" lIns="0" tIns="0" rIns="0" bIns="0" rtlCol="0" anchor="ctr"/>
           <a:lstStyle/>
           <a:p>
-            <a:pPr indent="0" marL="0">
+            <a:pPr marL="0" indent="0">
               <a:buNone/>
             </a:pPr>
             <a:r>
@@ -9272,7 +9283,7 @@
           <a:bodyPr wrap="square" lIns="0" tIns="0" rIns="0" bIns="0" rtlCol="0" anchor="t"/>
           <a:lstStyle/>
           <a:p>
-            <a:pPr indent="0" marL="0">
+            <a:pPr marL="0" indent="0">
               <a:buNone/>
             </a:pPr>
             <a:r>
@@ -9308,7 +9319,7 @@
           <a:bodyPr wrap="square" lIns="0" tIns="0" rIns="0" bIns="0" rtlCol="0" anchor="ctr"/>
           <a:lstStyle/>
           <a:p>
-            <a:pPr indent="0" marL="0">
+            <a:pPr marL="0" indent="0">
               <a:buNone/>
             </a:pPr>
             <a:r>
@@ -9344,7 +9355,7 @@
           <a:bodyPr wrap="square" lIns="0" tIns="0" rIns="0" bIns="0" rtlCol="0" anchor="t"/>
           <a:lstStyle/>
           <a:p>
-            <a:pPr indent="0" marL="0">
+            <a:pPr marL="0" indent="0">
               <a:buNone/>
             </a:pPr>
             <a:r>
@@ -9385,6 +9396,13 @@
             <a:prstDash val="solid"/>
           </a:ln>
         </p:spPr>
+        <p:txBody>
+          <a:bodyPr/>
+          <a:lstStyle/>
+          <a:p>
+            <a:endParaRPr lang="en-US"/>
+          </a:p>
+        </p:txBody>
       </p:sp>
       <p:sp>
         <p:nvSpPr>
@@ -9407,7 +9425,7 @@
           <a:bodyPr wrap="square" lIns="0" tIns="0" rIns="0" bIns="0" rtlCol="0" anchor="ctr"/>
           <a:lstStyle/>
           <a:p>
-            <a:pPr indent="0" marL="0">
+            <a:pPr marL="0" indent="0">
               <a:buNone/>
             </a:pPr>
             <a:r>
@@ -9418,9 +9436,6 @@
               </a:rPr>
               <a:t>Test-set patients: </a:t>
             </a:r>
-            <a:pPr indent="0" marL="0">
-              <a:buNone/>
-            </a:pPr>
             <a:r>
               <a:rPr lang="en-US" sz="1350" dirty="0">
                 <a:solidFill>
@@ -9429,9 +9444,6 @@
               </a:rPr>
               <a:t>cognition below about -0.5: 17 of 23 responded (74%); above: 3 of 18 (17%). AUC 0.78 for the rule, 0.87 for the forest. </a:t>
             </a:r>
-            <a:pPr indent="0" marL="0">
-              <a:buNone/>
-            </a:pPr>
             <a:r>
               <a:rPr lang="en-US" sz="1350" b="1" dirty="0">
                 <a:solidFill>
@@ -9440,9 +9452,6 @@
               </a:rPr>
               <a:t>This is where machine learning helped: </a:t>
             </a:r>
-            <a:pPr indent="0" marL="0">
-              <a:buNone/>
-            </a:pPr>
             <a:r>
               <a:rPr lang="en-US" sz="1350" dirty="0">
                 <a:solidFill>
@@ -9476,7 +9485,7 @@
           <a:bodyPr wrap="square" lIns="0" tIns="0" rIns="0" bIns="0" rtlCol="0" anchor="t"/>
           <a:lstStyle/>
           <a:p>
-            <a:pPr indent="0" marL="0">
+            <a:pPr marL="0" indent="0">
               <a:buNone/>
             </a:pPr>
             <a:r>
@@ -9507,6 +9516,7 @@
         <a:solidFill>
           <a:srgbClr val="FFFFFF"/>
         </a:solidFill>
+        <a:effectLst/>
       </p:bgPr>
     </p:bg>
     <p:spTree>
@@ -9526,9 +9536,11 @@
       <p:sp>
         <p:nvSpPr>
           <p:cNvPr id="2" name="Text 0"/>
-          <p:cNvSpPr/>
+          <p:cNvSpPr>
+            <a:spLocks noGrp="1"/>
+          </p:cNvSpPr>
           <p:nvPr>
-            <p:ph idx="100" type="title" hasCustomPrompt="1"/>
+            <p:ph type="title" idx="100" hasCustomPrompt="1"/>
           </p:nvPr>
         </p:nvSpPr>
         <p:spPr>
@@ -9546,7 +9558,7 @@
           <a:bodyPr wrap="square" lIns="0" tIns="0" rIns="0" bIns="0" rtlCol="0" anchor="t"/>
           <a:lstStyle/>
           <a:p>
-            <a:pPr algn="l" indent="0" marL="0">
+            <a:pPr marL="0" indent="0" algn="l">
               <a:buNone/>
             </a:pPr>
             <a:r>
@@ -9577,19 +9589,55 @@
         </p:nvGraphicFramePr>
         <p:xfrm>
           <a:off x="548640" y="1417320"/>
-          <a:ext cx="11064240" cy="914400"/>
+          <a:ext cx="11064240" cy="2507488"/>
         </p:xfrm>
         <a:graphic>
           <a:graphicData uri="http://schemas.openxmlformats.org/drawingml/2006/table">
             <a:tbl>
               <a:tblPr/>
               <a:tblGrid>
-                <a:gridCol w="1737360"/>
-                <a:gridCol w="2286000"/>
-                <a:gridCol w="1097280"/>
-                <a:gridCol w="2194560"/>
-                <a:gridCol w="2011680"/>
-                <a:gridCol w="1737360"/>
+                <a:gridCol w="1737360">
+                  <a:extLst>
+                    <a:ext uri="{9D8B030D-6E8A-4147-A177-3AD203B41FA5}">
+                      <a16:colId xmlns:a16="http://schemas.microsoft.com/office/drawing/2014/main" val="20000"/>
+                    </a:ext>
+                  </a:extLst>
+                </a:gridCol>
+                <a:gridCol w="2286000">
+                  <a:extLst>
+                    <a:ext uri="{9D8B030D-6E8A-4147-A177-3AD203B41FA5}">
+                      <a16:colId xmlns:a16="http://schemas.microsoft.com/office/drawing/2014/main" val="20001"/>
+                    </a:ext>
+                  </a:extLst>
+                </a:gridCol>
+                <a:gridCol w="1097280">
+                  <a:extLst>
+                    <a:ext uri="{9D8B030D-6E8A-4147-A177-3AD203B41FA5}">
+                      <a16:colId xmlns:a16="http://schemas.microsoft.com/office/drawing/2014/main" val="20002"/>
+                    </a:ext>
+                  </a:extLst>
+                </a:gridCol>
+                <a:gridCol w="2194560">
+                  <a:extLst>
+                    <a:ext uri="{9D8B030D-6E8A-4147-A177-3AD203B41FA5}">
+                      <a16:colId xmlns:a16="http://schemas.microsoft.com/office/drawing/2014/main" val="20003"/>
+                    </a:ext>
+                  </a:extLst>
+                </a:gridCol>
+                <a:gridCol w="2011680">
+                  <a:extLst>
+                    <a:ext uri="{9D8B030D-6E8A-4147-A177-3AD203B41FA5}">
+                      <a16:colId xmlns:a16="http://schemas.microsoft.com/office/drawing/2014/main" val="20004"/>
+                    </a:ext>
+                  </a:extLst>
+                </a:gridCol>
+                <a:gridCol w="1737360">
+                  <a:extLst>
+                    <a:ext uri="{9D8B030D-6E8A-4147-A177-3AD203B41FA5}">
+                      <a16:colId xmlns:a16="http://schemas.microsoft.com/office/drawing/2014/main" val="20005"/>
+                    </a:ext>
+                  </a:extLst>
+                </a:gridCol>
               </a:tblGrid>
               <a:tr h="502920">
                 <a:tc>
@@ -9597,7 +9645,7 @@
                     <a:bodyPr/>
                     <a:lstStyle/>
                     <a:p>
-                      <a:pPr indent="0" marL="0">
+                      <a:pPr marL="0" indent="0">
                         <a:buNone/>
                       </a:pPr>
                       <a:r>
@@ -9658,7 +9706,7 @@
                     <a:bodyPr/>
                     <a:lstStyle/>
                     <a:p>
-                      <a:pPr indent="0" marL="0">
+                      <a:pPr marL="0" indent="0">
                         <a:buNone/>
                       </a:pPr>
                       <a:r>
@@ -9719,7 +9767,7 @@
                     <a:bodyPr/>
                     <a:lstStyle/>
                     <a:p>
-                      <a:pPr indent="0" marL="0">
+                      <a:pPr marL="0" indent="0">
                         <a:buNone/>
                       </a:pPr>
                       <a:r>
@@ -9780,7 +9828,7 @@
                     <a:bodyPr/>
                     <a:lstStyle/>
                     <a:p>
-                      <a:pPr indent="0" marL="0">
+                      <a:pPr marL="0" indent="0">
                         <a:buNone/>
                       </a:pPr>
                       <a:r>
@@ -9841,7 +9889,7 @@
                     <a:bodyPr/>
                     <a:lstStyle/>
                     <a:p>
-                      <a:pPr indent="0" marL="0">
+                      <a:pPr marL="0" indent="0">
                         <a:buNone/>
                       </a:pPr>
                       <a:r>
@@ -9902,7 +9950,7 @@
                     <a:bodyPr/>
                     <a:lstStyle/>
                     <a:p>
-                      <a:pPr indent="0" marL="0">
+                      <a:pPr marL="0" indent="0">
                         <a:buNone/>
                       </a:pPr>
                       <a:r>
@@ -9958,6 +10006,11 @@
                     </a:solidFill>
                   </a:tcPr>
                 </a:tc>
+                <a:extLst>
+                  <a:ext uri="{0D108BD9-81ED-4DB2-BD59-A6C34878D82A}">
+                    <a16:rowId xmlns:a16="http://schemas.microsoft.com/office/drawing/2014/main" val="10000"/>
+                  </a:ext>
+                </a:extLst>
               </a:tr>
               <a:tr h="658368">
                 <a:tc>
@@ -9965,7 +10018,7 @@
                     <a:bodyPr/>
                     <a:lstStyle/>
                     <a:p>
-                      <a:pPr indent="0" marL="0">
+                      <a:pPr marL="0" indent="0">
                         <a:buNone/>
                       </a:pPr>
                       <a:r>
@@ -10023,7 +10076,7 @@
                     <a:bodyPr/>
                     <a:lstStyle/>
                     <a:p>
-                      <a:pPr indent="0" marL="0">
+                      <a:pPr marL="0" indent="0">
                         <a:buNone/>
                       </a:pPr>
                       <a:r>
@@ -10081,7 +10134,7 @@
                     <a:bodyPr/>
                     <a:lstStyle/>
                     <a:p>
-                      <a:pPr indent="0" marL="0">
+                      <a:pPr marL="0" indent="0">
                         <a:buNone/>
                       </a:pPr>
                       <a:r>
@@ -10139,7 +10192,7 @@
                     <a:bodyPr/>
                     <a:lstStyle/>
                     <a:p>
-                      <a:pPr indent="0" marL="0">
+                      <a:pPr marL="0" indent="0">
                         <a:buNone/>
                       </a:pPr>
                       <a:r>
@@ -10197,7 +10250,7 @@
                     <a:bodyPr/>
                     <a:lstStyle/>
                     <a:p>
-                      <a:pPr indent="0" marL="0">
+                      <a:pPr marL="0" indent="0">
                         <a:buNone/>
                       </a:pPr>
                       <a:r>
@@ -10255,7 +10308,7 @@
                     <a:bodyPr/>
                     <a:lstStyle/>
                     <a:p>
-                      <a:pPr indent="0" marL="0">
+                      <a:pPr marL="0" indent="0">
                         <a:buNone/>
                       </a:pPr>
                       <a:r>
@@ -10308,6 +10361,11 @@
                     </a:lnB>
                   </a:tcPr>
                 </a:tc>
+                <a:extLst>
+                  <a:ext uri="{0D108BD9-81ED-4DB2-BD59-A6C34878D82A}">
+                    <a16:rowId xmlns:a16="http://schemas.microsoft.com/office/drawing/2014/main" val="10001"/>
+                  </a:ext>
+                </a:extLst>
               </a:tr>
               <a:tr h="658368">
                 <a:tc>
@@ -10315,7 +10373,7 @@
                     <a:bodyPr/>
                     <a:lstStyle/>
                     <a:p>
-                      <a:pPr indent="0" marL="0">
+                      <a:pPr marL="0" indent="0">
                         <a:buNone/>
                       </a:pPr>
                       <a:r>
@@ -10373,7 +10431,7 @@
                     <a:bodyPr/>
                     <a:lstStyle/>
                     <a:p>
-                      <a:pPr indent="0" marL="0">
+                      <a:pPr marL="0" indent="0">
                         <a:buNone/>
                       </a:pPr>
                       <a:r>
@@ -10431,7 +10489,7 @@
                     <a:bodyPr/>
                     <a:lstStyle/>
                     <a:p>
-                      <a:pPr indent="0" marL="0">
+                      <a:pPr marL="0" indent="0">
                         <a:buNone/>
                       </a:pPr>
                       <a:r>
@@ -10489,7 +10547,7 @@
                     <a:bodyPr/>
                     <a:lstStyle/>
                     <a:p>
-                      <a:pPr indent="0" marL="0">
+                      <a:pPr marL="0" indent="0">
                         <a:buNone/>
                       </a:pPr>
                       <a:r>
@@ -10547,7 +10605,7 @@
                     <a:bodyPr/>
                     <a:lstStyle/>
                     <a:p>
-                      <a:pPr indent="0" marL="0">
+                      <a:pPr marL="0" indent="0">
                         <a:buNone/>
                       </a:pPr>
                       <a:r>
@@ -10605,7 +10663,7 @@
                     <a:bodyPr/>
                     <a:lstStyle/>
                     <a:p>
-                      <a:pPr indent="0" marL="0">
+                      <a:pPr marL="0" indent="0">
                         <a:buNone/>
                       </a:pPr>
                       <a:r>
@@ -10658,6 +10716,11 @@
                     </a:lnB>
                   </a:tcPr>
                 </a:tc>
+                <a:extLst>
+                  <a:ext uri="{0D108BD9-81ED-4DB2-BD59-A6C34878D82A}">
+                    <a16:rowId xmlns:a16="http://schemas.microsoft.com/office/drawing/2014/main" val="10002"/>
+                  </a:ext>
+                </a:extLst>
               </a:tr>
               <a:tr h="658368">
                 <a:tc>
@@ -10665,7 +10728,7 @@
                     <a:bodyPr/>
                     <a:lstStyle/>
                     <a:p>
-                      <a:pPr indent="0" marL="0">
+                      <a:pPr marL="0" indent="0">
                         <a:buNone/>
                       </a:pPr>
                       <a:r>
@@ -10723,7 +10786,7 @@
                     <a:bodyPr/>
                     <a:lstStyle/>
                     <a:p>
-                      <a:pPr indent="0" marL="0">
+                      <a:pPr marL="0" indent="0">
                         <a:buNone/>
                       </a:pPr>
                       <a:r>
@@ -10781,7 +10844,7 @@
                     <a:bodyPr/>
                     <a:lstStyle/>
                     <a:p>
-                      <a:pPr indent="0" marL="0">
+                      <a:pPr marL="0" indent="0">
                         <a:buNone/>
                       </a:pPr>
                       <a:r>
@@ -10839,7 +10902,7 @@
                     <a:bodyPr/>
                     <a:lstStyle/>
                     <a:p>
-                      <a:pPr indent="0" marL="0">
+                      <a:pPr marL="0" indent="0">
                         <a:buNone/>
                       </a:pPr>
                       <a:r>
@@ -10897,7 +10960,7 @@
                     <a:bodyPr/>
                     <a:lstStyle/>
                     <a:p>
-                      <a:pPr indent="0" marL="0">
+                      <a:pPr marL="0" indent="0">
                         <a:buNone/>
                       </a:pPr>
                       <a:r>
@@ -10955,7 +11018,7 @@
                     <a:bodyPr/>
                     <a:lstStyle/>
                     <a:p>
-                      <a:pPr indent="0" marL="0">
+                      <a:pPr marL="0" indent="0">
                         <a:buNone/>
                       </a:pPr>
                       <a:r>
@@ -11008,6 +11071,11 @@
                     </a:lnB>
                   </a:tcPr>
                 </a:tc>
+                <a:extLst>
+                  <a:ext uri="{0D108BD9-81ED-4DB2-BD59-A6C34878D82A}">
+                    <a16:rowId xmlns:a16="http://schemas.microsoft.com/office/drawing/2014/main" val="10003"/>
+                  </a:ext>
+                </a:extLst>
               </a:tr>
             </a:tbl>
           </a:graphicData>
@@ -11039,6 +11107,13 @@
             <a:prstDash val="solid"/>
           </a:ln>
         </p:spPr>
+        <p:txBody>
+          <a:bodyPr/>
+          <a:lstStyle/>
+          <a:p>
+            <a:endParaRPr lang="en-US"/>
+          </a:p>
+        </p:txBody>
       </p:sp>
       <p:sp>
         <p:nvSpPr>
@@ -11061,7 +11136,7 @@
           <a:bodyPr wrap="square" lIns="0" tIns="0" rIns="0" bIns="0" rtlCol="0" anchor="ctr"/>
           <a:lstStyle/>
           <a:p>
-            <a:pPr indent="0" marL="0">
+            <a:pPr marL="0" indent="0">
               <a:buNone/>
             </a:pPr>
             <a:r>
@@ -11072,9 +11147,6 @@
               </a:rPr>
               <a:t>Did machine learning find additional predictors? No. </a:t>
             </a:r>
-            <a:pPr indent="0" marL="0">
-              <a:buNone/>
-            </a:pPr>
             <a:r>
               <a:rPr lang="en-US" sz="1400" dirty="0">
                 <a:solidFill>
@@ -11083,9 +11155,6 @@
               </a:rPr>
               <a:t>The same covariates in every arm, chosen by covariate models and machine learning alike; a planted random column was never selected; three independent implementations and 20 repeated splits agree. </a:t>
             </a:r>
-            <a:pPr indent="0" marL="0">
-              <a:buNone/>
-            </a:pPr>
             <a:r>
               <a:rPr lang="en-US" sz="1400" b="1" dirty="0">
                 <a:solidFill>
@@ -11094,9 +11163,6 @@
               </a:rPr>
               <a:t>Did it improve stratification? Yes, in one way: </a:t>
             </a:r>
-            <a:pPr indent="0" marL="0">
-              <a:buNone/>
-            </a:pPr>
             <a:r>
               <a:rPr lang="en-US" sz="1400" dirty="0">
                 <a:solidFill>
@@ -11105,9 +11171,6 @@
               </a:rPr>
               <a:t>it found that the cognition effect is a threshold, and a one-term rule captures it. </a:t>
             </a:r>
-            <a:pPr indent="0" marL="0">
-              <a:buNone/>
-            </a:pPr>
             <a:r>
               <a:rPr lang="en-US" sz="1400" b="1" dirty="0">
                 <a:solidFill>
@@ -11141,7 +11204,7 @@
           <a:bodyPr wrap="square" lIns="0" tIns="0" rIns="0" bIns="0" rtlCol="0" anchor="t"/>
           <a:lstStyle/>
           <a:p>
-            <a:pPr indent="0" marL="0">
+            <a:pPr marL="0" indent="0">
               <a:buNone/>
             </a:pPr>
             <a:r>
@@ -11172,6 +11235,7 @@
         <a:solidFill>
           <a:srgbClr val="FFFFFF"/>
         </a:solidFill>
+        <a:effectLst/>
       </p:bgPr>
     </p:bg>
     <p:spTree>
@@ -11191,9 +11255,11 @@
       <p:sp>
         <p:nvSpPr>
           <p:cNvPr id="2" name="Text 0"/>
-          <p:cNvSpPr/>
+          <p:cNvSpPr>
+            <a:spLocks noGrp="1"/>
+          </p:cNvSpPr>
           <p:nvPr>
-            <p:ph idx="100" type="title" hasCustomPrompt="1"/>
+            <p:ph type="title" idx="100" hasCustomPrompt="1"/>
           </p:nvPr>
         </p:nvSpPr>
         <p:spPr>
@@ -11211,7 +11277,7 @@
           <a:bodyPr wrap="square" lIns="0" tIns="0" rIns="0" bIns="0" rtlCol="0" anchor="t"/>
           <a:lstStyle/>
           <a:p>
-            <a:pPr algn="l" indent="0" marL="0">
+            <a:pPr marL="0" indent="0" algn="l">
               <a:buNone/>
             </a:pPr>
             <a:r>
@@ -11247,7 +11313,7 @@
           <a:bodyPr wrap="square" lIns="0" tIns="0" rIns="0" bIns="0" rtlCol="0" anchor="ctr"/>
           <a:lstStyle/>
           <a:p>
-            <a:pPr indent="0" marL="0">
+            <a:pPr marL="0" indent="0">
               <a:buNone/>
             </a:pPr>
             <a:r>
@@ -11377,7 +11443,7 @@
           <a:bodyPr wrap="square" lIns="0" tIns="0" rIns="0" bIns="0" rtlCol="0" anchor="ctr"/>
           <a:lstStyle/>
           <a:p>
-            <a:pPr indent="0" marL="0">
+            <a:pPr marL="0" indent="0">
               <a:buNone/>
             </a:pPr>
             <a:r>
@@ -11418,6 +11484,13 @@
             <a:prstDash val="solid"/>
           </a:ln>
         </p:spPr>
+        <p:txBody>
+          <a:bodyPr/>
+          <a:lstStyle/>
+          <a:p>
+            <a:endParaRPr lang="en-US"/>
+          </a:p>
+        </p:txBody>
       </p:sp>
       <p:sp>
         <p:nvSpPr>
@@ -11440,7 +11513,7 @@
           <a:bodyPr wrap="square" lIns="0" tIns="0" rIns="0" bIns="0" rtlCol="0" anchor="ctr"/>
           <a:lstStyle/>
           <a:p>
-            <a:pPr indent="0" marL="0">
+            <a:pPr marL="0" indent="0">
               <a:buNone/>
             </a:pPr>
             <a:r>
@@ -11476,7 +11549,7 @@
           <a:bodyPr wrap="square" lIns="0" tIns="0" rIns="0" bIns="0" rtlCol="0" anchor="ctr"/>
           <a:lstStyle/>
           <a:p>
-            <a:pPr indent="0" marL="0">
+            <a:pPr marL="0" indent="0">
               <a:buNone/>
             </a:pPr>
             <a:r>
@@ -11565,6 +11638,7 @@
         <a:solidFill>
           <a:srgbClr val="FFFFFF"/>
         </a:solidFill>
+        <a:effectLst/>
       </p:bgPr>
     </p:bg>
     <p:spTree>
@@ -11584,9 +11658,11 @@
       <p:sp>
         <p:nvSpPr>
           <p:cNvPr id="2" name="Text 0"/>
-          <p:cNvSpPr/>
+          <p:cNvSpPr>
+            <a:spLocks noGrp="1"/>
+          </p:cNvSpPr>
           <p:nvPr>
-            <p:ph idx="100" type="title" hasCustomPrompt="1"/>
+            <p:ph type="title" idx="100" hasCustomPrompt="1"/>
           </p:nvPr>
         </p:nvSpPr>
         <p:spPr>
@@ -11604,7 +11680,7 @@
           <a:bodyPr wrap="square" lIns="0" tIns="0" rIns="0" bIns="0" rtlCol="0" anchor="t"/>
           <a:lstStyle/>
           <a:p>
-            <a:pPr algn="l" indent="0" marL="0">
+            <a:pPr marL="0" indent="0" algn="l">
               <a:buNone/>
             </a:pPr>
             <a:r>
@@ -11621,14 +11697,14 @@
       </p:sp>
       <p:pic>
         <p:nvPicPr>
-          <p:cNvPr id="3" name="Image 0" descr="/Users/euibeoms/Desktop/ACoP/hackathon/slides/figs/fig_sensitivity_splits.png">    </p:cNvPr>
+          <p:cNvPr id="3" name="Image 0" descr="/Users/euibeoms/Desktop/ACoP/hackathon/slides/figs/fig_sensitivity_splits.png"/>
           <p:cNvPicPr>
             <a:picLocks noChangeAspect="1"/>
           </p:cNvPicPr>
           <p:nvPr/>
         </p:nvPicPr>
         <p:blipFill>
-          <a:blip r:embed="rId1"/>
+          <a:blip r:embed="rId3"/>
           <a:stretch>
             <a:fillRect/>
           </a:stretch>
@@ -11664,7 +11740,7 @@
           <a:bodyPr wrap="square" lIns="0" tIns="0" rIns="0" bIns="0" rtlCol="0" anchor="t"/>
           <a:lstStyle/>
           <a:p>
-            <a:pPr indent="0" marL="0">
+            <a:pPr marL="0" indent="0">
               <a:buNone/>
             </a:pPr>
             <a:r>
@@ -11980,4 +12056,319 @@
     </a:ext>
   </a:extLst>
 </a:theme>
+</file>
+
+<file path=ppt/theme/theme2.xml><?xml version="1.0" encoding="utf-8"?>
+<a:theme xmlns:a="http://schemas.openxmlformats.org/drawingml/2006/main" name="Office Theme">
+  <a:themeElements>
+    <a:clrScheme name="Office">
+      <a:dk1>
+        <a:sysClr val="windowText" lastClr="000000"/>
+      </a:dk1>
+      <a:lt1>
+        <a:sysClr val="window" lastClr="FFFFFF"/>
+      </a:lt1>
+      <a:dk2>
+        <a:srgbClr val="0E2841"/>
+      </a:dk2>
+      <a:lt2>
+        <a:srgbClr val="E8E8E8"/>
+      </a:lt2>
+      <a:accent1>
+        <a:srgbClr val="156082"/>
+      </a:accent1>
+      <a:accent2>
+        <a:srgbClr val="E97132"/>
+      </a:accent2>
+      <a:accent3>
+        <a:srgbClr val="196B24"/>
+      </a:accent3>
+      <a:accent4>
+        <a:srgbClr val="0F9ED5"/>
+      </a:accent4>
+      <a:accent5>
+        <a:srgbClr val="A02B93"/>
+      </a:accent5>
+      <a:accent6>
+        <a:srgbClr val="4EA72E"/>
+      </a:accent6>
+      <a:hlink>
+        <a:srgbClr val="467886"/>
+      </a:hlink>
+      <a:folHlink>
+        <a:srgbClr val="96607D"/>
+      </a:folHlink>
+    </a:clrScheme>
+    <a:fontScheme name="Office">
+      <a:majorFont>
+        <a:latin typeface="Aptos Display" panose="02110004020202020204"/>
+        <a:ea typeface=""/>
+        <a:cs typeface=""/>
+        <a:font script="Jpan" typeface="游ゴシック Light"/>
+        <a:font script="Hang" typeface="맑은 고딕"/>
+        <a:font script="Hans" typeface="等线 Light"/>
+        <a:font script="Hant" typeface="新細明體"/>
+        <a:font script="Arab" typeface="Times New Roman"/>
+        <a:font script="Hebr" typeface="Times New Roman"/>
+        <a:font script="Thai" typeface="Angsana New"/>
+        <a:font script="Ethi" typeface="Nyala"/>
+        <a:font script="Beng" typeface="Vrinda"/>
+        <a:font script="Gujr" typeface="Shruti"/>
+        <a:font script="Khmr" typeface="MoolBoran"/>
+        <a:font script="Knda" typeface="Tunga"/>
+        <a:font script="Guru" typeface="Raavi"/>
+        <a:font script="Cans" typeface="Euphemia"/>
+        <a:font script="Cher" typeface="Plantagenet Cherokee"/>
+        <a:font script="Yiii" typeface="Microsoft Yi Baiti"/>
+        <a:font script="Tibt" typeface="Microsoft Himalaya"/>
+        <a:font script="Thaa" typeface="MV Boli"/>
+        <a:font script="Deva" typeface="Mangal"/>
+        <a:font script="Telu" typeface="Gautami"/>
+        <a:font script="Taml" typeface="Latha"/>
+        <a:font script="Syrc" typeface="Estrangelo Edessa"/>
+        <a:font script="Orya" typeface="Kalinga"/>
+        <a:font script="Mlym" typeface="Kartika"/>
+        <a:font script="Laoo" typeface="DokChampa"/>
+        <a:font script="Sinh" typeface="Iskoola Pota"/>
+        <a:font script="Mong" typeface="Mongolian Baiti"/>
+        <a:font script="Viet" typeface="Times New Roman"/>
+        <a:font script="Uigh" typeface="Microsoft Uighur"/>
+        <a:font script="Geor" typeface="Sylfaen"/>
+        <a:font script="Armn" typeface="Arial"/>
+        <a:font script="Bugi" typeface="Leelawadee UI"/>
+        <a:font script="Bopo" typeface="Microsoft JhengHei"/>
+        <a:font script="Java" typeface="Javanese Text"/>
+        <a:font script="Lisu" typeface="Segoe UI"/>
+        <a:font script="Mymr" typeface="Myanmar Text"/>
+        <a:font script="Nkoo" typeface="Ebrima"/>
+        <a:font script="Olck" typeface="Nirmala UI"/>
+        <a:font script="Osma" typeface="Ebrima"/>
+        <a:font script="Phag" typeface="Phagspa"/>
+        <a:font script="Syrn" typeface="Estrangelo Edessa"/>
+        <a:font script="Syrj" typeface="Estrangelo Edessa"/>
+        <a:font script="Syre" typeface="Estrangelo Edessa"/>
+        <a:font script="Sora" typeface="Nirmala UI"/>
+        <a:font script="Tale" typeface="Microsoft Tai Le"/>
+        <a:font script="Talu" typeface="Microsoft New Tai Lue"/>
+        <a:font script="Tfng" typeface="Ebrima"/>
+      </a:majorFont>
+      <a:minorFont>
+        <a:latin typeface="Aptos" panose="02110004020202020204"/>
+        <a:ea typeface=""/>
+        <a:cs typeface=""/>
+        <a:font script="Jpan" typeface="游ゴシック"/>
+        <a:font script="Hang" typeface="맑은 고딕"/>
+        <a:font script="Hans" typeface="等线"/>
+        <a:font script="Hant" typeface="新細明體"/>
+        <a:font script="Arab" typeface="Arial"/>
+        <a:font script="Hebr" typeface="Arial"/>
+        <a:font script="Thai" typeface="Cordia New"/>
+        <a:font script="Ethi" typeface="Nyala"/>
+        <a:font script="Beng" typeface="Vrinda"/>
+        <a:font script="Gujr" typeface="Shruti"/>
+        <a:font script="Khmr" typeface="DaunPenh"/>
+        <a:font script="Knda" typeface="Tunga"/>
+        <a:font script="Guru" typeface="Raavi"/>
+        <a:font script="Cans" typeface="Euphemia"/>
+        <a:font script="Cher" typeface="Plantagenet Cherokee"/>
+        <a:font script="Yiii" typeface="Microsoft Yi Baiti"/>
+        <a:font script="Tibt" typeface="Microsoft Himalaya"/>
+        <a:font script="Thaa" typeface="MV Boli"/>
+        <a:font script="Deva" typeface="Mangal"/>
+        <a:font script="Telu" typeface="Gautami"/>
+        <a:font script="Taml" typeface="Latha"/>
+        <a:font script="Syrc" typeface="Estrangelo Edessa"/>
+        <a:font script="Orya" typeface="Kalinga"/>
+        <a:font script="Mlym" typeface="Kartika"/>
+        <a:font script="Laoo" typeface="DokChampa"/>
+        <a:font script="Sinh" typeface="Iskoola Pota"/>
+        <a:font script="Mong" typeface="Mongolian Baiti"/>
+        <a:font script="Viet" typeface="Arial"/>
+        <a:font script="Uigh" typeface="Microsoft Uighur"/>
+        <a:font script="Geor" typeface="Sylfaen"/>
+        <a:font script="Armn" typeface="Arial"/>
+        <a:font script="Bugi" typeface="Leelawadee UI"/>
+        <a:font script="Bopo" typeface="Microsoft JhengHei"/>
+        <a:font script="Java" typeface="Javanese Text"/>
+        <a:font script="Lisu" typeface="Segoe UI"/>
+        <a:font script="Mymr" typeface="Myanmar Text"/>
+        <a:font script="Nkoo" typeface="Ebrima"/>
+        <a:font script="Olck" typeface="Nirmala UI"/>
+        <a:font script="Osma" typeface="Ebrima"/>
+        <a:font script="Phag" typeface="Phagspa"/>
+        <a:font script="Syrn" typeface="Estrangelo Edessa"/>
+        <a:font script="Syrj" typeface="Estrangelo Edessa"/>
+        <a:font script="Syre" typeface="Estrangelo Edessa"/>
+        <a:font script="Sora" typeface="Nirmala UI"/>
+        <a:font script="Tale" typeface="Microsoft Tai Le"/>
+        <a:font script="Talu" typeface="Microsoft New Tai Lue"/>
+        <a:font script="Tfng" typeface="Ebrima"/>
+      </a:minorFont>
+    </a:fontScheme>
+    <a:fmtScheme name="Office">
+      <a:fillStyleLst>
+        <a:solidFill>
+          <a:schemeClr val="phClr"/>
+        </a:solidFill>
+        <a:gradFill rotWithShape="1">
+          <a:gsLst>
+            <a:gs pos="0">
+              <a:schemeClr val="phClr">
+                <a:lumMod val="110000"/>
+                <a:satMod val="105000"/>
+                <a:tint val="67000"/>
+              </a:schemeClr>
+            </a:gs>
+            <a:gs pos="50000">
+              <a:schemeClr val="phClr">
+                <a:lumMod val="105000"/>
+                <a:satMod val="103000"/>
+                <a:tint val="73000"/>
+              </a:schemeClr>
+            </a:gs>
+            <a:gs pos="100000">
+              <a:schemeClr val="phClr">
+                <a:lumMod val="105000"/>
+                <a:satMod val="109000"/>
+                <a:tint val="81000"/>
+              </a:schemeClr>
+            </a:gs>
+          </a:gsLst>
+          <a:lin ang="5400000" scaled="0"/>
+        </a:gradFill>
+        <a:gradFill rotWithShape="1">
+          <a:gsLst>
+            <a:gs pos="0">
+              <a:schemeClr val="phClr">
+                <a:satMod val="103000"/>
+                <a:lumMod val="102000"/>
+                <a:tint val="94000"/>
+              </a:schemeClr>
+            </a:gs>
+            <a:gs pos="50000">
+              <a:schemeClr val="phClr">
+                <a:satMod val="110000"/>
+                <a:lumMod val="100000"/>
+                <a:shade val="100000"/>
+              </a:schemeClr>
+            </a:gs>
+            <a:gs pos="100000">
+              <a:schemeClr val="phClr">
+                <a:lumMod val="99000"/>
+                <a:satMod val="120000"/>
+                <a:shade val="78000"/>
+              </a:schemeClr>
+            </a:gs>
+          </a:gsLst>
+          <a:lin ang="5400000" scaled="0"/>
+        </a:gradFill>
+      </a:fillStyleLst>
+      <a:lnStyleLst>
+        <a:ln w="12700" cap="flat" cmpd="sng" algn="ctr">
+          <a:solidFill>
+            <a:schemeClr val="phClr"/>
+          </a:solidFill>
+          <a:prstDash val="solid"/>
+          <a:miter lim="800000"/>
+        </a:ln>
+        <a:ln w="19050" cap="flat" cmpd="sng" algn="ctr">
+          <a:solidFill>
+            <a:schemeClr val="phClr"/>
+          </a:solidFill>
+          <a:prstDash val="solid"/>
+          <a:miter lim="800000"/>
+        </a:ln>
+        <a:ln w="25400" cap="flat" cmpd="sng" algn="ctr">
+          <a:solidFill>
+            <a:schemeClr val="phClr"/>
+          </a:solidFill>
+          <a:prstDash val="solid"/>
+          <a:miter lim="800000"/>
+        </a:ln>
+      </a:lnStyleLst>
+      <a:effectStyleLst>
+        <a:effectStyle>
+          <a:effectLst/>
+        </a:effectStyle>
+        <a:effectStyle>
+          <a:effectLst/>
+        </a:effectStyle>
+        <a:effectStyle>
+          <a:effectLst>
+            <a:outerShdw blurRad="57150" dist="19050" dir="5400000" algn="ctr" rotWithShape="0">
+              <a:srgbClr val="000000">
+                <a:alpha val="63000"/>
+              </a:srgbClr>
+            </a:outerShdw>
+          </a:effectLst>
+        </a:effectStyle>
+      </a:effectStyleLst>
+      <a:bgFillStyleLst>
+        <a:solidFill>
+          <a:schemeClr val="phClr"/>
+        </a:solidFill>
+        <a:solidFill>
+          <a:schemeClr val="phClr">
+            <a:tint val="95000"/>
+            <a:satMod val="170000"/>
+          </a:schemeClr>
+        </a:solidFill>
+        <a:gradFill rotWithShape="1">
+          <a:gsLst>
+            <a:gs pos="0">
+              <a:schemeClr val="phClr">
+                <a:tint val="93000"/>
+                <a:satMod val="150000"/>
+                <a:shade val="98000"/>
+                <a:lumMod val="102000"/>
+              </a:schemeClr>
+            </a:gs>
+            <a:gs pos="50000">
+              <a:schemeClr val="phClr">
+                <a:tint val="98000"/>
+                <a:satMod val="130000"/>
+                <a:shade val="90000"/>
+                <a:lumMod val="103000"/>
+              </a:schemeClr>
+            </a:gs>
+            <a:gs pos="100000">
+              <a:schemeClr val="phClr">
+                <a:shade val="63000"/>
+                <a:satMod val="120000"/>
+              </a:schemeClr>
+            </a:gs>
+          </a:gsLst>
+          <a:lin ang="5400000" scaled="0"/>
+        </a:gradFill>
+      </a:bgFillStyleLst>
+    </a:fmtScheme>
+  </a:themeElements>
+  <a:objectDefaults>
+    <a:lnDef>
+      <a:spPr/>
+      <a:bodyPr/>
+      <a:lstStyle/>
+      <a:style>
+        <a:lnRef idx="2">
+          <a:schemeClr val="accent1"/>
+        </a:lnRef>
+        <a:fillRef idx="0">
+          <a:schemeClr val="accent1"/>
+        </a:fillRef>
+        <a:effectRef idx="1">
+          <a:schemeClr val="accent1"/>
+        </a:effectRef>
+        <a:fontRef idx="minor">
+          <a:schemeClr val="tx1"/>
+        </a:fontRef>
+      </a:style>
+    </a:lnDef>
+  </a:objectDefaults>
+  <a:extraClrSchemeLst/>
+  <a:extLst>
+    <a:ext uri="{05A4C25C-085E-4340-85A3-A5531E510DB2}">
+      <thm15:themeFamily xmlns:thm15="http://schemas.microsoft.com/office/thememl/2012/main" name="Office Theme" id="{2E142A2C-CD16-42D6-873A-C26D2A0506FA}" vid="{1BDDFF52-6CD6-40A5-AB3C-68EB2F1E4D0A}"/>
+    </a:ext>
+  </a:extLst>
+</a:theme>
 </file>
</xml_diff>